<commit_message>
vault backup: 2026-08-09 19:20:43
</commit_message>
<xml_diff>
--- a/CdBd 문서 체계 진단 및 개편 제안.pptx
+++ b/CdBd 문서 체계 진단 및 개편 제안.pptx
@@ -3280,8 +3280,31 @@
                 <a:ea typeface="Pretendard"/>
                 <a:cs typeface="Pretendard"/>
               </a:rPr>
-              <a:t>Claude가 우리 기능을
-다 알게 만들려면</a:t>
+              <a:t>Claude가 우리 기능을</a:t>
+            </a:r>
+          </a:p>
+          <a:p>
+            <a:pPr>
+              <a:lnSpc>
+                <a:spcPct val="122000"/>
+              </a:lnSpc>
+              <a:spcBef>
+                <a:spcPts val="0"/>
+              </a:spcBef>
+              <a:spcAft>
+                <a:spcPts val="0"/>
+              </a:spcAft>
+            </a:pPr>
+            <a:r>
+              <a:rPr sz="4600" b="1">
+                <a:solidFill>
+                  <a:srgbClr val="FFFFFF"/>
+                </a:solidFill>
+                <a:latin typeface="Pretendard"/>
+                <a:ea typeface="Pretendard"/>
+                <a:cs typeface="Pretendard"/>
+              </a:rPr>
+              <a:t>다 알게 만들려면</a:t>
             </a:r>
           </a:p>
         </p:txBody>
@@ -3872,9 +3895,55 @@
                 <a:ea typeface="Pretendard"/>
                 <a:cs typeface="Pretendard"/>
               </a:rPr>
-              <a:t>Claude가 대화를 시작할 때 보이지 않습니다.
-누군가 “이 문서 읽어봐”라고 말해줘야
-비로소 열립니다.</a:t>
+              <a:t>Claude가 대화를 시작할 때 보이지 않습니다.</a:t>
+            </a:r>
+          </a:p>
+          <a:p>
+            <a:pPr>
+              <a:lnSpc>
+                <a:spcPct val="155000"/>
+              </a:lnSpc>
+              <a:spcBef>
+                <a:spcPts val="0"/>
+              </a:spcBef>
+              <a:spcAft>
+                <a:spcPts val="0"/>
+              </a:spcAft>
+            </a:pPr>
+            <a:r>
+              <a:rPr sz="1350" b="0">
+                <a:solidFill>
+                  <a:srgbClr val="292929"/>
+                </a:solidFill>
+                <a:latin typeface="Pretendard"/>
+                <a:ea typeface="Pretendard"/>
+                <a:cs typeface="Pretendard"/>
+              </a:rPr>
+              <a:t>누군가 “이 문서 읽어봐”라고 말해줘야</a:t>
+            </a:r>
+          </a:p>
+          <a:p>
+            <a:pPr>
+              <a:lnSpc>
+                <a:spcPct val="155000"/>
+              </a:lnSpc>
+              <a:spcBef>
+                <a:spcPts val="0"/>
+              </a:spcBef>
+              <a:spcAft>
+                <a:spcPts val="0"/>
+              </a:spcAft>
+            </a:pPr>
+            <a:r>
+              <a:rPr sz="1350" b="0">
+                <a:solidFill>
+                  <a:srgbClr val="292929"/>
+                </a:solidFill>
+                <a:latin typeface="Pretendard"/>
+                <a:ea typeface="Pretendard"/>
+                <a:cs typeface="Pretendard"/>
+              </a:rPr>
+              <a:t>비로소 열립니다.</a:t>
             </a:r>
           </a:p>
           <a:p>
@@ -4015,9 +4084,55 @@
                 <a:ea typeface="Pretendard"/>
                 <a:cs typeface="Pretendard"/>
               </a:rPr>
-              <a:t>Claude가 대화 시작 시 항상 목록으로 봅니다.
-“룩북 시안 만들어줘”라고 말하면
-스스로 해당 스킬을 찾아 실행합니다.</a:t>
+              <a:t>Claude가 대화 시작 시 항상 목록으로 봅니다.</a:t>
+            </a:r>
+          </a:p>
+          <a:p>
+            <a:pPr>
+              <a:lnSpc>
+                <a:spcPct val="155000"/>
+              </a:lnSpc>
+              <a:spcBef>
+                <a:spcPts val="0"/>
+              </a:spcBef>
+              <a:spcAft>
+                <a:spcPts val="0"/>
+              </a:spcAft>
+            </a:pPr>
+            <a:r>
+              <a:rPr sz="1350" b="0">
+                <a:solidFill>
+                  <a:srgbClr val="292929"/>
+                </a:solidFill>
+                <a:latin typeface="Pretendard"/>
+                <a:ea typeface="Pretendard"/>
+                <a:cs typeface="Pretendard"/>
+              </a:rPr>
+              <a:t>“룩북 시안 만들어줘”라고 말하면</a:t>
+            </a:r>
+          </a:p>
+          <a:p>
+            <a:pPr>
+              <a:lnSpc>
+                <a:spcPct val="155000"/>
+              </a:lnSpc>
+              <a:spcBef>
+                <a:spcPts val="0"/>
+              </a:spcBef>
+              <a:spcAft>
+                <a:spcPts val="0"/>
+              </a:spcAft>
+            </a:pPr>
+            <a:r>
+              <a:rPr sz="1350" b="0">
+                <a:solidFill>
+                  <a:srgbClr val="292929"/>
+                </a:solidFill>
+                <a:latin typeface="Pretendard"/>
+                <a:ea typeface="Pretendard"/>
+                <a:cs typeface="Pretendard"/>
+              </a:rPr>
+              <a:t>스스로 해당 스킬을 찾아 실행합니다.</a:t>
             </a:r>
           </a:p>
           <a:p>
@@ -4709,8 +4824,31 @@
                 <a:ea typeface="Pretendard"/>
                 <a:cs typeface="Pretendard"/>
               </a:rPr>
-              <a:t>전 저장소 동일 골격 100~150줄.
-“이렇게 말하면 → 이걸 실행 → 정본 문서는 여기”</a:t>
+              <a:t>전 저장소 동일 골격 100~150줄.</a:t>
+            </a:r>
+          </a:p>
+          <a:p>
+            <a:pPr>
+              <a:lnSpc>
+                <a:spcPct val="145000"/>
+              </a:lnSpc>
+              <a:spcBef>
+                <a:spcPts val="0"/>
+              </a:spcBef>
+              <a:spcAft>
+                <a:spcPts val="0"/>
+              </a:spcAft>
+            </a:pPr>
+            <a:r>
+              <a:rPr sz="1250" b="0">
+                <a:solidFill>
+                  <a:srgbClr val="6B6B6B"/>
+                </a:solidFill>
+                <a:latin typeface="Pretendard"/>
+                <a:ea typeface="Pretendard"/>
+                <a:cs typeface="Pretendard"/>
+              </a:rPr>
+              <a:t>“이렇게 말하면 → 이걸 실행 → 정본 문서는 여기”</a:t>
             </a:r>
           </a:p>
         </p:txBody>
@@ -4895,8 +5033,31 @@
                 <a:ea typeface="Pretendard"/>
                 <a:cs typeface="Pretendard"/>
               </a:rPr>
-              <a:t>가장 자주 쓰는 것부터. 얇은 SKILL.md가
-정본 문서를 가리키기만 합니다.</a:t>
+              <a:t>가장 자주 쓰는 것부터. 얇은 SKILL.md가</a:t>
+            </a:r>
+          </a:p>
+          <a:p>
+            <a:pPr>
+              <a:lnSpc>
+                <a:spcPct val="145000"/>
+              </a:lnSpc>
+              <a:spcBef>
+                <a:spcPts val="0"/>
+              </a:spcBef>
+              <a:spcAft>
+                <a:spcPts val="0"/>
+              </a:spcAft>
+            </a:pPr>
+            <a:r>
+              <a:rPr sz="1250" b="0">
+                <a:solidFill>
+                  <a:srgbClr val="6B6B6B"/>
+                </a:solidFill>
+                <a:latin typeface="Pretendard"/>
+                <a:ea typeface="Pretendard"/>
+                <a:cs typeface="Pretendard"/>
+              </a:rPr>
+              <a:t>정본 문서를 가리키기만 합니다.</a:t>
             </a:r>
           </a:p>
         </p:txBody>
@@ -5081,8 +5242,31 @@
                 <a:ea typeface="Pretendard"/>
                 <a:cs typeface="Pretendard"/>
               </a:rPr>
-              <a:t>개인 PC에 있는 것을 저장소로 옮겨
-팀 전체가 같은 결과를 얻게 합니다.</a:t>
+              <a:t>개인 PC에 있는 것을 저장소로 옮겨</a:t>
+            </a:r>
+          </a:p>
+          <a:p>
+            <a:pPr>
+              <a:lnSpc>
+                <a:spcPct val="145000"/>
+              </a:lnSpc>
+              <a:spcBef>
+                <a:spcPts val="0"/>
+              </a:spcBef>
+              <a:spcAft>
+                <a:spcPts val="0"/>
+              </a:spcAft>
+            </a:pPr>
+            <a:r>
+              <a:rPr sz="1250" b="0">
+                <a:solidFill>
+                  <a:srgbClr val="6B6B6B"/>
+                </a:solidFill>
+                <a:latin typeface="Pretendard"/>
+                <a:ea typeface="Pretendard"/>
+                <a:cs typeface="Pretendard"/>
+              </a:rPr>
+              <a:t>팀 전체가 같은 결과를 얻게 합니다.</a:t>
             </a:r>
           </a:p>
         </p:txBody>
@@ -5267,8 +5451,31 @@
                 <a:ea typeface="Pretendard"/>
                 <a:cs typeface="Pretendard"/>
               </a:rPr>
-              <a:t>죽은 절대경로 3종, 깨진 위키링크 60여 건,
-브랜드 색 정본 확정.</a:t>
+              <a:t>죽은 절대경로 3종, 깨진 위키링크 60여 건,</a:t>
+            </a:r>
+          </a:p>
+          <a:p>
+            <a:pPr>
+              <a:lnSpc>
+                <a:spcPct val="145000"/>
+              </a:lnSpc>
+              <a:spcBef>
+                <a:spcPts val="0"/>
+              </a:spcBef>
+              <a:spcAft>
+                <a:spcPts val="0"/>
+              </a:spcAft>
+            </a:pPr>
+            <a:r>
+              <a:rPr sz="1250" b="0">
+                <a:solidFill>
+                  <a:srgbClr val="6B6B6B"/>
+                </a:solidFill>
+                <a:latin typeface="Pretendard"/>
+                <a:ea typeface="Pretendard"/>
+                <a:cs typeface="Pretendard"/>
+              </a:rPr>
+              <a:t>브랜드 색 정본 확정.</a:t>
             </a:r>
           </a:p>
         </p:txBody>
@@ -5932,8 +6139,31 @@
                 <a:ea typeface="Pretendard"/>
                 <a:cs typeface="Pretendard"/>
               </a:rPr>
-              <a:t>브랜드 토큰 · 문서 규칙 · 공통 스킬만 담습니다.
-각 저장소에 _core/ 폴더로 자동 삽입됩니다.</a:t>
+              <a:t>브랜드 토큰 · 문서 규칙 · 공통 스킬만 담습니다.</a:t>
+            </a:r>
+          </a:p>
+          <a:p>
+            <a:pPr>
+              <a:lnSpc>
+                <a:spcPct val="145000"/>
+              </a:lnSpc>
+              <a:spcBef>
+                <a:spcPts val="0"/>
+              </a:spcBef>
+              <a:spcAft>
+                <a:spcPts val="0"/>
+              </a:spcAft>
+            </a:pPr>
+            <a:r>
+              <a:rPr sz="1250" b="0">
+                <a:solidFill>
+                  <a:srgbClr val="6B6B6B"/>
+                </a:solidFill>
+                <a:latin typeface="Pretendard"/>
+                <a:ea typeface="Pretendard"/>
+                <a:cs typeface="Pretendard"/>
+              </a:rPr>
+              <a:t>각 저장소에 _core/ 폴더로 자동 삽입됩니다.</a:t>
             </a:r>
           </a:p>
         </p:txBody>
@@ -6118,8 +6348,31 @@
                 <a:ea typeface="Pretendard"/>
                 <a:cs typeface="Pretendard"/>
               </a:rPr>
-              <a:t>일부가 아니라 전부. 저장소별 발견율을
-100%로 맞춥니다.</a:t>
+              <a:t>일부가 아니라 전부. 저장소별 발견율을</a:t>
+            </a:r>
+          </a:p>
+          <a:p>
+            <a:pPr>
+              <a:lnSpc>
+                <a:spcPct val="145000"/>
+              </a:lnSpc>
+              <a:spcBef>
+                <a:spcPts val="0"/>
+              </a:spcBef>
+              <a:spcAft>
+                <a:spcPts val="0"/>
+              </a:spcAft>
+            </a:pPr>
+            <a:r>
+              <a:rPr sz="1250" b="0">
+                <a:solidFill>
+                  <a:srgbClr val="6B6B6B"/>
+                </a:solidFill>
+                <a:latin typeface="Pretendard"/>
+                <a:ea typeface="Pretendard"/>
+                <a:cs typeface="Pretendard"/>
+              </a:rPr>
+              <a:t>100%로 맞춥니다.</a:t>
             </a:r>
           </a:p>
         </p:txBody>
@@ -6304,8 +6557,31 @@
                 <a:ea typeface="Pretendard"/>
                 <a:cs typeface="Pretendard"/>
               </a:rPr>
-              <a:t>makevu-qrstp가 이미 모범입니다(메타데이터 98%).
-그 방식을 전 저장소로 확산합니다.</a:t>
+              <a:t>makevu-qrstp가 이미 모범입니다(메타데이터 98%).</a:t>
+            </a:r>
+          </a:p>
+          <a:p>
+            <a:pPr>
+              <a:lnSpc>
+                <a:spcPct val="145000"/>
+              </a:lnSpc>
+              <a:spcBef>
+                <a:spcPts val="0"/>
+              </a:spcBef>
+              <a:spcAft>
+                <a:spcPts val="0"/>
+              </a:spcAft>
+            </a:pPr>
+            <a:r>
+              <a:rPr sz="1250" b="0">
+                <a:solidFill>
+                  <a:srgbClr val="6B6B6B"/>
+                </a:solidFill>
+                <a:latin typeface="Pretendard"/>
+                <a:ea typeface="Pretendard"/>
+                <a:cs typeface="Pretendard"/>
+              </a:rPr>
+              <a:t>그 방식을 전 저장소로 확산합니다.</a:t>
             </a:r>
           </a:p>
         </p:txBody>
@@ -6490,8 +6766,31 @@
                 <a:ea typeface="Pretendard"/>
                 <a:cs typeface="Pretendard"/>
               </a:rPr>
-              <a:t>깨진 링크 · 실종된 문서 · 어긋난 브랜드 값을
-주기적으로 자동 점검합니다.</a:t>
+              <a:t>깨진 링크 · 실종된 문서 · 어긋난 브랜드 값을</a:t>
+            </a:r>
+          </a:p>
+          <a:p>
+            <a:pPr>
+              <a:lnSpc>
+                <a:spcPct val="145000"/>
+              </a:lnSpc>
+              <a:spcBef>
+                <a:spcPts val="0"/>
+              </a:spcBef>
+              <a:spcAft>
+                <a:spcPts val="0"/>
+              </a:spcAft>
+            </a:pPr>
+            <a:r>
+              <a:rPr sz="1250" b="0">
+                <a:solidFill>
+                  <a:srgbClr val="6B6B6B"/>
+                </a:solidFill>
+                <a:latin typeface="Pretendard"/>
+                <a:ea typeface="Pretendard"/>
+                <a:cs typeface="Pretendard"/>
+              </a:rPr>
+              <a:t>주기적으로 자동 점검합니다.</a:t>
             </a:r>
           </a:p>
         </p:txBody>
@@ -14405,9 +14704,55 @@
                 <a:ea typeface="Pretendard"/>
                 <a:cs typeface="Pretendard"/>
               </a:rPr>
-              <a:t>465권의 책(문서)이 있고 내용도 좋습니다.
-큐알 이벤트 제작법 372줄, 개발 문서
-가이드 787줄 — 밀도가 매우 높습니다.</a:t>
+              <a:t>465권의 책(문서)이 있고 내용도 좋습니다.</a:t>
+            </a:r>
+          </a:p>
+          <a:p>
+            <a:pPr>
+              <a:lnSpc>
+                <a:spcPct val="150000"/>
+              </a:lnSpc>
+              <a:spcBef>
+                <a:spcPts val="0"/>
+              </a:spcBef>
+              <a:spcAft>
+                <a:spcPts val="0"/>
+              </a:spcAft>
+            </a:pPr>
+            <a:r>
+              <a:rPr sz="1300" b="0">
+                <a:solidFill>
+                  <a:srgbClr val="6B6B6B"/>
+                </a:solidFill>
+                <a:latin typeface="Pretendard"/>
+                <a:ea typeface="Pretendard"/>
+                <a:cs typeface="Pretendard"/>
+              </a:rPr>
+              <a:t>큐알 이벤트 제작법 372줄, 개발 문서</a:t>
+            </a:r>
+          </a:p>
+          <a:p>
+            <a:pPr>
+              <a:lnSpc>
+                <a:spcPct val="150000"/>
+              </a:lnSpc>
+              <a:spcBef>
+                <a:spcPts val="0"/>
+              </a:spcBef>
+              <a:spcAft>
+                <a:spcPts val="0"/>
+              </a:spcAft>
+            </a:pPr>
+            <a:r>
+              <a:rPr sz="1300" b="0">
+                <a:solidFill>
+                  <a:srgbClr val="6B6B6B"/>
+                </a:solidFill>
+                <a:latin typeface="Pretendard"/>
+                <a:ea typeface="Pretendard"/>
+                <a:cs typeface="Pretendard"/>
+              </a:rPr>
+              <a:t>가이드 787줄 — 밀도가 매우 높습니다.</a:t>
             </a:r>
           </a:p>
         </p:txBody>
@@ -14547,9 +14892,55 @@
                 <a:ea typeface="Pretendard"/>
                 <a:cs typeface="Pretendard"/>
               </a:rPr>
-              <a:t>“이 작업을 하려면 몇 번 서가로 가라”는
-표지판이 한 장도 없습니다. 6개 저장소
-전체에 목차 파일이 0개입니다.</a:t>
+              <a:t>“이 작업을 하려면 몇 번 서가로 가라”는</a:t>
+            </a:r>
+          </a:p>
+          <a:p>
+            <a:pPr>
+              <a:lnSpc>
+                <a:spcPct val="150000"/>
+              </a:lnSpc>
+              <a:spcBef>
+                <a:spcPts val="0"/>
+              </a:spcBef>
+              <a:spcAft>
+                <a:spcPts val="0"/>
+              </a:spcAft>
+            </a:pPr>
+            <a:r>
+              <a:rPr sz="1300" b="0">
+                <a:solidFill>
+                  <a:srgbClr val="6B6B6B"/>
+                </a:solidFill>
+                <a:latin typeface="Pretendard"/>
+                <a:ea typeface="Pretendard"/>
+                <a:cs typeface="Pretendard"/>
+              </a:rPr>
+              <a:t>표지판이 한 장도 없습니다. 6개 저장소</a:t>
+            </a:r>
+          </a:p>
+          <a:p>
+            <a:pPr>
+              <a:lnSpc>
+                <a:spcPct val="150000"/>
+              </a:lnSpc>
+              <a:spcBef>
+                <a:spcPts val="0"/>
+              </a:spcBef>
+              <a:spcAft>
+                <a:spcPts val="0"/>
+              </a:spcAft>
+            </a:pPr>
+            <a:r>
+              <a:rPr sz="1300" b="0">
+                <a:solidFill>
+                  <a:srgbClr val="6B6B6B"/>
+                </a:solidFill>
+                <a:latin typeface="Pretendard"/>
+                <a:ea typeface="Pretendard"/>
+                <a:cs typeface="Pretendard"/>
+              </a:rPr>
+              <a:t>전체에 목차 파일이 0개입니다.</a:t>
             </a:r>
           </a:p>
         </p:txBody>
@@ -14642,8 +15033,31 @@
                 <a:ea typeface="Pretendard"/>
                 <a:cs typeface="Pretendard"/>
               </a:rPr>
-              <a:t>게다가 방이 6개로 나뉘어
-서로 문이 잠겨 있습니다</a:t>
+              <a:t>게다가 방이 6개로 나뉘어</a:t>
+            </a:r>
+          </a:p>
+          <a:p>
+            <a:pPr>
+              <a:lnSpc>
+                <a:spcPct val="125000"/>
+              </a:lnSpc>
+              <a:spcBef>
+                <a:spcPts val="0"/>
+              </a:spcBef>
+              <a:spcAft>
+                <a:spcPts val="0"/>
+              </a:spcAft>
+            </a:pPr>
+            <a:r>
+              <a:rPr sz="1700" b="1">
+                <a:solidFill>
+                  <a:srgbClr val="292929"/>
+                </a:solidFill>
+                <a:latin typeface="Pretendard"/>
+                <a:ea typeface="Pretendard"/>
+                <a:cs typeface="Pretendard"/>
+              </a:rPr>
+              <a:t>서로 문이 잠겨 있습니다</a:t>
             </a:r>
           </a:p>
         </p:txBody>
@@ -14690,9 +15104,55 @@
                 <a:ea typeface="Pretendard"/>
                 <a:cs typeface="Pretendard"/>
               </a:rPr>
-              <a:t>옆방에 뭐가 있는지 볼 수 없습니다.
-그래서 같은 책을 각 방이 따로 베껴
-뒀고, 내용이 서로 달라졌습니다.</a:t>
+              <a:t>옆방에 뭐가 있는지 볼 수 없습니다.</a:t>
+            </a:r>
+          </a:p>
+          <a:p>
+            <a:pPr>
+              <a:lnSpc>
+                <a:spcPct val="150000"/>
+              </a:lnSpc>
+              <a:spcBef>
+                <a:spcPts val="0"/>
+              </a:spcBef>
+              <a:spcAft>
+                <a:spcPts val="0"/>
+              </a:spcAft>
+            </a:pPr>
+            <a:r>
+              <a:rPr sz="1300" b="0">
+                <a:solidFill>
+                  <a:srgbClr val="6B6B6B"/>
+                </a:solidFill>
+                <a:latin typeface="Pretendard"/>
+                <a:ea typeface="Pretendard"/>
+                <a:cs typeface="Pretendard"/>
+              </a:rPr>
+              <a:t>그래서 같은 책을 각 방이 따로 베껴</a:t>
+            </a:r>
+          </a:p>
+          <a:p>
+            <a:pPr>
+              <a:lnSpc>
+                <a:spcPct val="150000"/>
+              </a:lnSpc>
+              <a:spcBef>
+                <a:spcPts val="0"/>
+              </a:spcBef>
+              <a:spcAft>
+                <a:spcPts val="0"/>
+              </a:spcAft>
+            </a:pPr>
+            <a:r>
+              <a:rPr sz="1300" b="0">
+                <a:solidFill>
+                  <a:srgbClr val="6B6B6B"/>
+                </a:solidFill>
+                <a:latin typeface="Pretendard"/>
+                <a:ea typeface="Pretendard"/>
+                <a:cs typeface="Pretendard"/>
+              </a:rPr>
+              <a:t>뒀고, 내용이 서로 달라졌습니다.</a:t>
             </a:r>
           </a:p>
         </p:txBody>
@@ -17195,8 +17655,31 @@
                 <a:ea typeface="Pretendard"/>
                 <a:cs typeface="Pretendard"/>
               </a:rPr>
-              <a:t>이 컴퓨터에 designer 계정은 없습니다.
-죽은 경로가 3종류 섞여 있습니다.</a:t>
+              <a:t>이 컴퓨터에 designer 계정은 없습니다.</a:t>
+            </a:r>
+          </a:p>
+          <a:p>
+            <a:pPr>
+              <a:lnSpc>
+                <a:spcPct val="140000"/>
+              </a:lnSpc>
+              <a:spcBef>
+                <a:spcPts val="0"/>
+              </a:spcBef>
+              <a:spcAft>
+                <a:spcPts val="0"/>
+              </a:spcAft>
+            </a:pPr>
+            <a:r>
+              <a:rPr sz="1250" b="0">
+                <a:solidFill>
+                  <a:srgbClr val="292929"/>
+                </a:solidFill>
+                <a:latin typeface="Pretendard"/>
+                <a:ea typeface="Pretendard"/>
+                <a:cs typeface="Pretendard"/>
+              </a:rPr>
+              <a:t>죽은 경로가 3종류 섞여 있습니다.</a:t>
             </a:r>
           </a:p>
         </p:txBody>
@@ -17384,8 +17867,31 @@
                 <a:ea typeface="Pretendard"/>
                 <a:cs typeface="Pretendard"/>
               </a:rPr>
-              <a:t>AGENTS.md에는 최신 규칙 3개 섹션이
-통째로 빠져 있습니다.</a:t>
+              <a:t>AGENTS.md에는 최신 규칙 3개 섹션이</a:t>
+            </a:r>
+          </a:p>
+          <a:p>
+            <a:pPr>
+              <a:lnSpc>
+                <a:spcPct val="140000"/>
+              </a:lnSpc>
+              <a:spcBef>
+                <a:spcPts val="0"/>
+              </a:spcBef>
+              <a:spcAft>
+                <a:spcPts val="0"/>
+              </a:spcAft>
+            </a:pPr>
+            <a:r>
+              <a:rPr sz="1250" b="0">
+                <a:solidFill>
+                  <a:srgbClr val="292929"/>
+                </a:solidFill>
+                <a:latin typeface="Pretendard"/>
+                <a:ea typeface="Pretendard"/>
+                <a:cs typeface="Pretendard"/>
+              </a:rPr>
+              <a:t>통째로 빠져 있습니다.</a:t>
             </a:r>
           </a:p>
         </p:txBody>

</xml_diff>

<commit_message>
vault backup: 2026-08-09 19:21:51
</commit_message>
<xml_diff>
--- a/CdBd 문서 체계 진단 및 개편 제안.pptx
+++ b/CdBd 문서 체계 진단 및 개편 제안.pptx
@@ -4355,8 +4355,8 @@
         </p:nvSpPr>
         <p:spPr>
           <a:xfrm>
-            <a:off x="777240" y="6263640"/>
-            <a:ext cx="10607040" cy="274320"/>
+            <a:off x="777240" y="6455664"/>
+            <a:ext cx="9509760" cy="256032"/>
           </a:xfrm>
           <a:prstGeom prst="rect">
             <a:avLst/>
@@ -4402,8 +4402,8 @@
         </p:nvSpPr>
         <p:spPr>
           <a:xfrm>
-            <a:off x="10607040" y="6263640"/>
-            <a:ext cx="822960" cy="274320"/>
+            <a:off x="10588752" y="6455664"/>
+            <a:ext cx="822960" cy="256032"/>
           </a:xfrm>
           <a:prstGeom prst="rect">
             <a:avLst/>
@@ -5670,8 +5670,8 @@
         </p:nvSpPr>
         <p:spPr>
           <a:xfrm>
-            <a:off x="777240" y="6263640"/>
-            <a:ext cx="10607040" cy="274320"/>
+            <a:off x="777240" y="6455664"/>
+            <a:ext cx="9509760" cy="256032"/>
           </a:xfrm>
           <a:prstGeom prst="rect">
             <a:avLst/>
@@ -5717,8 +5717,8 @@
         </p:nvSpPr>
         <p:spPr>
           <a:xfrm>
-            <a:off x="10607040" y="6263640"/>
-            <a:ext cx="822960" cy="274320"/>
+            <a:off x="10588752" y="6455664"/>
+            <a:ext cx="822960" cy="256032"/>
           </a:xfrm>
           <a:prstGeom prst="rect">
             <a:avLst/>
@@ -6985,8 +6985,8 @@
         </p:nvSpPr>
         <p:spPr>
           <a:xfrm>
-            <a:off x="777240" y="6263640"/>
-            <a:ext cx="10607040" cy="274320"/>
+            <a:off x="777240" y="6455664"/>
+            <a:ext cx="9509760" cy="256032"/>
           </a:xfrm>
           <a:prstGeom prst="rect">
             <a:avLst/>
@@ -7032,8 +7032,8 @@
         </p:nvSpPr>
         <p:spPr>
           <a:xfrm>
-            <a:off x="10607040" y="6263640"/>
-            <a:ext cx="822960" cy="274320"/>
+            <a:off x="10588752" y="6455664"/>
+            <a:ext cx="822960" cy="256032"/>
           </a:xfrm>
           <a:prstGeom prst="rect">
             <a:avLst/>
@@ -8298,8 +8298,8 @@
         </p:nvSpPr>
         <p:spPr>
           <a:xfrm>
-            <a:off x="777240" y="6263640"/>
-            <a:ext cx="10607040" cy="274320"/>
+            <a:off x="777240" y="6455664"/>
+            <a:ext cx="9509760" cy="256032"/>
           </a:xfrm>
           <a:prstGeom prst="rect">
             <a:avLst/>
@@ -8345,8 +8345,8 @@
         </p:nvSpPr>
         <p:spPr>
           <a:xfrm>
-            <a:off x="10607040" y="6263640"/>
-            <a:ext cx="822960" cy="274320"/>
+            <a:off x="10588752" y="6455664"/>
+            <a:ext cx="822960" cy="256032"/>
           </a:xfrm>
           <a:prstGeom prst="rect">
             <a:avLst/>
@@ -9402,8 +9402,8 @@
         </p:nvSpPr>
         <p:spPr>
           <a:xfrm>
-            <a:off x="777240" y="6263640"/>
-            <a:ext cx="10607040" cy="274320"/>
+            <a:off x="777240" y="6455664"/>
+            <a:ext cx="9509760" cy="256032"/>
           </a:xfrm>
           <a:prstGeom prst="rect">
             <a:avLst/>
@@ -9449,8 +9449,8 @@
         </p:nvSpPr>
         <p:spPr>
           <a:xfrm>
-            <a:off x="10607040" y="6263640"/>
-            <a:ext cx="822960" cy="274320"/>
+            <a:off x="10588752" y="6455664"/>
+            <a:ext cx="822960" cy="256032"/>
           </a:xfrm>
           <a:prstGeom prst="rect">
             <a:avLst/>
@@ -9909,8 +9909,8 @@
         </p:nvSpPr>
         <p:spPr>
           <a:xfrm>
-            <a:off x="777240" y="6263640"/>
-            <a:ext cx="10607040" cy="274320"/>
+            <a:off x="777240" y="6455664"/>
+            <a:ext cx="9509760" cy="256032"/>
           </a:xfrm>
           <a:prstGeom prst="rect">
             <a:avLst/>
@@ -9956,8 +9956,8 @@
         </p:nvSpPr>
         <p:spPr>
           <a:xfrm>
-            <a:off x="10607040" y="6263640"/>
-            <a:ext cx="822960" cy="274320"/>
+            <a:off x="10588752" y="6455664"/>
+            <a:ext cx="822960" cy="256032"/>
           </a:xfrm>
           <a:prstGeom prst="rect">
             <a:avLst/>
@@ -10429,8 +10429,8 @@
         </p:nvSpPr>
         <p:spPr>
           <a:xfrm>
-            <a:off x="777240" y="6263640"/>
-            <a:ext cx="10607040" cy="274320"/>
+            <a:off x="777240" y="6455664"/>
+            <a:ext cx="9509760" cy="256032"/>
           </a:xfrm>
           <a:prstGeom prst="rect">
             <a:avLst/>
@@ -10476,8 +10476,8 @@
         </p:nvSpPr>
         <p:spPr>
           <a:xfrm>
-            <a:off x="10607040" y="6263640"/>
-            <a:ext cx="822960" cy="274320"/>
+            <a:off x="10588752" y="6455664"/>
+            <a:ext cx="822960" cy="256032"/>
           </a:xfrm>
           <a:prstGeom prst="rect">
             <a:avLst/>
@@ -12316,8 +12316,8 @@
         </p:nvSpPr>
         <p:spPr>
           <a:xfrm>
-            <a:off x="777240" y="6263640"/>
-            <a:ext cx="10607040" cy="274320"/>
+            <a:off x="777240" y="6455664"/>
+            <a:ext cx="9509760" cy="256032"/>
           </a:xfrm>
           <a:prstGeom prst="rect">
             <a:avLst/>
@@ -12363,8 +12363,8 @@
         </p:nvSpPr>
         <p:spPr>
           <a:xfrm>
-            <a:off x="10607040" y="6263640"/>
-            <a:ext cx="822960" cy="274320"/>
+            <a:off x="10588752" y="6455664"/>
+            <a:ext cx="822960" cy="256032"/>
           </a:xfrm>
           <a:prstGeom prst="rect">
             <a:avLst/>
@@ -13161,8 +13161,8 @@
         </p:nvSpPr>
         <p:spPr>
           <a:xfrm>
-            <a:off x="777240" y="6263640"/>
-            <a:ext cx="10607040" cy="274320"/>
+            <a:off x="777240" y="6455664"/>
+            <a:ext cx="9509760" cy="256032"/>
           </a:xfrm>
           <a:prstGeom prst="rect">
             <a:avLst/>
@@ -13208,8 +13208,8 @@
         </p:nvSpPr>
         <p:spPr>
           <a:xfrm>
-            <a:off x="10607040" y="6263640"/>
-            <a:ext cx="822960" cy="274320"/>
+            <a:off x="10588752" y="6455664"/>
+            <a:ext cx="822960" cy="256032"/>
           </a:xfrm>
           <a:prstGeom prst="rect">
             <a:avLst/>
@@ -14327,8 +14327,8 @@
         </p:nvSpPr>
         <p:spPr>
           <a:xfrm>
-            <a:off x="777240" y="6263640"/>
-            <a:ext cx="10607040" cy="274320"/>
+            <a:off x="777240" y="6455664"/>
+            <a:ext cx="9509760" cy="256032"/>
           </a:xfrm>
           <a:prstGeom prst="rect">
             <a:avLst/>
@@ -14374,8 +14374,8 @@
         </p:nvSpPr>
         <p:spPr>
           <a:xfrm>
-            <a:off x="10607040" y="6263640"/>
-            <a:ext cx="822960" cy="274320"/>
+            <a:off x="10588752" y="6455664"/>
+            <a:ext cx="822960" cy="256032"/>
           </a:xfrm>
           <a:prstGeom prst="rect">
             <a:avLst/>
@@ -15280,8 +15280,8 @@
         </p:nvSpPr>
         <p:spPr>
           <a:xfrm>
-            <a:off x="777240" y="6263640"/>
-            <a:ext cx="10607040" cy="274320"/>
+            <a:off x="777240" y="6455664"/>
+            <a:ext cx="9509760" cy="256032"/>
           </a:xfrm>
           <a:prstGeom prst="rect">
             <a:avLst/>
@@ -15327,8 +15327,8 @@
         </p:nvSpPr>
         <p:spPr>
           <a:xfrm>
-            <a:off x="10607040" y="6263640"/>
-            <a:ext cx="822960" cy="274320"/>
+            <a:off x="10588752" y="6455664"/>
+            <a:ext cx="822960" cy="256032"/>
           </a:xfrm>
           <a:prstGeom prst="rect">
             <a:avLst/>
@@ -16190,8 +16190,8 @@
         </p:nvSpPr>
         <p:spPr>
           <a:xfrm>
-            <a:off x="777240" y="6263640"/>
-            <a:ext cx="10607040" cy="274320"/>
+            <a:off x="777240" y="6455664"/>
+            <a:ext cx="9509760" cy="256032"/>
           </a:xfrm>
           <a:prstGeom prst="rect">
             <a:avLst/>
@@ -16237,8 +16237,8 @@
         </p:nvSpPr>
         <p:spPr>
           <a:xfrm>
-            <a:off x="10607040" y="6263640"/>
-            <a:ext cx="822960" cy="274320"/>
+            <a:off x="10588752" y="6455664"/>
+            <a:ext cx="822960" cy="256032"/>
           </a:xfrm>
           <a:prstGeom prst="rect">
             <a:avLst/>
@@ -17230,8 +17230,8 @@
         </p:nvSpPr>
         <p:spPr>
           <a:xfrm>
-            <a:off x="777240" y="6263640"/>
-            <a:ext cx="10607040" cy="274320"/>
+            <a:off x="777240" y="6455664"/>
+            <a:ext cx="9509760" cy="256032"/>
           </a:xfrm>
           <a:prstGeom prst="rect">
             <a:avLst/>
@@ -17277,8 +17277,8 @@
         </p:nvSpPr>
         <p:spPr>
           <a:xfrm>
-            <a:off x="10607040" y="6263640"/>
-            <a:ext cx="822960" cy="274320"/>
+            <a:off x="10588752" y="6455664"/>
+            <a:ext cx="822960" cy="256032"/>
           </a:xfrm>
           <a:prstGeom prst="rect">
             <a:avLst/>
@@ -18512,8 +18512,8 @@
         </p:nvSpPr>
         <p:spPr>
           <a:xfrm>
-            <a:off x="777240" y="6263640"/>
-            <a:ext cx="10607040" cy="274320"/>
+            <a:off x="777240" y="6455664"/>
+            <a:ext cx="9509760" cy="256032"/>
           </a:xfrm>
           <a:prstGeom prst="rect">
             <a:avLst/>
@@ -18559,8 +18559,8 @@
         </p:nvSpPr>
         <p:spPr>
           <a:xfrm>
-            <a:off x="10607040" y="6263640"/>
-            <a:ext cx="822960" cy="274320"/>
+            <a:off x="10588752" y="6455664"/>
+            <a:ext cx="822960" cy="256032"/>
           </a:xfrm>
           <a:prstGeom prst="rect">
             <a:avLst/>

</xml_diff>

<commit_message>
vault backup: 2026-08-09 19:45:43
</commit_message>
<xml_diff>
--- a/CdBd 문서 체계 진단 및 개편 제안.pptx
+++ b/CdBd 문서 체계 진단 및 개편 제안.pptx
@@ -12838,49 +12838,7 @@
       </p:sp>
       <p:sp>
         <p:nvSpPr>
-          <p:cNvPr id="16" name="Rectangle 15"/>
-          <p:cNvSpPr/>
-          <p:nvPr/>
-        </p:nvSpPr>
-        <p:spPr>
-          <a:xfrm>
-            <a:off x="777240" y="6263640"/>
-            <a:ext cx="10634472" cy="0"/>
-          </a:xfrm>
-          <a:prstGeom prst="rect">
-            <a:avLst/>
-          </a:prstGeom>
-          <a:noFill/>
-          <a:ln>
-            <a:noFill/>
-          </a:ln>
-          <a:effectLst/>
-        </p:spPr>
-        <p:style>
-          <a:lnRef idx="1">
-            <a:schemeClr val="accent1"/>
-          </a:lnRef>
-          <a:fillRef idx="3">
-            <a:schemeClr val="accent1"/>
-          </a:fillRef>
-          <a:effectRef idx="2">
-            <a:schemeClr val="accent1"/>
-          </a:effectRef>
-          <a:fontRef idx="minor">
-            <a:schemeClr val="lt1"/>
-          </a:fontRef>
-        </p:style>
-        <p:txBody>
-          <a:bodyPr rtlCol="0" anchor="ctr" wrap="square"/>
-          <a:lstStyle/>
-          <a:p>
-            <a:pPr algn="ctr"/>
-          </a:p>
-        </p:txBody>
-      </p:sp>
-      <p:sp>
-        <p:nvSpPr>
-          <p:cNvPr id="17" name="TextBox 16"/>
+          <p:cNvPr id="16" name="TextBox 15"/>
           <p:cNvSpPr txBox="1"/>
           <p:nvPr/>
         </p:nvSpPr>
@@ -12975,7 +12933,7 @@
       </p:sp>
       <p:sp>
         <p:nvSpPr>
-          <p:cNvPr id="18" name="TextBox 17"/>
+          <p:cNvPr id="17" name="TextBox 16"/>
           <p:cNvSpPr txBox="1"/>
           <p:nvPr/>
         </p:nvSpPr>
@@ -13022,7 +12980,7 @@
       </p:sp>
       <p:sp>
         <p:nvSpPr>
-          <p:cNvPr id="19" name="TextBox 18"/>
+          <p:cNvPr id="18" name="TextBox 17"/>
           <p:cNvSpPr txBox="1"/>
           <p:nvPr/>
         </p:nvSpPr>

</xml_diff>

<commit_message>
vault backup: 2026-08-09 19:54:16
</commit_message>
<xml_diff>
--- a/CdBd 문서 체계 진단 및 개편 제안.pptx
+++ b/CdBd 문서 체계 진단 및 개편 제안.pptx
@@ -6,24 +6,24 @@
   </p:sldMasterIdLst>
   <p:sldIdLst>
     <p:sldId id="256" r:id="rId7"/>
-    <p:sldId id="257" r:id="rId9"/>
-    <p:sldId id="258" r:id="rId10"/>
-    <p:sldId id="259" r:id="rId11"/>
-    <p:sldId id="260" r:id="rId12"/>
-    <p:sldId id="261" r:id="rId13"/>
-    <p:sldId id="262" r:id="rId14"/>
-    <p:sldId id="263" r:id="rId15"/>
-    <p:sldId id="264" r:id="rId16"/>
-    <p:sldId id="265" r:id="rId17"/>
-    <p:sldId id="266" r:id="rId18"/>
-    <p:sldId id="267" r:id="rId19"/>
-    <p:sldId id="268" r:id="rId20"/>
-    <p:sldId id="269" r:id="rId21"/>
-    <p:sldId id="270" r:id="rId22"/>
-    <p:sldId id="271" r:id="rId23"/>
-    <p:sldId id="272" r:id="rId24"/>
-    <p:sldId id="273" r:id="rId25"/>
-    <p:sldId id="274" r:id="rId26"/>
+    <p:sldId id="257" r:id="rId8"/>
+    <p:sldId id="258" r:id="rId9"/>
+    <p:sldId id="259" r:id="rId10"/>
+    <p:sldId id="260" r:id="rId11"/>
+    <p:sldId id="261" r:id="rId12"/>
+    <p:sldId id="262" r:id="rId13"/>
+    <p:sldId id="263" r:id="rId14"/>
+    <p:sldId id="264" r:id="rId15"/>
+    <p:sldId id="265" r:id="rId16"/>
+    <p:sldId id="266" r:id="rId17"/>
+    <p:sldId id="267" r:id="rId18"/>
+    <p:sldId id="268" r:id="rId19"/>
+    <p:sldId id="269" r:id="rId20"/>
+    <p:sldId id="270" r:id="rId21"/>
+    <p:sldId id="271" r:id="rId22"/>
+    <p:sldId id="272" r:id="rId23"/>
+    <p:sldId id="273" r:id="rId24"/>
+    <p:sldId id="274" r:id="rId25"/>
   </p:sldIdLst>
   <p:sldSz cx="12191695" cy="6858000" type="screen4x3"/>
   <p:notesSz cx="6858000" cy="9144000"/>
@@ -123,2322 +123,6 @@
     </a:lvl9pPr>
   </p:defaultTextStyle>
 </p:presentation>
-</file>
-
-<file path=ppt/notesMasters/notesMaster1.xml><?xml version="1.0" encoding="utf-8"?>
-<p:notesMaster xmlns:a="http://schemas.openxmlformats.org/drawingml/2006/main" xmlns:p="http://schemas.openxmlformats.org/presentationml/2006/main" xmlns:r="http://schemas.openxmlformats.org/officeDocument/2006/relationships">
-  <p:cSld>
-    <p:bg>
-      <p:bgRef idx="1001">
-        <a:schemeClr val="bg1"/>
-      </p:bgRef>
-    </p:bg>
-    <p:spTree>
-      <p:nvGrpSpPr>
-        <p:cNvPr id="1" name=""/>
-        <p:cNvGrpSpPr/>
-        <p:nvPr/>
-      </p:nvGrpSpPr>
-      <p:grpSpPr>
-        <a:xfrm>
-          <a:off x="0" y="0"/>
-          <a:ext cx="0" cy="0"/>
-          <a:chOff x="0" y="0"/>
-          <a:chExt cx="0" cy="0"/>
-        </a:xfrm>
-      </p:grpSpPr>
-      <p:sp>
-        <p:nvSpPr>
-          <p:cNvPr id="2" name="Header Placeholder 1"/>
-          <p:cNvSpPr>
-            <a:spLocks noGrp="1"/>
-          </p:cNvSpPr>
-          <p:nvPr>
-            <p:ph type="hdr" sz="quarter"/>
-          </p:nvPr>
-        </p:nvSpPr>
-        <p:spPr>
-          <a:xfrm>
-            <a:off x="0" y="0"/>
-            <a:ext cx="2971800" cy="457200"/>
-          </a:xfrm>
-          <a:prstGeom prst="rect">
-            <a:avLst/>
-          </a:prstGeom>
-        </p:spPr>
-        <p:txBody>
-          <a:bodyPr vert="horz" lIns="91440" tIns="45720" rIns="91440" bIns="45720" rtlCol="0"/>
-          <a:lstStyle>
-            <a:lvl1pPr algn="l">
-              <a:defRPr sz="1200"/>
-            </a:lvl1pPr>
-          </a:lstStyle>
-          <a:p>
-            <a:endParaRPr lang="en-US"/>
-          </a:p>
-        </p:txBody>
-      </p:sp>
-      <p:sp>
-        <p:nvSpPr>
-          <p:cNvPr id="3" name="Date Placeholder 2"/>
-          <p:cNvSpPr>
-            <a:spLocks noGrp="1"/>
-          </p:cNvSpPr>
-          <p:nvPr>
-            <p:ph type="dt" idx="1"/>
-          </p:nvPr>
-        </p:nvSpPr>
-        <p:spPr>
-          <a:xfrm>
-            <a:off x="3884613" y="0"/>
-            <a:ext cx="2971800" cy="457200"/>
-          </a:xfrm>
-          <a:prstGeom prst="rect">
-            <a:avLst/>
-          </a:prstGeom>
-        </p:spPr>
-        <p:txBody>
-          <a:bodyPr vert="horz" lIns="91440" tIns="45720" rIns="91440" bIns="45720" rtlCol="0"/>
-          <a:lstStyle>
-            <a:lvl1pPr algn="r">
-              <a:defRPr sz="1200"/>
-            </a:lvl1pPr>
-          </a:lstStyle>
-          <a:p>
-            <a:fld id="{0F89C1C7-3DCD-1040-A9CF-14679D8B5DDD}" type="datetimeFigureOut">
-              <a:rPr lang="en-US" smtClean="0"/>
-              <a:t>10/17/16</a:t>
-            </a:fld>
-            <a:endParaRPr lang="en-US"/>
-          </a:p>
-        </p:txBody>
-      </p:sp>
-      <p:sp>
-        <p:nvSpPr>
-          <p:cNvPr id="4" name="Slide Image Placeholder 3"/>
-          <p:cNvSpPr>
-            <a:spLocks noGrp="1" noRot="1" noChangeAspect="1"/>
-          </p:cNvSpPr>
-          <p:nvPr>
-            <p:ph type="sldImg" idx="2"/>
-          </p:nvPr>
-        </p:nvSpPr>
-        <p:spPr>
-          <a:xfrm>
-            <a:off x="1143000" y="685800"/>
-            <a:ext cx="4572000" cy="3429000"/>
-          </a:xfrm>
-          <a:prstGeom prst="rect">
-            <a:avLst/>
-          </a:prstGeom>
-          <a:noFill/>
-          <a:ln w="12700">
-            <a:solidFill>
-              <a:prstClr val="black"/>
-            </a:solidFill>
-          </a:ln>
-        </p:spPr>
-        <p:txBody>
-          <a:bodyPr vert="horz" lIns="91440" tIns="45720" rIns="91440" bIns="45720" rtlCol="0" anchor="ctr"/>
-          <a:lstStyle/>
-          <a:p>
-            <a:endParaRPr lang="en-US"/>
-          </a:p>
-        </p:txBody>
-      </p:sp>
-      <p:sp>
-        <p:nvSpPr>
-          <p:cNvPr id="5" name="Notes Placeholder 4"/>
-          <p:cNvSpPr>
-            <a:spLocks noGrp="1"/>
-          </p:cNvSpPr>
-          <p:nvPr>
-            <p:ph type="body" sz="quarter" idx="3"/>
-          </p:nvPr>
-        </p:nvSpPr>
-        <p:spPr>
-          <a:xfrm>
-            <a:off x="685800" y="4343400"/>
-            <a:ext cx="5486400" cy="4114800"/>
-          </a:xfrm>
-          <a:prstGeom prst="rect">
-            <a:avLst/>
-          </a:prstGeom>
-        </p:spPr>
-        <p:txBody>
-          <a:bodyPr vert="horz" lIns="91440" tIns="45720" rIns="91440" bIns="45720" rtlCol="0"/>
-          <a:lstStyle/>
-          <a:p>
-            <a:pPr lvl="0"/>
-            <a:r>
-              <a:rPr lang="en-US" smtClean="0"/>
-              <a:t>Click to edit Master text styles</a:t>
-            </a:r>
-          </a:p>
-          <a:p>
-            <a:pPr lvl="1"/>
-            <a:r>
-              <a:rPr lang="en-US" smtClean="0"/>
-              <a:t>Second level</a:t>
-            </a:r>
-          </a:p>
-          <a:p>
-            <a:pPr lvl="2"/>
-            <a:r>
-              <a:rPr lang="en-US" smtClean="0"/>
-              <a:t>Third level</a:t>
-            </a:r>
-          </a:p>
-          <a:p>
-            <a:pPr lvl="3"/>
-            <a:r>
-              <a:rPr lang="en-US" smtClean="0"/>
-              <a:t>Fourth level</a:t>
-            </a:r>
-          </a:p>
-          <a:p>
-            <a:pPr lvl="4"/>
-            <a:r>
-              <a:rPr lang="en-US" smtClean="0"/>
-              <a:t>Fifth level</a:t>
-            </a:r>
-            <a:endParaRPr lang="en-US"/>
-          </a:p>
-        </p:txBody>
-      </p:sp>
-      <p:sp>
-        <p:nvSpPr>
-          <p:cNvPr id="6" name="Footer Placeholder 5"/>
-          <p:cNvSpPr>
-            <a:spLocks noGrp="1"/>
-          </p:cNvSpPr>
-          <p:nvPr>
-            <p:ph type="ftr" sz="quarter" idx="4"/>
-          </p:nvPr>
-        </p:nvSpPr>
-        <p:spPr>
-          <a:xfrm>
-            <a:off x="0" y="8685213"/>
-            <a:ext cx="2971800" cy="457200"/>
-          </a:xfrm>
-          <a:prstGeom prst="rect">
-            <a:avLst/>
-          </a:prstGeom>
-        </p:spPr>
-        <p:txBody>
-          <a:bodyPr vert="horz" lIns="91440" tIns="45720" rIns="91440" bIns="45720" rtlCol="0" anchor="b"/>
-          <a:lstStyle>
-            <a:lvl1pPr algn="l">
-              <a:defRPr sz="1200"/>
-            </a:lvl1pPr>
-          </a:lstStyle>
-          <a:p>
-            <a:endParaRPr lang="en-US"/>
-          </a:p>
-        </p:txBody>
-      </p:sp>
-      <p:sp>
-        <p:nvSpPr>
-          <p:cNvPr id="7" name="Slide Number Placeholder 6"/>
-          <p:cNvSpPr>
-            <a:spLocks noGrp="1"/>
-          </p:cNvSpPr>
-          <p:nvPr>
-            <p:ph type="sldNum" sz="quarter" idx="5"/>
-          </p:nvPr>
-        </p:nvSpPr>
-        <p:spPr>
-          <a:xfrm>
-            <a:off x="3884613" y="8685213"/>
-            <a:ext cx="2971800" cy="457200"/>
-          </a:xfrm>
-          <a:prstGeom prst="rect">
-            <a:avLst/>
-          </a:prstGeom>
-        </p:spPr>
-        <p:txBody>
-          <a:bodyPr vert="horz" lIns="91440" tIns="45720" rIns="91440" bIns="45720" rtlCol="0" anchor="b"/>
-          <a:lstStyle>
-            <a:lvl1pPr algn="r">
-              <a:defRPr sz="1200"/>
-            </a:lvl1pPr>
-          </a:lstStyle>
-          <a:p>
-            <a:fld id="{BB5E49A5-4136-284D-997B-48E1D791AD67}" type="slidenum">
-              <a:rPr lang="en-US" smtClean="0"/>
-              <a:t>‹#›</a:t>
-            </a:fld>
-            <a:endParaRPr lang="en-US"/>
-          </a:p>
-        </p:txBody>
-      </p:sp>
-    </p:spTree>
-    <p:extLst>
-      <p:ext uri="{BB962C8B-B14F-4D97-AF65-F5344CB8AC3E}">
-        <p14:creationId xmlns:p14="http://schemas.microsoft.com/office/powerpoint/2010/main" val="2623252185"/>
-      </p:ext>
-    </p:extLst>
-  </p:cSld>
-  <p:clrMap bg1="lt1" tx1="dk1" bg2="lt2" tx2="dk2" accent1="accent1" accent2="accent2" accent3="accent3" accent4="accent4" accent5="accent5" accent6="accent6" hlink="hlink" folHlink="folHlink"/>
-  <p:notesStyle>
-    <a:lvl1pPr marL="0" algn="l" defTabSz="457200" rtl="0" eaLnBrk="1" latinLnBrk="0" hangingPunct="1">
-      <a:defRPr sz="1200" kern="1200">
-        <a:solidFill>
-          <a:schemeClr val="tx1"/>
-        </a:solidFill>
-        <a:latin typeface="+mn-lt"/>
-        <a:ea typeface="+mn-ea"/>
-        <a:cs typeface="+mn-cs"/>
-      </a:defRPr>
-    </a:lvl1pPr>
-    <a:lvl2pPr marL="457200" algn="l" defTabSz="457200" rtl="0" eaLnBrk="1" latinLnBrk="0" hangingPunct="1">
-      <a:defRPr sz="1200" kern="1200">
-        <a:solidFill>
-          <a:schemeClr val="tx1"/>
-        </a:solidFill>
-        <a:latin typeface="+mn-lt"/>
-        <a:ea typeface="+mn-ea"/>
-        <a:cs typeface="+mn-cs"/>
-      </a:defRPr>
-    </a:lvl2pPr>
-    <a:lvl3pPr marL="914400" algn="l" defTabSz="457200" rtl="0" eaLnBrk="1" latinLnBrk="0" hangingPunct="1">
-      <a:defRPr sz="1200" kern="1200">
-        <a:solidFill>
-          <a:schemeClr val="tx1"/>
-        </a:solidFill>
-        <a:latin typeface="+mn-lt"/>
-        <a:ea typeface="+mn-ea"/>
-        <a:cs typeface="+mn-cs"/>
-      </a:defRPr>
-    </a:lvl3pPr>
-    <a:lvl4pPr marL="1371600" algn="l" defTabSz="457200" rtl="0" eaLnBrk="1" latinLnBrk="0" hangingPunct="1">
-      <a:defRPr sz="1200" kern="1200">
-        <a:solidFill>
-          <a:schemeClr val="tx1"/>
-        </a:solidFill>
-        <a:latin typeface="+mn-lt"/>
-        <a:ea typeface="+mn-ea"/>
-        <a:cs typeface="+mn-cs"/>
-      </a:defRPr>
-    </a:lvl4pPr>
-    <a:lvl5pPr marL="1828800" algn="l" defTabSz="457200" rtl="0" eaLnBrk="1" latinLnBrk="0" hangingPunct="1">
-      <a:defRPr sz="1200" kern="1200">
-        <a:solidFill>
-          <a:schemeClr val="tx1"/>
-        </a:solidFill>
-        <a:latin typeface="+mn-lt"/>
-        <a:ea typeface="+mn-ea"/>
-        <a:cs typeface="+mn-cs"/>
-      </a:defRPr>
-    </a:lvl5pPr>
-    <a:lvl6pPr marL="2286000" algn="l" defTabSz="457200" rtl="0" eaLnBrk="1" latinLnBrk="0" hangingPunct="1">
-      <a:defRPr sz="1200" kern="1200">
-        <a:solidFill>
-          <a:schemeClr val="tx1"/>
-        </a:solidFill>
-        <a:latin typeface="+mn-lt"/>
-        <a:ea typeface="+mn-ea"/>
-        <a:cs typeface="+mn-cs"/>
-      </a:defRPr>
-    </a:lvl6pPr>
-    <a:lvl7pPr marL="2743200" algn="l" defTabSz="457200" rtl="0" eaLnBrk="1" latinLnBrk="0" hangingPunct="1">
-      <a:defRPr sz="1200" kern="1200">
-        <a:solidFill>
-          <a:schemeClr val="tx1"/>
-        </a:solidFill>
-        <a:latin typeface="+mn-lt"/>
-        <a:ea typeface="+mn-ea"/>
-        <a:cs typeface="+mn-cs"/>
-      </a:defRPr>
-    </a:lvl7pPr>
-    <a:lvl8pPr marL="3200400" algn="l" defTabSz="457200" rtl="0" eaLnBrk="1" latinLnBrk="0" hangingPunct="1">
-      <a:defRPr sz="1200" kern="1200">
-        <a:solidFill>
-          <a:schemeClr val="tx1"/>
-        </a:solidFill>
-        <a:latin typeface="+mn-lt"/>
-        <a:ea typeface="+mn-ea"/>
-        <a:cs typeface="+mn-cs"/>
-      </a:defRPr>
-    </a:lvl8pPr>
-    <a:lvl9pPr marL="3657600" algn="l" defTabSz="457200" rtl="0" eaLnBrk="1" latinLnBrk="0" hangingPunct="1">
-      <a:defRPr sz="1200" kern="1200">
-        <a:solidFill>
-          <a:schemeClr val="tx1"/>
-        </a:solidFill>
-        <a:latin typeface="+mn-lt"/>
-        <a:ea typeface="+mn-ea"/>
-        <a:cs typeface="+mn-cs"/>
-      </a:defRPr>
-    </a:lvl9pPr>
-  </p:notesStyle>
-</p:notesMaster>
-</file>
-
-<file path=ppt/notesSlides/notesSlide1.xml><?xml version="1.0" encoding="utf-8"?>
-<p:notes xmlns:a="http://schemas.openxmlformats.org/drawingml/2006/main" xmlns:p="http://schemas.openxmlformats.org/presentationml/2006/main" xmlns:r="http://schemas.openxmlformats.org/officeDocument/2006/relationships">
-  <p:cSld>
-    <p:spTree>
-      <p:nvGrpSpPr>
-        <p:cNvPr id="1" name=""/>
-        <p:cNvGrpSpPr/>
-        <p:nvPr/>
-      </p:nvGrpSpPr>
-      <p:grpSpPr>
-        <a:xfrm>
-          <a:off x="0" y="0"/>
-          <a:ext cx="0" cy="0"/>
-          <a:chOff x="0" y="0"/>
-          <a:chExt cx="0" cy="0"/>
-        </a:xfrm>
-      </p:grpSpPr>
-      <p:sp>
-        <p:nvSpPr>
-          <p:cNvPr id="2" name="Slide Image Placeholder 1"/>
-          <p:cNvSpPr>
-            <a:spLocks noGrp="1"/>
-          </p:cNvSpPr>
-          <p:nvPr>
-            <p:ph type="sldImg" idx="2"/>
-          </p:nvPr>
-        </p:nvSpPr>
-        <p:spPr/>
-      </p:sp>
-      <p:sp>
-        <p:nvSpPr>
-          <p:cNvPr id="3" name="Notes Placeholder 2"/>
-          <p:cNvSpPr>
-            <a:spLocks noGrp="1"/>
-          </p:cNvSpPr>
-          <p:nvPr>
-            <p:ph type="body" idx="3" sz="quarter"/>
-          </p:nvPr>
-        </p:nvSpPr>
-        <p:spPr/>
-        <p:txBody>
-          <a:bodyPr/>
-          <a:lstStyle/>
-          <a:p>
-            <a:r>
-              <a:t>오늘 말씀드릴 건 세 가지입니다.</a:t>
-            </a:r>
-          </a:p>
-          <a:p>
-            <a:r>
-              <a:t>첫째, 우리 문서가 지금 어떤 상태인지.</a:t>
-            </a:r>
-          </a:p>
-          <a:p>
-            <a:r>
-              <a:t>둘째, 왜 Claude가 우리 기능을 못 찾는지.</a:t>
-            </a:r>
-          </a:p>
-          <a:p>
-            <a:r>
-              <a:t>셋째, 어떻게 고칠 수 있는지 — 두 가지 방식으로 제안드립니다.</a:t>
-            </a:r>
-          </a:p>
-          <a:p/>
-          <a:p>
-            <a:r>
-              <a:t>조사는 GitHub 계정에 있는 저장소 9개 전부, 마크다운 문서 465개를 전수로 읽어서 했습니다.</a:t>
-            </a:r>
-          </a:p>
-        </p:txBody>
-      </p:sp>
-      <p:sp>
-        <p:nvSpPr>
-          <p:cNvPr id="4" name="Slide Number Placeholder 3"/>
-          <p:cNvSpPr>
-            <a:spLocks noGrp="1"/>
-          </p:cNvSpPr>
-          <p:nvPr>
-            <p:ph type="sldNum" idx="5" sz="quarter"/>
-          </p:nvPr>
-        </p:nvSpPr>
-        <p:spPr/>
-      </p:sp>
-    </p:spTree>
-  </p:cSld>
-  <p:clrMapOvr>
-    <a:masterClrMapping/>
-  </p:clrMapOvr>
-</p:notes>
-</file>
-
-<file path=ppt/notesSlides/notesSlide10.xml><?xml version="1.0" encoding="utf-8"?>
-<p:notes xmlns:a="http://schemas.openxmlformats.org/drawingml/2006/main" xmlns:p="http://schemas.openxmlformats.org/presentationml/2006/main" xmlns:r="http://schemas.openxmlformats.org/officeDocument/2006/relationships">
-  <p:cSld>
-    <p:spTree>
-      <p:nvGrpSpPr>
-        <p:cNvPr id="1" name=""/>
-        <p:cNvGrpSpPr/>
-        <p:nvPr/>
-      </p:nvGrpSpPr>
-      <p:grpSpPr>
-        <a:xfrm>
-          <a:off x="0" y="0"/>
-          <a:ext cx="0" cy="0"/>
-          <a:chOff x="0" y="0"/>
-          <a:chExt cx="0" cy="0"/>
-        </a:xfrm>
-      </p:grpSpPr>
-      <p:sp>
-        <p:nvSpPr>
-          <p:cNvPr id="2" name="Slide Image Placeholder 1"/>
-          <p:cNvSpPr>
-            <a:spLocks noGrp="1"/>
-          </p:cNvSpPr>
-          <p:nvPr>
-            <p:ph type="sldImg" idx="2"/>
-          </p:nvPr>
-        </p:nvSpPr>
-        <p:spPr/>
-      </p:sp>
-      <p:sp>
-        <p:nvSpPr>
-          <p:cNvPr id="3" name="Notes Placeholder 2"/>
-          <p:cNvSpPr>
-            <a:spLocks noGrp="1"/>
-          </p:cNvSpPr>
-          <p:nvPr>
-            <p:ph type="body" idx="3" sz="quarter"/>
-          </p:nvPr>
-        </p:nvSpPr>
-        <p:spPr/>
-        <p:txBody>
-          <a:bodyPr/>
-          <a:lstStyle/>
-          <a:p>
-            <a:r>
-              <a:t>세 번째 원인입니다. 조금 사소해 보이지만 중요합니다.</a:t>
-            </a:r>
-          </a:p>
-          <a:p/>
-          <a:p>
-            <a:r>
-              <a:t>저장소끼리 막혀 있다고 했는데, 딱 한 군데 다리를 놓은 곳이 있었습니다. templates 저장소의 CLAUDE.md 72번째 줄에 '디자인 시스템 문서는 여기 있어요' 하고 주소를 적어놨습니다.</a:t>
-            </a:r>
-          </a:p>
-          <a:p/>
-          <a:p>
-            <a:r>
-              <a:t>그런데 그 주소가 /Users/designer/ 로 시작합니다. 이건 예전 담당자 컴퓨터의 폴더 경로입니다. 지금 이 컴퓨터의 사용자는 mustard입니다. designer라는 사용자는 없습니다.</a:t>
-            </a:r>
-          </a:p>
-          <a:p/>
-          <a:p>
-            <a:r>
-              <a:t>쉽게 말하면 본사가 이사를 갔는데 지점 주소록을 안 고친 겁니다. Claude가 그 주소로 찾아가면 '그런 폴더 없습니다'가 뜨고, 그러면 그냥 포기하고 자기가 아는 선에서 작업을 시작합니다.</a:t>
-            </a:r>
-          </a:p>
-          <a:p/>
-          <a:p>
-            <a:r>
-              <a:t>이런 죽은 주소가 세 종류나 섞여 있습니다. designer, leesunho, mustard. 앞의 둘은 이 컴퓨터에 없는 사용자입니다.</a:t>
-            </a:r>
-          </a:p>
-          <a:p/>
-          <a:p>
-            <a:r>
-              <a:t>이건 고치기 쉽습니다. 절대 주소 대신 상대 주소를 쓰면 됩니다.</a:t>
-            </a:r>
-          </a:p>
-        </p:txBody>
-      </p:sp>
-      <p:sp>
-        <p:nvSpPr>
-          <p:cNvPr id="4" name="Slide Number Placeholder 3"/>
-          <p:cNvSpPr>
-            <a:spLocks noGrp="1"/>
-          </p:cNvSpPr>
-          <p:nvPr>
-            <p:ph type="sldNum" idx="5" sz="quarter"/>
-          </p:nvPr>
-        </p:nvSpPr>
-        <p:spPr/>
-      </p:sp>
-    </p:spTree>
-  </p:cSld>
-  <p:clrMapOvr>
-    <a:masterClrMapping/>
-  </p:clrMapOvr>
-</p:notes>
-</file>
-
-<file path=ppt/notesSlides/notesSlide11.xml><?xml version="1.0" encoding="utf-8"?>
-<p:notes xmlns:a="http://schemas.openxmlformats.org/drawingml/2006/main" xmlns:p="http://schemas.openxmlformats.org/presentationml/2006/main" xmlns:r="http://schemas.openxmlformats.org/officeDocument/2006/relationships">
-  <p:cSld>
-    <p:spTree>
-      <p:nvGrpSpPr>
-        <p:cNvPr id="1" name=""/>
-        <p:cNvGrpSpPr/>
-        <p:nvPr/>
-      </p:nvGrpSpPr>
-      <p:grpSpPr>
-        <a:xfrm>
-          <a:off x="0" y="0"/>
-          <a:ext cx="0" cy="0"/>
-          <a:chOff x="0" y="0"/>
-          <a:chExt cx="0" cy="0"/>
-        </a:xfrm>
-      </p:grpSpPr>
-      <p:sp>
-        <p:nvSpPr>
-          <p:cNvPr id="2" name="Slide Image Placeholder 1"/>
-          <p:cNvSpPr>
-            <a:spLocks noGrp="1"/>
-          </p:cNvSpPr>
-          <p:nvPr>
-            <p:ph type="sldImg" idx="2"/>
-          </p:nvPr>
-        </p:nvSpPr>
-        <p:spPr/>
-      </p:sp>
-      <p:sp>
-        <p:nvSpPr>
-          <p:cNvPr id="3" name="Notes Placeholder 2"/>
-          <p:cNvSpPr>
-            <a:spLocks noGrp="1"/>
-          </p:cNvSpPr>
-          <p:nvPr>
-            <p:ph type="body" idx="3" sz="quarter"/>
-          </p:nvPr>
-        </p:nvSpPr>
-        <p:spPr/>
-        <p:txBody>
-          <a:bodyPr/>
-          <a:lstStyle/>
-          <a:p>
-            <a:r>
-              <a:t>네 번째 원인입니다.</a:t>
-            </a:r>
-          </a:p>
-          <a:p/>
-          <a:p>
-            <a:r>
-              <a:t>templates 저장소 안에 규칙 문서가 두 개 있습니다. CLAUDE.md랑 AGENTS.md인데, 내용이 거의 같습니다.</a:t>
-            </a:r>
-          </a:p>
-          <a:p/>
-          <a:p>
-            <a:r>
-              <a:t>쉽게 말하면 사규집이 두 권 있는 겁니다. 그런데 한 권은 하루 전 버전이고, 표지에 '구버전'이라는 표시가 없습니다.</a:t>
-            </a:r>
-          </a:p>
-          <a:p/>
-          <a:p>
-            <a:r>
-              <a:t>구체적으로 CLAUDE.md는 7월 24일자, AGENTS.md는 7월 23일자입니다. 24일에 추가된 규칙 세 개 — 프리셋 원본 건드리지 마라, PNG 알파 크롭 방법, 다크모드 투명도 보정 — 이 세 개가 AGENTS.md에는 통째로 없습니다.</a:t>
-            </a:r>
-          </a:p>
-          <a:p/>
-          <a:p>
-            <a:r>
-              <a:t>그러면 어떻게 되냐면, AGENTS.md를 먼저 읽은 Claude는 '프리셋 원본을 건드리지 마라'는 규칙을 모르는 상태로 작업을 시작합니다.</a:t>
-            </a:r>
-          </a:p>
-          <a:p/>
-          <a:p>
-            <a:r>
-              <a:t>design-service 저장소에도 똑같은 구조가 있습니다.</a:t>
-            </a:r>
-          </a:p>
-          <a:p/>
-          <a:p>
-            <a:r>
-              <a:t>게다가 .agents랑 .codex라는 복사본 폴더도 있는데, 이건 자동으로 단어를 바꿔치기하면서 만든 거라 claude.ai/design 이라는 서비스 이름이 Codex.ai/design 으로 잘못 바뀌어 있습니다. 그런 서비스는 존재하지 않습니다.</a:t>
-            </a:r>
-          </a:p>
-        </p:txBody>
-      </p:sp>
-      <p:sp>
-        <p:nvSpPr>
-          <p:cNvPr id="4" name="Slide Number Placeholder 3"/>
-          <p:cNvSpPr>
-            <a:spLocks noGrp="1"/>
-          </p:cNvSpPr>
-          <p:nvPr>
-            <p:ph type="sldNum" idx="5" sz="quarter"/>
-          </p:nvPr>
-        </p:nvSpPr>
-        <p:spPr/>
-      </p:sp>
-    </p:spTree>
-  </p:cSld>
-  <p:clrMapOvr>
-    <a:masterClrMapping/>
-  </p:clrMapOvr>
-</p:notes>
-</file>
-
-<file path=ppt/notesSlides/notesSlide12.xml><?xml version="1.0" encoding="utf-8"?>
-<p:notes xmlns:a="http://schemas.openxmlformats.org/drawingml/2006/main" xmlns:p="http://schemas.openxmlformats.org/presentationml/2006/main" xmlns:r="http://schemas.openxmlformats.org/officeDocument/2006/relationships">
-  <p:cSld>
-    <p:spTree>
-      <p:nvGrpSpPr>
-        <p:cNvPr id="1" name=""/>
-        <p:cNvGrpSpPr/>
-        <p:nvPr/>
-      </p:nvGrpSpPr>
-      <p:grpSpPr>
-        <a:xfrm>
-          <a:off x="0" y="0"/>
-          <a:ext cx="0" cy="0"/>
-          <a:chOff x="0" y="0"/>
-          <a:chExt cx="0" cy="0"/>
-        </a:xfrm>
-      </p:grpSpPr>
-      <p:sp>
-        <p:nvSpPr>
-          <p:cNvPr id="2" name="Slide Image Placeholder 1"/>
-          <p:cNvSpPr>
-            <a:spLocks noGrp="1"/>
-          </p:cNvSpPr>
-          <p:nvPr>
-            <p:ph type="sldImg" idx="2"/>
-          </p:nvPr>
-        </p:nvSpPr>
-        <p:spPr/>
-      </p:sp>
-      <p:sp>
-        <p:nvSpPr>
-          <p:cNvPr id="3" name="Notes Placeholder 2"/>
-          <p:cNvSpPr>
-            <a:spLocks noGrp="1"/>
-          </p:cNvSpPr>
-          <p:nvPr>
-            <p:ph type="body" idx="3" sz="quarter"/>
-          </p:nvPr>
-        </p:nvSpPr>
-        <p:spPr/>
-        <p:txBody>
-          <a:bodyPr/>
-          <a:lstStyle/>
-          <a:p>
-            <a:r>
-              <a:t>마지막 다섯 번째 원인입니다.</a:t>
-            </a:r>
-          </a:p>
-          <a:p/>
-          <a:p>
-            <a:r>
-              <a:t>CLAUDE.md라는 파일이 있습니다. Claude가 그 폴더를 열면 자동으로 읽는 유일한 파일입니다. 신입사원에게 첫날 건네는 안내문이라고 생각하시면 됩니다.</a:t>
-            </a:r>
-          </a:p>
-          <a:p/>
-          <a:p>
-            <a:r>
-              <a:t>그런데 이 안내문이 저장소마다 완전히 딴판입니다.</a:t>
-            </a:r>
-          </a:p>
-          <a:p/>
-          <a:p>
-            <a:r>
-              <a:t>디자인 시스템 저장소는 679바이트입니다. A4 반 장 분량이에요. 그 안에 정작 중요한 디자인 시스템 문서 99개 얘기가 한 줄도 없습니다.</a:t>
-            </a:r>
-          </a:p>
-          <a:p/>
-          <a:p>
-            <a:r>
-              <a:t>반대로 templates 저장소는 131KB, A4로 60장입니다. 신입한테 첫날 60장짜리 문서를 읽히는 셈인데, 그러면 핵심이 묻힙니다.</a:t>
-            </a:r>
-          </a:p>
-          <a:p/>
-          <a:p>
-            <a:r>
-              <a:t>design-service는 중간 분량인데, 안내문 안에 적힌 문서 주소 9개가 전부 틀렸습니다. 파일 이름이 바뀌었는데 안내문을 안 고친 겁니다. 그래서 그 표는 통째로 쓸모가 없습니다.</a:t>
-            </a:r>
-          </a:p>
-          <a:p/>
-          <a:p>
-            <a:r>
-              <a:t>그리고 결정적인 게 하나 있습니다. 5개 저장소 안내문 중에 '우리한테는 이런 스킬이 있어요'라고 소개하는 곳이 단 한 곳도 없습니다. 만들어놓고 알려주질 않는 겁니다.</a:t>
-            </a:r>
-          </a:p>
-        </p:txBody>
-      </p:sp>
-      <p:sp>
-        <p:nvSpPr>
-          <p:cNvPr id="4" name="Slide Number Placeholder 3"/>
-          <p:cNvSpPr>
-            <a:spLocks noGrp="1"/>
-          </p:cNvSpPr>
-          <p:nvPr>
-            <p:ph type="sldNum" idx="5" sz="quarter"/>
-          </p:nvPr>
-        </p:nvSpPr>
-        <p:spPr/>
-      </p:sp>
-    </p:spTree>
-  </p:cSld>
-  <p:clrMapOvr>
-    <a:masterClrMapping/>
-  </p:clrMapOvr>
-</p:notes>
-</file>
-
-<file path=ppt/notesSlides/notesSlide13.xml><?xml version="1.0" encoding="utf-8"?>
-<p:notes xmlns:a="http://schemas.openxmlformats.org/drawingml/2006/main" xmlns:p="http://schemas.openxmlformats.org/presentationml/2006/main" xmlns:r="http://schemas.openxmlformats.org/officeDocument/2006/relationships">
-  <p:cSld>
-    <p:spTree>
-      <p:nvGrpSpPr>
-        <p:cNvPr id="1" name=""/>
-        <p:cNvGrpSpPr/>
-        <p:nvPr/>
-      </p:nvGrpSpPr>
-      <p:grpSpPr>
-        <a:xfrm>
-          <a:off x="0" y="0"/>
-          <a:ext cx="0" cy="0"/>
-          <a:chOff x="0" y="0"/>
-          <a:chExt cx="0" cy="0"/>
-        </a:xfrm>
-      </p:grpSpPr>
-      <p:sp>
-        <p:nvSpPr>
-          <p:cNvPr id="2" name="Slide Image Placeholder 1"/>
-          <p:cNvSpPr>
-            <a:spLocks noGrp="1"/>
-          </p:cNvSpPr>
-          <p:nvPr>
-            <p:ph type="sldImg" idx="2"/>
-          </p:nvPr>
-        </p:nvSpPr>
-        <p:spPr/>
-      </p:sp>
-      <p:sp>
-        <p:nvSpPr>
-          <p:cNvPr id="3" name="Notes Placeholder 2"/>
-          <p:cNvSpPr>
-            <a:spLocks noGrp="1"/>
-          </p:cNvSpPr>
-          <p:nvPr>
-            <p:ph type="body" idx="3" sz="quarter"/>
-          </p:nvPr>
-        </p:nvSpPr>
-        <p:spPr/>
-        <p:txBody>
-          <a:bodyPr/>
-          <a:lstStyle/>
-          <a:p>
-            <a:r>
-              <a:t>여기까지가 진단이었습니다. 이제 해결 방안입니다.</a:t>
-            </a:r>
-          </a:p>
-          <a:p/>
-          <a:p>
-            <a:r>
-              <a:t>두 가지 방식을 제안드릴 건데, 그 전에 '그럼 문서를 더 잘 쓰면 되는 거 아니냐'는 질문에 먼저 답하겠습니다.</a:t>
-            </a:r>
-          </a:p>
-        </p:txBody>
-      </p:sp>
-      <p:sp>
-        <p:nvSpPr>
-          <p:cNvPr id="4" name="Slide Number Placeholder 3"/>
-          <p:cNvSpPr>
-            <a:spLocks noGrp="1"/>
-          </p:cNvSpPr>
-          <p:nvPr>
-            <p:ph type="sldNum" idx="5" sz="quarter"/>
-          </p:nvPr>
-        </p:nvSpPr>
-        <p:spPr/>
-      </p:sp>
-    </p:spTree>
-  </p:cSld>
-  <p:clrMapOvr>
-    <a:masterClrMapping/>
-  </p:clrMapOvr>
-</p:notes>
-</file>
-
-<file path=ppt/notesSlides/notesSlide14.xml><?xml version="1.0" encoding="utf-8"?>
-<p:notes xmlns:a="http://schemas.openxmlformats.org/drawingml/2006/main" xmlns:p="http://schemas.openxmlformats.org/presentationml/2006/main" xmlns:r="http://schemas.openxmlformats.org/officeDocument/2006/relationships">
-  <p:cSld>
-    <p:spTree>
-      <p:nvGrpSpPr>
-        <p:cNvPr id="1" name=""/>
-        <p:cNvGrpSpPr/>
-        <p:nvPr/>
-      </p:nvGrpSpPr>
-      <p:grpSpPr>
-        <a:xfrm>
-          <a:off x="0" y="0"/>
-          <a:ext cx="0" cy="0"/>
-          <a:chOff x="0" y="0"/>
-          <a:chExt cx="0" cy="0"/>
-        </a:xfrm>
-      </p:grpSpPr>
-      <p:sp>
-        <p:nvSpPr>
-          <p:cNvPr id="2" name="Slide Image Placeholder 1"/>
-          <p:cNvSpPr>
-            <a:spLocks noGrp="1"/>
-          </p:cNvSpPr>
-          <p:nvPr>
-            <p:ph type="sldImg" idx="2"/>
-          </p:nvPr>
-        </p:nvSpPr>
-        <p:spPr/>
-      </p:sp>
-      <p:sp>
-        <p:nvSpPr>
-          <p:cNvPr id="3" name="Notes Placeholder 2"/>
-          <p:cNvSpPr>
-            <a:spLocks noGrp="1"/>
-          </p:cNvSpPr>
-          <p:nvPr>
-            <p:ph type="body" idx="3" sz="quarter"/>
-          </p:nvPr>
-        </p:nvSpPr>
-        <p:spPr/>
-        <p:txBody>
-          <a:bodyPr/>
-          <a:lstStyle/>
-          <a:p>
-            <a:r>
-              <a:t>왜 스킬이어야 하는지 대화로 보여드리겠습니다.</a:t>
-            </a:r>
-          </a:p>
-          <a:p/>
-          <a:p>
-            <a:r>
-              <a:t>왼쪽이 지금입니다. 팀원이 '룩북 시안 만들어줘' 하면 Claude가 '어떤 룩북이요? 문서 좀 알려주세요' 하고 되묻습니다. 그러면 팀원이 '룩북 슬래시 1번 제작 프로세스 슬래시 1-2 시안점md 읽어봐' 하고 경로를 정확히 대줘야 합니다.</a:t>
-            </a:r>
-          </a:p>
-          <a:p/>
-          <a:p>
-            <a:r>
-              <a:t>즉 팀원이 문서 경로를 외우고 있어야 합니다. 모르면 시작을 못 합니다. 신입이 오면 이걸 다 알려줘야 하고요.</a:t>
-            </a:r>
-          </a:p>
-          <a:p/>
-          <a:p>
-            <a:r>
-              <a:t>오른쪽이 제안입니다. 스킬로 등록해두면 '룩북 시안 만들어줘' 한마디에 Claude가 알아서 해당 스킬을 찾고, 거기 적힌 대로 정본 문서를 읽고 시작합니다.</a:t>
-            </a:r>
-          </a:p>
-          <a:p/>
-          <a:p>
-            <a:r>
-              <a:t>중요한 건 스킬 자체는 아주 짧다는 겁니다. 밑에 예시를 보시면 대여섯 줄이에요. 문서 내용을 복사하는 게 아니라 '이 문서 읽어라'라고 가리키기만 합니다. 그래서 정본 문서를 고치면 자동으로 반영됩니다.</a:t>
-            </a:r>
-          </a:p>
-          <a:p/>
-          <a:p>
-            <a:r>
-              <a:t>그리고 가장 중요한 게 description 부분입니다. 여기에 팀원이 실제로 쓰는 말 — '룩북 시안 만들어줘', 'OO 브랜드 시안 뽑아줘' — 이런 한국어 문장을 넣어야 Claude가 알아듣습니다.</a:t>
-            </a:r>
-          </a:p>
-        </p:txBody>
-      </p:sp>
-      <p:sp>
-        <p:nvSpPr>
-          <p:cNvPr id="4" name="Slide Number Placeholder 3"/>
-          <p:cNvSpPr>
-            <a:spLocks noGrp="1"/>
-          </p:cNvSpPr>
-          <p:nvPr>
-            <p:ph type="sldNum" idx="5" sz="quarter"/>
-          </p:nvPr>
-        </p:nvSpPr>
-        <p:spPr/>
-      </p:sp>
-    </p:spTree>
-  </p:cSld>
-  <p:clrMapOvr>
-    <a:masterClrMapping/>
-  </p:clrMapOvr>
-</p:notes>
-</file>
-
-<file path=ppt/notesSlides/notesSlide15.xml><?xml version="1.0" encoding="utf-8"?>
-<p:notes xmlns:a="http://schemas.openxmlformats.org/drawingml/2006/main" xmlns:p="http://schemas.openxmlformats.org/presentationml/2006/main" xmlns:r="http://schemas.openxmlformats.org/officeDocument/2006/relationships">
-  <p:cSld>
-    <p:spTree>
-      <p:nvGrpSpPr>
-        <p:cNvPr id="1" name=""/>
-        <p:cNvGrpSpPr/>
-        <p:nvPr/>
-      </p:nvGrpSpPr>
-      <p:grpSpPr>
-        <a:xfrm>
-          <a:off x="0" y="0"/>
-          <a:ext cx="0" cy="0"/>
-          <a:chOff x="0" y="0"/>
-          <a:chExt cx="0" cy="0"/>
-        </a:xfrm>
-      </p:grpSpPr>
-      <p:sp>
-        <p:nvSpPr>
-          <p:cNvPr id="2" name="Slide Image Placeholder 1"/>
-          <p:cNvSpPr>
-            <a:spLocks noGrp="1"/>
-          </p:cNvSpPr>
-          <p:nvPr>
-            <p:ph type="sldImg" idx="2"/>
-          </p:nvPr>
-        </p:nvSpPr>
-        <p:spPr/>
-      </p:sp>
-      <p:sp>
-        <p:nvSpPr>
-          <p:cNvPr id="3" name="Notes Placeholder 2"/>
-          <p:cNvSpPr>
-            <a:spLocks noGrp="1"/>
-          </p:cNvSpPr>
-          <p:nvPr>
-            <p:ph type="body" idx="3" sz="quarter"/>
-          </p:nvPr>
-        </p:nvSpPr>
-        <p:spPr/>
-        <p:txBody>
-          <a:bodyPr/>
-          <a:lstStyle/>
-          <a:p>
-            <a:r>
-              <a:t>첫 번째 방식, '안내판 달기'입니다. 가볍게 시작하는 안입니다.</a:t>
-            </a:r>
-          </a:p>
-          <a:p/>
-          <a:p>
-            <a:r>
-              <a:t>지금 구조는 하나도 안 바꿉니다. 저장소 6개 그대로 두고, 각 저장소가 자기소개를 제대로 하게 만드는 겁니다.</a:t>
-            </a:r>
-          </a:p>
-          <a:p/>
-          <a:p>
-            <a:r>
-              <a:t>첫째, 안내문을 전 저장소 같은 형식으로 통일합니다. 100~150줄 정도로 짧게 하고, 핵심은 '이렇게 말하면 이걸 실행하고, 정본 문서는 여기다' 하는 표입니다.</a:t>
-            </a:r>
-          </a:p>
-          <a:p/>
-          <a:p>
-            <a:r>
-              <a:t>둘째, 기능을 전부 스킬로 만들지는 않고 자주 쓰는 20개만 합니다.</a:t>
-            </a:r>
-          </a:p>
-          <a:p/>
-          <a:p>
-            <a:r>
-              <a:t>셋째, 이선호님 컴퓨터에 있는 blog-thumbnail 스킬을 저장소로 옮깁니다. 이건 하루면 됩니다.</a:t>
-            </a:r>
-          </a:p>
-          <a:p/>
-          <a:p>
-            <a:r>
-              <a:t>넷째, 깨진 주소랑 링크를 한 번에 정리합니다. 브랜드 색도 하나로 확정하고요.</a:t>
-            </a:r>
-          </a:p>
-          <a:p/>
-          <a:p>
-            <a:r>
-              <a:t>이렇게 하면 Claude가 아는 기능이 7개에서 27개 정도로 늘어납니다.</a:t>
-            </a:r>
-          </a:p>
-          <a:p>
-            <a:r>
-              <a:t>빠르고, 마음에 안 들면 되돌리기도 쉽습니다.</a:t>
-            </a:r>
-          </a:p>
-          <a:p>
-            <a:r>
-              <a:t>다만 같은 내용이 여러 군데 있는 구조는 그대로라서, 시간이 지나면 또 어긋날 수 있습니다.</a:t>
-            </a:r>
-          </a:p>
-        </p:txBody>
-      </p:sp>
-      <p:sp>
-        <p:nvSpPr>
-          <p:cNvPr id="4" name="Slide Number Placeholder 3"/>
-          <p:cNvSpPr>
-            <a:spLocks noGrp="1"/>
-          </p:cNvSpPr>
-          <p:nvPr>
-            <p:ph type="sldNum" idx="5" sz="quarter"/>
-          </p:nvPr>
-        </p:nvSpPr>
-        <p:spPr/>
-      </p:sp>
-    </p:spTree>
-  </p:cSld>
-  <p:clrMapOvr>
-    <a:masterClrMapping/>
-  </p:clrMapOvr>
-</p:notes>
-</file>
-
-<file path=ppt/notesSlides/notesSlide16.xml><?xml version="1.0" encoding="utf-8"?>
-<p:notes xmlns:a="http://schemas.openxmlformats.org/drawingml/2006/main" xmlns:p="http://schemas.openxmlformats.org/presentationml/2006/main" xmlns:r="http://schemas.openxmlformats.org/officeDocument/2006/relationships">
-  <p:cSld>
-    <p:spTree>
-      <p:nvGrpSpPr>
-        <p:cNvPr id="1" name=""/>
-        <p:cNvGrpSpPr/>
-        <p:nvPr/>
-      </p:nvGrpSpPr>
-      <p:grpSpPr>
-        <a:xfrm>
-          <a:off x="0" y="0"/>
-          <a:ext cx="0" cy="0"/>
-          <a:chOff x="0" y="0"/>
-          <a:chExt cx="0" cy="0"/>
-        </a:xfrm>
-      </p:grpSpPr>
-      <p:sp>
-        <p:nvSpPr>
-          <p:cNvPr id="2" name="Slide Image Placeholder 1"/>
-          <p:cNvSpPr>
-            <a:spLocks noGrp="1"/>
-          </p:cNvSpPr>
-          <p:nvPr>
-            <p:ph type="sldImg" idx="2"/>
-          </p:nvPr>
-        </p:nvSpPr>
-        <p:spPr/>
-      </p:sp>
-      <p:sp>
-        <p:nvSpPr>
-          <p:cNvPr id="3" name="Notes Placeholder 2"/>
-          <p:cNvSpPr>
-            <a:spLocks noGrp="1"/>
-          </p:cNvSpPr>
-          <p:nvPr>
-            <p:ph type="body" idx="3" sz="quarter"/>
-          </p:nvPr>
-        </p:nvSpPr>
-        <p:spPr/>
-        <p:txBody>
-          <a:bodyPr/>
-          <a:lstStyle/>
-          <a:p>
-            <a:r>
-              <a:t>두 번째 방식, '정본 하나 + 자동 감시'입니다. 근본적으로 해결하는 안입니다.</a:t>
-            </a:r>
-          </a:p>
-          <a:p/>
-          <a:p>
-            <a:r>
-              <a:t>방식 A를 다 포함하고, 여기에 하나를 더 합니다. '같은 내용이 두 곳에 존재할 수 없는 구조'를 만드는 겁니다.</a:t>
-            </a:r>
-          </a:p>
-          <a:p/>
-          <a:p>
-            <a:r>
-              <a:t>왼쪽 예시를 보시면 이해가 빠르실 겁니다.</a:t>
-            </a:r>
-          </a:p>
-          <a:p>
-            <a:r>
-              <a:t>지금은 디자인시스템에 3DF69B, 마케팅에 4DE98B가 각각 적혀 있어서 갈라졌습니다.</a:t>
-            </a:r>
-          </a:p>
-          <a:p>
-            <a:r>
-              <a:t>방식 B를 적용하면 두 저장소가 _core라는 공통 폴더의 브랜드 토큰 파일 하나만 봅니다. 값을 고치면 양쪽에 동시에 반영되고, 애초에 두 값이 존재할 수가 없습니다.</a:t>
-            </a:r>
-          </a:p>
-          <a:p/>
-          <a:p>
-            <a:r>
-              <a:t>오른쪽이 구조입니다. cdbd-core라는 저장소를 새로 하나 만들어서 브랜드 토큰, 문서 작성 규칙, 공통 스킬만 넣습니다. 그리고 그걸 각 저장소 안에 _core 폴더로 자동 연결합니다.</a:t>
-            </a:r>
-          </a:p>
-          <a:p/>
-          <a:p>
-            <a:r>
-              <a:t>여기서 중요한 건 _core 폴더가 각 볼트 안에 실제로 물리적으로 들어간다는 겁니다. 그래서 옵시디언에서 링크도 되고 Claude도 읽을 수 있습니다. '볼트끼리 링크가 안 된다'는 제약을 우회하면서도 정본은 하나로 유지됩니다.</a:t>
-            </a:r>
-          </a:p>
-          <a:p/>
-          <a:p>
-            <a:r>
-              <a:t>그 위에 기능 82개를 전부 스킬로 만들고, 문서 형식을 통일하고, 깨진 링크를 자동으로 점검하는 스크립트를 돌립니다.</a:t>
-            </a:r>
-          </a:p>
-          <a:p/>
-          <a:p>
-            <a:r>
-              <a:t>참고로 '저장소 6개를 그냥 하나로 합치면 안 되냐'고 하실 수 있는데, 고객 자료가 있는 design-service는 분리해서 관리해야 해서 제외했습니다.</a:t>
-            </a:r>
-          </a:p>
-        </p:txBody>
-      </p:sp>
-      <p:sp>
-        <p:nvSpPr>
-          <p:cNvPr id="4" name="Slide Number Placeholder 3"/>
-          <p:cNvSpPr>
-            <a:spLocks noGrp="1"/>
-          </p:cNvSpPr>
-          <p:nvPr>
-            <p:ph type="sldNum" idx="5" sz="quarter"/>
-          </p:nvPr>
-        </p:nvSpPr>
-        <p:spPr/>
-      </p:sp>
-    </p:spTree>
-  </p:cSld>
-  <p:clrMapOvr>
-    <a:masterClrMapping/>
-  </p:clrMapOvr>
-</p:notes>
-</file>
-
-<file path=ppt/notesSlides/notesSlide17.xml><?xml version="1.0" encoding="utf-8"?>
-<p:notes xmlns:a="http://schemas.openxmlformats.org/drawingml/2006/main" xmlns:p="http://schemas.openxmlformats.org/presentationml/2006/main" xmlns:r="http://schemas.openxmlformats.org/officeDocument/2006/relationships">
-  <p:cSld>
-    <p:spTree>
-      <p:nvGrpSpPr>
-        <p:cNvPr id="1" name=""/>
-        <p:cNvGrpSpPr/>
-        <p:nvPr/>
-      </p:nvGrpSpPr>
-      <p:grpSpPr>
-        <a:xfrm>
-          <a:off x="0" y="0"/>
-          <a:ext cx="0" cy="0"/>
-          <a:chOff x="0" y="0"/>
-          <a:chExt cx="0" cy="0"/>
-        </a:xfrm>
-      </p:grpSpPr>
-      <p:sp>
-        <p:nvSpPr>
-          <p:cNvPr id="2" name="Slide Image Placeholder 1"/>
-          <p:cNvSpPr>
-            <a:spLocks noGrp="1"/>
-          </p:cNvSpPr>
-          <p:nvPr>
-            <p:ph type="sldImg" idx="2"/>
-          </p:nvPr>
-        </p:nvSpPr>
-        <p:spPr/>
-      </p:sp>
-      <p:sp>
-        <p:nvSpPr>
-          <p:cNvPr id="3" name="Notes Placeholder 2"/>
-          <p:cNvSpPr>
-            <a:spLocks noGrp="1"/>
-          </p:cNvSpPr>
-          <p:nvPr>
-            <p:ph type="body" idx="3" sz="quarter"/>
-          </p:nvPr>
-        </p:nvSpPr>
-        <p:spPr/>
-        <p:txBody>
-          <a:bodyPr/>
-          <a:lstStyle/>
-          <a:p>
-            <a:r>
-              <a:t>두 방식을 비교하면 이렇습니다.</a:t>
-            </a:r>
-          </a:p>
-          <a:p/>
-          <a:p>
-            <a:r>
-              <a:t>가장 중요한 첫 줄을 봐주세요. 지금은 Claude가 82개 중 7개를 압니다. 방식 A면 27개, 방식 B면 82개 전부입니다.</a:t>
-            </a:r>
-          </a:p>
-          <a:p/>
-          <a:p>
-            <a:r>
-              <a:t>세 번째 줄, '누가 시켜도 같은 결과가 나오나' — 이게 우리가 원래 하려던 거였죠. A는 '대체로', B는 '예'입니다.</a:t>
-            </a:r>
-          </a:p>
-          <a:p/>
-          <a:p>
-            <a:r>
-              <a:t>네 번째 줄이 두 방식의 결정적 차이입니다. 브랜드 값이 또 갈라질 수 있냐. A는 가능성이 남고, B는 구조적으로 불가능합니다.</a:t>
-            </a:r>
-          </a:p>
-          <a:p/>
-          <a:p>
-            <a:r>
-              <a:t>제 권장은 이렇습니다. 방식 A를 저장소 하나에 먼저 시범 적용해보시는 겁니다. makevu-qrstp가 좋겠습니다. 기능은 20개로 가장 많은데 등록된 게 0개라 효과가 확실히 보일 거고, 문서 형식도 이미 잘 정리돼 있어서 작업이 수월합니다.</a:t>
-            </a:r>
-          </a:p>
-          <a:p/>
-          <a:p>
-            <a:r>
-              <a:t>거기서 효과를 확인하고 나서 방식 B로 확장할지 결정하시면 됩니다.</a:t>
-            </a:r>
-          </a:p>
-        </p:txBody>
-      </p:sp>
-      <p:sp>
-        <p:nvSpPr>
-          <p:cNvPr id="4" name="Slide Number Placeholder 3"/>
-          <p:cNvSpPr>
-            <a:spLocks noGrp="1"/>
-          </p:cNvSpPr>
-          <p:nvPr>
-            <p:ph type="sldNum" idx="5" sz="quarter"/>
-          </p:nvPr>
-        </p:nvSpPr>
-        <p:spPr/>
-      </p:sp>
-    </p:spTree>
-  </p:cSld>
-  <p:clrMapOvr>
-    <a:masterClrMapping/>
-  </p:clrMapOvr>
-</p:notes>
-</file>
-
-<file path=ppt/notesSlides/notesSlide18.xml><?xml version="1.0" encoding="utf-8"?>
-<p:notes xmlns:a="http://schemas.openxmlformats.org/drawingml/2006/main" xmlns:p="http://schemas.openxmlformats.org/presentationml/2006/main" xmlns:r="http://schemas.openxmlformats.org/officeDocument/2006/relationships">
-  <p:cSld>
-    <p:spTree>
-      <p:nvGrpSpPr>
-        <p:cNvPr id="1" name=""/>
-        <p:cNvGrpSpPr/>
-        <p:nvPr/>
-      </p:nvGrpSpPr>
-      <p:grpSpPr>
-        <a:xfrm>
-          <a:off x="0" y="0"/>
-          <a:ext cx="0" cy="0"/>
-          <a:chOff x="0" y="0"/>
-          <a:chExt cx="0" cy="0"/>
-        </a:xfrm>
-      </p:grpSpPr>
-      <p:sp>
-        <p:nvSpPr>
-          <p:cNvPr id="2" name="Slide Image Placeholder 1"/>
-          <p:cNvSpPr>
-            <a:spLocks noGrp="1"/>
-          </p:cNvSpPr>
-          <p:nvPr>
-            <p:ph type="sldImg" idx="2"/>
-          </p:nvPr>
-        </p:nvSpPr>
-        <p:spPr/>
-      </p:sp>
-      <p:sp>
-        <p:nvSpPr>
-          <p:cNvPr id="3" name="Notes Placeholder 2"/>
-          <p:cNvSpPr>
-            <a:spLocks noGrp="1"/>
-          </p:cNvSpPr>
-          <p:nvPr>
-            <p:ph type="body" idx="3" sz="quarter"/>
-          </p:nvPr>
-        </p:nvSpPr>
-        <p:spPr/>
-        <p:txBody>
-          <a:bodyPr/>
-          <a:lstStyle/>
-          <a:p>
-            <a:r>
-              <a:t>방식 A로 가든 B로 가든, 이건 지금 고쳐야 합니다.</a:t>
-            </a:r>
-          </a:p>
-          <a:p/>
-          <a:p>
-            <a:r>
-              <a:t>1번과 2번은 오늘 바로 부탁드립니다.</a:t>
-            </a:r>
-          </a:p>
-          <a:p>
-            <a:r>
-              <a:t>고객 자료 공개 설정은 시간이 지날수록 위험이 커집니다.</a:t>
-            </a:r>
-          </a:p>
-          <a:p>
-            <a:r>
-              <a:t>브랜드 색은 지금도 잘못된 값으로 이미지가 만들어지고 있습니다.</a:t>
-            </a:r>
-          </a:p>
-          <a:p/>
-          <a:p>
-            <a:r>
-              <a:t>3번 4번은 이번 주 안에. 둘 다 반나절이면 됩니다.</a:t>
-            </a:r>
-          </a:p>
-          <a:p/>
-          <a:p>
-            <a:r>
-              <a:t>5번 6번은 이번 달 안에 하면 됩니다.</a:t>
-            </a:r>
-          </a:p>
-        </p:txBody>
-      </p:sp>
-      <p:sp>
-        <p:nvSpPr>
-          <p:cNvPr id="4" name="Slide Number Placeholder 3"/>
-          <p:cNvSpPr>
-            <a:spLocks noGrp="1"/>
-          </p:cNvSpPr>
-          <p:nvPr>
-            <p:ph type="sldNum" idx="5" sz="quarter"/>
-          </p:nvPr>
-        </p:nvSpPr>
-        <p:spPr/>
-      </p:sp>
-    </p:spTree>
-  </p:cSld>
-  <p:clrMapOvr>
-    <a:masterClrMapping/>
-  </p:clrMapOvr>
-</p:notes>
-</file>
-
-<file path=ppt/notesSlides/notesSlide19.xml><?xml version="1.0" encoding="utf-8"?>
-<p:notes xmlns:a="http://schemas.openxmlformats.org/drawingml/2006/main" xmlns:p="http://schemas.openxmlformats.org/presentationml/2006/main" xmlns:r="http://schemas.openxmlformats.org/officeDocument/2006/relationships">
-  <p:cSld>
-    <p:spTree>
-      <p:nvGrpSpPr>
-        <p:cNvPr id="1" name=""/>
-        <p:cNvGrpSpPr/>
-        <p:nvPr/>
-      </p:nvGrpSpPr>
-      <p:grpSpPr>
-        <a:xfrm>
-          <a:off x="0" y="0"/>
-          <a:ext cx="0" cy="0"/>
-          <a:chOff x="0" y="0"/>
-          <a:chExt cx="0" cy="0"/>
-        </a:xfrm>
-      </p:grpSpPr>
-      <p:sp>
-        <p:nvSpPr>
-          <p:cNvPr id="2" name="Slide Image Placeholder 1"/>
-          <p:cNvSpPr>
-            <a:spLocks noGrp="1"/>
-          </p:cNvSpPr>
-          <p:nvPr>
-            <p:ph type="sldImg" idx="2"/>
-          </p:nvPr>
-        </p:nvSpPr>
-        <p:spPr/>
-      </p:sp>
-      <p:sp>
-        <p:nvSpPr>
-          <p:cNvPr id="3" name="Notes Placeholder 2"/>
-          <p:cNvSpPr>
-            <a:spLocks noGrp="1"/>
-          </p:cNvSpPr>
-          <p:nvPr>
-            <p:ph type="body" idx="3" sz="quarter"/>
-          </p:nvPr>
-        </p:nvSpPr>
-        <p:spPr/>
-        <p:txBody>
-          <a:bodyPr/>
-          <a:lstStyle/>
-          <a:p>
-            <a:r>
-              <a:t>마지막으로 한 가지만 더 말씀드리겠습니다.</a:t>
-            </a:r>
-          </a:p>
-          <a:p/>
-          <a:p>
-            <a:r>
-              <a:t>사실 오늘 제가 말씀드린 진단은, 우리 팀이 이미 한 번 했던 겁니다.</a:t>
-            </a:r>
-          </a:p>
-          <a:p/>
-          <a:p>
-            <a:r>
-              <a:t>design-system 저장소에 'CdBd 에디터 문서 구축 계획'이라는 문서가 있는데, 거기 이렇게 적혀 있습니다.</a:t>
-            </a:r>
-          </a:p>
-          <a:p>
-            <a:r>
-              <a:t>'팀원 A B C가 각자의 Claude에게 똑같이 부탁했을 때 같은 결과가 나오게.'</a:t>
-            </a:r>
-          </a:p>
-          <a:p>
-            <a:r>
-              <a:t>'위키링크는 Claude에게 클릭이 아닙니다.'</a:t>
-            </a:r>
-          </a:p>
-          <a:p>
-            <a:r>
-              <a:t>'CLAUDE.md 679바이트, 카드 문서 49개 언급 0줄.'</a:t>
-            </a:r>
-          </a:p>
-          <a:p/>
-          <a:p>
-            <a:r>
-              <a:t>제가 오늘 말씀드린 거랑 똑같습니다. 진단도 처방도 이미 나와 있었어요.</a:t>
-            </a:r>
-          </a:p>
-          <a:p/>
-          <a:p>
-            <a:r>
-              <a:t>그런데 그 처방이 실제로 적용된 비율은 0%입니다.</a:t>
-            </a:r>
-          </a:p>
-          <a:p/>
-          <a:p>
-            <a:r>
-              <a:t>왜냐면 그 계획서가 HTML 파일 한 장으로 되어 있어서 옵시디언 검색에도 안 걸리고, 위키링크도 안 걸리고, 그래서 아무도 — Claude조차 — 다시 읽지 못했기 때문입니다.</a:t>
-            </a:r>
-          </a:p>
-          <a:p/>
-          <a:p>
-            <a:r>
-              <a:t>그래서 이번엔 반드시 '자동 점검'을 넣어야 합니다. 사람이 기억해서 챙기는 방식으로는 또 같은 일이 반복됩니다.</a:t>
-            </a:r>
-          </a:p>
-          <a:p/>
-          <a:p>
-            <a:r>
-              <a:t>여기까지입니다. 질문 주시면 답변드리겠습니다.</a:t>
-            </a:r>
-          </a:p>
-        </p:txBody>
-      </p:sp>
-      <p:sp>
-        <p:nvSpPr>
-          <p:cNvPr id="4" name="Slide Number Placeholder 3"/>
-          <p:cNvSpPr>
-            <a:spLocks noGrp="1"/>
-          </p:cNvSpPr>
-          <p:nvPr>
-            <p:ph type="sldNum" idx="5" sz="quarter"/>
-          </p:nvPr>
-        </p:nvSpPr>
-        <p:spPr/>
-      </p:sp>
-    </p:spTree>
-  </p:cSld>
-  <p:clrMapOvr>
-    <a:masterClrMapping/>
-  </p:clrMapOvr>
-</p:notes>
-</file>
-
-<file path=ppt/notesSlides/notesSlide2.xml><?xml version="1.0" encoding="utf-8"?>
-<p:notes xmlns:a="http://schemas.openxmlformats.org/drawingml/2006/main" xmlns:p="http://schemas.openxmlformats.org/presentationml/2006/main" xmlns:r="http://schemas.openxmlformats.org/officeDocument/2006/relationships">
-  <p:cSld>
-    <p:spTree>
-      <p:nvGrpSpPr>
-        <p:cNvPr id="1" name=""/>
-        <p:cNvGrpSpPr/>
-        <p:nvPr/>
-      </p:nvGrpSpPr>
-      <p:grpSpPr>
-        <a:xfrm>
-          <a:off x="0" y="0"/>
-          <a:ext cx="0" cy="0"/>
-          <a:chOff x="0" y="0"/>
-          <a:chExt cx="0" cy="0"/>
-        </a:xfrm>
-      </p:grpSpPr>
-      <p:sp>
-        <p:nvSpPr>
-          <p:cNvPr id="2" name="Slide Image Placeholder 1"/>
-          <p:cNvSpPr>
-            <a:spLocks noGrp="1"/>
-          </p:cNvSpPr>
-          <p:nvPr>
-            <p:ph type="sldImg" idx="2"/>
-          </p:nvPr>
-        </p:nvSpPr>
-        <p:spPr/>
-      </p:sp>
-      <p:sp>
-        <p:nvSpPr>
-          <p:cNvPr id="3" name="Notes Placeholder 2"/>
-          <p:cNvSpPr>
-            <a:spLocks noGrp="1"/>
-          </p:cNvSpPr>
-          <p:nvPr>
-            <p:ph type="body" idx="3" sz="quarter"/>
-          </p:nvPr>
-        </p:nvSpPr>
-        <p:spPr/>
-        <p:txBody>
-          <a:bodyPr/>
-          <a:lstStyle/>
-          <a:p>
-            <a:r>
-              <a:t>여기가 오늘의 결론입니다.</a:t>
-            </a:r>
-          </a:p>
-          <a:p/>
-          <a:p>
-            <a:r>
-              <a:t>우리가 Claude에게 시킬 수 있는 작업을 세어보니 82개였습니다. 룩북 시안 제작, QR 이벤트 제작, 블로그 썸네일, 카드뉴스... 이런 것들이요.</a:t>
-            </a:r>
-          </a:p>
-          <a:p/>
-          <a:p>
-            <a:r>
-              <a:t>그런데 Claude가 '아, 이런 걸 할 수 있구나' 하고 스스로 아는 건 7개뿐입니다.</a:t>
-            </a:r>
-          </a:p>
-          <a:p>
-            <a:r>
-              <a:t>나머지 75개는 우리가 매번 '이 문서 읽어봐'라고 알려줘야 합니다.</a:t>
-            </a:r>
-          </a:p>
-          <a:p/>
-          <a:p>
-            <a:r>
-              <a:t>중요한 건 문서를 못 써서가 아니라는 겁니다. 문서는 정말 잘 쓰여 있습니다. 문제는 '연결'입니다.</a:t>
-            </a:r>
-          </a:p>
-        </p:txBody>
-      </p:sp>
-      <p:sp>
-        <p:nvSpPr>
-          <p:cNvPr id="4" name="Slide Number Placeholder 3"/>
-          <p:cNvSpPr>
-            <a:spLocks noGrp="1"/>
-          </p:cNvSpPr>
-          <p:nvPr>
-            <p:ph type="sldNum" idx="5" sz="quarter"/>
-          </p:nvPr>
-        </p:nvSpPr>
-        <p:spPr/>
-      </p:sp>
-    </p:spTree>
-  </p:cSld>
-  <p:clrMapOvr>
-    <a:masterClrMapping/>
-  </p:clrMapOvr>
-</p:notes>
-</file>
-
-<file path=ppt/notesSlides/notesSlide3.xml><?xml version="1.0" encoding="utf-8"?>
-<p:notes xmlns:a="http://schemas.openxmlformats.org/drawingml/2006/main" xmlns:p="http://schemas.openxmlformats.org/presentationml/2006/main" xmlns:r="http://schemas.openxmlformats.org/officeDocument/2006/relationships">
-  <p:cSld>
-    <p:spTree>
-      <p:nvGrpSpPr>
-        <p:cNvPr id="1" name=""/>
-        <p:cNvGrpSpPr/>
-        <p:nvPr/>
-      </p:nvGrpSpPr>
-      <p:grpSpPr>
-        <a:xfrm>
-          <a:off x="0" y="0"/>
-          <a:ext cx="0" cy="0"/>
-          <a:chOff x="0" y="0"/>
-          <a:chExt cx="0" cy="0"/>
-        </a:xfrm>
-      </p:grpSpPr>
-      <p:sp>
-        <p:nvSpPr>
-          <p:cNvPr id="2" name="Slide Image Placeholder 1"/>
-          <p:cNvSpPr>
-            <a:spLocks noGrp="1"/>
-          </p:cNvSpPr>
-          <p:nvPr>
-            <p:ph type="sldImg" idx="2"/>
-          </p:nvPr>
-        </p:nvSpPr>
-        <p:spPr/>
-      </p:sp>
-      <p:sp>
-        <p:nvSpPr>
-          <p:cNvPr id="3" name="Notes Placeholder 2"/>
-          <p:cNvSpPr>
-            <a:spLocks noGrp="1"/>
-          </p:cNvSpPr>
-          <p:nvPr>
-            <p:ph type="body" idx="3" sz="quarter"/>
-          </p:nvPr>
-        </p:nvSpPr>
-        <p:spPr/>
-        <p:txBody>
-          <a:bodyPr/>
-          <a:lstStyle/>
-          <a:p>
-            <a:r>
-              <a:t>먼저 우리가 뭘 갖고 있는지부터 정리했습니다.</a:t>
-            </a:r>
-          </a:p>
-          <a:p/>
-          <a:p>
-            <a:r>
-              <a:t>온보딩 문서에는 저장소가 6개라고 되어 있는데, GitHub 계정을 직접 조회해보니 9개였습니다.</a:t>
-            </a:r>
-          </a:p>
-          <a:p/>
-          <a:p>
-            <a:r>
-              <a:t>추가로 나온 3개(documentation, mintlify-docs, docs)는 열어보니 Mintlify라는 문서 사이트 서비스의 기본 템플릿을 그대로 받아놓은 것이었습니다. 커밋이 'Initial commit' 하나뿐이고, CdBd 관련 내용은 한 줄도 없습니다. docs와 mintlify-docs는 파일까지 똑같은 완전 중복본입니다.</a:t>
-            </a:r>
-          </a:p>
-          <a:p/>
-          <a:p>
-            <a:r>
-              <a:t>→ 정리하면 좋겠습니다. 지금은 '이게 뭐지?' 하고 헷갈리게 만드는 역할만 합니다.</a:t>
-            </a:r>
-          </a:p>
-          <a:p/>
-          <a:p>
-            <a:r>
-              <a:t>그리고 용량을 봐주세요. marketing이 517MB입니다. 임시 캡처 이미지가 그대로 커밋된 결과입니다.</a:t>
-            </a:r>
-          </a:p>
-        </p:txBody>
-      </p:sp>
-      <p:sp>
-        <p:nvSpPr>
-          <p:cNvPr id="4" name="Slide Number Placeholder 3"/>
-          <p:cNvSpPr>
-            <a:spLocks noGrp="1"/>
-          </p:cNvSpPr>
-          <p:nvPr>
-            <p:ph type="sldNum" idx="5" sz="quarter"/>
-          </p:nvPr>
-        </p:nvSpPr>
-        <p:spPr/>
-      </p:sp>
-    </p:spTree>
-  </p:cSld>
-  <p:clrMapOvr>
-    <a:masterClrMapping/>
-  </p:clrMapOvr>
-</p:notes>
-</file>
-
-<file path=ppt/notesSlides/notesSlide4.xml><?xml version="1.0" encoding="utf-8"?>
-<p:notes xmlns:a="http://schemas.openxmlformats.org/drawingml/2006/main" xmlns:p="http://schemas.openxmlformats.org/presentationml/2006/main" xmlns:r="http://schemas.openxmlformats.org/officeDocument/2006/relationships">
-  <p:cSld>
-    <p:spTree>
-      <p:nvGrpSpPr>
-        <p:cNvPr id="1" name=""/>
-        <p:cNvGrpSpPr/>
-        <p:nvPr/>
-      </p:nvGrpSpPr>
-      <p:grpSpPr>
-        <a:xfrm>
-          <a:off x="0" y="0"/>
-          <a:ext cx="0" cy="0"/>
-          <a:chOff x="0" y="0"/>
-          <a:chExt cx="0" cy="0"/>
-        </a:xfrm>
-      </p:grpSpPr>
-      <p:sp>
-        <p:nvSpPr>
-          <p:cNvPr id="2" name="Slide Image Placeholder 1"/>
-          <p:cNvSpPr>
-            <a:spLocks noGrp="1"/>
-          </p:cNvSpPr>
-          <p:nvPr>
-            <p:ph type="sldImg" idx="2"/>
-          </p:nvPr>
-        </p:nvSpPr>
-        <p:spPr/>
-      </p:sp>
-      <p:sp>
-        <p:nvSpPr>
-          <p:cNvPr id="3" name="Notes Placeholder 2"/>
-          <p:cNvSpPr>
-            <a:spLocks noGrp="1"/>
-          </p:cNvSpPr>
-          <p:nvPr>
-            <p:ph type="body" idx="3" sz="quarter"/>
-          </p:nvPr>
-        </p:nvSpPr>
-        <p:spPr/>
-        <p:txBody>
-          <a:bodyPr/>
-          <a:lstStyle/>
-          <a:p>
-            <a:r>
-              <a:t>이건 문서 체계 얘기는 아니지만, 조사하다 발견해서 꼭 말씀드려야 할 것 같습니다.</a:t>
-            </a:r>
-          </a:p>
-          <a:p/>
-          <a:p>
-            <a:r>
-              <a:t>GitHub 저장소는 Public이냐 Private이냐 두 가지 설정이 있습니다. Public이면 주소만 알면 누구나, 로그인도 안 하고 전부 볼 수 있고 다운로드도 됩니다.</a:t>
-            </a:r>
-          </a:p>
-          <a:p/>
-          <a:p>
-            <a:r>
-              <a:t>우리 ONBOARDING 문서에는 'cdbd-design-service는 고객 대행 작업이라 비공개'라고 적혀 있습니다. 그런데 실제 설정은 Public입니다.</a:t>
-            </a:r>
-          </a:p>
-          <a:p/>
-          <a:p>
-            <a:r>
-              <a:t>왜 이렇게 됐냐면 — 문서에 '비공개로 한다'고 쓰는 것과, GitHub 웹사이트에 들어가서 설정을 Private으로 바꾸는 건 완전히 별개 작업이기 때문입니다. 의도는 적었는데 실제 설정은 안 바꾼 것으로 보입니다.</a:t>
-            </a:r>
-          </a:p>
-          <a:p/>
-          <a:p>
-            <a:r>
-              <a:t>제가 로그인을 안 한 상태로 접근해봤더니 실제로 열렸습니다.</a:t>
-            </a:r>
-          </a:p>
-          <a:p/>
-          <a:p>
-            <a:r>
-              <a:t>그리고 더 문제인 건, 파일 이름 자체에 고객사 이름이 들어 있다는 겁니다. 신세계 와인앤모어, 이비엠, 산드로, 대아청과, PRENDANG. 파일 이름은 GitHub 검색에도 잡히고 검색엔진에도 노출될 수 있습니다.</a:t>
-            </a:r>
-          </a:p>
-          <a:p/>
-          <a:p>
-            <a:r>
-              <a:t>반대로 디자인 시스템 저장소는 private으로 잠겨 있습니다. 공개할 건 잠겨 있고, 잠글 건 열려 있는 상태입니다.</a:t>
-            </a:r>
-          </a:p>
-          <a:p/>
-          <a:p>
-            <a:r>
-              <a:t>→ 이건 오늘 논의와 별개로 오늘 바로 확인 부탁드립니다.</a:t>
-            </a:r>
-          </a:p>
-        </p:txBody>
-      </p:sp>
-      <p:sp>
-        <p:nvSpPr>
-          <p:cNvPr id="4" name="Slide Number Placeholder 3"/>
-          <p:cNvSpPr>
-            <a:spLocks noGrp="1"/>
-          </p:cNvSpPr>
-          <p:nvPr>
-            <p:ph type="sldNum" idx="5" sz="quarter"/>
-          </p:nvPr>
-        </p:nvSpPr>
-        <p:spPr/>
-      </p:sp>
-    </p:spTree>
-  </p:cSld>
-  <p:clrMapOvr>
-    <a:masterClrMapping/>
-  </p:clrMapOvr>
-</p:notes>
-</file>
-
-<file path=ppt/notesSlides/notesSlide5.xml><?xml version="1.0" encoding="utf-8"?>
-<p:notes xmlns:a="http://schemas.openxmlformats.org/drawingml/2006/main" xmlns:p="http://schemas.openxmlformats.org/presentationml/2006/main" xmlns:r="http://schemas.openxmlformats.org/officeDocument/2006/relationships">
-  <p:cSld>
-    <p:spTree>
-      <p:nvGrpSpPr>
-        <p:cNvPr id="1" name=""/>
-        <p:cNvGrpSpPr/>
-        <p:nvPr/>
-      </p:nvGrpSpPr>
-      <p:grpSpPr>
-        <a:xfrm>
-          <a:off x="0" y="0"/>
-          <a:ext cx="0" cy="0"/>
-          <a:chOff x="0" y="0"/>
-          <a:chExt cx="0" cy="0"/>
-        </a:xfrm>
-      </p:grpSpPr>
-      <p:sp>
-        <p:nvSpPr>
-          <p:cNvPr id="2" name="Slide Image Placeholder 1"/>
-          <p:cNvSpPr>
-            <a:spLocks noGrp="1"/>
-          </p:cNvSpPr>
-          <p:nvPr>
-            <p:ph type="sldImg" idx="2"/>
-          </p:nvPr>
-        </p:nvSpPr>
-        <p:spPr/>
-      </p:sp>
-      <p:sp>
-        <p:nvSpPr>
-          <p:cNvPr id="3" name="Notes Placeholder 2"/>
-          <p:cNvSpPr>
-            <a:spLocks noGrp="1"/>
-          </p:cNvSpPr>
-          <p:nvPr>
-            <p:ph type="body" idx="3" sz="quarter"/>
-          </p:nvPr>
-        </p:nvSpPr>
-        <p:spPr/>
-        <p:txBody>
-          <a:bodyPr/>
-          <a:lstStyle/>
-          <a:p>
-            <a:r>
-              <a:t>저장소별로 세어봤습니다.</a:t>
-            </a:r>
-          </a:p>
-          <a:p/>
-          <a:p>
-            <a:r>
-              <a:t>templates는 35%로 그나마 낫습니다. 스킬이라는 걸 6개 만들어놨기 때문입니다.</a:t>
-            </a:r>
-          </a:p>
-          <a:p>
-            <a:r>
-              <a:t>design-system은 12%.</a:t>
-            </a:r>
-          </a:p>
-          <a:p>
-            <a:r>
-              <a:t>그리고 marketing, design-service, makevu-qrstp는 0%입니다. 하나도 없습니다.</a:t>
-            </a:r>
-          </a:p>
-          <a:p/>
-          <a:p>
-            <a:r>
-              <a:t>makevu-qrstp를 보면 기능이 20개나 되는데 등록된 건 0개입니다. QR 이벤트 만드는 절차가 372줄짜리로 아주 잘 정리돼 있는데, Claude는 그 문서가 있다는 걸 모릅니다.</a:t>
-            </a:r>
-          </a:p>
-          <a:p/>
-          <a:p>
-            <a:r>
-              <a:t>왜 이런 일이 생기는지, 다음 장부터 설명드리겠습니다.</a:t>
-            </a:r>
-          </a:p>
-        </p:txBody>
-      </p:sp>
-      <p:sp>
-        <p:nvSpPr>
-          <p:cNvPr id="4" name="Slide Number Placeholder 3"/>
-          <p:cNvSpPr>
-            <a:spLocks noGrp="1"/>
-          </p:cNvSpPr>
-          <p:nvPr>
-            <p:ph type="sldNum" idx="5" sz="quarter"/>
-          </p:nvPr>
-        </p:nvSpPr>
-        <p:spPr/>
-      </p:sp>
-    </p:spTree>
-  </p:cSld>
-  <p:clrMapOvr>
-    <a:masterClrMapping/>
-  </p:clrMapOvr>
-</p:notes>
-</file>
-
-<file path=ppt/notesSlides/notesSlide6.xml><?xml version="1.0" encoding="utf-8"?>
-<p:notes xmlns:a="http://schemas.openxmlformats.org/drawingml/2006/main" xmlns:p="http://schemas.openxmlformats.org/presentationml/2006/main" xmlns:r="http://schemas.openxmlformats.org/officeDocument/2006/relationships">
-  <p:cSld>
-    <p:spTree>
-      <p:nvGrpSpPr>
-        <p:cNvPr id="1" name=""/>
-        <p:cNvGrpSpPr/>
-        <p:nvPr/>
-      </p:nvGrpSpPr>
-      <p:grpSpPr>
-        <a:xfrm>
-          <a:off x="0" y="0"/>
-          <a:ext cx="0" cy="0"/>
-          <a:chOff x="0" y="0"/>
-          <a:chExt cx="0" cy="0"/>
-        </a:xfrm>
-      </p:grpSpPr>
-      <p:sp>
-        <p:nvSpPr>
-          <p:cNvPr id="2" name="Slide Image Placeholder 1"/>
-          <p:cNvSpPr>
-            <a:spLocks noGrp="1"/>
-          </p:cNvSpPr>
-          <p:nvPr>
-            <p:ph type="sldImg" idx="2"/>
-          </p:nvPr>
-        </p:nvSpPr>
-        <p:spPr/>
-      </p:sp>
-      <p:sp>
-        <p:nvSpPr>
-          <p:cNvPr id="3" name="Notes Placeholder 2"/>
-          <p:cNvSpPr>
-            <a:spLocks noGrp="1"/>
-          </p:cNvSpPr>
-          <p:nvPr>
-            <p:ph type="body" idx="3" sz="quarter"/>
-          </p:nvPr>
-        </p:nvSpPr>
-        <p:spPr/>
-        <p:txBody>
-          <a:bodyPr/>
-          <a:lstStyle/>
-          <a:p>
-            <a:r>
-              <a:t>비유로 설명드리겠습니다. 우리 문서를 도서관이라고 해봅시다.</a:t>
-            </a:r>
-          </a:p>
-          <a:p/>
-          <a:p>
-            <a:r>
-              <a:t>첫째, 책은 훌륭합니다. 465권이 있고 내용도 좋습니다. makevu의 QR 이벤트 제작법은 372줄, design-system의 개발 문서 가이드는 787줄입니다. 정말 꼼꼼하게 쓰여 있습니다.</a:t>
-            </a:r>
-          </a:p>
-          <a:p/>
-          <a:p>
-            <a:r>
-              <a:t>둘째, 그런데 안내판이 없습니다. '룩북 작업을 하려면 3번 서가로 가세요' 같은 표지판이 한 장도 없습니다. 6개 저장소를 다 뒤져봤는데 목차 역할을 하는 파일이 0개였습니다.</a:t>
-            </a:r>
-          </a:p>
-          <a:p/>
-          <a:p>
-            <a:r>
-              <a:t>셋째, 게다가 방이 6개로 나뉘어 있고 서로 문이 잠겨 있습니다. 마케팅 방에서 일하는 사람은 디자인 시스템 방에 뭐가 있는지 볼 수가 없습니다. 그래서 필요한 책을 각자 베껴 갔는데, 베낀 내용이 서로 달라졌습니다. 이건 뒤에서 실제 사례로 보여드리겠습니다.</a:t>
-            </a:r>
-          </a:p>
-          <a:p/>
-          <a:p>
-            <a:r>
-              <a:t>정리하면 — 책을 더 쓸 필요는 없습니다. 안내판을 달고 문을 열어야 합니다.</a:t>
-            </a:r>
-          </a:p>
-        </p:txBody>
-      </p:sp>
-      <p:sp>
-        <p:nvSpPr>
-          <p:cNvPr id="4" name="Slide Number Placeholder 3"/>
-          <p:cNvSpPr>
-            <a:spLocks noGrp="1"/>
-          </p:cNvSpPr>
-          <p:nvPr>
-            <p:ph type="sldNum" idx="5" sz="quarter"/>
-          </p:nvPr>
-        </p:nvSpPr>
-        <p:spPr/>
-      </p:sp>
-    </p:spTree>
-  </p:cSld>
-  <p:clrMapOvr>
-    <a:masterClrMapping/>
-  </p:clrMapOvr>
-</p:notes>
-</file>
-
-<file path=ppt/notesSlides/notesSlide7.xml><?xml version="1.0" encoding="utf-8"?>
-<p:notes xmlns:a="http://schemas.openxmlformats.org/drawingml/2006/main" xmlns:p="http://schemas.openxmlformats.org/presentationml/2006/main" xmlns:r="http://schemas.openxmlformats.org/officeDocument/2006/relationships">
-  <p:cSld>
-    <p:spTree>
-      <p:nvGrpSpPr>
-        <p:cNvPr id="1" name=""/>
-        <p:cNvGrpSpPr/>
-        <p:nvPr/>
-      </p:nvGrpSpPr>
-      <p:grpSpPr>
-        <a:xfrm>
-          <a:off x="0" y="0"/>
-          <a:ext cx="0" cy="0"/>
-          <a:chOff x="0" y="0"/>
-          <a:chExt cx="0" cy="0"/>
-        </a:xfrm>
-      </p:grpSpPr>
-      <p:sp>
-        <p:nvSpPr>
-          <p:cNvPr id="2" name="Slide Image Placeholder 1"/>
-          <p:cNvSpPr>
-            <a:spLocks noGrp="1"/>
-          </p:cNvSpPr>
-          <p:nvPr>
-            <p:ph type="sldImg" idx="2"/>
-          </p:nvPr>
-        </p:nvSpPr>
-        <p:spPr/>
-      </p:sp>
-      <p:sp>
-        <p:nvSpPr>
-          <p:cNvPr id="3" name="Notes Placeholder 2"/>
-          <p:cNvSpPr>
-            <a:spLocks noGrp="1"/>
-          </p:cNvSpPr>
-          <p:nvPr>
-            <p:ph type="body" idx="3" sz="quarter"/>
-          </p:nvPr>
-        </p:nvSpPr>
-        <p:spPr/>
-        <p:txBody>
-          <a:bodyPr/>
-          <a:lstStyle/>
-          <a:p>
-            <a:r>
-              <a:t>이게 오늘 가장 중요한 장입니다.</a:t>
-            </a:r>
-          </a:p>
-          <a:p/>
-          <a:p>
-            <a:r>
-              <a:t>우리는 문서를 쓸 때 위키링크를 많이 씁니다. '색상은 1-3 색상 팔레트 참고' 이런 식으로요.</a:t>
-            </a:r>
-          </a:p>
-          <a:p/>
-          <a:p>
-            <a:r>
-              <a:t>사람은 이걸 보면 궁금하니까 눌러서 열어봅니다. 링크가 실제로 연결 역할을 합니다.</a:t>
-            </a:r>
-          </a:p>
-          <a:p/>
-          <a:p>
-            <a:r>
-              <a:t>그런데 Claude는 다릅니다. Claude에게 그건 그냥 글자입니다. '아 그런 문서가 있구나' 하고 읽고 지나갑니다. 스스로 열지 않습니다.</a:t>
-            </a:r>
-          </a:p>
-          <a:p/>
-          <a:p>
-            <a:r>
-              <a:t>그래서 우리가 아무리 정성껏 '이건 저 문서 참고해'라고 써놔도, Claude는 그 문서를 안 읽은 채로 작업을 시작합니다.</a:t>
-            </a:r>
-          </a:p>
-          <a:p/>
-          <a:p>
-            <a:r>
-              <a:t>여기서 중요한 결론이 나옵니다. 문서를 더 잘 쓰는 걸로는 이 문제가 해결되지 않는다는 겁니다. '읽으라고 시키는 장치'가 따로 필요합니다. 그게 뒤에 나올 '스킬'입니다.</a:t>
-            </a:r>
-          </a:p>
-          <a:p/>
-          <a:p>
-            <a:r>
-              <a:t>참고로 이 표현은 제가 만든 게 아니라, 우리 팀이 이미 작성해둔 문서에 있던 문장입니다.</a:t>
-            </a:r>
-          </a:p>
-        </p:txBody>
-      </p:sp>
-      <p:sp>
-        <p:nvSpPr>
-          <p:cNvPr id="4" name="Slide Number Placeholder 3"/>
-          <p:cNvSpPr>
-            <a:spLocks noGrp="1"/>
-          </p:cNvSpPr>
-          <p:nvPr>
-            <p:ph type="sldNum" idx="5" sz="quarter"/>
-          </p:nvPr>
-        </p:nvSpPr>
-        <p:spPr/>
-      </p:sp>
-    </p:spTree>
-  </p:cSld>
-  <p:clrMapOvr>
-    <a:masterClrMapping/>
-  </p:clrMapOvr>
-</p:notes>
-</file>
-
-<file path=ppt/notesSlides/notesSlide8.xml><?xml version="1.0" encoding="utf-8"?>
-<p:notes xmlns:a="http://schemas.openxmlformats.org/drawingml/2006/main" xmlns:p="http://schemas.openxmlformats.org/presentationml/2006/main" xmlns:r="http://schemas.openxmlformats.org/officeDocument/2006/relationships">
-  <p:cSld>
-    <p:spTree>
-      <p:nvGrpSpPr>
-        <p:cNvPr id="1" name=""/>
-        <p:cNvGrpSpPr/>
-        <p:nvPr/>
-      </p:nvGrpSpPr>
-      <p:grpSpPr>
-        <a:xfrm>
-          <a:off x="0" y="0"/>
-          <a:ext cx="0" cy="0"/>
-          <a:chOff x="0" y="0"/>
-          <a:chExt cx="0" cy="0"/>
-        </a:xfrm>
-      </p:grpSpPr>
-      <p:sp>
-        <p:nvSpPr>
-          <p:cNvPr id="2" name="Slide Image Placeholder 1"/>
-          <p:cNvSpPr>
-            <a:spLocks noGrp="1"/>
-          </p:cNvSpPr>
-          <p:nvPr>
-            <p:ph type="sldImg" idx="2"/>
-          </p:nvPr>
-        </p:nvSpPr>
-        <p:spPr/>
-      </p:sp>
-      <p:sp>
-        <p:nvSpPr>
-          <p:cNvPr id="3" name="Notes Placeholder 2"/>
-          <p:cNvSpPr>
-            <a:spLocks noGrp="1"/>
-          </p:cNvSpPr>
-          <p:nvPr>
-            <p:ph type="body" idx="3" sz="quarter"/>
-          </p:nvPr>
-        </p:nvSpPr>
-        <p:spPr/>
-        <p:txBody>
-          <a:bodyPr/>
-          <a:lstStyle/>
-          <a:p>
-            <a:r>
-              <a:t>이제 원인을 하나씩 보겠습니다. 다섯 가지인데, 첫 번째가 가장 큽니다.</a:t>
-            </a:r>
-          </a:p>
-          <a:p/>
-          <a:p>
-            <a:r>
-              <a:t>Claude는 폴더를 열면 거기 있는 CLAUDE.md 파일과 .claude 폴더를 자동으로 읽습니다. 신입사원에게 첫날 건네는 안내문 같은 겁니다.</a:t>
-            </a:r>
-          </a:p>
-          <a:p/>
-          <a:p>
-            <a:r>
-              <a:t>그런데 우리 맨 바깥 design 폴더에는 그 안내문이 아예 없습니다. .claude 폴더는 만들어져 있는데 안이 텅 비어 있습니다.</a:t>
-            </a:r>
-          </a:p>
-          <a:p/>
-          <a:p>
-            <a:r>
-              <a:t>그래서 제가 이번에 맨 바깥에서 조사를 시작했더니, 우리가 만들어둔 스킬 7개랑 에이전트 19개가 하나도 안 보였습니다.</a:t>
-            </a:r>
-          </a:p>
-          <a:p/>
-          <a:p>
-            <a:r>
-              <a:t>그런데 더 심각한 게 있습니다. 지금 유일하게 동작하는 blog-thumbnail 스킬이 저장소가 아니라 이선호님 컴퓨터의 개인 폴더에 들어 있습니다.</a:t>
-            </a:r>
-          </a:p>
-          <a:p/>
-          <a:p>
-            <a:r>
-              <a:t>이게 무슨 뜻이냐면 — git에 없으니까 팀원이 저장소를 받아도 그 스킬은 안 따라옵니다. 이선호님 컴퓨터에서는 '썸네일 만들어줘'가 되는데, 강현이님 컴퓨터에서는 안 됩니다.</a:t>
-            </a:r>
-          </a:p>
-          <a:p/>
-          <a:p>
-            <a:r>
-              <a:t>'팀원 누가 시켜도 같은 결과'라는 우리 목표와 정면으로 충돌하는 지점입니다.</a:t>
-            </a:r>
-          </a:p>
-        </p:txBody>
-      </p:sp>
-      <p:sp>
-        <p:nvSpPr>
-          <p:cNvPr id="4" name="Slide Number Placeholder 3"/>
-          <p:cNvSpPr>
-            <a:spLocks noGrp="1"/>
-          </p:cNvSpPr>
-          <p:nvPr>
-            <p:ph type="sldNum" idx="5" sz="quarter"/>
-          </p:nvPr>
-        </p:nvSpPr>
-        <p:spPr/>
-      </p:sp>
-    </p:spTree>
-  </p:cSld>
-  <p:clrMapOvr>
-    <a:masterClrMapping/>
-  </p:clrMapOvr>
-</p:notes>
-</file>
-
-<file path=ppt/notesSlides/notesSlide9.xml><?xml version="1.0" encoding="utf-8"?>
-<p:notes xmlns:a="http://schemas.openxmlformats.org/drawingml/2006/main" xmlns:p="http://schemas.openxmlformats.org/presentationml/2006/main" xmlns:r="http://schemas.openxmlformats.org/officeDocument/2006/relationships">
-  <p:cSld>
-    <p:spTree>
-      <p:nvGrpSpPr>
-        <p:cNvPr id="1" name=""/>
-        <p:cNvGrpSpPr/>
-        <p:nvPr/>
-      </p:nvGrpSpPr>
-      <p:grpSpPr>
-        <a:xfrm>
-          <a:off x="0" y="0"/>
-          <a:ext cx="0" cy="0"/>
-          <a:chOff x="0" y="0"/>
-          <a:chExt cx="0" cy="0"/>
-        </a:xfrm>
-      </p:grpSpPr>
-      <p:sp>
-        <p:nvSpPr>
-          <p:cNvPr id="2" name="Slide Image Placeholder 1"/>
-          <p:cNvSpPr>
-            <a:spLocks noGrp="1"/>
-          </p:cNvSpPr>
-          <p:nvPr>
-            <p:ph type="sldImg" idx="2"/>
-          </p:nvPr>
-        </p:nvSpPr>
-        <p:spPr/>
-      </p:sp>
-      <p:sp>
-        <p:nvSpPr>
-          <p:cNvPr id="3" name="Notes Placeholder 2"/>
-          <p:cNvSpPr>
-            <a:spLocks noGrp="1"/>
-          </p:cNvSpPr>
-          <p:nvPr>
-            <p:ph type="body" idx="3" sz="quarter"/>
-          </p:nvPr>
-        </p:nvSpPr>
-        <p:spPr/>
-        <p:txBody>
-          <a:bodyPr/>
-          <a:lstStyle/>
-          <a:p>
-            <a:r>
-              <a:t>두 번째 원인입니다.</a:t>
-            </a:r>
-          </a:p>
-          <a:p/>
-          <a:p>
-            <a:r>
-              <a:t>우리는 볼트를 6개로 일부러 나눴습니다. 온보딩 문서에도 '볼트 간 위키링크는 되지 않습니다, 의도된 설계입니다'라고 적혀 있습니다.</a:t>
-            </a:r>
-          </a:p>
-          <a:p/>
-          <a:p>
-            <a:r>
-              <a:t>사람한테는 괜찮습니다. 볼트 전환하면 되니까요. 그런데 Claude한테는 옆방이 아예 존재하지 않는 것과 같습니다.</a:t>
-            </a:r>
-          </a:p>
-          <a:p/>
-          <a:p>
-            <a:r>
-              <a:t>그래서 실제로 이런 일이 벌어졌습니다.</a:t>
-            </a:r>
-          </a:p>
-          <a:p/>
-          <a:p>
-            <a:r>
-              <a:t>우리 브랜드 그린 색이 지금 두 개입니다.</a:t>
-            </a:r>
-          </a:p>
-          <a:p>
-            <a:r>
-              <a:t>디자인 시스템에는 3DF69B로 정본이 기록돼 있고,</a:t>
-            </a:r>
-          </a:p>
-          <a:p>
-            <a:r>
-              <a:t>마케팅 저장소에는 4DE98B로 적혀 있습니다.</a:t>
-            </a:r>
-          </a:p>
-          <a:p/>
-          <a:p>
-            <a:r>
-              <a:t>왜 이렇게 됐냐면 — 마케팅 담당자가 디자인 시스템 문서를 볼 수가 없으니까 화면을 캡처해서 스포이드로 색을 뽑아 쓴 겁니다. 실제로 작업 기록에 '컬러 시스템 실측값 추출'이라고 적혀 있습니다.</a:t>
-            </a:r>
-          </a:p>
-          <a:p/>
-          <a:p>
-            <a:r>
-              <a:t>두 저장소가 서로를 참조한 기록이 한 건도 없어서, 두 달 넘게 아무도 몰랐습니다.</a:t>
-            </a:r>
-          </a:p>
-          <a:p>
-            <a:r>
-              <a:t>지금도 잘못된 색이 블로그 이미지에 쓰이고 있습니다.</a:t>
-            </a:r>
-          </a:p>
-          <a:p/>
-          <a:p>
-            <a:r>
-              <a:t>그리고 이건 색깔 하나 얘기가 아닙니다. design-service랑 makevu도 templates의 팔레트랑 폰트를 각자 베껴 갔는데, 둘 다 원본 문서 번호를 틀리게 적어놨습니다. 원본이 바뀌어도 추적이 안 됩니다.</a:t>
-            </a:r>
-          </a:p>
-        </p:txBody>
-      </p:sp>
-      <p:sp>
-        <p:nvSpPr>
-          <p:cNvPr id="4" name="Slide Number Placeholder 3"/>
-          <p:cNvSpPr>
-            <a:spLocks noGrp="1"/>
-          </p:cNvSpPr>
-          <p:nvPr>
-            <p:ph type="sldNum" idx="5" sz="quarter"/>
-          </p:nvPr>
-        </p:nvSpPr>
-        <p:spPr/>
-      </p:sp>
-    </p:spTree>
-  </p:cSld>
-  <p:clrMapOvr>
-    <a:masterClrMapping/>
-  </p:clrMapOvr>
-</p:notes>
 </file>
 
 <file path=ppt/slideLayouts/slideLayout1.xml><?xml version="1.0" encoding="utf-8"?>
@@ -24939,324 +22623,4 @@
   </a:objectDefaults>
   <a:extraClrSchemeLst/>
 </a:theme>
-</file>
-
-<file path=ppt/theme/theme2.xml><?xml version="1.0" encoding="utf-8"?>
-<a:theme xmlns:a="http://schemas.openxmlformats.org/drawingml/2006/main" name="Office Theme">
-  <a:themeElements>
-    <a:clrScheme name="Office">
-      <a:dk1>
-        <a:sysClr val="windowText" lastClr="000000"/>
-      </a:dk1>
-      <a:lt1>
-        <a:sysClr val="window" lastClr="FFFFFF"/>
-      </a:lt1>
-      <a:dk2>
-        <a:srgbClr val="1F497D"/>
-      </a:dk2>
-      <a:lt2>
-        <a:srgbClr val="EEECE1"/>
-      </a:lt2>
-      <a:accent1>
-        <a:srgbClr val="4F81BD"/>
-      </a:accent1>
-      <a:accent2>
-        <a:srgbClr val="C0504D"/>
-      </a:accent2>
-      <a:accent3>
-        <a:srgbClr val="9BBB59"/>
-      </a:accent3>
-      <a:accent4>
-        <a:srgbClr val="8064A2"/>
-      </a:accent4>
-      <a:accent5>
-        <a:srgbClr val="4BACC6"/>
-      </a:accent5>
-      <a:accent6>
-        <a:srgbClr val="F79646"/>
-      </a:accent6>
-      <a:hlink>
-        <a:srgbClr val="0000FF"/>
-      </a:hlink>
-      <a:folHlink>
-        <a:srgbClr val="800080"/>
-      </a:folHlink>
-    </a:clrScheme>
-    <a:fontScheme name="Office">
-      <a:majorFont>
-        <a:latin typeface="Calibri"/>
-        <a:ea typeface=""/>
-        <a:cs typeface=""/>
-        <a:font script="Jpan" typeface="ＭＳ Ｐゴシック"/>
-        <a:font script="Hang" typeface="맑은 고딕"/>
-        <a:font script="Hans" typeface="宋体"/>
-        <a:font script="Hant" typeface="新細明體"/>
-        <a:font script="Arab" typeface="Times New Roman"/>
-        <a:font script="Hebr" typeface="Times New Roman"/>
-        <a:font script="Thai" typeface="Angsana New"/>
-        <a:font script="Ethi" typeface="Nyala"/>
-        <a:font script="Beng" typeface="Vrinda"/>
-        <a:font script="Gujr" typeface="Shruti"/>
-        <a:font script="Khmr" typeface="MoolBoran"/>
-        <a:font script="Knda" typeface="Tunga"/>
-        <a:font script="Guru" typeface="Raavi"/>
-        <a:font script="Cans" typeface="Euphemia"/>
-        <a:font script="Cher" typeface="Plantagenet Cherokee"/>
-        <a:font script="Yiii" typeface="Microsoft Yi Baiti"/>
-        <a:font script="Tibt" typeface="Microsoft Himalaya"/>
-        <a:font script="Thaa" typeface="MV Boli"/>
-        <a:font script="Deva" typeface="Mangal"/>
-        <a:font script="Telu" typeface="Gautami"/>
-        <a:font script="Taml" typeface="Latha"/>
-        <a:font script="Syrc" typeface="Estrangelo Edessa"/>
-        <a:font script="Orya" typeface="Kalinga"/>
-        <a:font script="Mlym" typeface="Kartika"/>
-        <a:font script="Laoo" typeface="DokChampa"/>
-        <a:font script="Sinh" typeface="Iskoola Pota"/>
-        <a:font script="Mong" typeface="Mongolian Baiti"/>
-        <a:font script="Viet" typeface="Times New Roman"/>
-        <a:font script="Uigh" typeface="Microsoft Uighur"/>
-        <a:font script="Geor" typeface="Sylfaen"/>
-      </a:majorFont>
-      <a:minorFont>
-        <a:latin typeface="Calibri"/>
-        <a:ea typeface=""/>
-        <a:cs typeface=""/>
-        <a:font script="Jpan" typeface="ＭＳ Ｐゴシック"/>
-        <a:font script="Hang" typeface="맑은 고딕"/>
-        <a:font script="Hans" typeface="宋体"/>
-        <a:font script="Hant" typeface="新細明體"/>
-        <a:font script="Arab" typeface="Arial"/>
-        <a:font script="Hebr" typeface="Arial"/>
-        <a:font script="Thai" typeface="Cordia New"/>
-        <a:font script="Ethi" typeface="Nyala"/>
-        <a:font script="Beng" typeface="Vrinda"/>
-        <a:font script="Gujr" typeface="Shruti"/>
-        <a:font script="Khmr" typeface="DaunPenh"/>
-        <a:font script="Knda" typeface="Tunga"/>
-        <a:font script="Guru" typeface="Raavi"/>
-        <a:font script="Cans" typeface="Euphemia"/>
-        <a:font script="Cher" typeface="Plantagenet Cherokee"/>
-        <a:font script="Yiii" typeface="Microsoft Yi Baiti"/>
-        <a:font script="Tibt" typeface="Microsoft Himalaya"/>
-        <a:font script="Thaa" typeface="MV Boli"/>
-        <a:font script="Deva" typeface="Mangal"/>
-        <a:font script="Telu" typeface="Gautami"/>
-        <a:font script="Taml" typeface="Latha"/>
-        <a:font script="Syrc" typeface="Estrangelo Edessa"/>
-        <a:font script="Orya" typeface="Kalinga"/>
-        <a:font script="Mlym" typeface="Kartika"/>
-        <a:font script="Laoo" typeface="DokChampa"/>
-        <a:font script="Sinh" typeface="Iskoola Pota"/>
-        <a:font script="Mong" typeface="Mongolian Baiti"/>
-        <a:font script="Viet" typeface="Arial"/>
-        <a:font script="Uigh" typeface="Microsoft Uighur"/>
-        <a:font script="Geor" typeface="Sylfaen"/>
-      </a:minorFont>
-    </a:fontScheme>
-    <a:fmtScheme name="Office">
-      <a:fillStyleLst>
-        <a:solidFill>
-          <a:schemeClr val="phClr"/>
-        </a:solidFill>
-        <a:gradFill rotWithShape="1">
-          <a:gsLst>
-            <a:gs pos="0">
-              <a:schemeClr val="phClr">
-                <a:tint val="50000"/>
-                <a:satMod val="300000"/>
-              </a:schemeClr>
-            </a:gs>
-            <a:gs pos="35000">
-              <a:schemeClr val="phClr">
-                <a:tint val="37000"/>
-                <a:satMod val="300000"/>
-              </a:schemeClr>
-            </a:gs>
-            <a:gs pos="100000">
-              <a:schemeClr val="phClr">
-                <a:tint val="15000"/>
-                <a:satMod val="350000"/>
-              </a:schemeClr>
-            </a:gs>
-          </a:gsLst>
-          <a:lin ang="16200000" scaled="1"/>
-        </a:gradFill>
-        <a:gradFill rotWithShape="1">
-          <a:gsLst>
-            <a:gs pos="0">
-              <a:schemeClr val="phClr">
-                <a:tint val="100000"/>
-                <a:shade val="100000"/>
-                <a:satMod val="130000"/>
-              </a:schemeClr>
-            </a:gs>
-            <a:gs pos="100000">
-              <a:schemeClr val="phClr">
-                <a:tint val="50000"/>
-                <a:shade val="100000"/>
-                <a:satMod val="350000"/>
-              </a:schemeClr>
-            </a:gs>
-          </a:gsLst>
-          <a:lin ang="16200000" scaled="0"/>
-        </a:gradFill>
-      </a:fillStyleLst>
-      <a:lnStyleLst>
-        <a:ln w="9525" cap="flat" cmpd="sng" algn="ctr">
-          <a:solidFill>
-            <a:schemeClr val="phClr">
-              <a:shade val="95000"/>
-              <a:satMod val="105000"/>
-            </a:schemeClr>
-          </a:solidFill>
-          <a:prstDash val="solid"/>
-        </a:ln>
-        <a:ln w="25400" cap="flat" cmpd="sng" algn="ctr">
-          <a:solidFill>
-            <a:schemeClr val="phClr"/>
-          </a:solidFill>
-          <a:prstDash val="solid"/>
-        </a:ln>
-        <a:ln w="38100" cap="flat" cmpd="sng" algn="ctr">
-          <a:solidFill>
-            <a:schemeClr val="phClr"/>
-          </a:solidFill>
-          <a:prstDash val="solid"/>
-        </a:ln>
-      </a:lnStyleLst>
-      <a:effectStyleLst>
-        <a:effectStyle>
-          <a:effectLst>
-            <a:outerShdw blurRad="40000" dist="20000" dir="5400000" rotWithShape="0">
-              <a:srgbClr val="000000">
-                <a:alpha val="38000"/>
-              </a:srgbClr>
-            </a:outerShdw>
-          </a:effectLst>
-        </a:effectStyle>
-        <a:effectStyle>
-          <a:effectLst>
-            <a:outerShdw blurRad="40000" dist="23000" dir="5400000" rotWithShape="0">
-              <a:srgbClr val="000000">
-                <a:alpha val="35000"/>
-              </a:srgbClr>
-            </a:outerShdw>
-          </a:effectLst>
-        </a:effectStyle>
-        <a:effectStyle>
-          <a:effectLst>
-            <a:outerShdw blurRad="40000" dist="23000" dir="5400000" rotWithShape="0">
-              <a:srgbClr val="000000">
-                <a:alpha val="35000"/>
-              </a:srgbClr>
-            </a:outerShdw>
-          </a:effectLst>
-          <a:scene3d>
-            <a:camera prst="orthographicFront">
-              <a:rot lat="0" lon="0" rev="0"/>
-            </a:camera>
-            <a:lightRig rig="threePt" dir="t">
-              <a:rot lat="0" lon="0" rev="1200000"/>
-            </a:lightRig>
-          </a:scene3d>
-          <a:sp3d>
-            <a:bevelT w="63500" h="25400"/>
-          </a:sp3d>
-        </a:effectStyle>
-      </a:effectStyleLst>
-      <a:bgFillStyleLst>
-        <a:solidFill>
-          <a:schemeClr val="phClr"/>
-        </a:solidFill>
-        <a:gradFill rotWithShape="1">
-          <a:gsLst>
-            <a:gs pos="0">
-              <a:schemeClr val="phClr">
-                <a:tint val="40000"/>
-                <a:satMod val="350000"/>
-              </a:schemeClr>
-            </a:gs>
-            <a:gs pos="40000">
-              <a:schemeClr val="phClr">
-                <a:tint val="45000"/>
-                <a:shade val="99000"/>
-                <a:satMod val="350000"/>
-              </a:schemeClr>
-            </a:gs>
-            <a:gs pos="100000">
-              <a:schemeClr val="phClr">
-                <a:shade val="20000"/>
-                <a:satMod val="255000"/>
-              </a:schemeClr>
-            </a:gs>
-          </a:gsLst>
-          <a:path path="circle">
-            <a:fillToRect l="50000" t="-80000" r="50000" b="180000"/>
-          </a:path>
-        </a:gradFill>
-        <a:gradFill rotWithShape="1">
-          <a:gsLst>
-            <a:gs pos="0">
-              <a:schemeClr val="phClr">
-                <a:tint val="80000"/>
-                <a:satMod val="300000"/>
-              </a:schemeClr>
-            </a:gs>
-            <a:gs pos="100000">
-              <a:schemeClr val="phClr">
-                <a:shade val="30000"/>
-                <a:satMod val="200000"/>
-              </a:schemeClr>
-            </a:gs>
-          </a:gsLst>
-          <a:path path="circle">
-            <a:fillToRect l="50000" t="50000" r="50000" b="50000"/>
-          </a:path>
-        </a:gradFill>
-      </a:bgFillStyleLst>
-    </a:fmtScheme>
-  </a:themeElements>
-  <a:objectDefaults>
-    <a:spDef>
-      <a:spPr/>
-      <a:bodyPr/>
-      <a:lstStyle/>
-      <a:style>
-        <a:lnRef idx="1">
-          <a:schemeClr val="accent1"/>
-        </a:lnRef>
-        <a:fillRef idx="3">
-          <a:schemeClr val="accent1"/>
-        </a:fillRef>
-        <a:effectRef idx="2">
-          <a:schemeClr val="accent1"/>
-        </a:effectRef>
-        <a:fontRef idx="minor">
-          <a:schemeClr val="lt1"/>
-        </a:fontRef>
-      </a:style>
-    </a:spDef>
-    <a:lnDef>
-      <a:spPr/>
-      <a:bodyPr/>
-      <a:lstStyle/>
-      <a:style>
-        <a:lnRef idx="2">
-          <a:schemeClr val="accent1"/>
-        </a:lnRef>
-        <a:fillRef idx="0">
-          <a:schemeClr val="accent1"/>
-        </a:fillRef>
-        <a:effectRef idx="1">
-          <a:schemeClr val="accent1"/>
-        </a:effectRef>
-        <a:fontRef idx="minor">
-          <a:schemeClr val="tx1"/>
-        </a:fontRef>
-      </a:style>
-    </a:lnDef>
-  </a:objectDefaults>
-  <a:extraClrSchemeLst/>
-</a:theme>
 </file>
</xml_diff>

<commit_message>
vault backup: 2026-08-09 20:26:31
</commit_message>
<xml_diff>
--- a/CdBd 문서 체계 진단 및 개편 제안.pptx
+++ b/CdBd 문서 체계 진단 및 개편 제안.pptx
@@ -4374,7 +4374,7 @@
                 <a:ea typeface="Pretendard"/>
                 <a:cs typeface="Pretendard"/>
               </a:rPr>
-              <a:t>9</a:t>
+              <a:t>10</a:t>
             </a:r>
           </a:p>
         </p:txBody>
@@ -5116,7 +5116,7 @@
                 <a:ea typeface="Pretendard"/>
                 <a:cs typeface="Pretendard"/>
               </a:rPr>
-              <a:t>10</a:t>
+              <a:t>11</a:t>
             </a:r>
           </a:p>
         </p:txBody>
@@ -6024,7 +6024,7 @@
                 <a:ea typeface="Pretendard"/>
                 <a:cs typeface="Pretendard"/>
               </a:rPr>
-              <a:t>11</a:t>
+              <a:t>12</a:t>
             </a:r>
           </a:p>
         </p:txBody>
@@ -6872,7 +6872,7 @@
                 <a:ea typeface="Pretendard"/>
                 <a:cs typeface="Pretendard"/>
               </a:rPr>
-              <a:t>12</a:t>
+              <a:t>13</a:t>
             </a:r>
           </a:p>
         </p:txBody>
@@ -8020,7 +8020,7 @@
                 <a:ea typeface="Pretendard"/>
                 <a:cs typeface="Pretendard"/>
               </a:rPr>
-              <a:t>13</a:t>
+              <a:t>14</a:t>
             </a:r>
           </a:p>
         </p:txBody>
@@ -9188,7 +9188,7 @@
                 <a:ea typeface="Pretendard"/>
                 <a:cs typeface="Pretendard"/>
               </a:rPr>
-              <a:t>14</a:t>
+              <a:t>15</a:t>
             </a:r>
           </a:p>
         </p:txBody>
@@ -10096,7 +10096,7 @@
                 <a:ea typeface="Pretendard"/>
                 <a:cs typeface="Pretendard"/>
               </a:rPr>
-              <a:t>15</a:t>
+              <a:t>16</a:t>
             </a:r>
           </a:p>
         </p:txBody>
@@ -11642,7 +11642,7 @@
                 <a:ea typeface="Pretendard"/>
                 <a:cs typeface="Pretendard"/>
               </a:rPr>
-              <a:t>16</a:t>
+              <a:t>17</a:t>
             </a:r>
           </a:p>
         </p:txBody>
@@ -13569,7 +13569,7 @@
                 <a:ea typeface="Pretendard"/>
                 <a:cs typeface="Pretendard"/>
               </a:rPr>
-              <a:t>17</a:t>
+              <a:t>19</a:t>
             </a:r>
           </a:p>
         </p:txBody>
@@ -14281,7 +14281,7 @@
                 <a:ea typeface="Pretendard"/>
                 <a:cs typeface="Pretendard"/>
               </a:rPr>
-              <a:t>6 – 9</a:t>
+              <a:t>6 – 8</a:t>
             </a:r>
           </a:p>
         </p:txBody>
@@ -14559,7 +14559,7 @@
                 <a:ea typeface="Pretendard"/>
                 <a:cs typeface="Pretendard"/>
               </a:rPr>
-              <a:t>10 – 17</a:t>
+              <a:t>9 – 17</a:t>
             </a:r>
           </a:p>
         </p:txBody>
@@ -14790,7 +14790,7 @@
                 <a:ea typeface="Pretendard"/>
                 <a:cs typeface="Pretendard"/>
               </a:rPr>
-              <a:t>가볍게 시작하는 안 / 근본적으로 고치는 안</a:t>
+              <a:t>가볍게 시작하는 안 / 근본적으로 고치는 안 + 구조도</a:t>
             </a:r>
           </a:p>
         </p:txBody>
@@ -15021,7 +15021,7 @@
                 <a:ea typeface="Pretendard"/>
                 <a:cs typeface="Pretendard"/>
               </a:rPr>
-              <a:t>즉시 조치 · 마무리</a:t>
+              <a:t>비교 · 즉시 조치</a:t>
             </a:r>
           </a:p>
         </p:txBody>
@@ -15068,7 +15068,7 @@
                 <a:ea typeface="Pretendard"/>
                 <a:cs typeface="Pretendard"/>
               </a:rPr>
-              <a:t>어느 방식을 택하든 지금 해야 할 것</a:t>
+              <a:t>두 방식 비교와, 어느 쪽이든 지금 해야 할 것</a:t>
             </a:r>
           </a:p>
         </p:txBody>
@@ -15115,7 +15115,7 @@
                 <a:ea typeface="Pretendard"/>
                 <a:cs typeface="Pretendard"/>
               </a:rPr>
-              <a:t>24 – 25</a:t>
+              <a:t>24 – 26</a:t>
             </a:r>
           </a:p>
         </p:txBody>
@@ -15162,7 +15162,7 @@
                 <a:ea typeface="Pretendard"/>
                 <a:cs typeface="Pretendard"/>
               </a:rPr>
-              <a:t>총 25장 · 15~20분  ·  가장 중요한 장은 03번입니다. 원인을 알아야 어느 해결안이 맞는지 판단하실 수 있습니다.</a:t>
+              <a:t>총 26장 · 20~25분  ·  가장 중요한 장은 03번입니다. 원인을 알아야 어느 해결안이 맞는지 판단하실 수 있습니다.</a:t>
             </a:r>
           </a:p>
         </p:txBody>
@@ -16764,7 +16764,7 @@
                 <a:ea typeface="Pretendard"/>
                 <a:cs typeface="Pretendard"/>
               </a:rPr>
-              <a:t>18</a:t>
+              <a:t>20</a:t>
             </a:r>
           </a:p>
         </p:txBody>
@@ -17981,7 +17981,7 @@
                 <a:ea typeface="Pretendard"/>
                 <a:cs typeface="Pretendard"/>
               </a:rPr>
-              <a:t>19</a:t>
+              <a:t>21</a:t>
             </a:r>
           </a:p>
         </p:txBody>
@@ -20185,7 +20185,7 @@
                 <a:ea typeface="Pretendard"/>
                 <a:cs typeface="Pretendard"/>
               </a:rPr>
-              <a:t>20</a:t>
+              <a:t>22</a:t>
             </a:r>
           </a:p>
         </p:txBody>
@@ -21352,7 +21352,7 @@
                 <a:ea typeface="Pretendard"/>
                 <a:cs typeface="Pretendard"/>
               </a:rPr>
-              <a:t>21</a:t>
+              <a:t>23</a:t>
             </a:r>
           </a:p>
         </p:txBody>
@@ -23045,7 +23045,7 @@
                 <a:ea typeface="Pretendard"/>
                 <a:cs typeface="Pretendard"/>
               </a:rPr>
-              <a:t>22</a:t>
+              <a:t>24</a:t>
             </a:r>
           </a:p>
         </p:txBody>
@@ -24385,7 +24385,7 @@
                 <a:ea typeface="Pretendard"/>
                 <a:cs typeface="Pretendard"/>
               </a:rPr>
-              <a:t>23</a:t>
+              <a:t>25</a:t>
             </a:r>
           </a:p>
         </p:txBody>
@@ -24892,7 +24892,7 @@
                 <a:ea typeface="Pretendard"/>
                 <a:cs typeface="Pretendard"/>
               </a:rPr>
-              <a:t>24</a:t>
+              <a:t>26</a:t>
             </a:r>
           </a:p>
         </p:txBody>
@@ -25443,7 +25443,7 @@
                 <a:ea typeface="Pretendard"/>
                 <a:cs typeface="Pretendard"/>
               </a:rPr>
-              <a:t>2</a:t>
+              <a:t>3</a:t>
             </a:r>
           </a:p>
         </p:txBody>
@@ -27330,7 +27330,7 @@
                 <a:ea typeface="Pretendard"/>
                 <a:cs typeface="Pretendard"/>
               </a:rPr>
-              <a:t>3</a:t>
+              <a:t>4</a:t>
             </a:r>
           </a:p>
         </p:txBody>
@@ -28606,7 +28606,7 @@
                 <a:ea typeface="Pretendard"/>
                 <a:cs typeface="Pretendard"/>
               </a:rPr>
-              <a:t>4</a:t>
+              <a:t>5</a:t>
             </a:r>
           </a:p>
         </p:txBody>
@@ -29772,7 +29772,7 @@
                 <a:ea typeface="Pretendard"/>
                 <a:cs typeface="Pretendard"/>
               </a:rPr>
-              <a:t>5</a:t>
+              <a:t>6</a:t>
             </a:r>
           </a:p>
         </p:txBody>
@@ -30917,7 +30917,7 @@
                 <a:ea typeface="Pretendard"/>
                 <a:cs typeface="Pretendard"/>
               </a:rPr>
-              <a:t>6</a:t>
+              <a:t>7</a:t>
             </a:r>
           </a:p>
         </p:txBody>
@@ -31825,7 +31825,7 @@
                 <a:ea typeface="Pretendard"/>
                 <a:cs typeface="Pretendard"/>
               </a:rPr>
-              <a:t>7</a:t>
+              <a:t>8</a:t>
             </a:r>
           </a:p>
         </p:txBody>
@@ -33192,7 +33192,7 @@
                 <a:ea typeface="Pretendard"/>
                 <a:cs typeface="Pretendard"/>
               </a:rPr>
-              <a:t>8</a:t>
+              <a:t>9</a:t>
             </a:r>
           </a:p>
         </p:txBody>

</xml_diff>

<commit_message>
vault backup: 2026-08-09 20:27:40
</commit_message>
<xml_diff>
--- a/CdBd 문서 체계 진단 및 개편 제안.pptx
+++ b/CdBd 문서 체계 진단 및 개편 제안.pptx
@@ -8238,7 +8238,7 @@
         </p:nvGraphicFramePr>
         <p:xfrm>
           <a:off x="777240" y="2286000"/>
-          <a:ext cx="10634472" cy="2011680"/>
+          <a:ext cx="10634472" cy="1828800"/>
         </p:xfrm>
         <a:graphic>
           <a:graphicData uri="http://schemas.openxmlformats.org/drawingml/2006/table">
@@ -8252,7 +8252,7 @@
                 <a:gridCol w="1645920"/>
                 <a:gridCol w="1490472"/>
               </a:tblGrid>
-              <a:tr h="402336">
+              <a:tr h="365760">
                 <a:tc>
                   <a:txBody>
                     <a:bodyPr/>
@@ -8370,7 +8370,7 @@
                   </a:tcPr>
                 </a:tc>
               </a:tr>
-              <a:tr h="402336">
+              <a:tr h="365760">
                 <a:tc>
                   <a:txBody>
                     <a:bodyPr/>
@@ -8488,7 +8488,7 @@
                   </a:tcPr>
                 </a:tc>
               </a:tr>
-              <a:tr h="402336">
+              <a:tr h="365760">
                 <a:tc>
                   <a:txBody>
                     <a:bodyPr/>
@@ -8606,7 +8606,7 @@
                   </a:tcPr>
                 </a:tc>
               </a:tr>
-              <a:tr h="402336">
+              <a:tr h="365760">
                 <a:tc>
                   <a:txBody>
                     <a:bodyPr/>
@@ -8724,7 +8724,7 @@
                   </a:tcPr>
                 </a:tc>
               </a:tr>
-              <a:tr h="402336">
+              <a:tr h="365760">
                 <a:tc>
                   <a:txBody>
                     <a:bodyPr/>
@@ -8854,7 +8854,7 @@
         </p:nvSpPr>
         <p:spPr>
           <a:xfrm>
-            <a:off x="777240" y="4160520"/>
+            <a:off x="777240" y="4279392"/>
             <a:ext cx="10607040" cy="274320"/>
           </a:xfrm>
           <a:prstGeom prst="rect">
@@ -8901,7 +8901,7 @@
         </p:nvSpPr>
         <p:spPr>
           <a:xfrm>
-            <a:off x="777240" y="4553712"/>
+            <a:off x="777240" y="4645152"/>
             <a:ext cx="10607040" cy="1645920"/>
           </a:xfrm>
           <a:prstGeom prst="rect">
@@ -18326,7 +18326,7 @@
             </a:r>
           </a:p>
           <a:p>
-            <a:pPr>
+            <a:pPr algn="ctr">
               <a:lnSpc>
                 <a:spcPct val="150000"/>
               </a:lnSpc>
@@ -18350,7 +18350,7 @@
             </a:r>
           </a:p>
           <a:p>
-            <a:pPr>
+            <a:pPr algn="ctr">
               <a:lnSpc>
                 <a:spcPct val="150000"/>
               </a:lnSpc>
@@ -18646,7 +18646,7 @@
             </a:r>
           </a:p>
           <a:p>
-            <a:pPr>
+            <a:pPr algn="ctr">
               <a:lnSpc>
                 <a:spcPct val="125000"/>
               </a:lnSpc>
@@ -18945,7 +18945,7 @@
             </a:r>
           </a:p>
           <a:p>
-            <a:pPr>
+            <a:pPr algn="ctr">
               <a:lnSpc>
                 <a:spcPct val="125000"/>
               </a:lnSpc>
@@ -19244,7 +19244,7 @@
             </a:r>
           </a:p>
           <a:p>
-            <a:pPr>
+            <a:pPr algn="ctr">
               <a:lnSpc>
                 <a:spcPct val="125000"/>
               </a:lnSpc>
@@ -19543,7 +19543,7 @@
             </a:r>
           </a:p>
           <a:p>
-            <a:pPr>
+            <a:pPr algn="ctr">
               <a:lnSpc>
                 <a:spcPct val="125000"/>
               </a:lnSpc>
@@ -19842,7 +19842,7 @@
             </a:r>
           </a:p>
           <a:p>
-            <a:pPr>
+            <a:pPr algn="ctr">
               <a:lnSpc>
                 <a:spcPct val="125000"/>
               </a:lnSpc>

</xml_diff>

<commit_message>
vault backup: 2026-08-09 20:50:23
</commit_message>
<xml_diff>
--- a/CdBd 문서 체계 진단 및 개편 제안.pptx
+++ b/CdBd 문서 체계 진단 및 개편 제안.pptx
@@ -13869,7 +13869,7 @@
                 <a:ea typeface="Pretendard"/>
                 <a:cs typeface="Pretendard"/>
               </a:rPr>
-              <a:t>9 – 17</a:t>
+              <a:t>9 – 18</a:t>
             </a:r>
           </a:p>
         </p:txBody>
@@ -14147,7 +14147,7 @@
                 <a:ea typeface="Pretendard"/>
                 <a:cs typeface="Pretendard"/>
               </a:rPr>
-              <a:t>18 – 23</a:t>
+              <a:t>19 – 24</a:t>
             </a:r>
           </a:p>
         </p:txBody>
@@ -14425,7 +14425,7 @@
                 <a:ea typeface="Pretendard"/>
                 <a:cs typeface="Pretendard"/>
               </a:rPr>
-              <a:t>24 – 26</a:t>
+              <a:t>25 – 27</a:t>
             </a:r>
           </a:p>
         </p:txBody>
@@ -14472,7 +14472,7 @@
                 <a:ea typeface="Pretendard"/>
                 <a:cs typeface="Pretendard"/>
               </a:rPr>
-              <a:t>총 26장 · 20~25분  ·  가장 중요한 장은 03번입니다. 원인을 알아야 어느 해결안이 맞는지 판단하실 수 있습니다.</a:t>
+              <a:t>총 27장 · 20~25분  ·  가장 중요한 장은 03번입니다. 원인을 알아야 어느 해결안이 맞는지 판단하실 수 있습니다.</a:t>
             </a:r>
           </a:p>
         </p:txBody>
@@ -17051,7 +17051,7 @@
                 <a:ea typeface="Pretendard"/>
                 <a:cs typeface="Pretendard"/>
               </a:rPr>
-              <a:t>gstack·blog-thumbnail을 git에. 로그인 정보는 .env.example로 “여기에 이렇게 넣으세요” 안내.</a:t>
+              <a:t>gstack·blog-thumbnail을 git에. 로그인 정보는 .env.example로 안내. CdBd 전용 플러그인 마켓플레이스도 선택지.</a:t>
             </a:r>
           </a:p>
         </p:txBody>

</xml_diff>

<commit_message>
vault backup: 2026-08-09 20:51:33
</commit_message>
<xml_diff>
--- a/CdBd 문서 체계 진단 및 개편 제안.pptx
+++ b/CdBd 문서 체계 진단 및 개편 제안.pptx
@@ -5626,8 +5626,8 @@
           <p:nvPr/>
         </p:nvGraphicFramePr>
         <p:xfrm>
-          <a:off x="777240" y="4206240"/>
-          <a:ext cx="10634472" cy="1828800"/>
+          <a:off x="777240" y="4160520"/>
+          <a:ext cx="10634472" cy="1609344"/>
         </p:xfrm>
         <a:graphic>
           <a:graphicData uri="http://schemas.openxmlformats.org/drawingml/2006/table">
@@ -5639,7 +5639,7 @@
                 <a:gridCol w="4572000"/>
                 <a:gridCol w="6062472"/>
               </a:tblGrid>
-              <a:tr h="457200">
+              <a:tr h="402336">
                 <a:tc>
                   <a:txBody>
                     <a:bodyPr/>
@@ -5651,7 +5651,7 @@
                         </a:lnSpc>
                       </a:pPr>
                       <a:r>
-                        <a:rPr sz="1300" b="1">
+                        <a:rPr sz="1250" b="1">
                           <a:solidFill>
                             <a:srgbClr val="FFFFFF"/>
                           </a:solidFill>
@@ -5680,7 +5680,7 @@
                         </a:lnSpc>
                       </a:pPr>
                       <a:r>
-                        <a:rPr sz="1300" b="1">
+                        <a:rPr sz="1250" b="1">
                           <a:solidFill>
                             <a:srgbClr val="FFFFFF"/>
                           </a:solidFill>
@@ -5699,7 +5699,7 @@
                   </a:tcPr>
                 </a:tc>
               </a:tr>
-              <a:tr h="457200">
+              <a:tr h="402336">
                 <a:tc>
                   <a:txBody>
                     <a:bodyPr/>
@@ -5711,7 +5711,7 @@
                         </a:lnSpc>
                       </a:pPr>
                       <a:r>
-                        <a:rPr sz="1300" b="0">
+                        <a:rPr sz="1250" b="0">
                           <a:solidFill>
                             <a:srgbClr val="292929"/>
                           </a:solidFill>
@@ -5740,7 +5740,7 @@
                         </a:lnSpc>
                       </a:pPr>
                       <a:r>
-                        <a:rPr sz="1300" b="0">
+                        <a:rPr sz="1250" b="0">
                           <a:solidFill>
                             <a:srgbClr val="292929"/>
                           </a:solidFill>
@@ -5759,7 +5759,7 @@
                   </a:tcPr>
                 </a:tc>
               </a:tr>
-              <a:tr h="457200">
+              <a:tr h="402336">
                 <a:tc>
                   <a:txBody>
                     <a:bodyPr/>
@@ -5771,7 +5771,7 @@
                         </a:lnSpc>
                       </a:pPr>
                       <a:r>
-                        <a:rPr sz="1300" b="0">
+                        <a:rPr sz="1250" b="0">
                           <a:solidFill>
                             <a:srgbClr val="292929"/>
                           </a:solidFill>
@@ -5800,7 +5800,7 @@
                         </a:lnSpc>
                       </a:pPr>
                       <a:r>
-                        <a:rPr sz="1300" b="0">
+                        <a:rPr sz="1250" b="0">
                           <a:solidFill>
                             <a:srgbClr val="292929"/>
                           </a:solidFill>
@@ -5819,7 +5819,7 @@
                   </a:tcPr>
                 </a:tc>
               </a:tr>
-              <a:tr h="457200">
+              <a:tr h="402336">
                 <a:tc>
                   <a:txBody>
                     <a:bodyPr/>
@@ -5831,7 +5831,7 @@
                         </a:lnSpc>
                       </a:pPr>
                       <a:r>
-                        <a:rPr sz="1300" b="0">
+                        <a:rPr sz="1250" b="0">
                           <a:solidFill>
                             <a:srgbClr val="292929"/>
                           </a:solidFill>
@@ -5860,7 +5860,7 @@
                         </a:lnSpc>
                       </a:pPr>
                       <a:r>
-                        <a:rPr sz="1300" b="0">
+                        <a:rPr sz="1250" b="0">
                           <a:solidFill>
                             <a:srgbClr val="292929"/>
                           </a:solidFill>
@@ -5891,8 +5891,8 @@
         </p:nvSpPr>
         <p:spPr>
           <a:xfrm>
-            <a:off x="777240" y="5806440"/>
-            <a:ext cx="10634472" cy="548640"/>
+            <a:off x="777240" y="5888736"/>
+            <a:ext cx="10634472" cy="502920"/>
           </a:xfrm>
           <a:prstGeom prst="rect">
             <a:avLst/>
@@ -5935,7 +5935,7 @@
         </p:nvSpPr>
         <p:spPr>
           <a:xfrm>
-            <a:off x="1051560" y="5961888"/>
+            <a:off x="1051560" y="6016752"/>
             <a:ext cx="10241280" cy="274320"/>
           </a:xfrm>
           <a:prstGeom prst="rect">

</xml_diff>

<commit_message>
vault backup: 2026-08-09 20:57:01
</commit_message>
<xml_diff>
--- a/CdBd 문서 체계 진단 및 개편 제안.pptx
+++ b/CdBd 문서 체계 진단 및 개편 제안.pptx
@@ -8336,7 +8336,7 @@
                           <a:ea typeface="Pretendard"/>
                           <a:cs typeface="Pretendard"/>
                         </a:rPr>
-                        <a:t>2.9 KB</a:t>
+                        <a:t>3.9 KB</a:t>
                       </a:r>
                     </a:p>
                   </a:txBody>
@@ -8365,7 +8365,7 @@
                           <a:ea typeface="Pretendard"/>
                           <a:cs typeface="Pretendard"/>
                         </a:rPr>
-                        <a:t>A4 1장</a:t>
+                        <a:t>A4 2장</a:t>
                       </a:r>
                     </a:p>
                   </a:txBody>
@@ -8394,7 +8394,7 @@
                           <a:ea typeface="Pretendard"/>
                           <a:cs typeface="Pretendard"/>
                         </a:rPr>
-                        <a:t>기능 12개 중 썸네일 1개만 다룸</a:t>
+                        <a:t>기능 26개 중 썸네일 관련만 다룸</a:t>
                       </a:r>
                     </a:p>
                   </a:txBody>
@@ -13544,7 +13544,7 @@
                 <a:ea typeface="Pretendard"/>
                 <a:cs typeface="Pretendard"/>
               </a:rPr>
-              <a:t>기능 82개 중 Claude가 아는 건 7개 — 왜 그런지</a:t>
+              <a:t>기능 96개 중 Claude가 아는 건 7개 — 왜 그런지</a:t>
             </a:r>
           </a:p>
         </p:txBody>

</xml_diff>

<commit_message>
vault backup: 2026-08-09 20:58:08
</commit_message>
<xml_diff>
--- a/CdBd 문서 체계 진단 및 개편 제안.pptx
+++ b/CdBd 문서 체계 진단 및 개편 제안.pptx
@@ -3362,7 +3362,7 @@
                 <a:ea typeface="Pretendard"/>
                 <a:cs typeface="Pretendard"/>
               </a:rPr>
-              <a:t>저장소 9개 · 문서 465개 전수 조사 결과와 개편 제안</a:t>
+              <a:t>저장소 10개 · 마크다운 문서 450여 개 전수 조사 결과와 개편 제안</a:t>
             </a:r>
           </a:p>
           <a:p>
@@ -26636,7 +26636,7 @@
                 <a:ea typeface="Pretendard"/>
                 <a:cs typeface="Pretendard"/>
               </a:rPr>
-              <a:t>ONBOARDING.md는 6개라고 안내하지만, GitHub 계정을 조회해보니 실제로는 9개였습니다.</a:t>
+              <a:t>ONBOARDING.md는 6개라고 안내하지만, 실제로는 10개였습니다. (4개는 아무도 모르고 있던 것)</a:t>
             </a:r>
           </a:p>
         </p:txBody>
@@ -26651,7 +26651,7 @@
         </p:nvGraphicFramePr>
         <p:xfrm>
           <a:off x="777240" y="2212848"/>
-          <a:ext cx="10634472" cy="3383280"/>
+          <a:ext cx="10634472" cy="3419856"/>
         </p:xfrm>
         <a:graphic>
           <a:graphicData uri="http://schemas.openxmlformats.org/drawingml/2006/table">
@@ -26666,7 +26666,7 @@
                 <a:gridCol w="1371600"/>
                 <a:gridCol w="2404872"/>
               </a:tblGrid>
-              <a:tr h="338328">
+              <a:tr h="310896">
                 <a:tc>
                   <a:txBody>
                     <a:bodyPr/>
@@ -26678,7 +26678,7 @@
                         </a:lnSpc>
                       </a:pPr>
                       <a:r>
-                        <a:rPr sz="1200" b="1">
+                        <a:rPr sz="1150" b="1">
                           <a:solidFill>
                             <a:srgbClr val="FFFFFF"/>
                           </a:solidFill>
@@ -26707,7 +26707,7 @@
                         </a:lnSpc>
                       </a:pPr>
                       <a:r>
-                        <a:rPr sz="1200" b="1">
+                        <a:rPr sz="1150" b="1">
                           <a:solidFill>
                             <a:srgbClr val="FFFFFF"/>
                           </a:solidFill>
@@ -26736,7 +26736,7 @@
                         </a:lnSpc>
                       </a:pPr>
                       <a:r>
-                        <a:rPr sz="1200" b="1">
+                        <a:rPr sz="1150" b="1">
                           <a:solidFill>
                             <a:srgbClr val="FFFFFF"/>
                           </a:solidFill>
@@ -26765,7 +26765,7 @@
                         </a:lnSpc>
                       </a:pPr>
                       <a:r>
-                        <a:rPr sz="1200" b="1">
+                        <a:rPr sz="1150" b="1">
                           <a:solidFill>
                             <a:srgbClr val="FFFFFF"/>
                           </a:solidFill>
@@ -26794,7 +26794,7 @@
                         </a:lnSpc>
                       </a:pPr>
                       <a:r>
-                        <a:rPr sz="1200" b="1">
+                        <a:rPr sz="1150" b="1">
                           <a:solidFill>
                             <a:srgbClr val="FFFFFF"/>
                           </a:solidFill>
@@ -26813,7 +26813,7 @@
                   </a:tcPr>
                 </a:tc>
               </a:tr>
-              <a:tr h="338328">
+              <a:tr h="310896">
                 <a:tc>
                   <a:txBody>
                     <a:bodyPr/>
@@ -26825,7 +26825,7 @@
                         </a:lnSpc>
                       </a:pPr>
                       <a:r>
-                        <a:rPr sz="1200" b="0">
+                        <a:rPr sz="1150" b="0">
                           <a:solidFill>
                             <a:srgbClr val="292929"/>
                           </a:solidFill>
@@ -26854,7 +26854,7 @@
                         </a:lnSpc>
                       </a:pPr>
                       <a:r>
-                        <a:rPr sz="1200" b="0">
+                        <a:rPr sz="1150" b="0">
                           <a:solidFill>
                             <a:srgbClr val="292929"/>
                           </a:solidFill>
@@ -26883,7 +26883,7 @@
                         </a:lnSpc>
                       </a:pPr>
                       <a:r>
-                        <a:rPr sz="1200" b="0">
+                        <a:rPr sz="1150" b="0">
                           <a:solidFill>
                             <a:srgbClr val="292929"/>
                           </a:solidFill>
@@ -26912,7 +26912,7 @@
                         </a:lnSpc>
                       </a:pPr>
                       <a:r>
-                        <a:rPr sz="1200" b="0">
+                        <a:rPr sz="1150" b="0">
                           <a:solidFill>
                             <a:srgbClr val="292929"/>
                           </a:solidFill>
@@ -26941,7 +26941,7 @@
                         </a:lnSpc>
                       </a:pPr>
                       <a:r>
-                        <a:rPr sz="1200" b="0">
+                        <a:rPr sz="1150" b="0">
                           <a:solidFill>
                             <a:srgbClr val="292929"/>
                           </a:solidFill>
@@ -26960,7 +26960,7 @@
                   </a:tcPr>
                 </a:tc>
               </a:tr>
-              <a:tr h="338328">
+              <a:tr h="310896">
                 <a:tc>
                   <a:txBody>
                     <a:bodyPr/>
@@ -26972,7 +26972,7 @@
                         </a:lnSpc>
                       </a:pPr>
                       <a:r>
-                        <a:rPr sz="1200" b="0">
+                        <a:rPr sz="1150" b="0">
                           <a:solidFill>
                             <a:srgbClr val="292929"/>
                           </a:solidFill>
@@ -27001,7 +27001,7 @@
                         </a:lnSpc>
                       </a:pPr>
                       <a:r>
-                        <a:rPr sz="1200" b="0">
+                        <a:rPr sz="1150" b="0">
                           <a:solidFill>
                             <a:srgbClr val="292929"/>
                           </a:solidFill>
@@ -27030,7 +27030,7 @@
                         </a:lnSpc>
                       </a:pPr>
                       <a:r>
-                        <a:rPr sz="1200" b="0">
+                        <a:rPr sz="1150" b="0">
                           <a:solidFill>
                             <a:srgbClr val="292929"/>
                           </a:solidFill>
@@ -27059,7 +27059,7 @@
                         </a:lnSpc>
                       </a:pPr>
                       <a:r>
-                        <a:rPr sz="1200" b="0">
+                        <a:rPr sz="1150" b="0">
                           <a:solidFill>
                             <a:srgbClr val="292929"/>
                           </a:solidFill>
@@ -27088,7 +27088,7 @@
                         </a:lnSpc>
                       </a:pPr>
                       <a:r>
-                        <a:rPr sz="1200" b="0">
+                        <a:rPr sz="1150" b="0">
                           <a:solidFill>
                             <a:srgbClr val="292929"/>
                           </a:solidFill>
@@ -27107,7 +27107,7 @@
                   </a:tcPr>
                 </a:tc>
               </a:tr>
-              <a:tr h="338328">
+              <a:tr h="310896">
                 <a:tc>
                   <a:txBody>
                     <a:bodyPr/>
@@ -27119,7 +27119,7 @@
                         </a:lnSpc>
                       </a:pPr>
                       <a:r>
-                        <a:rPr sz="1200" b="0">
+                        <a:rPr sz="1150" b="0">
                           <a:solidFill>
                             <a:srgbClr val="292929"/>
                           </a:solidFill>
@@ -27148,7 +27148,7 @@
                         </a:lnSpc>
                       </a:pPr>
                       <a:r>
-                        <a:rPr sz="1200" b="0">
+                        <a:rPr sz="1150" b="0">
                           <a:solidFill>
                             <a:srgbClr val="292929"/>
                           </a:solidFill>
@@ -27177,7 +27177,7 @@
                         </a:lnSpc>
                       </a:pPr>
                       <a:r>
-                        <a:rPr sz="1200" b="0">
+                        <a:rPr sz="1150" b="0">
                           <a:solidFill>
                             <a:srgbClr val="292929"/>
                           </a:solidFill>
@@ -27206,7 +27206,7 @@
                         </a:lnSpc>
                       </a:pPr>
                       <a:r>
-                        <a:rPr sz="1200" b="0">
+                        <a:rPr sz="1150" b="0">
                           <a:solidFill>
                             <a:srgbClr val="292929"/>
                           </a:solidFill>
@@ -27235,7 +27235,7 @@
                         </a:lnSpc>
                       </a:pPr>
                       <a:r>
-                        <a:rPr sz="1200" b="0">
+                        <a:rPr sz="1150" b="0">
                           <a:solidFill>
                             <a:srgbClr val="292929"/>
                           </a:solidFill>
@@ -27254,7 +27254,7 @@
                   </a:tcPr>
                 </a:tc>
               </a:tr>
-              <a:tr h="338328">
+              <a:tr h="310896">
                 <a:tc>
                   <a:txBody>
                     <a:bodyPr/>
@@ -27266,7 +27266,7 @@
                         </a:lnSpc>
                       </a:pPr>
                       <a:r>
-                        <a:rPr sz="1200" b="0">
+                        <a:rPr sz="1150" b="0">
                           <a:solidFill>
                             <a:srgbClr val="292929"/>
                           </a:solidFill>
@@ -27295,7 +27295,7 @@
                         </a:lnSpc>
                       </a:pPr>
                       <a:r>
-                        <a:rPr sz="1200" b="0">
+                        <a:rPr sz="1150" b="0">
                           <a:solidFill>
                             <a:srgbClr val="292929"/>
                           </a:solidFill>
@@ -27324,7 +27324,7 @@
                         </a:lnSpc>
                       </a:pPr>
                       <a:r>
-                        <a:rPr sz="1200" b="0">
+                        <a:rPr sz="1150" b="0">
                           <a:solidFill>
                             <a:srgbClr val="292929"/>
                           </a:solidFill>
@@ -27353,7 +27353,7 @@
                         </a:lnSpc>
                       </a:pPr>
                       <a:r>
-                        <a:rPr sz="1200" b="0">
+                        <a:rPr sz="1150" b="0">
                           <a:solidFill>
                             <a:srgbClr val="292929"/>
                           </a:solidFill>
@@ -27382,7 +27382,7 @@
                         </a:lnSpc>
                       </a:pPr>
                       <a:r>
-                        <a:rPr sz="1200" b="0">
+                        <a:rPr sz="1150" b="0">
                           <a:solidFill>
                             <a:srgbClr val="292929"/>
                           </a:solidFill>
@@ -27401,7 +27401,7 @@
                   </a:tcPr>
                 </a:tc>
               </a:tr>
-              <a:tr h="338328">
+              <a:tr h="310896">
                 <a:tc>
                   <a:txBody>
                     <a:bodyPr/>
@@ -27413,7 +27413,7 @@
                         </a:lnSpc>
                       </a:pPr>
                       <a:r>
-                        <a:rPr sz="1200" b="0">
+                        <a:rPr sz="1150" b="0">
                           <a:solidFill>
                             <a:srgbClr val="292929"/>
                           </a:solidFill>
@@ -27442,7 +27442,7 @@
                         </a:lnSpc>
                       </a:pPr>
                       <a:r>
-                        <a:rPr sz="1200" b="0">
+                        <a:rPr sz="1150" b="0">
                           <a:solidFill>
                             <a:srgbClr val="292929"/>
                           </a:solidFill>
@@ -27471,7 +27471,7 @@
                         </a:lnSpc>
                       </a:pPr>
                       <a:r>
-                        <a:rPr sz="1200" b="0">
+                        <a:rPr sz="1150" b="0">
                           <a:solidFill>
                             <a:srgbClr val="292929"/>
                           </a:solidFill>
@@ -27500,7 +27500,7 @@
                         </a:lnSpc>
                       </a:pPr>
                       <a:r>
-                        <a:rPr sz="1200" b="0">
+                        <a:rPr sz="1150" b="0">
                           <a:solidFill>
                             <a:srgbClr val="292929"/>
                           </a:solidFill>
@@ -27529,7 +27529,7 @@
                         </a:lnSpc>
                       </a:pPr>
                       <a:r>
-                        <a:rPr sz="1200" b="0">
+                        <a:rPr sz="1150" b="0">
                           <a:solidFill>
                             <a:srgbClr val="292929"/>
                           </a:solidFill>
@@ -27548,7 +27548,7 @@
                   </a:tcPr>
                 </a:tc>
               </a:tr>
-              <a:tr h="338328">
+              <a:tr h="310896">
                 <a:tc>
                   <a:txBody>
                     <a:bodyPr/>
@@ -27560,7 +27560,7 @@
                         </a:lnSpc>
                       </a:pPr>
                       <a:r>
-                        <a:rPr sz="1200" b="0">
+                        <a:rPr sz="1150" b="0">
                           <a:solidFill>
                             <a:srgbClr val="292929"/>
                           </a:solidFill>
@@ -27589,7 +27589,7 @@
                         </a:lnSpc>
                       </a:pPr>
                       <a:r>
-                        <a:rPr sz="1200" b="0">
+                        <a:rPr sz="1150" b="0">
                           <a:solidFill>
                             <a:srgbClr val="292929"/>
                           </a:solidFill>
@@ -27618,7 +27618,7 @@
                         </a:lnSpc>
                       </a:pPr>
                       <a:r>
-                        <a:rPr sz="1200" b="0">
+                        <a:rPr sz="1150" b="0">
                           <a:solidFill>
                             <a:srgbClr val="292929"/>
                           </a:solidFill>
@@ -27647,7 +27647,7 @@
                         </a:lnSpc>
                       </a:pPr>
                       <a:r>
-                        <a:rPr sz="1200" b="0">
+                        <a:rPr sz="1150" b="0">
                           <a:solidFill>
                             <a:srgbClr val="292929"/>
                           </a:solidFill>
@@ -27676,7 +27676,7 @@
                         </a:lnSpc>
                       </a:pPr>
                       <a:r>
-                        <a:rPr sz="1200" b="0">
+                        <a:rPr sz="1150" b="0">
                           <a:solidFill>
                             <a:srgbClr val="292929"/>
                           </a:solidFill>
@@ -27695,7 +27695,7 @@
                   </a:tcPr>
                 </a:tc>
               </a:tr>
-              <a:tr h="338328">
+              <a:tr h="310896">
                 <a:tc>
                   <a:txBody>
                     <a:bodyPr/>
@@ -27707,7 +27707,7 @@
                         </a:lnSpc>
                       </a:pPr>
                       <a:r>
-                        <a:rPr sz="1200" b="0">
+                        <a:rPr sz="1150" b="0">
                           <a:solidFill>
                             <a:srgbClr val="292929"/>
                           </a:solidFill>
@@ -27736,7 +27736,7 @@
                         </a:lnSpc>
                       </a:pPr>
                       <a:r>
-                        <a:rPr sz="1200" b="0">
+                        <a:rPr sz="1150" b="0">
                           <a:solidFill>
                             <a:srgbClr val="292929"/>
                           </a:solidFill>
@@ -27765,7 +27765,7 @@
                         </a:lnSpc>
                       </a:pPr>
                       <a:r>
-                        <a:rPr sz="1200" b="0">
+                        <a:rPr sz="1150" b="0">
                           <a:solidFill>
                             <a:srgbClr val="292929"/>
                           </a:solidFill>
@@ -27794,7 +27794,7 @@
                         </a:lnSpc>
                       </a:pPr>
                       <a:r>
-                        <a:rPr sz="1200" b="0">
+                        <a:rPr sz="1150" b="0">
                           <a:solidFill>
                             <a:srgbClr val="292929"/>
                           </a:solidFill>
@@ -27823,7 +27823,7 @@
                         </a:lnSpc>
                       </a:pPr>
                       <a:r>
-                        <a:rPr sz="1200" b="0">
+                        <a:rPr sz="1150" b="0">
                           <a:solidFill>
                             <a:srgbClr val="292929"/>
                           </a:solidFill>
@@ -27842,7 +27842,7 @@
                   </a:tcPr>
                 </a:tc>
               </a:tr>
-              <a:tr h="338328">
+              <a:tr h="310896">
                 <a:tc>
                   <a:txBody>
                     <a:bodyPr/>
@@ -27854,7 +27854,7 @@
                         </a:lnSpc>
                       </a:pPr>
                       <a:r>
-                        <a:rPr sz="1200" b="0">
+                        <a:rPr sz="1150" b="0">
                           <a:solidFill>
                             <a:srgbClr val="292929"/>
                           </a:solidFill>
@@ -27883,7 +27883,7 @@
                         </a:lnSpc>
                       </a:pPr>
                       <a:r>
-                        <a:rPr sz="1200" b="0">
+                        <a:rPr sz="1150" b="0">
                           <a:solidFill>
                             <a:srgbClr val="292929"/>
                           </a:solidFill>
@@ -27912,7 +27912,7 @@
                         </a:lnSpc>
                       </a:pPr>
                       <a:r>
-                        <a:rPr sz="1200" b="0">
+                        <a:rPr sz="1150" b="0">
                           <a:solidFill>
                             <a:srgbClr val="292929"/>
                           </a:solidFill>
@@ -27941,7 +27941,7 @@
                         </a:lnSpc>
                       </a:pPr>
                       <a:r>
-                        <a:rPr sz="1200" b="0">
+                        <a:rPr sz="1150" b="0">
                           <a:solidFill>
                             <a:srgbClr val="292929"/>
                           </a:solidFill>
@@ -27970,7 +27970,7 @@
                         </a:lnSpc>
                       </a:pPr>
                       <a:r>
-                        <a:rPr sz="1200" b="0">
+                        <a:rPr sz="1150" b="0">
                           <a:solidFill>
                             <a:srgbClr val="292929"/>
                           </a:solidFill>
@@ -27989,7 +27989,7 @@
                   </a:tcPr>
                 </a:tc>
               </a:tr>
-              <a:tr h="338328">
+              <a:tr h="310896">
                 <a:tc>
                   <a:txBody>
                     <a:bodyPr/>
@@ -28001,7 +28001,7 @@
                         </a:lnSpc>
                       </a:pPr>
                       <a:r>
-                        <a:rPr sz="1200" b="0">
+                        <a:rPr sz="1150" b="0">
                           <a:solidFill>
                             <a:srgbClr val="292929"/>
                           </a:solidFill>
@@ -28030,7 +28030,7 @@
                         </a:lnSpc>
                       </a:pPr>
                       <a:r>
-                        <a:rPr sz="1200" b="0">
+                        <a:rPr sz="1150" b="0">
                           <a:solidFill>
                             <a:srgbClr val="292929"/>
                           </a:solidFill>
@@ -28059,7 +28059,7 @@
                         </a:lnSpc>
                       </a:pPr>
                       <a:r>
-                        <a:rPr sz="1200" b="0">
+                        <a:rPr sz="1150" b="0">
                           <a:solidFill>
                             <a:srgbClr val="292929"/>
                           </a:solidFill>
@@ -28088,7 +28088,7 @@
                         </a:lnSpc>
                       </a:pPr>
                       <a:r>
-                        <a:rPr sz="1200" b="0">
+                        <a:rPr sz="1150" b="0">
                           <a:solidFill>
                             <a:srgbClr val="292929"/>
                           </a:solidFill>
@@ -28117,7 +28117,154 @@
                         </a:lnSpc>
                       </a:pPr>
                       <a:r>
-                        <a:rPr sz="1200" b="0">
+                        <a:rPr sz="1150" b="0">
+                          <a:solidFill>
+                            <a:srgbClr val="292929"/>
+                          </a:solidFill>
+                          <a:latin typeface="Pretendard"/>
+                          <a:ea typeface="Pretendard"/>
+                          <a:cs typeface="Pretendard"/>
+                        </a:rPr>
+                        <a:t>미사용 · 방치</a:t>
+                      </a:r>
+                    </a:p>
+                  </a:txBody>
+                  <a:tcPr marL="128016" marR="91440" marT="36576" marB="36576" anchor="ctr">
+                    <a:solidFill>
+                      <a:srgbClr val="FFF6E6"/>
+                    </a:solidFill>
+                  </a:tcPr>
+                </a:tc>
+              </a:tr>
+              <a:tr h="310896">
+                <a:tc>
+                  <a:txBody>
+                    <a:bodyPr/>
+                    <a:lstStyle/>
+                    <a:p>
+                      <a:pPr algn="l">
+                        <a:lnSpc>
+                          <a:spcPct val="115000"/>
+                        </a:lnSpc>
+                      </a:pPr>
+                      <a:r>
+                        <a:rPr sz="1150" b="0">
+                          <a:solidFill>
+                            <a:srgbClr val="292929"/>
+                          </a:solidFill>
+                          <a:latin typeface="Pretendard"/>
+                          <a:ea typeface="Pretendard"/>
+                          <a:cs typeface="Pretendard"/>
+                        </a:rPr>
+                        <a:t>git-sync-mustard73</a:t>
+                      </a:r>
+                    </a:p>
+                  </a:txBody>
+                  <a:tcPr marL="128016" marR="91440" marT="36576" marB="36576" anchor="ctr">
+                    <a:solidFill>
+                      <a:srgbClr val="FFF6E6"/>
+                    </a:solidFill>
+                  </a:tcPr>
+                </a:tc>
+                <a:tc>
+                  <a:txBody>
+                    <a:bodyPr/>
+                    <a:lstStyle/>
+                    <a:p>
+                      <a:pPr algn="l">
+                        <a:lnSpc>
+                          <a:spcPct val="115000"/>
+                        </a:lnSpc>
+                      </a:pPr>
+                      <a:r>
+                        <a:rPr sz="1150" b="0">
+                          <a:solidFill>
+                            <a:srgbClr val="292929"/>
+                          </a:solidFill>
+                          <a:latin typeface="Pretendard"/>
+                          <a:ea typeface="Pretendard"/>
+                          <a:cs typeface="Pretendard"/>
+                        </a:rPr>
+                        <a:t>옛 단일 볼트 잔재 (private)</a:t>
+                      </a:r>
+                    </a:p>
+                  </a:txBody>
+                  <a:tcPr marL="128016" marR="91440" marT="36576" marB="36576" anchor="ctr">
+                    <a:solidFill>
+                      <a:srgbClr val="FFF6E6"/>
+                    </a:solidFill>
+                  </a:tcPr>
+                </a:tc>
+                <a:tc>
+                  <a:txBody>
+                    <a:bodyPr/>
+                    <a:lstStyle/>
+                    <a:p>
+                      <a:pPr algn="ctr">
+                        <a:lnSpc>
+                          <a:spcPct val="115000"/>
+                        </a:lnSpc>
+                      </a:pPr>
+                      <a:r>
+                        <a:rPr sz="1150" b="0">
+                          <a:solidFill>
+                            <a:srgbClr val="292929"/>
+                          </a:solidFill>
+                          <a:latin typeface="Pretendard"/>
+                          <a:ea typeface="Pretendard"/>
+                          <a:cs typeface="Pretendard"/>
+                        </a:rPr>
+                        <a:t>2</a:t>
+                      </a:r>
+                    </a:p>
+                  </a:txBody>
+                  <a:tcPr marL="128016" marR="91440" marT="36576" marB="36576" anchor="ctr">
+                    <a:solidFill>
+                      <a:srgbClr val="FFF6E6"/>
+                    </a:solidFill>
+                  </a:tcPr>
+                </a:tc>
+                <a:tc>
+                  <a:txBody>
+                    <a:bodyPr/>
+                    <a:lstStyle/>
+                    <a:p>
+                      <a:pPr algn="r">
+                        <a:lnSpc>
+                          <a:spcPct val="115000"/>
+                        </a:lnSpc>
+                      </a:pPr>
+                      <a:r>
+                        <a:rPr sz="1150" b="0">
+                          <a:solidFill>
+                            <a:srgbClr val="292929"/>
+                          </a:solidFill>
+                          <a:latin typeface="Pretendard"/>
+                          <a:ea typeface="Pretendard"/>
+                          <a:cs typeface="Pretendard"/>
+                        </a:rPr>
+                        <a:t>—</a:t>
+                      </a:r>
+                    </a:p>
+                  </a:txBody>
+                  <a:tcPr marL="128016" marR="91440" marT="36576" marB="36576" anchor="ctr">
+                    <a:solidFill>
+                      <a:srgbClr val="FFF6E6"/>
+                    </a:solidFill>
+                  </a:tcPr>
+                </a:tc>
+                <a:tc>
+                  <a:txBody>
+                    <a:bodyPr/>
+                    <a:lstStyle/>
+                    <a:p>
+                      <a:pPr algn="l">
+                        <a:lnSpc>
+                          <a:spcPct val="115000"/>
+                        </a:lnSpc>
+                      </a:pPr>
+                      <a:r>
+                        <a:rPr sz="1150" b="0">
                           <a:solidFill>
                             <a:srgbClr val="292929"/>
                           </a:solidFill>
@@ -28226,7 +28373,7 @@
                 <a:ea typeface="Pretendard"/>
                 <a:cs typeface="Pretendard"/>
               </a:rPr>
-              <a:t>아래 3개는 문서 사이트를 만들려다 중단한 흔적입니다. 커밋 1개, CdBd 내용 0줄, 그중 2개는 완전히 동일한 중복본 — 쓸 수 있는 기능이 없습니다.</a:t>
+              <a:t>아래 4개는 아무도 안 쓰는 저장소입니다. Mintlify 3개는 문서 사이트를 만들려다 중단한 흔적(커밋 1개·CdBd 내용 0줄·2개는 완전 중복본), 맨 아래는 옛 볼트 잔재입니다.</a:t>
             </a:r>
           </a:p>
         </p:txBody>
@@ -28273,7 +28420,7 @@
                 <a:ea typeface="Pretendard"/>
                 <a:cs typeface="Pretendard"/>
               </a:rPr>
-              <a:t>이 3개는 GitHub에만 있고 우리 컴퓨터에는 clone되어 있지 않습니다</a:t>
+              <a:t>Mintlify 3개는 GitHub에만 있고 우리 컴퓨터에 clone되어 있지 않습니다 · git-sync-mustard73은 이 컴퓨터 바탕화면에 남아 있습니다</a:t>
             </a:r>
           </a:p>
         </p:txBody>

</xml_diff>

<commit_message>
vault backup: 2026-08-09 21:13:19
</commit_message>
<xml_diff>
--- a/CdBd 문서 체계 진단 및 개편 제안.pptx
+++ b/CdBd 문서 체계 진단 및 개편 제안.pptx
@@ -10287,7 +10287,7 @@
                 <a:ea typeface="Pretendard"/>
                 <a:cs typeface="Pretendard"/>
               </a:rPr>
-              <a:t>①⑤</a:t>
+              <a:t>①②</a:t>
             </a:r>
           </a:p>
         </p:txBody>
@@ -10751,7 +10751,7 @@
                 <a:ea typeface="Pretendard"/>
                 <a:cs typeface="Pretendard"/>
               </a:rPr>
-              <a:t>⑥</a:t>
+              <a:t>⑤</a:t>
             </a:r>
           </a:p>
         </p:txBody>
@@ -10983,7 +10983,7 @@
                 <a:ea typeface="Pretendard"/>
                 <a:cs typeface="Pretendard"/>
               </a:rPr>
-              <a:t>⑦</a:t>
+              <a:t>⑤</a:t>
             </a:r>
           </a:p>
         </p:txBody>
@@ -11215,7 +11215,7 @@
                 <a:ea typeface="Pretendard"/>
                 <a:cs typeface="Pretendard"/>
               </a:rPr>
-              <a:t>③④</a:t>
+              <a:t>④</a:t>
             </a:r>
           </a:p>
         </p:txBody>
@@ -11454,7 +11454,7 @@
                 <a:ea typeface="Pretendard"/>
                 <a:cs typeface="Pretendard"/>
               </a:rPr>
-              <a:t>원인 ②(정보 갈라짐)가 그대로 남음</a:t>
+              <a:t>원인 ③(정보 갈라짐)이 그대로 남음</a:t>
             </a:r>
           </a:p>
         </p:txBody>
@@ -16570,7 +16570,7 @@
                 <a:ea typeface="Pretendard"/>
                 <a:cs typeface="Pretendard"/>
               </a:rPr>
-              <a:t>3 – 5</a:t>
+              <a:t>3 – 4</a:t>
             </a:r>
           </a:p>
         </p:txBody>
@@ -16848,7 +16848,7 @@
                 <a:ea typeface="Pretendard"/>
                 <a:cs typeface="Pretendard"/>
               </a:rPr>
-              <a:t>6 – 8</a:t>
+              <a:t>5 – 6</a:t>
             </a:r>
           </a:p>
         </p:txBody>
@@ -17032,7 +17032,7 @@
                 <a:ea typeface="Pretendard"/>
                 <a:cs typeface="Pretendard"/>
               </a:rPr>
-              <a:t>근본 원인 7가지</a:t>
+              <a:t>근본 원인 5가지</a:t>
             </a:r>
           </a:p>
         </p:txBody>
@@ -17126,7 +17126,7 @@
                 <a:ea typeface="Pretendard"/>
                 <a:cs typeface="Pretendard"/>
               </a:rPr>
-              <a:t>9 – 18</a:t>
+              <a:t>7 – 13</a:t>
             </a:r>
           </a:p>
         </p:txBody>
@@ -17404,7 +17404,7 @@
                 <a:ea typeface="Pretendard"/>
                 <a:cs typeface="Pretendard"/>
               </a:rPr>
-              <a:t>19 – 24</a:t>
+              <a:t>14 – 19</a:t>
             </a:r>
           </a:p>
         </p:txBody>
@@ -17682,7 +17682,7 @@
                 <a:ea typeface="Pretendard"/>
                 <a:cs typeface="Pretendard"/>
               </a:rPr>
-              <a:t>25 – 27</a:t>
+              <a:t>20 – 22</a:t>
             </a:r>
           </a:p>
         </p:txBody>
@@ -17729,7 +17729,7 @@
                 <a:ea typeface="Pretendard"/>
                 <a:cs typeface="Pretendard"/>
               </a:rPr>
-              <a:t>총 27장 · 20~25분  ·  가장 중요한 장은 03번입니다. 원인을 알아야 어느 해결안이 맞는지 판단하실 수 있습니다.</a:t>
+              <a:t>총 22장 · 15~20분  ·  가장 중요한 장은 03번입니다. 원인을 알아야 어느 해결안이 맞는지 판단하실 수 있습니다.</a:t>
             </a:r>
           </a:p>
         </p:txBody>
@@ -19578,7 +19578,7 @@
                 <a:ea typeface="Pretendard"/>
                 <a:cs typeface="Pretendard"/>
               </a:rPr>
-              <a:t>어느 방식을 택하든, 지금 고쳐야 할 6가지</a:t>
+              <a:t>어느 방식을 택하든, 지금 고쳐야 할 8가지</a:t>
             </a:r>
           </a:p>
         </p:txBody>
@@ -19774,124 +19774,6 @@
                           <a:ea typeface="Pretendard"/>
                           <a:cs typeface="Pretendard"/>
                         </a:rPr>
-                        <a:t>cdbd-design-service 공개 설정 점검</a:t>
-                      </a:r>
-                    </a:p>
-                  </a:txBody>
-                  <a:tcPr marL="128016" marR="91440" marT="36576" marB="36576" anchor="ctr">
-                    <a:solidFill>
-                      <a:srgbClr val="FDEEEE"/>
-                    </a:solidFill>
-                  </a:tcPr>
-                </a:tc>
-                <a:tc>
-                  <a:txBody>
-                    <a:bodyPr/>
-                    <a:lstStyle/>
-                    <a:p>
-                      <a:pPr algn="l">
-                        <a:lnSpc>
-                          <a:spcPct val="115000"/>
-                        </a:lnSpc>
-                      </a:pPr>
-                      <a:r>
-                        <a:rPr sz="1250" b="0">
-                          <a:solidFill>
-                            <a:srgbClr val="292929"/>
-                          </a:solidFill>
-                          <a:latin typeface="Pretendard"/>
-                          <a:ea typeface="Pretendard"/>
-                          <a:cs typeface="Pretendard"/>
-                        </a:rPr>
-                        <a:t>고객 자료가 인터넷에 공개돼 있음</a:t>
-                      </a:r>
-                    </a:p>
-                  </a:txBody>
-                  <a:tcPr marL="128016" marR="91440" marT="36576" marB="36576" anchor="ctr">
-                    <a:solidFill>
-                      <a:srgbClr val="FDEEEE"/>
-                    </a:solidFill>
-                  </a:tcPr>
-                </a:tc>
-                <a:tc>
-                  <a:txBody>
-                    <a:bodyPr/>
-                    <a:lstStyle/>
-                    <a:p>
-                      <a:pPr algn="ctr">
-                        <a:lnSpc>
-                          <a:spcPct val="115000"/>
-                        </a:lnSpc>
-                      </a:pPr>
-                      <a:r>
-                        <a:rPr sz="1250" b="0">
-                          <a:solidFill>
-                            <a:srgbClr val="292929"/>
-                          </a:solidFill>
-                          <a:latin typeface="Pretendard"/>
-                          <a:ea typeface="Pretendard"/>
-                          <a:cs typeface="Pretendard"/>
-                        </a:rPr>
-                        <a:t>🔴 오늘</a:t>
-                      </a:r>
-                    </a:p>
-                  </a:txBody>
-                  <a:tcPr marL="128016" marR="91440" marT="36576" marB="36576" anchor="ctr">
-                    <a:solidFill>
-                      <a:srgbClr val="FDEEEE"/>
-                    </a:solidFill>
-                  </a:tcPr>
-                </a:tc>
-              </a:tr>
-              <a:tr h="429768">
-                <a:tc>
-                  <a:txBody>
-                    <a:bodyPr/>
-                    <a:lstStyle/>
-                    <a:p>
-                      <a:pPr algn="ctr">
-                        <a:lnSpc>
-                          <a:spcPct val="115000"/>
-                        </a:lnSpc>
-                      </a:pPr>
-                      <a:r>
-                        <a:rPr sz="1250" b="0">
-                          <a:solidFill>
-                            <a:srgbClr val="292929"/>
-                          </a:solidFill>
-                          <a:latin typeface="Pretendard"/>
-                          <a:ea typeface="Pretendard"/>
-                          <a:cs typeface="Pretendard"/>
-                        </a:rPr>
-                        <a:t>2</a:t>
-                      </a:r>
-                    </a:p>
-                  </a:txBody>
-                  <a:tcPr marL="128016" marR="91440" marT="36576" marB="36576" anchor="ctr">
-                    <a:solidFill>
-                      <a:srgbClr val="FDEEEE"/>
-                    </a:solidFill>
-                  </a:tcPr>
-                </a:tc>
-                <a:tc>
-                  <a:txBody>
-                    <a:bodyPr/>
-                    <a:lstStyle/>
-                    <a:p>
-                      <a:pPr algn="l">
-                        <a:lnSpc>
-                          <a:spcPct val="115000"/>
-                        </a:lnSpc>
-                      </a:pPr>
-                      <a:r>
-                        <a:rPr sz="1250" b="0">
-                          <a:solidFill>
-                            <a:srgbClr val="292929"/>
-                          </a:solidFill>
-                          <a:latin typeface="Pretendard"/>
-                          <a:ea typeface="Pretendard"/>
-                          <a:cs typeface="Pretendard"/>
-                        </a:rPr>
                         <a:t>브랜드 그린 정본 확정 (#3DF69B / #4DE98B)</a:t>
                       </a:r>
                     </a:p>
@@ -19981,13 +19863,13 @@
                           <a:ea typeface="Pretendard"/>
                           <a:cs typeface="Pretendard"/>
                         </a:rPr>
-                        <a:t>3</a:t>
+                        <a:t>2</a:t>
                       </a:r>
                     </a:p>
                   </a:txBody>
                   <a:tcPr marL="128016" marR="91440" marT="36576" marB="36576" anchor="ctr">
                     <a:solidFill>
-                      <a:srgbClr val="FFF6E6"/>
+                      <a:srgbClr val="FDEEEE"/>
                     </a:solidFill>
                   </a:tcPr>
                 </a:tc>
@@ -20016,7 +19898,7 @@
                   </a:txBody>
                   <a:tcPr marL="128016" marR="91440" marT="36576" marB="36576" anchor="ctr">
                     <a:solidFill>
-                      <a:srgbClr val="FFF6E6"/>
+                      <a:srgbClr val="FDEEEE"/>
                     </a:solidFill>
                   </a:tcPr>
                 </a:tc>
@@ -20045,7 +19927,7 @@
                   </a:txBody>
                   <a:tcPr marL="128016" marR="91440" marT="36576" marB="36576" anchor="ctr">
                     <a:solidFill>
-                      <a:srgbClr val="FFF6E6"/>
+                      <a:srgbClr val="FDEEEE"/>
                     </a:solidFill>
                   </a:tcPr>
                 </a:tc>
@@ -20068,13 +19950,13 @@
                           <a:ea typeface="Pretendard"/>
                           <a:cs typeface="Pretendard"/>
                         </a:rPr>
-                        <a:t>🟠 이번 주</a:t>
+                        <a:t>🔴 오늘</a:t>
                       </a:r>
                     </a:p>
                   </a:txBody>
                   <a:tcPr marL="128016" marR="91440" marT="36576" marB="36576" anchor="ctr">
                     <a:solidFill>
-                      <a:srgbClr val="FFF6E6"/>
+                      <a:srgbClr val="FDEEEE"/>
                     </a:solidFill>
                   </a:tcPr>
                 </a:tc>
@@ -20099,7 +19981,7 @@
                           <a:ea typeface="Pretendard"/>
                           <a:cs typeface="Pretendard"/>
                         </a:rPr>
-                        <a:t>4</a:t>
+                        <a:t>3</a:t>
                       </a:r>
                     </a:p>
                   </a:txBody>
@@ -20217,13 +20099,13 @@
                           <a:ea typeface="Pretendard"/>
                           <a:cs typeface="Pretendard"/>
                         </a:rPr>
-                        <a:t>5</a:t>
+                        <a:t>4</a:t>
                       </a:r>
                     </a:p>
                   </a:txBody>
                   <a:tcPr marL="128016" marR="91440" marT="36576" marB="36576" anchor="ctr">
                     <a:solidFill>
-                      <a:srgbClr val="FFFFFF"/>
+                      <a:srgbClr val="FFF6E6"/>
                     </a:solidFill>
                   </a:tcPr>
                 </a:tc>
@@ -20252,7 +20134,7 @@
                   </a:txBody>
                   <a:tcPr marL="128016" marR="91440" marT="36576" marB="36576" anchor="ctr">
                     <a:solidFill>
-                      <a:srgbClr val="FFFFFF"/>
+                      <a:srgbClr val="FFF6E6"/>
                     </a:solidFill>
                   </a:tcPr>
                 </a:tc>
@@ -20281,7 +20163,7 @@
                   </a:txBody>
                   <a:tcPr marL="128016" marR="91440" marT="36576" marB="36576" anchor="ctr">
                     <a:solidFill>
-                      <a:srgbClr val="FFFFFF"/>
+                      <a:srgbClr val="FFF6E6"/>
                     </a:solidFill>
                   </a:tcPr>
                 </a:tc>
@@ -20310,7 +20192,125 @@
                   </a:txBody>
                   <a:tcPr marL="128016" marR="91440" marT="36576" marB="36576" anchor="ctr">
                     <a:solidFill>
-                      <a:srgbClr val="FFFFFF"/>
+                      <a:srgbClr val="FFF6E6"/>
+                    </a:solidFill>
+                  </a:tcPr>
+                </a:tc>
+              </a:tr>
+              <a:tr h="429768">
+                <a:tc>
+                  <a:txBody>
+                    <a:bodyPr/>
+                    <a:lstStyle/>
+                    <a:p>
+                      <a:pPr algn="ctr">
+                        <a:lnSpc>
+                          <a:spcPct val="115000"/>
+                        </a:lnSpc>
+                      </a:pPr>
+                      <a:r>
+                        <a:rPr sz="1250" b="0">
+                          <a:solidFill>
+                            <a:srgbClr val="292929"/>
+                          </a:solidFill>
+                          <a:latin typeface="Pretendard"/>
+                          <a:ea typeface="Pretendard"/>
+                          <a:cs typeface="Pretendard"/>
+                        </a:rPr>
+                        <a:t>5</a:t>
+                      </a:r>
+                    </a:p>
+                  </a:txBody>
+                  <a:tcPr marL="128016" marR="91440" marT="36576" marB="36576" anchor="ctr">
+                    <a:solidFill>
+                      <a:srgbClr val="FFF6E6"/>
+                    </a:solidFill>
+                  </a:tcPr>
+                </a:tc>
+                <a:tc>
+                  <a:txBody>
+                    <a:bodyPr/>
+                    <a:lstStyle/>
+                    <a:p>
+                      <a:pPr algn="l">
+                        <a:lnSpc>
+                          <a:spcPct val="115000"/>
+                        </a:lnSpc>
+                      </a:pPr>
+                      <a:r>
+                        <a:rPr sz="1250" b="0">
+                          <a:solidFill>
+                            <a:srgbClr val="292929"/>
+                          </a:solidFill>
+                          <a:latin typeface="Pretendard"/>
+                          <a:ea typeface="Pretendard"/>
+                          <a:cs typeface="Pretendard"/>
+                        </a:rPr>
+                        <a:t>AGENTS.md 등 중복 규칙집 정리</a:t>
+                      </a:r>
+                    </a:p>
+                  </a:txBody>
+                  <a:tcPr marL="128016" marR="91440" marT="36576" marB="36576" anchor="ctr">
+                    <a:solidFill>
+                      <a:srgbClr val="FFF6E6"/>
+                    </a:solidFill>
+                  </a:tcPr>
+                </a:tc>
+                <a:tc>
+                  <a:txBody>
+                    <a:bodyPr/>
+                    <a:lstStyle/>
+                    <a:p>
+                      <a:pPr algn="l">
+                        <a:lnSpc>
+                          <a:spcPct val="115000"/>
+                        </a:lnSpc>
+                      </a:pPr>
+                      <a:r>
+                        <a:rPr sz="1250" b="0">
+                          <a:solidFill>
+                            <a:srgbClr val="292929"/>
+                          </a:solidFill>
+                          <a:latin typeface="Pretendard"/>
+                          <a:ea typeface="Pretendard"/>
+                          <a:cs typeface="Pretendard"/>
+                        </a:rPr>
+                        <a:t>낡은 규칙으로 작업하게 됨</a:t>
+                      </a:r>
+                    </a:p>
+                  </a:txBody>
+                  <a:tcPr marL="128016" marR="91440" marT="36576" marB="36576" anchor="ctr">
+                    <a:solidFill>
+                      <a:srgbClr val="FFF6E6"/>
+                    </a:solidFill>
+                  </a:tcPr>
+                </a:tc>
+                <a:tc>
+                  <a:txBody>
+                    <a:bodyPr/>
+                    <a:lstStyle/>
+                    <a:p>
+                      <a:pPr algn="ctr">
+                        <a:lnSpc>
+                          <a:spcPct val="115000"/>
+                        </a:lnSpc>
+                      </a:pPr>
+                      <a:r>
+                        <a:rPr sz="1250" b="0">
+                          <a:solidFill>
+                            <a:srgbClr val="292929"/>
+                          </a:solidFill>
+                          <a:latin typeface="Pretendard"/>
+                          <a:ea typeface="Pretendard"/>
+                          <a:cs typeface="Pretendard"/>
+                        </a:rPr>
+                        <a:t>🟠 이번 주</a:t>
+                      </a:r>
+                    </a:p>
+                  </a:txBody>
+                  <a:tcPr marL="128016" marR="91440" marT="36576" marB="36576" anchor="ctr">
+                    <a:solidFill>
+                      <a:srgbClr val="FFF6E6"/>
                     </a:solidFill>
                   </a:tcPr>
                 </a:tc>
@@ -20600,7 +20600,7 @@
                           <a:ea typeface="Pretendard"/>
                           <a:cs typeface="Pretendard"/>
                         </a:rPr>
-                        <a:t>미사용 저장소 3개 정리</a:t>
+                        <a:t>미사용 저장소 4개 정리</a:t>
                       </a:r>
                     </a:p>
                   </a:txBody>
@@ -20715,7 +20715,7 @@
                 <a:ea typeface="Pretendard"/>
                 <a:cs typeface="Pretendard"/>
               </a:rPr>
-              <a:t/>
+              <a:t>※ 문서 체계와 별개로, cdbd-design-service의 GitHub 공개 설정 건은 따로 보고드렸습니다 (고객 자료 노출)</a:t>
             </a:r>
           </a:p>
         </p:txBody>
@@ -26946,7 +26946,7 @@
                 <a:ea typeface="Pretendard"/>
                 <a:cs typeface="Pretendard"/>
               </a:rPr>
-              <a:t>원인 ① ⑤</a:t>
+              <a:t>원인 ① ②</a:t>
             </a:r>
           </a:p>
         </p:txBody>
@@ -27248,7 +27248,7 @@
                 <a:ea typeface="Pretendard"/>
                 <a:cs typeface="Pretendard"/>
               </a:rPr>
-              <a:t>원인 ② ③ ④</a:t>
+              <a:t>원인 ③ ④</a:t>
             </a:r>
           </a:p>
         </p:txBody>
@@ -27550,7 +27550,7 @@
                 <a:ea typeface="Pretendard"/>
                 <a:cs typeface="Pretendard"/>
               </a:rPr>
-              <a:t>원인 ⑥ ⑦</a:t>
+              <a:t>원인 ⑤</a:t>
             </a:r>
           </a:p>
         </p:txBody>

</xml_diff>

<commit_message>
vault backup: 2026-08-09 21:14:27
</commit_message>
<xml_diff>
--- a/CdBd 문서 체계 진단 및 개편 제안.pptx
+++ b/CdBd 문서 체계 진단 및 개편 제안.pptx
@@ -6378,7 +6378,7 @@
         </p:nvSpPr>
         <p:spPr>
           <a:xfrm>
-            <a:off x="777240" y="3703320"/>
+            <a:off x="777240" y="4041648"/>
             <a:ext cx="10607040" cy="914400"/>
           </a:xfrm>
           <a:prstGeom prst="rect">
@@ -6476,7 +6476,7 @@
         </p:nvSpPr>
         <p:spPr>
           <a:xfrm>
-            <a:off x="777240" y="4754880"/>
+            <a:off x="777240" y="4892040"/>
             <a:ext cx="10607040" cy="274320"/>
           </a:xfrm>
           <a:prstGeom prst="rect">
@@ -6523,7 +6523,7 @@
         </p:nvSpPr>
         <p:spPr>
           <a:xfrm>
-            <a:off x="777240" y="5120640"/>
+            <a:off x="777240" y="5257800"/>
             <a:ext cx="10634472" cy="1005840"/>
           </a:xfrm>
           <a:prstGeom prst="rect">
@@ -6567,7 +6567,7 @@
         </p:nvSpPr>
         <p:spPr>
           <a:xfrm>
-            <a:off x="1051560" y="5266944"/>
+            <a:off x="1051560" y="5404104"/>
             <a:ext cx="10058400" cy="777240"/>
           </a:xfrm>
           <a:prstGeom prst="rect">

</xml_diff>

<commit_message>
vault backup: 2026-08-09 21:38:02
</commit_message>
<xml_diff>
--- a/CdBd 문서 체계 진단 및 개편 제안.pptx
+++ b/CdBd 문서 체계 진단 및 개편 제안.pptx
@@ -6409,7 +6409,7 @@
                 <a:ea typeface="Pretendard"/>
                 <a:cs typeface="Pretendard"/>
               </a:rPr>
-              <a:t>· 권한 설정 파일에 남의 컴퓨터 경로가 박혀 있습니다 — </a:t>
+              <a:t>· 권한 설정에 남의 컴퓨터 경로가 박혀 있습니다 — </a:t>
             </a:r>
             <a:r>
               <a:rPr sz="1300" b="1">
@@ -6421,6 +6421,17 @@
                 <a:cs typeface="Pretendard"/>
               </a:rPr>
               <a:t>/Users/leesunho/…</a:t>
+            </a:r>
+            <a:r>
+              <a:rPr sz="1300" b="0">
+                <a:solidFill>
+                  <a:srgbClr val="292929"/>
+                </a:solidFill>
+                <a:latin typeface="Pretendard"/>
+                <a:ea typeface="Pretendard"/>
+                <a:cs typeface="Pretendard"/>
+              </a:rPr>
+              <a:t>  → 다른 컴퓨터에선 매번 승인 팝업, 무인 실행은 멈춤</a:t>
             </a:r>
           </a:p>
           <a:p>
@@ -7301,7 +7312,7 @@
                           <a:ea typeface="Pretendard"/>
                           <a:cs typeface="Pretendard"/>
                         </a:rPr>
-                        <a:t>첫날 안내문이 저장소마다 딴판</a:t>
+                        <a:t>안내문에 공통 뼈대가 없음</a:t>
                       </a:r>
                     </a:p>
                   </a:txBody>
@@ -7330,7 +7341,7 @@
                           <a:ea typeface="Pretendard"/>
                           <a:cs typeface="Pretendard"/>
                         </a:rPr>
-                        <a:t>679 B ~ 131 KB (200배 차이)</a:t>
+                        <a:t>라우팅 표 0/5 · 스킬 소개 0 · 경로 오류</a:t>
                       </a:r>
                     </a:p>
                   </a:txBody>
@@ -8375,7 +8386,7 @@
                 <a:ea typeface="Pretendard"/>
                 <a:cs typeface="Pretendard"/>
               </a:rPr>
-              <a:t>④ 해결 방안</a:t>
+              <a:t>④ 해결 방안 · A·B 공통 토대</a:t>
             </a:r>
           </a:p>
         </p:txBody>
@@ -8429,14 +8440,58 @@
       </p:sp>
       <p:sp>
         <p:nvSpPr>
-          <p:cNvPr id="5" name="TextBox 4"/>
+          <p:cNvPr id="5" name="Rectangle 4"/>
+          <p:cNvSpPr/>
+          <p:nvPr/>
+        </p:nvSpPr>
+        <p:spPr>
+          <a:xfrm>
+            <a:off x="777240" y="1719072"/>
+            <a:ext cx="10634472" cy="384048"/>
+          </a:xfrm>
+          <a:prstGeom prst="rect">
+            <a:avLst/>
+          </a:prstGeom>
+          <a:solidFill>
+            <a:srgbClr val="F2F0FF"/>
+          </a:solidFill>
+          <a:ln>
+            <a:noFill/>
+          </a:ln>
+          <a:effectLst/>
+        </p:spPr>
+        <p:style>
+          <a:lnRef idx="1">
+            <a:schemeClr val="accent1"/>
+          </a:lnRef>
+          <a:fillRef idx="3">
+            <a:schemeClr val="accent1"/>
+          </a:fillRef>
+          <a:effectRef idx="2">
+            <a:schemeClr val="accent1"/>
+          </a:effectRef>
+          <a:fontRef idx="minor">
+            <a:schemeClr val="lt1"/>
+          </a:fontRef>
+        </p:style>
+        <p:txBody>
+          <a:bodyPr rtlCol="0" anchor="ctr" wrap="square"/>
+          <a:lstStyle/>
+          <a:p>
+            <a:pPr algn="ctr"/>
+          </a:p>
+        </p:txBody>
+      </p:sp>
+      <p:sp>
+        <p:nvSpPr>
+          <p:cNvPr id="6" name="TextBox 5"/>
           <p:cNvSpPr txBox="1"/>
           <p:nvPr/>
         </p:nvSpPr>
         <p:spPr>
           <a:xfrm>
-            <a:off x="777240" y="1737360"/>
-            <a:ext cx="5120640" cy="274320"/>
+            <a:off x="1005840" y="1810512"/>
+            <a:ext cx="10241280" cy="274320"/>
           </a:xfrm>
           <a:prstGeom prst="rect">
             <a:avLst/>
@@ -8461,6 +8516,53 @@
               </a:spcAft>
             </a:pPr>
             <a:r>
+              <a:rPr sz="1250" b="1">
+                <a:solidFill>
+                  <a:srgbClr val="6C4CFF"/>
+                </a:solidFill>
+                <a:latin typeface="Pretendard"/>
+                <a:ea typeface="Pretendard"/>
+                <a:cs typeface="Pretendard"/>
+              </a:rPr>
+              <a:t>이건 방식 A·B 둘 다에 해당합니다. 차이는 몇 개를 만드느냐뿐입니다 — A는 자주 쓰는 약 20개, B는 96개 전부.</a:t>
+            </a:r>
+          </a:p>
+        </p:txBody>
+      </p:sp>
+      <p:sp>
+        <p:nvSpPr>
+          <p:cNvPr id="7" name="TextBox 6"/>
+          <p:cNvSpPr txBox="1"/>
+          <p:nvPr/>
+        </p:nvSpPr>
+        <p:spPr>
+          <a:xfrm>
+            <a:off x="777240" y="2212848"/>
+            <a:ext cx="5120640" cy="274320"/>
+          </a:xfrm>
+          <a:prstGeom prst="rect">
+            <a:avLst/>
+          </a:prstGeom>
+          <a:noFill/>
+        </p:spPr>
+        <p:txBody>
+          <a:bodyPr wrap="square" lIns="0" rIns="0" tIns="0" bIns="0" anchor="t">
+            <a:spAutoFit/>
+          </a:bodyPr>
+          <a:lstStyle/>
+          <a:p>
+            <a:pPr algn="l">
+              <a:lnSpc>
+                <a:spcPct val="135000"/>
+              </a:lnSpc>
+              <a:spcBef>
+                <a:spcPts val="0"/>
+              </a:spcBef>
+              <a:spcAft>
+                <a:spcPts val="0"/>
+              </a:spcAft>
+            </a:pPr>
+            <a:r>
               <a:rPr sz="1500" b="1">
                 <a:solidFill>
                   <a:srgbClr val="E53A40"/>
@@ -8476,13 +8578,13 @@
       </p:sp>
       <p:sp>
         <p:nvSpPr>
-          <p:cNvPr id="6" name="Rounded Rectangle 5"/>
+          <p:cNvPr id="8" name="Rounded Rectangle 7"/>
           <p:cNvSpPr/>
           <p:nvPr/>
         </p:nvSpPr>
         <p:spPr>
           <a:xfrm>
-            <a:off x="777240" y="2084831"/>
+            <a:off x="777240" y="2542032"/>
             <a:ext cx="4663440" cy="493776"/>
           </a:xfrm>
           <a:prstGeom prst="roundRect">
@@ -8522,13 +8624,13 @@
       </p:sp>
       <p:sp>
         <p:nvSpPr>
-          <p:cNvPr id="7" name="TextBox 6"/>
+          <p:cNvPr id="9" name="TextBox 8"/>
           <p:cNvSpPr txBox="1"/>
           <p:nvPr/>
         </p:nvSpPr>
         <p:spPr>
           <a:xfrm>
-            <a:off x="978408" y="2167127"/>
+            <a:off x="978408" y="2624327"/>
             <a:ext cx="914400" cy="219456"/>
           </a:xfrm>
           <a:prstGeom prst="rect">
@@ -8569,13 +8671,13 @@
       </p:sp>
       <p:sp>
         <p:nvSpPr>
-          <p:cNvPr id="8" name="TextBox 7"/>
+          <p:cNvPr id="10" name="TextBox 9"/>
           <p:cNvSpPr txBox="1"/>
           <p:nvPr/>
         </p:nvSpPr>
         <p:spPr>
           <a:xfrm>
-            <a:off x="1920240" y="2157984"/>
+            <a:off x="1920240" y="2615184"/>
             <a:ext cx="3291839" cy="347472"/>
           </a:xfrm>
           <a:prstGeom prst="rect">
@@ -8616,13 +8718,13 @@
       </p:sp>
       <p:sp>
         <p:nvSpPr>
-          <p:cNvPr id="9" name="Rounded Rectangle 8"/>
+          <p:cNvPr id="11" name="Rounded Rectangle 10"/>
           <p:cNvSpPr/>
           <p:nvPr/>
         </p:nvSpPr>
         <p:spPr>
           <a:xfrm>
-            <a:off x="1234440" y="2697479"/>
+            <a:off x="1234440" y="3154679"/>
             <a:ext cx="4663440" cy="731520"/>
           </a:xfrm>
           <a:prstGeom prst="roundRect">
@@ -8662,13 +8764,13 @@
       </p:sp>
       <p:sp>
         <p:nvSpPr>
-          <p:cNvPr id="10" name="TextBox 9"/>
+          <p:cNvPr id="12" name="TextBox 11"/>
           <p:cNvSpPr txBox="1"/>
           <p:nvPr/>
         </p:nvSpPr>
         <p:spPr>
           <a:xfrm>
-            <a:off x="1435608" y="2779775"/>
+            <a:off x="1435608" y="3236975"/>
             <a:ext cx="914400" cy="219456"/>
           </a:xfrm>
           <a:prstGeom prst="rect">
@@ -8709,13 +8811,13 @@
       </p:sp>
       <p:sp>
         <p:nvSpPr>
-          <p:cNvPr id="11" name="TextBox 10"/>
+          <p:cNvPr id="13" name="TextBox 12"/>
           <p:cNvSpPr txBox="1"/>
           <p:nvPr/>
         </p:nvSpPr>
         <p:spPr>
           <a:xfrm>
-            <a:off x="2377440" y="2770632"/>
+            <a:off x="2377440" y="3227832"/>
             <a:ext cx="3291839" cy="585216"/>
           </a:xfrm>
           <a:prstGeom prst="rect">
@@ -8780,13 +8882,13 @@
       </p:sp>
       <p:sp>
         <p:nvSpPr>
-          <p:cNvPr id="12" name="Rounded Rectangle 11"/>
+          <p:cNvPr id="14" name="Rounded Rectangle 13"/>
           <p:cNvSpPr/>
           <p:nvPr/>
         </p:nvSpPr>
         <p:spPr>
           <a:xfrm>
-            <a:off x="777240" y="3547872"/>
+            <a:off x="777240" y="4005072"/>
             <a:ext cx="4663440" cy="731520"/>
           </a:xfrm>
           <a:prstGeom prst="roundRect">
@@ -8826,13 +8928,13 @@
       </p:sp>
       <p:sp>
         <p:nvSpPr>
-          <p:cNvPr id="13" name="TextBox 12"/>
+          <p:cNvPr id="15" name="TextBox 14"/>
           <p:cNvSpPr txBox="1"/>
           <p:nvPr/>
         </p:nvSpPr>
         <p:spPr>
           <a:xfrm>
-            <a:off x="978408" y="3630168"/>
+            <a:off x="978408" y="4087368"/>
             <a:ext cx="914400" cy="219456"/>
           </a:xfrm>
           <a:prstGeom prst="rect">
@@ -8873,13 +8975,13 @@
       </p:sp>
       <p:sp>
         <p:nvSpPr>
-          <p:cNvPr id="14" name="TextBox 13"/>
+          <p:cNvPr id="16" name="TextBox 15"/>
           <p:cNvSpPr txBox="1"/>
           <p:nvPr/>
         </p:nvSpPr>
         <p:spPr>
           <a:xfrm>
-            <a:off x="1920240" y="3621024"/>
+            <a:off x="1920240" y="4078224"/>
             <a:ext cx="3291839" cy="585216"/>
           </a:xfrm>
           <a:prstGeom prst="rect">
@@ -8944,13 +9046,13 @@
       </p:sp>
       <p:sp>
         <p:nvSpPr>
-          <p:cNvPr id="15" name="Rounded Rectangle 14"/>
+          <p:cNvPr id="17" name="Rounded Rectangle 16"/>
           <p:cNvSpPr/>
           <p:nvPr/>
         </p:nvSpPr>
         <p:spPr>
           <a:xfrm>
-            <a:off x="1234440" y="4398264"/>
+            <a:off x="1234440" y="4855464"/>
             <a:ext cx="4663440" cy="493776"/>
           </a:xfrm>
           <a:prstGeom prst="roundRect">
@@ -8990,13 +9092,13 @@
       </p:sp>
       <p:sp>
         <p:nvSpPr>
-          <p:cNvPr id="16" name="TextBox 15"/>
+          <p:cNvPr id="18" name="TextBox 17"/>
           <p:cNvSpPr txBox="1"/>
           <p:nvPr/>
         </p:nvSpPr>
         <p:spPr>
           <a:xfrm>
-            <a:off x="1435608" y="4480559"/>
+            <a:off x="1435608" y="4937759"/>
             <a:ext cx="914400" cy="219456"/>
           </a:xfrm>
           <a:prstGeom prst="rect">
@@ -9037,13 +9139,13 @@
       </p:sp>
       <p:sp>
         <p:nvSpPr>
-          <p:cNvPr id="17" name="TextBox 16"/>
+          <p:cNvPr id="19" name="TextBox 18"/>
           <p:cNvSpPr txBox="1"/>
           <p:nvPr/>
         </p:nvSpPr>
         <p:spPr>
           <a:xfrm>
-            <a:off x="2377440" y="4471416"/>
+            <a:off x="2377440" y="4928616"/>
             <a:ext cx="3291839" cy="347472"/>
           </a:xfrm>
           <a:prstGeom prst="rect">
@@ -9084,13 +9186,13 @@
       </p:sp>
       <p:sp>
         <p:nvSpPr>
-          <p:cNvPr id="18" name="TextBox 17"/>
+          <p:cNvPr id="20" name="TextBox 19"/>
           <p:cNvSpPr txBox="1"/>
           <p:nvPr/>
         </p:nvSpPr>
         <p:spPr>
           <a:xfrm>
-            <a:off x="777240" y="5074920"/>
+            <a:off x="777240" y="5532120"/>
             <a:ext cx="5120640" cy="457200"/>
           </a:xfrm>
           <a:prstGeom prst="rect">
@@ -9124,44 +9226,20 @@
                 <a:ea typeface="Pretendard"/>
                 <a:cs typeface="Pretendard"/>
               </a:rPr>
-              <a:t>→ 팀원이 문서 경로를 외우고 있어야 합니다.</a:t>
-            </a:r>
-          </a:p>
-          <a:p>
-            <a:pPr>
-              <a:lnSpc>
-                <a:spcPct val="145000"/>
-              </a:lnSpc>
-              <a:spcBef>
-                <a:spcPts val="0"/>
-              </a:spcBef>
-              <a:spcAft>
-                <a:spcPts val="0"/>
-              </a:spcAft>
-            </a:pPr>
-            <a:r>
-              <a:rPr sz="1300" b="1">
-                <a:solidFill>
-                  <a:srgbClr val="E53A40"/>
-                </a:solidFill>
-                <a:latin typeface="Pretendard"/>
-                <a:ea typeface="Pretendard"/>
-                <a:cs typeface="Pretendard"/>
-              </a:rPr>
-              <a:t>   모르면 시작조차 못 합니다.</a:t>
-            </a:r>
-          </a:p>
-        </p:txBody>
-      </p:sp>
-      <p:sp>
-        <p:nvSpPr>
-          <p:cNvPr id="19" name="TextBox 18"/>
+              <a:t>→ 팀원이 문서 경로를 외우고 있어야 합니다. 모르면 시작조차 못 합니다.</a:t>
+            </a:r>
+          </a:p>
+        </p:txBody>
+      </p:sp>
+      <p:sp>
+        <p:nvSpPr>
+          <p:cNvPr id="21" name="TextBox 20"/>
           <p:cNvSpPr txBox="1"/>
           <p:nvPr/>
         </p:nvSpPr>
         <p:spPr>
           <a:xfrm>
-            <a:off x="6263640" y="1737360"/>
+            <a:off x="6263640" y="2212848"/>
             <a:ext cx="5148072" cy="274320"/>
           </a:xfrm>
           <a:prstGeom prst="rect">
@@ -9202,13 +9280,13 @@
       </p:sp>
       <p:sp>
         <p:nvSpPr>
-          <p:cNvPr id="20" name="Rounded Rectangle 19"/>
+          <p:cNvPr id="22" name="Rounded Rectangle 21"/>
           <p:cNvSpPr/>
           <p:nvPr/>
         </p:nvSpPr>
         <p:spPr>
           <a:xfrm>
-            <a:off x="6263640" y="2084831"/>
+            <a:off x="6263640" y="2542032"/>
             <a:ext cx="4690872" cy="493776"/>
           </a:xfrm>
           <a:prstGeom prst="roundRect">
@@ -9248,13 +9326,13 @@
       </p:sp>
       <p:sp>
         <p:nvSpPr>
-          <p:cNvPr id="21" name="TextBox 20"/>
+          <p:cNvPr id="23" name="TextBox 22"/>
           <p:cNvSpPr txBox="1"/>
           <p:nvPr/>
         </p:nvSpPr>
         <p:spPr>
           <a:xfrm>
-            <a:off x="6464807" y="2167127"/>
+            <a:off x="6464807" y="2624327"/>
             <a:ext cx="914400" cy="219456"/>
           </a:xfrm>
           <a:prstGeom prst="rect">
@@ -9295,13 +9373,13 @@
       </p:sp>
       <p:sp>
         <p:nvSpPr>
-          <p:cNvPr id="22" name="TextBox 21"/>
+          <p:cNvPr id="24" name="TextBox 23"/>
           <p:cNvSpPr txBox="1"/>
           <p:nvPr/>
         </p:nvSpPr>
         <p:spPr>
           <a:xfrm>
-            <a:off x="7406640" y="2157984"/>
+            <a:off x="7406640" y="2615184"/>
             <a:ext cx="3319272" cy="347472"/>
           </a:xfrm>
           <a:prstGeom prst="rect">
@@ -9342,13 +9420,13 @@
       </p:sp>
       <p:sp>
         <p:nvSpPr>
-          <p:cNvPr id="23" name="Rounded Rectangle 22"/>
+          <p:cNvPr id="25" name="Rounded Rectangle 24"/>
           <p:cNvSpPr/>
           <p:nvPr/>
         </p:nvSpPr>
         <p:spPr>
           <a:xfrm>
-            <a:off x="6720840" y="2697479"/>
+            <a:off x="6720840" y="3154679"/>
             <a:ext cx="4690872" cy="969264"/>
           </a:xfrm>
           <a:prstGeom prst="roundRect">
@@ -9388,13 +9466,13 @@
       </p:sp>
       <p:sp>
         <p:nvSpPr>
-          <p:cNvPr id="24" name="TextBox 23"/>
+          <p:cNvPr id="26" name="TextBox 25"/>
           <p:cNvSpPr txBox="1"/>
           <p:nvPr/>
         </p:nvSpPr>
         <p:spPr>
           <a:xfrm>
-            <a:off x="6922007" y="2779775"/>
+            <a:off x="6922007" y="3236975"/>
             <a:ext cx="914400" cy="219456"/>
           </a:xfrm>
           <a:prstGeom prst="rect">
@@ -9435,13 +9513,13 @@
       </p:sp>
       <p:sp>
         <p:nvSpPr>
-          <p:cNvPr id="25" name="TextBox 24"/>
+          <p:cNvPr id="27" name="TextBox 26"/>
           <p:cNvSpPr txBox="1"/>
           <p:nvPr/>
         </p:nvSpPr>
         <p:spPr>
           <a:xfrm>
-            <a:off x="7863840" y="2770632"/>
+            <a:off x="7863840" y="3227832"/>
             <a:ext cx="3319272" cy="822960"/>
           </a:xfrm>
           <a:prstGeom prst="rect">
@@ -9530,13 +9608,13 @@
       </p:sp>
       <p:sp>
         <p:nvSpPr>
-          <p:cNvPr id="26" name="TextBox 25"/>
+          <p:cNvPr id="28" name="TextBox 27"/>
           <p:cNvSpPr txBox="1"/>
           <p:nvPr/>
         </p:nvSpPr>
         <p:spPr>
           <a:xfrm>
-            <a:off x="6263640" y="3794760"/>
+            <a:off x="6263640" y="4224528"/>
             <a:ext cx="5148072" cy="457200"/>
           </a:xfrm>
           <a:prstGeom prst="rect">
@@ -9570,45 +9648,21 @@
                 <a:ea typeface="Pretendard"/>
                 <a:cs typeface="Pretendard"/>
               </a:rPr>
-              <a:t>→ 팀원은 하고 싶은 말만 하면 됩니다.</a:t>
-            </a:r>
-          </a:p>
-          <a:p>
-            <a:pPr>
-              <a:lnSpc>
-                <a:spcPct val="145000"/>
-              </a:lnSpc>
-              <a:spcBef>
-                <a:spcPts val="0"/>
-              </a:spcBef>
-              <a:spcAft>
-                <a:spcPts val="0"/>
-              </a:spcAft>
-            </a:pPr>
-            <a:r>
-              <a:rPr sz="1300" b="1">
-                <a:solidFill>
-                  <a:srgbClr val="1C9E63"/>
-                </a:solidFill>
-                <a:latin typeface="Pretendard"/>
-                <a:ea typeface="Pretendard"/>
-                <a:cs typeface="Pretendard"/>
-              </a:rPr>
-              <a:t>   누가 시켜도 같은 절차로 진행됩니다.</a:t>
-            </a:r>
-          </a:p>
-        </p:txBody>
-      </p:sp>
-      <p:sp>
-        <p:nvSpPr>
-          <p:cNvPr id="27" name="Rectangle 26"/>
+              <a:t>→ 팀원은 하고 싶은 말만 하면 됩니다. 누가 시켜도 같은 절차로 진행됩니다.</a:t>
+            </a:r>
+          </a:p>
+        </p:txBody>
+      </p:sp>
+      <p:sp>
+        <p:nvSpPr>
+          <p:cNvPr id="29" name="Rectangle 28"/>
           <p:cNvSpPr/>
           <p:nvPr/>
         </p:nvSpPr>
         <p:spPr>
           <a:xfrm>
-            <a:off x="6263640" y="4617720"/>
-            <a:ext cx="5148072" cy="1463040"/>
+            <a:off x="6263640" y="4800600"/>
+            <a:ext cx="5148072" cy="1417320"/>
           </a:xfrm>
           <a:prstGeom prst="rect">
             <a:avLst/>
@@ -9645,13 +9699,13 @@
       </p:sp>
       <p:sp>
         <p:nvSpPr>
-          <p:cNvPr id="28" name="TextBox 27"/>
+          <p:cNvPr id="30" name="TextBox 29"/>
           <p:cNvSpPr txBox="1"/>
           <p:nvPr/>
         </p:nvSpPr>
         <p:spPr>
           <a:xfrm>
-            <a:off x="6492240" y="4773168"/>
+            <a:off x="6492240" y="4956048"/>
             <a:ext cx="4709160" cy="1188720"/>
           </a:xfrm>
           <a:prstGeom prst="rect">
@@ -9788,13 +9842,13 @@
       </p:sp>
       <p:sp>
         <p:nvSpPr>
-          <p:cNvPr id="29" name="TextBox 28"/>
+          <p:cNvPr id="31" name="TextBox 30"/>
           <p:cNvSpPr txBox="1"/>
           <p:nvPr/>
         </p:nvSpPr>
         <p:spPr>
           <a:xfrm>
-            <a:off x="777240" y="5669280"/>
+            <a:off x="777240" y="5989320"/>
             <a:ext cx="5120640" cy="457200"/>
           </a:xfrm>
           <a:prstGeom prst="rect">
@@ -9820,7 +9874,7 @@
               </a:spcAft>
             </a:pPr>
             <a:r>
-              <a:rPr sz="1300" b="0">
+              <a:rPr sz="1250" b="0">
                 <a:solidFill>
                   <a:srgbClr val="6B6B6B"/>
                 </a:solidFill>
@@ -9828,38 +9882,14 @@
                 <a:ea typeface="Pretendard"/>
                 <a:cs typeface="Pretendard"/>
               </a:rPr>
-              <a:t>스킬은 이렇게 짧습니다. 내용을 베끼지 않고</a:t>
-            </a:r>
-          </a:p>
-          <a:p>
-            <a:pPr>
-              <a:lnSpc>
-                <a:spcPct val="145000"/>
-              </a:lnSpc>
-              <a:spcBef>
-                <a:spcPts val="0"/>
-              </a:spcBef>
-              <a:spcAft>
-                <a:spcPts val="0"/>
-              </a:spcAft>
-            </a:pPr>
-            <a:r>
-              <a:rPr sz="1300" b="0">
-                <a:solidFill>
-                  <a:srgbClr val="6B6B6B"/>
-                </a:solidFill>
-                <a:latin typeface="Pretendard"/>
-                <a:ea typeface="Pretendard"/>
-                <a:cs typeface="Pretendard"/>
-              </a:rPr>
-              <a:t>“이 문서를 읽어라”라고 가리키기만 합니다.</a:t>
-            </a:r>
-          </a:p>
-        </p:txBody>
-      </p:sp>
-      <p:sp>
-        <p:nvSpPr>
-          <p:cNvPr id="30" name="TextBox 29"/>
+              <a:t>스킬은 이렇게 짧습니다. 내용을 베끼지 않고 “이 문서를 읽어라”라고 가리키기만 합니다.</a:t>
+            </a:r>
+          </a:p>
+        </p:txBody>
+      </p:sp>
+      <p:sp>
+        <p:nvSpPr>
+          <p:cNvPr id="32" name="TextBox 31"/>
           <p:cNvSpPr txBox="1"/>
           <p:nvPr/>
         </p:nvSpPr>
@@ -9906,7 +9936,7 @@
       </p:sp>
       <p:sp>
         <p:nvSpPr>
-          <p:cNvPr id="31" name="TextBox 30"/>
+          <p:cNvPr id="33" name="TextBox 32"/>
           <p:cNvSpPr txBox="1"/>
           <p:nvPr/>
         </p:nvSpPr>
@@ -19921,7 +19951,7 @@
                           <a:ea typeface="Pretendard"/>
                           <a:cs typeface="Pretendard"/>
                         </a:rPr>
-                        <a:t>다른 팀원 컴퓨터에서 무조건 실패</a:t>
+                        <a:t>다른 컴퓨터에선 매번 승인 팝업 · 무인 실행 멈춤</a:t>
                       </a:r>
                     </a:p>
                   </a:txBody>
@@ -28906,7 +28936,7 @@
                 <a:ea typeface="Pretendard"/>
                 <a:cs typeface="Pretendard"/>
               </a:rPr>
-              <a:t>원인 ② 첫날 안내문이 저장소마다 딴판입니다</a:t>
+              <a:t>원인 ② 안내문에 공통 뼈대가 없습니다</a:t>
             </a:r>
           </a:p>
         </p:txBody>
@@ -28919,8 +28949,8 @@
         </p:nvSpPr>
         <p:spPr>
           <a:xfrm>
-            <a:off x="777240" y="1783080"/>
-            <a:ext cx="10607040" cy="320040"/>
+            <a:off x="777240" y="1737360"/>
+            <a:ext cx="10607040" cy="274320"/>
           </a:xfrm>
           <a:prstGeom prst="rect">
             <a:avLst/>
@@ -28945,7 +28975,7 @@
               </a:spcAft>
             </a:pPr>
             <a:r>
-              <a:rPr sz="1450" b="0">
+              <a:rPr sz="1400" b="0">
                 <a:solidFill>
                   <a:srgbClr val="6B6B6B"/>
                 </a:solidFill>
@@ -28953,22 +28983,581 @@
                 <a:ea typeface="Pretendard"/>
                 <a:cs typeface="Pretendard"/>
               </a:rPr>
-              <a:t>CLAUDE.md는 Claude가 그 폴더를 열자마자 자동으로 읽는 유일한 파일입니다. 신입에게 첫날 건네는 안내문이라고 보시면 됩니다.</a:t>
+              <a:t>CLAUDE.md는 Claude가 폴더를 열자마자 자동으로 읽는 유일한 파일 — 신입에게 첫날 건네는 안내문입니다.</a:t>
+            </a:r>
+          </a:p>
+        </p:txBody>
+      </p:sp>
+      <p:sp>
+        <p:nvSpPr>
+          <p:cNvPr id="6" name="Rectangle 5"/>
+          <p:cNvSpPr/>
+          <p:nvPr/>
+        </p:nvSpPr>
+        <p:spPr>
+          <a:xfrm>
+            <a:off x="777240" y="2148840"/>
+            <a:ext cx="5120640" cy="1965960"/>
+          </a:xfrm>
+          <a:prstGeom prst="rect">
+            <a:avLst/>
+          </a:prstGeom>
+          <a:solidFill>
+            <a:srgbClr val="ECFAF2"/>
+          </a:solidFill>
+          <a:ln w="19050">
+            <a:solidFill>
+              <a:srgbClr val="1C9E63"/>
+            </a:solidFill>
+          </a:ln>
+          <a:effectLst/>
+        </p:spPr>
+        <p:style>
+          <a:lnRef idx="1">
+            <a:schemeClr val="accent1"/>
+          </a:lnRef>
+          <a:fillRef idx="3">
+            <a:schemeClr val="accent1"/>
+          </a:fillRef>
+          <a:effectRef idx="2">
+            <a:schemeClr val="accent1"/>
+          </a:effectRef>
+          <a:fontRef idx="minor">
+            <a:schemeClr val="lt1"/>
+          </a:fontRef>
+        </p:style>
+        <p:txBody>
+          <a:bodyPr rtlCol="0" anchor="ctr" wrap="square"/>
+          <a:lstStyle/>
+          <a:p>
+            <a:pPr algn="ctr"/>
+          </a:p>
+        </p:txBody>
+      </p:sp>
+      <p:sp>
+        <p:nvSpPr>
+          <p:cNvPr id="7" name="TextBox 6"/>
+          <p:cNvSpPr txBox="1"/>
+          <p:nvPr/>
+        </p:nvSpPr>
+        <p:spPr>
+          <a:xfrm>
+            <a:off x="1024128" y="2331720"/>
+            <a:ext cx="4617720" cy="274320"/>
+          </a:xfrm>
+          <a:prstGeom prst="rect">
+            <a:avLst/>
+          </a:prstGeom>
+          <a:noFill/>
+        </p:spPr>
+        <p:txBody>
+          <a:bodyPr wrap="square" lIns="0" rIns="0" tIns="0" bIns="0" anchor="t">
+            <a:spAutoFit/>
+          </a:bodyPr>
+          <a:lstStyle/>
+          <a:p>
+            <a:pPr algn="l">
+              <a:lnSpc>
+                <a:spcPct val="135000"/>
+              </a:lnSpc>
+              <a:spcBef>
+                <a:spcPts val="0"/>
+              </a:spcBef>
+              <a:spcAft>
+                <a:spcPts val="0"/>
+              </a:spcAft>
+            </a:pPr>
+            <a:r>
+              <a:rPr sz="1450" b="1">
+                <a:solidFill>
+                  <a:srgbClr val="1C9E63"/>
+                </a:solidFill>
+                <a:latin typeface="Pretendard"/>
+                <a:ea typeface="Pretendard"/>
+                <a:cs typeface="Pretendard"/>
+              </a:rPr>
+              <a:t>저장소마다 달라도 되는 것 — 내용</a:t>
+            </a:r>
+          </a:p>
+        </p:txBody>
+      </p:sp>
+      <p:sp>
+        <p:nvSpPr>
+          <p:cNvPr id="8" name="TextBox 7"/>
+          <p:cNvSpPr txBox="1"/>
+          <p:nvPr/>
+        </p:nvSpPr>
+        <p:spPr>
+          <a:xfrm>
+            <a:off x="1024128" y="2697480"/>
+            <a:ext cx="4617720" cy="1280160"/>
+          </a:xfrm>
+          <a:prstGeom prst="rect">
+            <a:avLst/>
+          </a:prstGeom>
+          <a:noFill/>
+        </p:spPr>
+        <p:txBody>
+          <a:bodyPr wrap="square" lIns="0" rIns="0" tIns="0" bIns="0" anchor="t">
+            <a:spAutoFit/>
+          </a:bodyPr>
+          <a:lstStyle/>
+          <a:p>
+            <a:pPr algn="l">
+              <a:lnSpc>
+                <a:spcPct val="160000"/>
+              </a:lnSpc>
+              <a:spcBef>
+                <a:spcPts val="0"/>
+              </a:spcBef>
+              <a:spcAft>
+                <a:spcPts val="0"/>
+              </a:spcAft>
+            </a:pPr>
+            <a:r>
+              <a:rPr sz="1250" b="0">
+                <a:solidFill>
+                  <a:srgbClr val="292929"/>
+                </a:solidFill>
+                <a:latin typeface="Pretendard"/>
+                <a:ea typeface="Pretendard"/>
+                <a:cs typeface="Pretendard"/>
+              </a:rPr>
+              <a:t>· design-system — 아이콘 · 컴포넌트 규칙</a:t>
+            </a:r>
+          </a:p>
+          <a:p>
+            <a:pPr>
+              <a:lnSpc>
+                <a:spcPct val="160000"/>
+              </a:lnSpc>
+              <a:spcBef>
+                <a:spcPts val="0"/>
+              </a:spcBef>
+              <a:spcAft>
+                <a:spcPts val="0"/>
+              </a:spcAft>
+            </a:pPr>
+            <a:r>
+              <a:rPr sz="1250" b="0">
+                <a:solidFill>
+                  <a:srgbClr val="292929"/>
+                </a:solidFill>
+                <a:latin typeface="Pretendard"/>
+                <a:ea typeface="Pretendard"/>
+                <a:cs typeface="Pretendard"/>
+              </a:rPr>
+              <a:t>· makevu-qrstp — QR 이벤트 제작 절차</a:t>
+            </a:r>
+          </a:p>
+          <a:p>
+            <a:pPr>
+              <a:lnSpc>
+                <a:spcPct val="160000"/>
+              </a:lnSpc>
+              <a:spcBef>
+                <a:spcPts val="0"/>
+              </a:spcBef>
+              <a:spcAft>
+                <a:spcPts val="0"/>
+              </a:spcAft>
+            </a:pPr>
+            <a:r>
+              <a:rPr sz="1250" b="0">
+                <a:solidFill>
+                  <a:srgbClr val="292929"/>
+                </a:solidFill>
+                <a:latin typeface="Pretendard"/>
+                <a:ea typeface="Pretendard"/>
+                <a:cs typeface="Pretendard"/>
+              </a:rPr>
+              <a:t>· design-service — 룩북 제작 프로세스</a:t>
+            </a:r>
+          </a:p>
+          <a:p>
+            <a:pPr>
+              <a:lnSpc>
+                <a:spcPct val="160000"/>
+              </a:lnSpc>
+              <a:spcBef>
+                <a:spcPts val="0"/>
+              </a:spcBef>
+              <a:spcAft>
+                <a:spcPts val="0"/>
+              </a:spcAft>
+            </a:pPr>
+            <a:r>
+              <a:rPr sz="1250" b="0">
+                <a:solidFill>
+                  <a:srgbClr val="292929"/>
+                </a:solidFill>
+                <a:latin typeface="Pretendard"/>
+                <a:ea typeface="Pretendard"/>
+                <a:cs typeface="Pretendard"/>
+              </a:rPr>
+              <a:t>· marketing — 썸네일 · 카드뉴스 규칙</a:t>
+            </a:r>
+          </a:p>
+          <a:p>
+            <a:pPr>
+              <a:lnSpc>
+                <a:spcPct val="135000"/>
+              </a:lnSpc>
+              <a:spcBef>
+                <a:spcPts val="800"/>
+              </a:spcBef>
+              <a:spcAft>
+                <a:spcPts val="0"/>
+              </a:spcAft>
+            </a:pPr>
+            <a:r>
+              <a:rPr sz="1250" b="1">
+                <a:solidFill>
+                  <a:srgbClr val="1C9E63"/>
+                </a:solidFill>
+                <a:latin typeface="Pretendard"/>
+                <a:ea typeface="Pretendard"/>
+                <a:cs typeface="Pretendard"/>
+              </a:rPr>
+              <a:t>→ 이건 다른 게 정상이고, 그래야 합니다.</a:t>
+            </a:r>
+          </a:p>
+        </p:txBody>
+      </p:sp>
+      <p:sp>
+        <p:nvSpPr>
+          <p:cNvPr id="9" name="Rectangle 8"/>
+          <p:cNvSpPr/>
+          <p:nvPr/>
+        </p:nvSpPr>
+        <p:spPr>
+          <a:xfrm>
+            <a:off x="6263640" y="2148840"/>
+            <a:ext cx="5148072" cy="1965960"/>
+          </a:xfrm>
+          <a:prstGeom prst="rect">
+            <a:avLst/>
+          </a:prstGeom>
+          <a:solidFill>
+            <a:srgbClr val="FDEEEE"/>
+          </a:solidFill>
+          <a:ln w="19050">
+            <a:solidFill>
+              <a:srgbClr val="E53A40"/>
+            </a:solidFill>
+          </a:ln>
+          <a:effectLst/>
+        </p:spPr>
+        <p:style>
+          <a:lnRef idx="1">
+            <a:schemeClr val="accent1"/>
+          </a:lnRef>
+          <a:fillRef idx="3">
+            <a:schemeClr val="accent1"/>
+          </a:fillRef>
+          <a:effectRef idx="2">
+            <a:schemeClr val="accent1"/>
+          </a:effectRef>
+          <a:fontRef idx="minor">
+            <a:schemeClr val="lt1"/>
+          </a:fontRef>
+        </p:style>
+        <p:txBody>
+          <a:bodyPr rtlCol="0" anchor="ctr" wrap="square"/>
+          <a:lstStyle/>
+          <a:p>
+            <a:pPr algn="ctr"/>
+          </a:p>
+        </p:txBody>
+      </p:sp>
+      <p:sp>
+        <p:nvSpPr>
+          <p:cNvPr id="10" name="TextBox 9"/>
+          <p:cNvSpPr txBox="1"/>
+          <p:nvPr/>
+        </p:nvSpPr>
+        <p:spPr>
+          <a:xfrm>
+            <a:off x="6510528" y="2331720"/>
+            <a:ext cx="4617720" cy="274320"/>
+          </a:xfrm>
+          <a:prstGeom prst="rect">
+            <a:avLst/>
+          </a:prstGeom>
+          <a:noFill/>
+        </p:spPr>
+        <p:txBody>
+          <a:bodyPr wrap="square" lIns="0" rIns="0" tIns="0" bIns="0" anchor="t">
+            <a:spAutoFit/>
+          </a:bodyPr>
+          <a:lstStyle/>
+          <a:p>
+            <a:pPr algn="l">
+              <a:lnSpc>
+                <a:spcPct val="135000"/>
+              </a:lnSpc>
+              <a:spcBef>
+                <a:spcPts val="0"/>
+              </a:spcBef>
+              <a:spcAft>
+                <a:spcPts val="0"/>
+              </a:spcAft>
+            </a:pPr>
+            <a:r>
+              <a:rPr sz="1450" b="1">
+                <a:solidFill>
+                  <a:srgbClr val="E53A40"/>
+                </a:solidFill>
+                <a:latin typeface="Pretendard"/>
+                <a:ea typeface="Pretendard"/>
+                <a:cs typeface="Pretendard"/>
+              </a:rPr>
+              <a:t>어느 저장소든 있어야 하는 것 — 뼈대</a:t>
+            </a:r>
+          </a:p>
+        </p:txBody>
+      </p:sp>
+      <p:sp>
+        <p:nvSpPr>
+          <p:cNvPr id="11" name="TextBox 10"/>
+          <p:cNvSpPr txBox="1"/>
+          <p:nvPr/>
+        </p:nvSpPr>
+        <p:spPr>
+          <a:xfrm>
+            <a:off x="6510528" y="2697480"/>
+            <a:ext cx="4709160" cy="1280160"/>
+          </a:xfrm>
+          <a:prstGeom prst="rect">
+            <a:avLst/>
+          </a:prstGeom>
+          <a:noFill/>
+        </p:spPr>
+        <p:txBody>
+          <a:bodyPr wrap="square" lIns="0" rIns="0" tIns="0" bIns="0" anchor="t">
+            <a:spAutoFit/>
+          </a:bodyPr>
+          <a:lstStyle/>
+          <a:p>
+            <a:pPr algn="l">
+              <a:lnSpc>
+                <a:spcPct val="140000"/>
+              </a:lnSpc>
+              <a:spcBef>
+                <a:spcPts val="600"/>
+              </a:spcBef>
+            </a:pPr>
+            <a:r>
+              <a:rPr sz="1200" b="0">
+                <a:solidFill>
+                  <a:srgbClr val="292929"/>
+                </a:solidFill>
+                <a:latin typeface="Pretendard"/>
+                <a:ea typeface="Pretendard"/>
+                <a:cs typeface="Pretendard"/>
+              </a:rPr>
+              <a:t>· 기능 라우팅 표 “이렇게 말하면 → 이 스킬”   </a:t>
+            </a:r>
+            <a:r>
+              <a:rPr sz="1200" b="1">
+                <a:solidFill>
+                  <a:srgbClr val="E53A40"/>
+                </a:solidFill>
+                <a:latin typeface="Pretendard"/>
+                <a:ea typeface="Pretendard"/>
+                <a:cs typeface="Pretendard"/>
+              </a:rPr>
+              <a:t>0 / 5</a:t>
+            </a:r>
+          </a:p>
+          <a:p>
+            <a:pPr>
+              <a:lnSpc>
+                <a:spcPct val="140000"/>
+              </a:lnSpc>
+              <a:spcBef>
+                <a:spcPts val="600"/>
+              </a:spcBef>
+            </a:pPr>
+            <a:r>
+              <a:rPr sz="1200" b="0">
+                <a:solidFill>
+                  <a:srgbClr val="292929"/>
+                </a:solidFill>
+                <a:latin typeface="Pretendard"/>
+                <a:ea typeface="Pretendard"/>
+                <a:cs typeface="Pretendard"/>
+              </a:rPr>
+              <a:t>· 자기 저장소 스킬 소개   </a:t>
+            </a:r>
+            <a:r>
+              <a:rPr sz="1200" b="1">
+                <a:solidFill>
+                  <a:srgbClr val="E53A40"/>
+                </a:solidFill>
+                <a:latin typeface="Pretendard"/>
+                <a:ea typeface="Pretendard"/>
+                <a:cs typeface="Pretendard"/>
+              </a:rPr>
+              <a:t>각주뿐 · 라우팅 0</a:t>
+            </a:r>
+          </a:p>
+          <a:p>
+            <a:pPr>
+              <a:lnSpc>
+                <a:spcPct val="140000"/>
+              </a:lnSpc>
+              <a:spcBef>
+                <a:spcPts val="600"/>
+              </a:spcBef>
+            </a:pPr>
+            <a:r>
+              <a:rPr sz="1200" b="0">
+                <a:solidFill>
+                  <a:srgbClr val="292929"/>
+                </a:solidFill>
+                <a:latin typeface="Pretendard"/>
+                <a:ea typeface="Pretendard"/>
+                <a:cs typeface="Pretendard"/>
+              </a:rPr>
+              <a:t>· Figma 선로드 규칙   </a:t>
+            </a:r>
+            <a:r>
+              <a:rPr sz="1200" b="1">
+                <a:solidFill>
+                  <a:srgbClr val="E53A40"/>
+                </a:solidFill>
+                <a:latin typeface="Pretendard"/>
+                <a:ea typeface="Pretendard"/>
+                <a:cs typeface="Pretendard"/>
+              </a:rPr>
+              <a:t>쓰는 곳 4 중 2</a:t>
+            </a:r>
+          </a:p>
+          <a:p>
+            <a:pPr>
+              <a:lnSpc>
+                <a:spcPct val="140000"/>
+              </a:lnSpc>
+              <a:spcBef>
+                <a:spcPts val="600"/>
+              </a:spcBef>
+            </a:pPr>
+            <a:r>
+              <a:rPr sz="1200" b="0">
+                <a:solidFill>
+                  <a:srgbClr val="292929"/>
+                </a:solidFill>
+                <a:latin typeface="Pretendard"/>
+                <a:ea typeface="Pretendard"/>
+                <a:cs typeface="Pretendard"/>
+              </a:rPr>
+              <a:t>· 세션 컨텍스트 작성 규칙   </a:t>
+            </a:r>
+            <a:r>
+              <a:rPr sz="1200" b="1">
+                <a:solidFill>
+                  <a:srgbClr val="E53A40"/>
+                </a:solidFill>
+                <a:latin typeface="Pretendard"/>
+                <a:ea typeface="Pretendard"/>
+                <a:cs typeface="Pretendard"/>
+              </a:rPr>
+              <a:t>1 / 5</a:t>
+            </a:r>
+          </a:p>
+          <a:p>
+            <a:pPr>
+              <a:lnSpc>
+                <a:spcPct val="140000"/>
+              </a:lnSpc>
+              <a:spcBef>
+                <a:spcPts val="600"/>
+              </a:spcBef>
+            </a:pPr>
+            <a:r>
+              <a:rPr sz="1200" b="0">
+                <a:solidFill>
+                  <a:srgbClr val="292929"/>
+                </a:solidFill>
+                <a:latin typeface="Pretendard"/>
+                <a:ea typeface="Pretendard"/>
+                <a:cs typeface="Pretendard"/>
+              </a:rPr>
+              <a:t>· 다른 저장소 참조 방법   </a:t>
+            </a:r>
+            <a:r>
+              <a:rPr sz="1200" b="1">
+                <a:solidFill>
+                  <a:srgbClr val="E53A40"/>
+                </a:solidFill>
+                <a:latin typeface="Pretendard"/>
+                <a:ea typeface="Pretendard"/>
+                <a:cs typeface="Pretendard"/>
+              </a:rPr>
+              <a:t>1 / 5 (죽은 주소)</a:t>
+            </a:r>
+          </a:p>
+        </p:txBody>
+      </p:sp>
+      <p:sp>
+        <p:nvSpPr>
+          <p:cNvPr id="12" name="TextBox 11"/>
+          <p:cNvSpPr txBox="1"/>
+          <p:nvPr/>
+        </p:nvSpPr>
+        <p:spPr>
+          <a:xfrm>
+            <a:off x="777240" y="4279392"/>
+            <a:ext cx="10607040" cy="274320"/>
+          </a:xfrm>
+          <a:prstGeom prst="rect">
+            <a:avLst/>
+          </a:prstGeom>
+          <a:noFill/>
+        </p:spPr>
+        <p:txBody>
+          <a:bodyPr wrap="square" lIns="0" rIns="0" tIns="0" bIns="0" anchor="t">
+            <a:spAutoFit/>
+          </a:bodyPr>
+          <a:lstStyle/>
+          <a:p>
+            <a:pPr algn="l">
+              <a:lnSpc>
+                <a:spcPct val="135000"/>
+              </a:lnSpc>
+              <a:spcBef>
+                <a:spcPts val="0"/>
+              </a:spcBef>
+              <a:spcAft>
+                <a:spcPts val="0"/>
+              </a:spcAft>
+            </a:pPr>
+            <a:r>
+              <a:rPr sz="1500" b="1">
+                <a:solidFill>
+                  <a:srgbClr val="6C4CFF"/>
+                </a:solidFill>
+                <a:latin typeface="Pretendard"/>
+                <a:ea typeface="Pretendard"/>
+                <a:cs typeface="Pretendard"/>
+              </a:rPr>
+              <a:t>게다가 안내문 내용 자체가 틀린 곳이 있습니다</a:t>
             </a:r>
           </a:p>
         </p:txBody>
       </p:sp>
       <p:graphicFrame>
         <p:nvGraphicFramePr>
-          <p:cNvPr id="6" name="Table 5"/>
+          <p:cNvPr id="13" name="Table 12"/>
           <p:cNvGraphicFramePr>
             <a:graphicFrameLocks noGrp="1"/>
           </p:cNvGraphicFramePr>
           <p:nvPr/>
         </p:nvGraphicFramePr>
         <p:xfrm>
-          <a:off x="777240" y="2331720"/>
-          <a:ext cx="10634472" cy="2523744"/>
+          <a:off x="777240" y="4663440"/>
+          <a:ext cx="10634471" cy="1261872"/>
         </p:xfrm>
         <a:graphic>
           <a:graphicData uri="http://schemas.openxmlformats.org/drawingml/2006/table">
@@ -28978,9 +29567,8 @@
               </a:tblPr>
               <a:tblGrid>
                 <a:gridCol w="2743200"/>
-                <a:gridCol w="1645920"/>
-                <a:gridCol w="1645920"/>
-                <a:gridCol w="4599432"/>
+                <a:gridCol w="3840480"/>
+                <a:gridCol w="4050791"/>
               </a:tblGrid>
               <a:tr h="420624">
                 <a:tc>
@@ -28988,7 +29576,7 @@
                     <a:bodyPr/>
                     <a:lstStyle/>
                     <a:p>
-                      <a:pPr algn="l">
+                      <a:pPr>
                         <a:lnSpc>
                           <a:spcPct val="115000"/>
                         </a:lnSpc>
@@ -29017,7 +29605,7 @@
                     <a:bodyPr/>
                     <a:lstStyle/>
                     <a:p>
-                      <a:pPr algn="r">
+                      <a:pPr>
                         <a:lnSpc>
                           <a:spcPct val="115000"/>
                         </a:lnSpc>
@@ -29031,7 +29619,7 @@
                           <a:ea typeface="Pretendard"/>
                           <a:cs typeface="Pretendard"/>
                         </a:rPr>
-                        <a:t>안내문 분량</a:t>
+                        <a:t>안내문에 적힌 것</a:t>
                       </a:r>
                     </a:p>
                   </a:txBody>
@@ -29046,7 +29634,7 @@
                     <a:bodyPr/>
                     <a:lstStyle/>
                     <a:p>
-                      <a:pPr algn="ctr">
+                      <a:pPr>
                         <a:lnSpc>
                           <a:spcPct val="115000"/>
                         </a:lnSpc>
@@ -29060,36 +29648,7 @@
                           <a:ea typeface="Pretendard"/>
                           <a:cs typeface="Pretendard"/>
                         </a:rPr>
-                        <a:t>종이로 치면</a:t>
-                      </a:r>
-                    </a:p>
-                  </a:txBody>
-                  <a:tcPr marL="128016" marR="91440" marT="36576" marB="36576" anchor="ctr">
-                    <a:solidFill>
-                      <a:srgbClr val="292929"/>
-                    </a:solidFill>
-                  </a:tcPr>
-                </a:tc>
-                <a:tc>
-                  <a:txBody>
-                    <a:bodyPr/>
-                    <a:lstStyle/>
-                    <a:p>
-                      <a:pPr algn="l">
-                        <a:lnSpc>
-                          <a:spcPct val="115000"/>
-                        </a:lnSpc>
-                      </a:pPr>
-                      <a:r>
-                        <a:rPr sz="1250" b="1">
-                          <a:solidFill>
-                            <a:srgbClr val="FFFFFF"/>
-                          </a:solidFill>
-                          <a:latin typeface="Pretendard"/>
-                          <a:ea typeface="Pretendard"/>
-                          <a:cs typeface="Pretendard"/>
-                        </a:rPr>
-                        <a:t>문제</a:t>
+                        <a:t>실제</a:t>
                       </a:r>
                     </a:p>
                   </a:txBody>
@@ -29106,7 +29665,96 @@
                     <a:bodyPr/>
                     <a:lstStyle/>
                     <a:p>
-                      <a:pPr algn="l">
+                      <a:pPr>
+                        <a:lnSpc>
+                          <a:spcPct val="115000"/>
+                        </a:lnSpc>
+                      </a:pPr>
+                      <a:r>
+                        <a:rPr sz="1250" b="0">
+                          <a:solidFill>
+                            <a:srgbClr val="292929"/>
+                          </a:solidFill>
+                          <a:latin typeface="Pretendard"/>
+                          <a:ea typeface="Pretendard"/>
+                          <a:cs typeface="Pretendard"/>
+                        </a:rPr>
+                        <a:t>cdbd-design-service</a:t>
+                      </a:r>
+                    </a:p>
+                  </a:txBody>
+                  <a:tcPr marL="128016" marR="91440" marT="36576" marB="36576" anchor="ctr">
+                    <a:solidFill>
+                      <a:srgbClr val="FDEEEE"/>
+                    </a:solidFill>
+                  </a:tcPr>
+                </a:tc>
+                <a:tc>
+                  <a:txBody>
+                    <a:bodyPr/>
+                    <a:lstStyle/>
+                    <a:p>
+                      <a:pPr>
+                        <a:lnSpc>
+                          <a:spcPct val="115000"/>
+                        </a:lnSpc>
+                      </a:pPr>
+                      <a:r>
+                        <a:rPr sz="1250" b="0">
+                          <a:solidFill>
+                            <a:srgbClr val="292929"/>
+                          </a:solidFill>
+                          <a:latin typeface="Pretendard"/>
+                          <a:ea typeface="Pretendard"/>
+                          <a:cs typeface="Pretendard"/>
+                        </a:rPr>
+                        <a:t>핵심 문서 표의 경로 9개</a:t>
+                      </a:r>
+                    </a:p>
+                  </a:txBody>
+                  <a:tcPr marL="128016" marR="91440" marT="36576" marB="36576" anchor="ctr">
+                    <a:solidFill>
+                      <a:srgbClr val="FDEEEE"/>
+                    </a:solidFill>
+                  </a:tcPr>
+                </a:tc>
+                <a:tc>
+                  <a:txBody>
+                    <a:bodyPr/>
+                    <a:lstStyle/>
+                    <a:p>
+                      <a:pPr>
+                        <a:lnSpc>
+                          <a:spcPct val="115000"/>
+                        </a:lnSpc>
+                      </a:pPr>
+                      <a:r>
+                        <a:rPr sz="1250" b="0">
+                          <a:solidFill>
+                            <a:srgbClr val="292929"/>
+                          </a:solidFill>
+                          <a:latin typeface="Pretendard"/>
+                          <a:ea typeface="Pretendard"/>
+                          <a:cs typeface="Pretendard"/>
+                        </a:rPr>
+                        <a:t>전부 옛 파일명 — 표 전체가 무용</a:t>
+                      </a:r>
+                    </a:p>
+                  </a:txBody>
+                  <a:tcPr marL="128016" marR="91440" marT="36576" marB="36576" anchor="ctr">
+                    <a:solidFill>
+                      <a:srgbClr val="FDEEEE"/>
+                    </a:solidFill>
+                  </a:tcPr>
+                </a:tc>
+              </a:tr>
+              <a:tr h="420624">
+                <a:tc>
+                  <a:txBody>
+                    <a:bodyPr/>
+                    <a:lstStyle/>
+                    <a:p>
+                      <a:pPr>
                         <a:lnSpc>
                           <a:spcPct val="115000"/>
                         </a:lnSpc>
@@ -29135,7 +29783,7 @@
                     <a:bodyPr/>
                     <a:lstStyle/>
                     <a:p>
-                      <a:pPr algn="r">
+                      <a:pPr>
                         <a:lnSpc>
                           <a:spcPct val="115000"/>
                         </a:lnSpc>
@@ -29149,7 +29797,7 @@
                           <a:ea typeface="Pretendard"/>
                           <a:cs typeface="Pretendard"/>
                         </a:rPr>
-                        <a:t>679 B</a:t>
+                        <a:t>“CdBd 디자인 시스템/MEMORY.md”</a:t>
                       </a:r>
                     </a:p>
                   </a:txBody>
@@ -29164,7 +29812,7 @@
                     <a:bodyPr/>
                     <a:lstStyle/>
                     <a:p>
-                      <a:pPr algn="ctr">
+                      <a:pPr>
                         <a:lnSpc>
                           <a:spcPct val="115000"/>
                         </a:lnSpc>
@@ -29178,36 +29826,7 @@
                           <a:ea typeface="Pretendard"/>
                           <a:cs typeface="Pretendard"/>
                         </a:rPr>
-                        <a:t>A4 반 장</a:t>
-                      </a:r>
-                    </a:p>
-                  </a:txBody>
-                  <a:tcPr marL="128016" marR="91440" marT="36576" marB="36576" anchor="ctr">
-                    <a:solidFill>
-                      <a:srgbClr val="FDEEEE"/>
-                    </a:solidFill>
-                  </a:tcPr>
-                </a:tc>
-                <a:tc>
-                  <a:txBody>
-                    <a:bodyPr/>
-                    <a:lstStyle/>
-                    <a:p>
-                      <a:pPr algn="l">
-                        <a:lnSpc>
-                          <a:spcPct val="115000"/>
-                        </a:lnSpc>
-                      </a:pPr>
-                      <a:r>
-                        <a:rPr sz="1250" b="0">
-                          <a:solidFill>
-                            <a:srgbClr val="292929"/>
-                          </a:solidFill>
-                          <a:latin typeface="Pretendard"/>
-                          <a:ea typeface="Pretendard"/>
-                          <a:cs typeface="Pretendard"/>
-                        </a:rPr>
-                        <a:t>99개 문서 얘기가 한 줄도 없음</a:t>
+                        <a:t>그런 폴더가 없음 (실제는 루트)</a:t>
                       </a:r>
                     </a:p>
                   </a:txBody>
@@ -29218,498 +29837,26 @@
                   </a:tcPr>
                 </a:tc>
               </a:tr>
-              <a:tr h="420624">
-                <a:tc>
-                  <a:txBody>
-                    <a:bodyPr/>
-                    <a:lstStyle/>
-                    <a:p>
-                      <a:pPr algn="l">
-                        <a:lnSpc>
-                          <a:spcPct val="115000"/>
-                        </a:lnSpc>
-                      </a:pPr>
-                      <a:r>
-                        <a:rPr sz="1250" b="0">
-                          <a:solidFill>
-                            <a:srgbClr val="292929"/>
-                          </a:solidFill>
-                          <a:latin typeface="Pretendard"/>
-                          <a:ea typeface="Pretendard"/>
-                          <a:cs typeface="Pretendard"/>
-                        </a:rPr>
-                        <a:t>cdbd-marketing</a:t>
-                      </a:r>
-                    </a:p>
-                  </a:txBody>
-                  <a:tcPr marL="128016" marR="91440" marT="36576" marB="36576" anchor="ctr">
-                    <a:solidFill>
-                      <a:srgbClr val="FFFFFF"/>
-                    </a:solidFill>
-                  </a:tcPr>
-                </a:tc>
-                <a:tc>
-                  <a:txBody>
-                    <a:bodyPr/>
-                    <a:lstStyle/>
-                    <a:p>
-                      <a:pPr algn="r">
-                        <a:lnSpc>
-                          <a:spcPct val="115000"/>
-                        </a:lnSpc>
-                      </a:pPr>
-                      <a:r>
-                        <a:rPr sz="1250" b="0">
-                          <a:solidFill>
-                            <a:srgbClr val="292929"/>
-                          </a:solidFill>
-                          <a:latin typeface="Pretendard"/>
-                          <a:ea typeface="Pretendard"/>
-                          <a:cs typeface="Pretendard"/>
-                        </a:rPr>
-                        <a:t>3.9 KB</a:t>
-                      </a:r>
-                    </a:p>
-                  </a:txBody>
-                  <a:tcPr marL="128016" marR="91440" marT="36576" marB="36576" anchor="ctr">
-                    <a:solidFill>
-                      <a:srgbClr val="FFFFFF"/>
-                    </a:solidFill>
-                  </a:tcPr>
-                </a:tc>
-                <a:tc>
-                  <a:txBody>
-                    <a:bodyPr/>
-                    <a:lstStyle/>
-                    <a:p>
-                      <a:pPr algn="ctr">
-                        <a:lnSpc>
-                          <a:spcPct val="115000"/>
-                        </a:lnSpc>
-                      </a:pPr>
-                      <a:r>
-                        <a:rPr sz="1250" b="0">
-                          <a:solidFill>
-                            <a:srgbClr val="292929"/>
-                          </a:solidFill>
-                          <a:latin typeface="Pretendard"/>
-                          <a:ea typeface="Pretendard"/>
-                          <a:cs typeface="Pretendard"/>
-                        </a:rPr>
-                        <a:t>A4 2장</a:t>
-                      </a:r>
-                    </a:p>
-                  </a:txBody>
-                  <a:tcPr marL="128016" marR="91440" marT="36576" marB="36576" anchor="ctr">
-                    <a:solidFill>
-                      <a:srgbClr val="FFFFFF"/>
-                    </a:solidFill>
-                  </a:tcPr>
-                </a:tc>
-                <a:tc>
-                  <a:txBody>
-                    <a:bodyPr/>
-                    <a:lstStyle/>
-                    <a:p>
-                      <a:pPr algn="l">
-                        <a:lnSpc>
-                          <a:spcPct val="115000"/>
-                        </a:lnSpc>
-                      </a:pPr>
-                      <a:r>
-                        <a:rPr sz="1250" b="0">
-                          <a:solidFill>
-                            <a:srgbClr val="292929"/>
-                          </a:solidFill>
-                          <a:latin typeface="Pretendard"/>
-                          <a:ea typeface="Pretendard"/>
-                          <a:cs typeface="Pretendard"/>
-                        </a:rPr>
-                        <a:t>기능 26개 중 썸네일 관련만 다룸</a:t>
-                      </a:r>
-                    </a:p>
-                  </a:txBody>
-                  <a:tcPr marL="128016" marR="91440" marT="36576" marB="36576" anchor="ctr">
-                    <a:solidFill>
-                      <a:srgbClr val="FFFFFF"/>
-                    </a:solidFill>
-                  </a:tcPr>
-                </a:tc>
-              </a:tr>
-              <a:tr h="420624">
-                <a:tc>
-                  <a:txBody>
-                    <a:bodyPr/>
-                    <a:lstStyle/>
-                    <a:p>
-                      <a:pPr algn="l">
-                        <a:lnSpc>
-                          <a:spcPct val="115000"/>
-                        </a:lnSpc>
-                      </a:pPr>
-                      <a:r>
-                        <a:rPr sz="1250" b="0">
-                          <a:solidFill>
-                            <a:srgbClr val="292929"/>
-                          </a:solidFill>
-                          <a:latin typeface="Pretendard"/>
-                          <a:ea typeface="Pretendard"/>
-                          <a:cs typeface="Pretendard"/>
-                        </a:rPr>
-                        <a:t>makevu-qrstp</a:t>
-                      </a:r>
-                    </a:p>
-                  </a:txBody>
-                  <a:tcPr marL="128016" marR="91440" marT="36576" marB="36576" anchor="ctr">
-                    <a:solidFill>
-                      <a:srgbClr val="FFFFFF"/>
-                    </a:solidFill>
-                  </a:tcPr>
-                </a:tc>
-                <a:tc>
-                  <a:txBody>
-                    <a:bodyPr/>
-                    <a:lstStyle/>
-                    <a:p>
-                      <a:pPr algn="r">
-                        <a:lnSpc>
-                          <a:spcPct val="115000"/>
-                        </a:lnSpc>
-                      </a:pPr>
-                      <a:r>
-                        <a:rPr sz="1250" b="0">
-                          <a:solidFill>
-                            <a:srgbClr val="292929"/>
-                          </a:solidFill>
-                          <a:latin typeface="Pretendard"/>
-                          <a:ea typeface="Pretendard"/>
-                          <a:cs typeface="Pretendard"/>
-                        </a:rPr>
-                        <a:t>3.8 KB</a:t>
-                      </a:r>
-                    </a:p>
-                  </a:txBody>
-                  <a:tcPr marL="128016" marR="91440" marT="36576" marB="36576" anchor="ctr">
-                    <a:solidFill>
-                      <a:srgbClr val="FFFFFF"/>
-                    </a:solidFill>
-                  </a:tcPr>
-                </a:tc>
-                <a:tc>
-                  <a:txBody>
-                    <a:bodyPr/>
-                    <a:lstStyle/>
-                    <a:p>
-                      <a:pPr algn="ctr">
-                        <a:lnSpc>
-                          <a:spcPct val="115000"/>
-                        </a:lnSpc>
-                      </a:pPr>
-                      <a:r>
-                        <a:rPr sz="1250" b="0">
-                          <a:solidFill>
-                            <a:srgbClr val="292929"/>
-                          </a:solidFill>
-                          <a:latin typeface="Pretendard"/>
-                          <a:ea typeface="Pretendard"/>
-                          <a:cs typeface="Pretendard"/>
-                        </a:rPr>
-                        <a:t>A4 2장</a:t>
-                      </a:r>
-                    </a:p>
-                  </a:txBody>
-                  <a:tcPr marL="128016" marR="91440" marT="36576" marB="36576" anchor="ctr">
-                    <a:solidFill>
-                      <a:srgbClr val="FFFFFF"/>
-                    </a:solidFill>
-                  </a:tcPr>
-                </a:tc>
-                <a:tc>
-                  <a:txBody>
-                    <a:bodyPr/>
-                    <a:lstStyle/>
-                    <a:p>
-                      <a:pPr algn="l">
-                        <a:lnSpc>
-                          <a:spcPct val="115000"/>
-                        </a:lnSpc>
-                      </a:pPr>
-                      <a:r>
-                        <a:rPr sz="1250" b="0">
-                          <a:solidFill>
-                            <a:srgbClr val="292929"/>
-                          </a:solidFill>
-                          <a:latin typeface="Pretendard"/>
-                          <a:ea typeface="Pretendard"/>
-                          <a:cs typeface="Pretendard"/>
-                        </a:rPr>
-                        <a:t>참조 이벤트 57건 · 소개서 · 홈페이지 언급 0</a:t>
-                      </a:r>
-                    </a:p>
-                  </a:txBody>
-                  <a:tcPr marL="128016" marR="91440" marT="36576" marB="36576" anchor="ctr">
-                    <a:solidFill>
-                      <a:srgbClr val="FFFFFF"/>
-                    </a:solidFill>
-                  </a:tcPr>
-                </a:tc>
-              </a:tr>
-              <a:tr h="420624">
-                <a:tc>
-                  <a:txBody>
-                    <a:bodyPr/>
-                    <a:lstStyle/>
-                    <a:p>
-                      <a:pPr algn="l">
-                        <a:lnSpc>
-                          <a:spcPct val="115000"/>
-                        </a:lnSpc>
-                      </a:pPr>
-                      <a:r>
-                        <a:rPr sz="1250" b="0">
-                          <a:solidFill>
-                            <a:srgbClr val="292929"/>
-                          </a:solidFill>
-                          <a:latin typeface="Pretendard"/>
-                          <a:ea typeface="Pretendard"/>
-                          <a:cs typeface="Pretendard"/>
-                        </a:rPr>
-                        <a:t>cdbd-design-service</a:t>
-                      </a:r>
-                    </a:p>
-                  </a:txBody>
-                  <a:tcPr marL="128016" marR="91440" marT="36576" marB="36576" anchor="ctr">
-                    <a:solidFill>
-                      <a:srgbClr val="FFFFFF"/>
-                    </a:solidFill>
-                  </a:tcPr>
-                </a:tc>
-                <a:tc>
-                  <a:txBody>
-                    <a:bodyPr/>
-                    <a:lstStyle/>
-                    <a:p>
-                      <a:pPr algn="r">
-                        <a:lnSpc>
-                          <a:spcPct val="115000"/>
-                        </a:lnSpc>
-                      </a:pPr>
-                      <a:r>
-                        <a:rPr sz="1250" b="0">
-                          <a:solidFill>
-                            <a:srgbClr val="292929"/>
-                          </a:solidFill>
-                          <a:latin typeface="Pretendard"/>
-                          <a:ea typeface="Pretendard"/>
-                          <a:cs typeface="Pretendard"/>
-                        </a:rPr>
-                        <a:t>34.9 KB</a:t>
-                      </a:r>
-                    </a:p>
-                  </a:txBody>
-                  <a:tcPr marL="128016" marR="91440" marT="36576" marB="36576" anchor="ctr">
-                    <a:solidFill>
-                      <a:srgbClr val="FFFFFF"/>
-                    </a:solidFill>
-                  </a:tcPr>
-                </a:tc>
-                <a:tc>
-                  <a:txBody>
-                    <a:bodyPr/>
-                    <a:lstStyle/>
-                    <a:p>
-                      <a:pPr algn="ctr">
-                        <a:lnSpc>
-                          <a:spcPct val="115000"/>
-                        </a:lnSpc>
-                      </a:pPr>
-                      <a:r>
-                        <a:rPr sz="1250" b="0">
-                          <a:solidFill>
-                            <a:srgbClr val="292929"/>
-                          </a:solidFill>
-                          <a:latin typeface="Pretendard"/>
-                          <a:ea typeface="Pretendard"/>
-                          <a:cs typeface="Pretendard"/>
-                        </a:rPr>
-                        <a:t>A4 16장</a:t>
-                      </a:r>
-                    </a:p>
-                  </a:txBody>
-                  <a:tcPr marL="128016" marR="91440" marT="36576" marB="36576" anchor="ctr">
-                    <a:solidFill>
-                      <a:srgbClr val="FFFFFF"/>
-                    </a:solidFill>
-                  </a:tcPr>
-                </a:tc>
-                <a:tc>
-                  <a:txBody>
-                    <a:bodyPr/>
-                    <a:lstStyle/>
-                    <a:p>
-                      <a:pPr algn="l">
-                        <a:lnSpc>
-                          <a:spcPct val="115000"/>
-                        </a:lnSpc>
-                      </a:pPr>
-                      <a:r>
-                        <a:rPr sz="1250" b="0">
-                          <a:solidFill>
-                            <a:srgbClr val="292929"/>
-                          </a:solidFill>
-                          <a:latin typeface="Pretendard"/>
-                          <a:ea typeface="Pretendard"/>
-                          <a:cs typeface="Pretendard"/>
-                        </a:rPr>
-                        <a:t>안내문 속 문서 주소 9개가 전부 틀림</a:t>
-                      </a:r>
-                    </a:p>
-                  </a:txBody>
-                  <a:tcPr marL="128016" marR="91440" marT="36576" marB="36576" anchor="ctr">
-                    <a:solidFill>
-                      <a:srgbClr val="FFFFFF"/>
-                    </a:solidFill>
-                  </a:tcPr>
-                </a:tc>
-              </a:tr>
-              <a:tr h="420624">
-                <a:tc>
-                  <a:txBody>
-                    <a:bodyPr/>
-                    <a:lstStyle/>
-                    <a:p>
-                      <a:pPr algn="l">
-                        <a:lnSpc>
-                          <a:spcPct val="115000"/>
-                        </a:lnSpc>
-                      </a:pPr>
-                      <a:r>
-                        <a:rPr sz="1250" b="0">
-                          <a:solidFill>
-                            <a:srgbClr val="292929"/>
-                          </a:solidFill>
-                          <a:latin typeface="Pretendard"/>
-                          <a:ea typeface="Pretendard"/>
-                          <a:cs typeface="Pretendard"/>
-                        </a:rPr>
-                        <a:t>cdbd-templates</a:t>
-                      </a:r>
-                    </a:p>
-                  </a:txBody>
-                  <a:tcPr marL="128016" marR="91440" marT="36576" marB="36576" anchor="ctr">
-                    <a:solidFill>
-                      <a:srgbClr val="FFF6E6"/>
-                    </a:solidFill>
-                  </a:tcPr>
-                </a:tc>
-                <a:tc>
-                  <a:txBody>
-                    <a:bodyPr/>
-                    <a:lstStyle/>
-                    <a:p>
-                      <a:pPr algn="r">
-                        <a:lnSpc>
-                          <a:spcPct val="115000"/>
-                        </a:lnSpc>
-                      </a:pPr>
-                      <a:r>
-                        <a:rPr sz="1250" b="0">
-                          <a:solidFill>
-                            <a:srgbClr val="292929"/>
-                          </a:solidFill>
-                          <a:latin typeface="Pretendard"/>
-                          <a:ea typeface="Pretendard"/>
-                          <a:cs typeface="Pretendard"/>
-                        </a:rPr>
-                        <a:t>131 KB</a:t>
-                      </a:r>
-                    </a:p>
-                  </a:txBody>
-                  <a:tcPr marL="128016" marR="91440" marT="36576" marB="36576" anchor="ctr">
-                    <a:solidFill>
-                      <a:srgbClr val="FFF6E6"/>
-                    </a:solidFill>
-                  </a:tcPr>
-                </a:tc>
-                <a:tc>
-                  <a:txBody>
-                    <a:bodyPr/>
-                    <a:lstStyle/>
-                    <a:p>
-                      <a:pPr algn="ctr">
-                        <a:lnSpc>
-                          <a:spcPct val="115000"/>
-                        </a:lnSpc>
-                      </a:pPr>
-                      <a:r>
-                        <a:rPr sz="1250" b="0">
-                          <a:solidFill>
-                            <a:srgbClr val="292929"/>
-                          </a:solidFill>
-                          <a:latin typeface="Pretendard"/>
-                          <a:ea typeface="Pretendard"/>
-                          <a:cs typeface="Pretendard"/>
-                        </a:rPr>
-                        <a:t>A4 60장</a:t>
-                      </a:r>
-                    </a:p>
-                  </a:txBody>
-                  <a:tcPr marL="128016" marR="91440" marT="36576" marB="36576" anchor="ctr">
-                    <a:solidFill>
-                      <a:srgbClr val="FFF6E6"/>
-                    </a:solidFill>
-                  </a:tcPr>
-                </a:tc>
-                <a:tc>
-                  <a:txBody>
-                    <a:bodyPr/>
-                    <a:lstStyle/>
-                    <a:p>
-                      <a:pPr algn="l">
-                        <a:lnSpc>
-                          <a:spcPct val="115000"/>
-                        </a:lnSpc>
-                      </a:pPr>
-                      <a:r>
-                        <a:rPr sz="1250" b="0">
-                          <a:solidFill>
-                            <a:srgbClr val="292929"/>
-                          </a:solidFill>
-                          <a:latin typeface="Pretendard"/>
-                          <a:ea typeface="Pretendard"/>
-                          <a:cs typeface="Pretendard"/>
-                        </a:rPr>
-                        <a:t>너무 길어 핵심이 묻힘</a:t>
-                      </a:r>
-                    </a:p>
-                  </a:txBody>
-                  <a:tcPr marL="128016" marR="91440" marT="36576" marB="36576" anchor="ctr">
-                    <a:solidFill>
-                      <a:srgbClr val="FFF6E6"/>
-                    </a:solidFill>
-                  </a:tcPr>
-                </a:tc>
-              </a:tr>
             </a:tbl>
           </a:graphicData>
         </a:graphic>
       </p:graphicFrame>
       <p:sp>
         <p:nvSpPr>
-          <p:cNvPr id="7" name="Rectangle 6"/>
+          <p:cNvPr id="14" name="Rectangle 13"/>
           <p:cNvSpPr/>
           <p:nvPr/>
         </p:nvSpPr>
         <p:spPr>
           <a:xfrm>
-            <a:off x="777240" y="4846320"/>
-            <a:ext cx="10634472" cy="1234440"/>
+            <a:off x="777240" y="6035040"/>
+            <a:ext cx="10634472" cy="457200"/>
           </a:xfrm>
           <a:prstGeom prst="rect">
             <a:avLst/>
           </a:prstGeom>
           <a:solidFill>
-            <a:srgbClr val="F2F0FF"/>
+            <a:srgbClr val="292929"/>
           </a:solidFill>
           <a:ln>
             <a:noFill/>
@@ -29740,14 +29887,14 @@
       </p:sp>
       <p:sp>
         <p:nvSpPr>
-          <p:cNvPr id="8" name="TextBox 7"/>
+          <p:cNvPr id="15" name="TextBox 14"/>
           <p:cNvSpPr txBox="1"/>
           <p:nvPr/>
         </p:nvSpPr>
         <p:spPr>
           <a:xfrm>
-            <a:off x="1051560" y="5029200"/>
-            <a:ext cx="10058400" cy="914400"/>
+            <a:off x="1051560" y="6144768"/>
+            <a:ext cx="10241280" cy="274320"/>
           </a:xfrm>
           <a:prstGeom prst="rect">
             <a:avLst/>
@@ -29772,46 +29919,22 @@
               </a:spcAft>
             </a:pPr>
             <a:r>
-              <a:rPr sz="1600" b="1">
-                <a:solidFill>
-                  <a:srgbClr val="6C4CFF"/>
-                </a:solidFill>
-                <a:latin typeface="Pretendard"/>
-                <a:ea typeface="Pretendard"/>
-                <a:cs typeface="Pretendard"/>
-              </a:rPr>
-              <a:t>한쪽은 아무것도 안 알려주고, 한쪽은 60장을 읽히려 합니다. 둘 다 안 됩니다.</a:t>
-            </a:r>
-          </a:p>
-          <a:p>
-            <a:pPr>
-              <a:lnSpc>
-                <a:spcPct val="135000"/>
-              </a:lnSpc>
-              <a:spcBef>
-                <a:spcPts val="800"/>
-              </a:spcBef>
-              <a:spcAft>
-                <a:spcPts val="0"/>
-              </a:spcAft>
-            </a:pPr>
-            <a:r>
-              <a:rPr sz="1400" b="0">
-                <a:solidFill>
-                  <a:srgbClr val="292929"/>
-                </a:solidFill>
-                <a:latin typeface="Pretendard"/>
-                <a:ea typeface="Pretendard"/>
-                <a:cs typeface="Pretendard"/>
-              </a:rPr>
-              <a:t>그리고 5개 저장소의 안내문 중, 자기 저장소가 가진 스킬을 소개하는 곳은 단 한 곳도 없습니다.</a:t>
-            </a:r>
-          </a:p>
-        </p:txBody>
-      </p:sp>
-      <p:sp>
-        <p:nvSpPr>
-          <p:cNvPr id="9" name="TextBox 8"/>
+              <a:rPr sz="1300" b="1">
+                <a:solidFill>
+                  <a:srgbClr val="FFFFFF"/>
+                </a:solidFill>
+                <a:latin typeface="Pretendard"/>
+                <a:ea typeface="Pretendard"/>
+                <a:cs typeface="Pretendard"/>
+              </a:rPr>
+              <a:t>해결은 “분량을 맞춰라”가 아닙니다. 뼈대(骨)는 공통으로 정하고, 내용(肉)은 저장소마다 다르게 — 이게 맞습니다.</a:t>
+            </a:r>
+          </a:p>
+        </p:txBody>
+      </p:sp>
+      <p:sp>
+        <p:nvSpPr>
+          <p:cNvPr id="16" name="TextBox 15"/>
           <p:cNvSpPr txBox="1"/>
           <p:nvPr/>
         </p:nvSpPr>
@@ -29858,7 +29981,7 @@
       </p:sp>
       <p:sp>
         <p:nvSpPr>
-          <p:cNvPr id="10" name="TextBox 9"/>
+          <p:cNvPr id="17" name="TextBox 16"/>
           <p:cNvSpPr txBox="1"/>
           <p:nvPr/>
         </p:nvSpPr>

</xml_diff>

<commit_message>
vault backup: 2026-08-09 21:39:11
</commit_message>
<xml_diff>
--- a/CdBd 문서 체계 진단 및 개편 제안.pptx
+++ b/CdBd 문서 체계 진단 및 개편 제안.pptx
@@ -9848,8 +9848,8 @@
         </p:nvSpPr>
         <p:spPr>
           <a:xfrm>
-            <a:off x="777240" y="5989320"/>
-            <a:ext cx="5120640" cy="457200"/>
+            <a:off x="777240" y="5961888"/>
+            <a:ext cx="5120640" cy="320040"/>
           </a:xfrm>
           <a:prstGeom prst="rect">
             <a:avLst/>
@@ -9864,17 +9864,17 @@
           <a:p>
             <a:pPr algn="l">
               <a:lnSpc>
-                <a:spcPct val="145000"/>
-              </a:lnSpc>
-              <a:spcBef>
-                <a:spcPts val="0"/>
-              </a:spcBef>
-              <a:spcAft>
-                <a:spcPts val="0"/>
-              </a:spcAft>
-            </a:pPr>
-            <a:r>
-              <a:rPr sz="1250" b="0">
+                <a:spcPct val="135000"/>
+              </a:lnSpc>
+              <a:spcBef>
+                <a:spcPts val="0"/>
+              </a:spcBef>
+              <a:spcAft>
+                <a:spcPts val="0"/>
+              </a:spcAft>
+            </a:pPr>
+            <a:r>
+              <a:rPr sz="1200" b="0">
                 <a:solidFill>
                   <a:srgbClr val="6B6B6B"/>
                 </a:solidFill>
@@ -9882,7 +9882,7 @@
                 <a:ea typeface="Pretendard"/>
                 <a:cs typeface="Pretendard"/>
               </a:rPr>
-              <a:t>스킬은 이렇게 짧습니다. 내용을 베끼지 않고 “이 문서를 읽어라”라고 가리키기만 합니다.</a:t>
+              <a:t>스킬은 짧습니다 — 내용을 베끼지 않고 정본 문서를 가리키기만 합니다.</a:t>
             </a:r>
           </a:p>
         </p:txBody>
@@ -28996,8 +28996,8 @@
         </p:nvSpPr>
         <p:spPr>
           <a:xfrm>
-            <a:off x="777240" y="2148840"/>
-            <a:ext cx="5120640" cy="1965960"/>
+            <a:off x="777240" y="2103120"/>
+            <a:ext cx="5120640" cy="2194560"/>
           </a:xfrm>
           <a:prstGeom prst="rect">
             <a:avLst/>
@@ -29042,7 +29042,7 @@
         </p:nvSpPr>
         <p:spPr>
           <a:xfrm>
-            <a:off x="1024128" y="2331720"/>
+            <a:off x="1024128" y="2286000"/>
             <a:ext cx="4617720" cy="274320"/>
           </a:xfrm>
           <a:prstGeom prst="rect">
@@ -29089,8 +29089,8 @@
         </p:nvSpPr>
         <p:spPr>
           <a:xfrm>
-            <a:off x="1024128" y="2697480"/>
-            <a:ext cx="4617720" cy="1280160"/>
+            <a:off x="1024128" y="2651760"/>
+            <a:ext cx="4617720" cy="1463040"/>
           </a:xfrm>
           <a:prstGeom prst="rect">
             <a:avLst/>
@@ -29232,8 +29232,8 @@
         </p:nvSpPr>
         <p:spPr>
           <a:xfrm>
-            <a:off x="6263640" y="2148840"/>
-            <a:ext cx="5148072" cy="1965960"/>
+            <a:off x="6263640" y="2103120"/>
+            <a:ext cx="5148072" cy="2194560"/>
           </a:xfrm>
           <a:prstGeom prst="rect">
             <a:avLst/>
@@ -29278,7 +29278,7 @@
         </p:nvSpPr>
         <p:spPr>
           <a:xfrm>
-            <a:off x="6510528" y="2331720"/>
+            <a:off x="6510528" y="2286000"/>
             <a:ext cx="4617720" cy="274320"/>
           </a:xfrm>
           <a:prstGeom prst="rect">
@@ -29325,8 +29325,8 @@
         </p:nvSpPr>
         <p:spPr>
           <a:xfrm>
-            <a:off x="6510528" y="2697480"/>
-            <a:ext cx="4709160" cy="1280160"/>
+            <a:off x="6510528" y="2651760"/>
+            <a:ext cx="4709160" cy="1554480"/>
           </a:xfrm>
           <a:prstGeom prst="rect">
             <a:avLst/>
@@ -29344,7 +29344,7 @@
                 <a:spcPct val="140000"/>
               </a:lnSpc>
               <a:spcBef>
-                <a:spcPts val="600"/>
+                <a:spcPts val="500"/>
               </a:spcBef>
             </a:pPr>
             <a:r>
@@ -29376,7 +29376,7 @@
                 <a:spcPct val="140000"/>
               </a:lnSpc>
               <a:spcBef>
-                <a:spcPts val="600"/>
+                <a:spcPts val="500"/>
               </a:spcBef>
             </a:pPr>
             <a:r>
@@ -29408,7 +29408,7 @@
                 <a:spcPct val="140000"/>
               </a:lnSpc>
               <a:spcBef>
-                <a:spcPts val="600"/>
+                <a:spcPts val="500"/>
               </a:spcBef>
             </a:pPr>
             <a:r>
@@ -29440,7 +29440,7 @@
                 <a:spcPct val="140000"/>
               </a:lnSpc>
               <a:spcBef>
-                <a:spcPts val="600"/>
+                <a:spcPts val="500"/>
               </a:spcBef>
             </a:pPr>
             <a:r>
@@ -29472,7 +29472,7 @@
                 <a:spcPct val="140000"/>
               </a:lnSpc>
               <a:spcBef>
-                <a:spcPts val="600"/>
+                <a:spcPts val="500"/>
               </a:spcBef>
             </a:pPr>
             <a:r>
@@ -29508,7 +29508,7 @@
         </p:nvSpPr>
         <p:spPr>
           <a:xfrm>
-            <a:off x="777240" y="4279392"/>
+            <a:off x="777240" y="4480560"/>
             <a:ext cx="10607040" cy="274320"/>
           </a:xfrm>
           <a:prstGeom prst="rect">
@@ -29556,8 +29556,8 @@
           <p:nvPr/>
         </p:nvGraphicFramePr>
         <p:xfrm>
-          <a:off x="777240" y="4663440"/>
-          <a:ext cx="10634471" cy="1261872"/>
+          <a:off x="777240" y="4846320"/>
+          <a:ext cx="10634471" cy="1097280"/>
         </p:xfrm>
         <a:graphic>
           <a:graphicData uri="http://schemas.openxmlformats.org/drawingml/2006/table">
@@ -29570,7 +29570,7 @@
                 <a:gridCol w="3840480"/>
                 <a:gridCol w="4050791"/>
               </a:tblGrid>
-              <a:tr h="420624">
+              <a:tr h="365760">
                 <a:tc>
                   <a:txBody>
                     <a:bodyPr/>
@@ -29582,7 +29582,7 @@
                         </a:lnSpc>
                       </a:pPr>
                       <a:r>
-                        <a:rPr sz="1250" b="1">
+                        <a:rPr sz="1200" b="1">
                           <a:solidFill>
                             <a:srgbClr val="FFFFFF"/>
                           </a:solidFill>
@@ -29611,7 +29611,7 @@
                         </a:lnSpc>
                       </a:pPr>
                       <a:r>
-                        <a:rPr sz="1250" b="1">
+                        <a:rPr sz="1200" b="1">
                           <a:solidFill>
                             <a:srgbClr val="FFFFFF"/>
                           </a:solidFill>
@@ -29640,7 +29640,7 @@
                         </a:lnSpc>
                       </a:pPr>
                       <a:r>
-                        <a:rPr sz="1250" b="1">
+                        <a:rPr sz="1200" b="1">
                           <a:solidFill>
                             <a:srgbClr val="FFFFFF"/>
                           </a:solidFill>
@@ -29659,7 +29659,7 @@
                   </a:tcPr>
                 </a:tc>
               </a:tr>
-              <a:tr h="420624">
+              <a:tr h="365760">
                 <a:tc>
                   <a:txBody>
                     <a:bodyPr/>
@@ -29671,7 +29671,7 @@
                         </a:lnSpc>
                       </a:pPr>
                       <a:r>
-                        <a:rPr sz="1250" b="0">
+                        <a:rPr sz="1200" b="0">
                           <a:solidFill>
                             <a:srgbClr val="292929"/>
                           </a:solidFill>
@@ -29700,7 +29700,7 @@
                         </a:lnSpc>
                       </a:pPr>
                       <a:r>
-                        <a:rPr sz="1250" b="0">
+                        <a:rPr sz="1200" b="0">
                           <a:solidFill>
                             <a:srgbClr val="292929"/>
                           </a:solidFill>
@@ -29729,7 +29729,7 @@
                         </a:lnSpc>
                       </a:pPr>
                       <a:r>
-                        <a:rPr sz="1250" b="0">
+                        <a:rPr sz="1200" b="0">
                           <a:solidFill>
                             <a:srgbClr val="292929"/>
                           </a:solidFill>
@@ -29748,7 +29748,7 @@
                   </a:tcPr>
                 </a:tc>
               </a:tr>
-              <a:tr h="420624">
+              <a:tr h="365760">
                 <a:tc>
                   <a:txBody>
                     <a:bodyPr/>
@@ -29760,7 +29760,7 @@
                         </a:lnSpc>
                       </a:pPr>
                       <a:r>
-                        <a:rPr sz="1250" b="0">
+                        <a:rPr sz="1200" b="0">
                           <a:solidFill>
                             <a:srgbClr val="292929"/>
                           </a:solidFill>
@@ -29789,7 +29789,7 @@
                         </a:lnSpc>
                       </a:pPr>
                       <a:r>
-                        <a:rPr sz="1250" b="0">
+                        <a:rPr sz="1200" b="0">
                           <a:solidFill>
                             <a:srgbClr val="292929"/>
                           </a:solidFill>
@@ -29818,7 +29818,7 @@
                         </a:lnSpc>
                       </a:pPr>
                       <a:r>
-                        <a:rPr sz="1250" b="0">
+                        <a:rPr sz="1200" b="0">
                           <a:solidFill>
                             <a:srgbClr val="292929"/>
                           </a:solidFill>
@@ -29850,7 +29850,7 @@
         <p:spPr>
           <a:xfrm>
             <a:off x="777240" y="6035040"/>
-            <a:ext cx="10634472" cy="457200"/>
+            <a:ext cx="10634472" cy="411480"/>
           </a:xfrm>
           <a:prstGeom prst="rect">
             <a:avLst/>
@@ -29893,7 +29893,7 @@
         </p:nvSpPr>
         <p:spPr>
           <a:xfrm>
-            <a:off x="1051560" y="6144768"/>
+            <a:off x="1051560" y="6117336"/>
             <a:ext cx="10241280" cy="274320"/>
           </a:xfrm>
           <a:prstGeom prst="rect">

</xml_diff>

<commit_message>
vault backup: 2026-08-09 21:57:26
</commit_message>
<xml_diff>
--- a/CdBd 문서 체계 진단 및 개편 제안.pptx
+++ b/CdBd 문서 체계 진단 및 개편 제안.pptx
@@ -8214,17 +8214,17 @@
           <a:p>
             <a:pPr algn="l">
               <a:lnSpc>
-                <a:spcPct val="135000"/>
-              </a:lnSpc>
-              <a:spcBef>
-                <a:spcPts val="0"/>
-              </a:spcBef>
-              <a:spcAft>
-                <a:spcPts val="0"/>
-              </a:spcAft>
-            </a:pPr>
-            <a:r>
-              <a:rPr sz="4200" b="1">
+                <a:spcPct val="120000"/>
+              </a:lnSpc>
+              <a:spcBef>
+                <a:spcPts val="0"/>
+              </a:spcBef>
+              <a:spcAft>
+                <a:spcPts val="0"/>
+              </a:spcAft>
+            </a:pPr>
+            <a:r>
+              <a:rPr sz="4000" b="1">
                 <a:solidFill>
                   <a:srgbClr val="FFFFFF"/>
                 </a:solidFill>
@@ -8232,7 +8232,31 @@
                 <a:ea typeface="Pretendard"/>
                 <a:cs typeface="Pretendard"/>
               </a:rPr>
-              <a:t>두 가지 방식을 제안합니다</a:t>
+              <a:t>질문 두 개로 나눠서</a:t>
+            </a:r>
+          </a:p>
+          <a:p>
+            <a:pPr>
+              <a:lnSpc>
+                <a:spcPct val="120000"/>
+              </a:lnSpc>
+              <a:spcBef>
+                <a:spcPts val="0"/>
+              </a:spcBef>
+              <a:spcAft>
+                <a:spcPts val="0"/>
+              </a:spcAft>
+            </a:pPr>
+            <a:r>
+              <a:rPr sz="4000" b="1">
+                <a:solidFill>
+                  <a:srgbClr val="FFFFFF"/>
+                </a:solidFill>
+                <a:latin typeface="Pretendard"/>
+                <a:ea typeface="Pretendard"/>
+                <a:cs typeface="Pretendard"/>
+              </a:rPr>
+              <a:t>답하겠습니다</a:t>
             </a:r>
           </a:p>
         </p:txBody>
@@ -8245,7 +8269,7 @@
         </p:nvSpPr>
         <p:spPr>
           <a:xfrm>
-            <a:off x="1280160" y="4434840"/>
+            <a:off x="1280160" y="4892040"/>
             <a:ext cx="9601200" cy="457200"/>
           </a:xfrm>
           <a:prstGeom prst="rect">
@@ -8279,7 +8303,7 @@
                 <a:ea typeface="Pretendard"/>
                 <a:cs typeface="Pretendard"/>
               </a:rPr>
-              <a:t>그 전에 — 왜 “문서를 더 잘 쓰기”가 답이 아닌지 먼저 보시겠습니다.</a:t>
+              <a:t>① 정본을 어디 두나   ·   ② Claude에게 어떻게 전달하나</a:t>
             </a:r>
           </a:p>
         </p:txBody>
@@ -8388,7 +8412,7 @@
                 <a:ea typeface="Pretendard"/>
                 <a:cs typeface="Pretendard"/>
               </a:rPr>
-              <a:t>④ 해결 방안 · A·B 공통 토대</a:t>
+              <a:t>④ 해결 방안 · 모든 안의 공통 토대</a:t>
             </a:r>
           </a:p>
         </p:txBody>
@@ -8526,7 +8550,7 @@
                 <a:ea typeface="Pretendard"/>
                 <a:cs typeface="Pretendard"/>
               </a:rPr>
-              <a:t>이건 방식 A·B 둘 다에 해당합니다. 차이는 몇 개를 만드느냐뿐입니다 — A는 자주 쓰는 약 20개, B는 96개 전부.</a:t>
+              <a:t>이건 뒤에 나올 모든 안에 공통으로 해당합니다. 차이는 “몇 개를 만드느냐”와 “어디에 두느냐”뿐입니다.</a:t>
             </a:r>
           </a:p>
         </p:txBody>
@@ -17158,7 +17182,7 @@
                 <a:ea typeface="Pretendard"/>
                 <a:cs typeface="Pretendard"/>
               </a:rPr>
-              <a:t>해결 방안 2가지</a:t>
+              <a:t>해결 방안</a:t>
             </a:r>
           </a:p>
         </p:txBody>
@@ -17205,7 +17229,7 @@
                 <a:ea typeface="Pretendard"/>
                 <a:cs typeface="Pretendard"/>
               </a:rPr>
-              <a:t>가볍게 시작하는 안 / 근본적으로 고치는 안 + 구조도</a:t>
+              <a:t>질문 두 개로 나눠서 · 네 가지 안 총평 · 권장 구조도</a:t>
             </a:r>
           </a:p>
         </p:txBody>
@@ -17252,7 +17276,7 @@
                 <a:ea typeface="Pretendard"/>
                 <a:cs typeface="Pretendard"/>
               </a:rPr>
-              <a:t>14 – 19</a:t>
+              <a:t>14 – 21</a:t>
             </a:r>
           </a:p>
         </p:txBody>
@@ -17483,7 +17507,7 @@
                 <a:ea typeface="Pretendard"/>
                 <a:cs typeface="Pretendard"/>
               </a:rPr>
-              <a:t>두 방식 비교와, 어느 쪽이든 지금 해야 할 것</a:t>
+              <a:t>지금 vs 권장안, 어느 쪽이든 지금 해야 할 것</a:t>
             </a:r>
           </a:p>
         </p:txBody>
@@ -17530,7 +17554,7 @@
                 <a:ea typeface="Pretendard"/>
                 <a:cs typeface="Pretendard"/>
               </a:rPr>
-              <a:t>20 – 22</a:t>
+              <a:t>22 – 24</a:t>
             </a:r>
           </a:p>
         </p:txBody>
@@ -17577,7 +17601,7 @@
                 <a:ea typeface="Pretendard"/>
                 <a:cs typeface="Pretendard"/>
               </a:rPr>
-              <a:t>총 22장 · 15~20분  ·  가장 중요한 장은 03번입니다. 원인을 알아야 어느 해결안이 맞는지 판단하실 수 있습니다.</a:t>
+              <a:t>총 24장 · 20분  ·  가장 중요한 장은 03번입니다. 원인을 알아야 어느 해결안이 맞는지 판단하실 수 있습니다.</a:t>
             </a:r>
           </a:p>
         </p:txBody>
@@ -17733,7 +17757,7 @@
                 <a:ea typeface="Pretendard"/>
                 <a:cs typeface="Pretendard"/>
               </a:rPr>
-              <a:t>cdbd-core를 만들면 파일이 이렇게 배치됩니다</a:t>
+              <a:t>권장안을 적용하면 이렇게 배치됩니다</a:t>
             </a:r>
           </a:p>
         </p:txBody>
@@ -20385,7 +20409,7 @@
                 <a:ea typeface="Pretendard"/>
                 <a:cs typeface="Pretendard"/>
               </a:rPr>
-              <a:t>방식 B 적용 후</a:t>
+              <a:t>권장안 적용 후</a:t>
             </a:r>
           </a:p>
         </p:txBody>
@@ -21104,7 +21128,7 @@
                 <a:ea typeface="Pretendard"/>
                 <a:cs typeface="Pretendard"/>
               </a:rPr>
-              <a:t>무엇이 달라지나</a:t>
+              <a:t>무엇이 달라지나 — 지금 · 1단계만 · 권장안</a:t>
             </a:r>
           </a:p>
         </p:txBody>
@@ -21241,7 +21265,7 @@
                           <a:ea typeface="Pretendard"/>
                           <a:cs typeface="Pretendard"/>
                         </a:rPr>
-                        <a:t>방식 A</a:t>
+                        <a:t>A만 했을 때</a:t>
                       </a:r>
                     </a:p>
                   </a:txBody>
@@ -21270,7 +21294,7 @@
                           <a:ea typeface="Pretendard"/>
                           <a:cs typeface="Pretendard"/>
                         </a:rPr>
-                        <a:t>방식 B</a:t>
+                        <a:t>권장안</a:t>
                       </a:r>
                     </a:p>
                   </a:txBody>
@@ -22152,7 +22176,7 @@
                           <a:ea typeface="Pretendard"/>
                           <a:cs typeface="Pretendard"/>
                         </a:rPr>
-                        <a:t>스크립트 한 줄</a:t>
+                        <a:t>플러그인 설치 1회</a:t>
                       </a:r>
                     </a:p>
                   </a:txBody>
@@ -22547,7 +22571,7 @@
                 <a:ea typeface="Pretendard"/>
                 <a:cs typeface="Pretendard"/>
               </a:rPr>
-              <a:t>권장: 방식 A를 저장소 1개에 먼저 시범 적용해 효과를 확인한 뒤, 방식 B로 확장하는 순서입니다.</a:t>
+              <a:t>권장 순서: A(1단계)를 저장소 1개에 먼저 적용해 효과를 확인한 뒤, _core + 플러그인으로 확장합니다.</a:t>
             </a:r>
           </a:p>
         </p:txBody>

</xml_diff>

<commit_message>
vault backup: 2026-08-09 21:58:34
</commit_message>
<xml_diff>
--- a/CdBd 문서 체계 진단 및 개편 제안.pptx
+++ b/CdBd 문서 체계 진단 및 개편 제안.pptx
@@ -13704,7 +13704,7 @@
         <p:spPr>
           <a:xfrm>
             <a:off x="777240" y="2148840"/>
-            <a:ext cx="5166360" cy="3200400"/>
+            <a:ext cx="5166360" cy="3429000"/>
           </a:xfrm>
           <a:prstGeom prst="rect">
             <a:avLst/>
@@ -13891,7 +13891,7 @@
         <p:spPr>
           <a:xfrm>
             <a:off x="1051560" y="3246120"/>
-            <a:ext cx="4617720" cy="914400"/>
+            <a:ext cx="4617720" cy="1051560"/>
           </a:xfrm>
           <a:prstGeom prst="rect">
             <a:avLst/>
@@ -13906,17 +13906,17 @@
           <a:p>
             <a:pPr algn="l">
               <a:lnSpc>
-                <a:spcPct val="140000"/>
-              </a:lnSpc>
-              <a:spcBef>
-                <a:spcPts val="500"/>
-              </a:spcBef>
-              <a:spcAft>
-                <a:spcPts val="0"/>
-              </a:spcAft>
-            </a:pPr>
-            <a:r>
-              <a:rPr sz="1200" b="0">
+                <a:spcPct val="135000"/>
+              </a:lnSpc>
+              <a:spcBef>
+                <a:spcPts val="400"/>
+              </a:spcBef>
+              <a:spcAft>
+                <a:spcPts val="0"/>
+              </a:spcAft>
+            </a:pPr>
+            <a:r>
+              <a:rPr sz="1150" b="0">
                 <a:solidFill>
                   <a:srgbClr val="292929"/>
                 </a:solidFill>
@@ -13930,17 +13930,17 @@
           <a:p>
             <a:pPr>
               <a:lnSpc>
-                <a:spcPct val="140000"/>
-              </a:lnSpc>
-              <a:spcBef>
-                <a:spcPts val="500"/>
-              </a:spcBef>
-              <a:spcAft>
-                <a:spcPts val="0"/>
-              </a:spcAft>
-            </a:pPr>
-            <a:r>
-              <a:rPr sz="1200" b="0">
+                <a:spcPct val="135000"/>
+              </a:lnSpc>
+              <a:spcBef>
+                <a:spcPts val="400"/>
+              </a:spcBef>
+              <a:spcAft>
+                <a:spcPts val="0"/>
+              </a:spcAft>
+            </a:pPr>
+            <a:r>
+              <a:rPr sz="1150" b="0">
                 <a:solidFill>
                   <a:srgbClr val="292929"/>
                 </a:solidFill>
@@ -13961,7 +13961,7 @@
         </p:nvSpPr>
         <p:spPr>
           <a:xfrm>
-            <a:off x="1051560" y="4315968"/>
+            <a:off x="1051560" y="4434840"/>
             <a:ext cx="4617720" cy="228600"/>
           </a:xfrm>
           <a:prstGeom prst="rect">
@@ -14008,8 +14008,8 @@
         </p:nvSpPr>
         <p:spPr>
           <a:xfrm>
-            <a:off x="1051560" y="4544568"/>
-            <a:ext cx="4617720" cy="731520"/>
+            <a:off x="1051560" y="4645152"/>
+            <a:ext cx="4617720" cy="822960"/>
           </a:xfrm>
           <a:prstGeom prst="rect">
             <a:avLst/>
@@ -14024,17 +14024,17 @@
           <a:p>
             <a:pPr algn="l">
               <a:lnSpc>
-                <a:spcPct val="140000"/>
-              </a:lnSpc>
-              <a:spcBef>
-                <a:spcPts val="500"/>
-              </a:spcBef>
-              <a:spcAft>
-                <a:spcPts val="0"/>
-              </a:spcAft>
-            </a:pPr>
-            <a:r>
-              <a:rPr sz="1200" b="0">
+                <a:spcPct val="135000"/>
+              </a:lnSpc>
+              <a:spcBef>
+                <a:spcPts val="400"/>
+              </a:spcBef>
+              <a:spcAft>
+                <a:spcPts val="0"/>
+              </a:spcAft>
+            </a:pPr>
+            <a:r>
+              <a:rPr sz="1150" b="0">
                 <a:solidFill>
                   <a:srgbClr val="292929"/>
                 </a:solidFill>
@@ -14048,17 +14048,17 @@
           <a:p>
             <a:pPr>
               <a:lnSpc>
-                <a:spcPct val="140000"/>
-              </a:lnSpc>
-              <a:spcBef>
-                <a:spcPts val="500"/>
-              </a:spcBef>
-              <a:spcAft>
-                <a:spcPts val="0"/>
-              </a:spcAft>
-            </a:pPr>
-            <a:r>
-              <a:rPr sz="1200" b="0">
+                <a:spcPct val="135000"/>
+              </a:lnSpc>
+              <a:spcBef>
+                <a:spcPts val="400"/>
+              </a:spcBef>
+              <a:spcAft>
+                <a:spcPts val="0"/>
+              </a:spcAft>
+            </a:pPr>
+            <a:r>
+              <a:rPr sz="1150" b="0">
                 <a:solidFill>
                   <a:srgbClr val="292929"/>
                 </a:solidFill>
@@ -14072,17 +14072,17 @@
           <a:p>
             <a:pPr>
               <a:lnSpc>
-                <a:spcPct val="140000"/>
-              </a:lnSpc>
-              <a:spcBef>
-                <a:spcPts val="500"/>
-              </a:spcBef>
-              <a:spcAft>
-                <a:spcPts val="0"/>
-              </a:spcAft>
-            </a:pPr>
-            <a:r>
-              <a:rPr sz="1200" b="0">
+                <a:spcPct val="135000"/>
+              </a:lnSpc>
+              <a:spcBef>
+                <a:spcPts val="400"/>
+              </a:spcBef>
+              <a:spcAft>
+                <a:spcPts val="0"/>
+              </a:spcAft>
+            </a:pPr>
+            <a:r>
+              <a:rPr sz="1150" b="0">
                 <a:solidFill>
                   <a:srgbClr val="292929"/>
                 </a:solidFill>
@@ -14103,8 +14103,8 @@
         </p:nvSpPr>
         <p:spPr>
           <a:xfrm>
-            <a:off x="1051560" y="5010912"/>
-            <a:ext cx="4617720" cy="256032"/>
+            <a:off x="4297680" y="2304288"/>
+            <a:ext cx="1371600" cy="292608"/>
           </a:xfrm>
           <a:prstGeom prst="rect">
             <a:avLst/>
@@ -14112,8 +14112,10 @@
           <a:solidFill>
             <a:srgbClr val="FFFFFF"/>
           </a:solidFill>
-          <a:ln>
-            <a:noFill/>
+          <a:ln w="12700">
+            <a:solidFill>
+              <a:srgbClr val="6B6B6B"/>
+            </a:solidFill>
           </a:ln>
           <a:effectLst/>
         </p:spPr>
@@ -14147,8 +14149,8 @@
         </p:nvSpPr>
         <p:spPr>
           <a:xfrm>
-            <a:off x="1051560" y="5038344"/>
-            <a:ext cx="4617720" cy="228600"/>
+            <a:off x="4297680" y="2350008"/>
+            <a:ext cx="1371600" cy="228600"/>
           </a:xfrm>
           <a:prstGeom prst="rect">
             <a:avLst/>
@@ -14173,7 +14175,7 @@
               </a:spcAft>
             </a:pPr>
             <a:r>
-              <a:rPr sz="1250" b="1">
+              <a:rPr sz="1200" b="1">
                 <a:solidFill>
                   <a:srgbClr val="6B6B6B"/>
                 </a:solidFill>
@@ -14195,7 +14197,7 @@
         <p:spPr>
           <a:xfrm>
             <a:off x="6245352" y="2148840"/>
-            <a:ext cx="5166360" cy="3200400"/>
+            <a:ext cx="5166360" cy="3429000"/>
           </a:xfrm>
           <a:prstGeom prst="rect">
             <a:avLst/>
@@ -14382,7 +14384,7 @@
         <p:spPr>
           <a:xfrm>
             <a:off x="6519672" y="3246120"/>
-            <a:ext cx="4617720" cy="914400"/>
+            <a:ext cx="4617720" cy="1051560"/>
           </a:xfrm>
           <a:prstGeom prst="rect">
             <a:avLst/>
@@ -14397,17 +14399,17 @@
           <a:p>
             <a:pPr algn="l">
               <a:lnSpc>
-                <a:spcPct val="140000"/>
-              </a:lnSpc>
-              <a:spcBef>
-                <a:spcPts val="500"/>
-              </a:spcBef>
-              <a:spcAft>
-                <a:spcPts val="0"/>
-              </a:spcAft>
-            </a:pPr>
-            <a:r>
-              <a:rPr sz="1200" b="0">
+                <a:spcPct val="135000"/>
+              </a:lnSpc>
+              <a:spcBef>
+                <a:spcPts val="400"/>
+              </a:spcBef>
+              <a:spcAft>
+                <a:spcPts val="0"/>
+              </a:spcAft>
+            </a:pPr>
+            <a:r>
+              <a:rPr sz="1150" b="0">
                 <a:solidFill>
                   <a:srgbClr val="292929"/>
                 </a:solidFill>
@@ -14421,17 +14423,17 @@
           <a:p>
             <a:pPr>
               <a:lnSpc>
-                <a:spcPct val="140000"/>
-              </a:lnSpc>
-              <a:spcBef>
-                <a:spcPts val="500"/>
-              </a:spcBef>
-              <a:spcAft>
-                <a:spcPts val="0"/>
-              </a:spcAft>
-            </a:pPr>
-            <a:r>
-              <a:rPr sz="1200" b="0">
+                <a:spcPct val="135000"/>
+              </a:lnSpc>
+              <a:spcBef>
+                <a:spcPts val="400"/>
+              </a:spcBef>
+              <a:spcAft>
+                <a:spcPts val="0"/>
+              </a:spcAft>
+            </a:pPr>
+            <a:r>
+              <a:rPr sz="1150" b="0">
                 <a:solidFill>
                   <a:srgbClr val="292929"/>
                 </a:solidFill>
@@ -14445,17 +14447,17 @@
           <a:p>
             <a:pPr>
               <a:lnSpc>
-                <a:spcPct val="140000"/>
-              </a:lnSpc>
-              <a:spcBef>
-                <a:spcPts val="500"/>
-              </a:spcBef>
-              <a:spcAft>
-                <a:spcPts val="0"/>
-              </a:spcAft>
-            </a:pPr>
-            <a:r>
-              <a:rPr sz="1200" b="0">
+                <a:spcPct val="135000"/>
+              </a:lnSpc>
+              <a:spcBef>
+                <a:spcPts val="400"/>
+              </a:spcBef>
+              <a:spcAft>
+                <a:spcPts val="0"/>
+              </a:spcAft>
+            </a:pPr>
+            <a:r>
+              <a:rPr sz="1150" b="0">
                 <a:solidFill>
                   <a:srgbClr val="292929"/>
                 </a:solidFill>
@@ -14476,7 +14478,7 @@
         </p:nvSpPr>
         <p:spPr>
           <a:xfrm>
-            <a:off x="6519672" y="4315968"/>
+            <a:off x="6519672" y="4434840"/>
             <a:ext cx="4617720" cy="228600"/>
           </a:xfrm>
           <a:prstGeom prst="rect">
@@ -14523,8 +14525,8 @@
         </p:nvSpPr>
         <p:spPr>
           <a:xfrm>
-            <a:off x="6519672" y="4544568"/>
-            <a:ext cx="4617720" cy="731520"/>
+            <a:off x="6519672" y="4645152"/>
+            <a:ext cx="4617720" cy="822960"/>
           </a:xfrm>
           <a:prstGeom prst="rect">
             <a:avLst/>
@@ -14539,17 +14541,17 @@
           <a:p>
             <a:pPr algn="l">
               <a:lnSpc>
-                <a:spcPct val="140000"/>
-              </a:lnSpc>
-              <a:spcBef>
-                <a:spcPts val="500"/>
-              </a:spcBef>
-              <a:spcAft>
-                <a:spcPts val="0"/>
-              </a:spcAft>
-            </a:pPr>
-            <a:r>
-              <a:rPr sz="1200" b="0">
+                <a:spcPct val="135000"/>
+              </a:lnSpc>
+              <a:spcBef>
+                <a:spcPts val="400"/>
+              </a:spcBef>
+              <a:spcAft>
+                <a:spcPts val="0"/>
+              </a:spcAft>
+            </a:pPr>
+            <a:r>
+              <a:rPr sz="1150" b="0">
                 <a:solidFill>
                   <a:srgbClr val="292929"/>
                 </a:solidFill>
@@ -14563,17 +14565,17 @@
           <a:p>
             <a:pPr>
               <a:lnSpc>
-                <a:spcPct val="140000"/>
-              </a:lnSpc>
-              <a:spcBef>
-                <a:spcPts val="500"/>
-              </a:spcBef>
-              <a:spcAft>
-                <a:spcPts val="0"/>
-              </a:spcAft>
-            </a:pPr>
-            <a:r>
-              <a:rPr sz="1200" b="0">
+                <a:spcPct val="135000"/>
+              </a:lnSpc>
+              <a:spcBef>
+                <a:spcPts val="400"/>
+              </a:spcBef>
+              <a:spcAft>
+                <a:spcPts val="0"/>
+              </a:spcAft>
+            </a:pPr>
+            <a:r>
+              <a:rPr sz="1150" b="0">
                 <a:solidFill>
                   <a:srgbClr val="292929"/>
                 </a:solidFill>
@@ -14594,8 +14596,8 @@
         </p:nvSpPr>
         <p:spPr>
           <a:xfrm>
-            <a:off x="6519672" y="5010912"/>
-            <a:ext cx="4617720" cy="256032"/>
+            <a:off x="9765792" y="2304288"/>
+            <a:ext cx="1371600" cy="292608"/>
           </a:xfrm>
           <a:prstGeom prst="rect">
             <a:avLst/>
@@ -14603,8 +14605,10 @@
           <a:solidFill>
             <a:srgbClr val="FFFFFF"/>
           </a:solidFill>
-          <a:ln>
-            <a:noFill/>
+          <a:ln w="12700">
+            <a:solidFill>
+              <a:srgbClr val="1C9E63"/>
+            </a:solidFill>
           </a:ln>
           <a:effectLst/>
         </p:spPr>
@@ -14638,8 +14642,8 @@
         </p:nvSpPr>
         <p:spPr>
           <a:xfrm>
-            <a:off x="6519672" y="5038344"/>
-            <a:ext cx="4617720" cy="228600"/>
+            <a:off x="9765792" y="2350008"/>
+            <a:ext cx="1371600" cy="228600"/>
           </a:xfrm>
           <a:prstGeom prst="rect">
             <a:avLst/>
@@ -14664,7 +14668,7 @@
               </a:spcAft>
             </a:pPr>
             <a:r>
-              <a:rPr sz="1250" b="1">
+              <a:rPr sz="1200" b="1">
                 <a:solidFill>
                   <a:srgbClr val="1C9E63"/>
                 </a:solidFill>
@@ -14685,8 +14689,8 @@
         </p:nvSpPr>
         <p:spPr>
           <a:xfrm>
-            <a:off x="777240" y="5532120"/>
-            <a:ext cx="10634472" cy="777240"/>
+            <a:off x="777240" y="5715000"/>
+            <a:ext cx="10634472" cy="621792"/>
           </a:xfrm>
           <a:prstGeom prst="rect">
             <a:avLst/>
@@ -14729,8 +14733,8 @@
         </p:nvSpPr>
         <p:spPr>
           <a:xfrm>
-            <a:off x="1051560" y="5669280"/>
-            <a:ext cx="10058400" cy="548640"/>
+            <a:off x="1051560" y="5815584"/>
+            <a:ext cx="10058400" cy="457200"/>
           </a:xfrm>
           <a:prstGeom prst="rect">
             <a:avLst/>
@@ -14755,7 +14759,7 @@
               </a:spcAft>
             </a:pPr>
             <a:r>
-              <a:rPr sz="1150" b="0">
+              <a:rPr sz="1100" b="0">
                 <a:solidFill>
                   <a:srgbClr val="9A9A9A"/>
                 </a:solidFill>
@@ -14772,14 +14776,14 @@
                 <a:spcPct val="135000"/>
               </a:lnSpc>
               <a:spcBef>
-                <a:spcPts val="400"/>
-              </a:spcBef>
-              <a:spcAft>
-                <a:spcPts val="0"/>
-              </a:spcAft>
-            </a:pPr>
-            <a:r>
-              <a:rPr sz="1400" b="1">
+                <a:spcPts val="300"/>
+              </a:spcBef>
+              <a:spcAft>
+                <a:spcPts val="0"/>
+              </a:spcAft>
+            </a:pPr>
+            <a:r>
+              <a:rPr sz="1350" b="1">
                 <a:solidFill>
                   <a:srgbClr val="3DF69B"/>
                 </a:solidFill>
@@ -15052,7 +15056,7 @@
         </p:nvGraphicFramePr>
         <p:xfrm>
           <a:off x="777240" y="2011680"/>
-          <a:ext cx="10634472" cy="3401568"/>
+          <a:ext cx="10634472" cy="2743200"/>
         </p:xfrm>
         <a:graphic>
           <a:graphicData uri="http://schemas.openxmlformats.org/drawingml/2006/table">
@@ -15066,7 +15070,7 @@
                 <a:gridCol w="2011680"/>
                 <a:gridCol w="5285232"/>
               </a:tblGrid>
-              <a:tr h="566928">
+              <a:tr h="457200">
                 <a:tc>
                   <a:txBody>
                     <a:bodyPr/>
@@ -15184,7 +15188,7 @@
                   </a:tcPr>
                 </a:tc>
               </a:tr>
-              <a:tr h="566928">
+              <a:tr h="457200">
                 <a:tc>
                   <a:txBody>
                     <a:bodyPr/>
@@ -15302,7 +15306,7 @@
                   </a:tcPr>
                 </a:tc>
               </a:tr>
-              <a:tr h="566928">
+              <a:tr h="457200">
                 <a:tc>
                   <a:txBody>
                     <a:bodyPr/>
@@ -15420,7 +15424,7 @@
                   </a:tcPr>
                 </a:tc>
               </a:tr>
-              <a:tr h="566928">
+              <a:tr h="457200">
                 <a:tc>
                   <a:txBody>
                     <a:bodyPr/>
@@ -15538,7 +15542,7 @@
                   </a:tcPr>
                 </a:tc>
               </a:tr>
-              <a:tr h="566928">
+              <a:tr h="457200">
                 <a:tc>
                   <a:txBody>
                     <a:bodyPr/>
@@ -15656,7 +15660,7 @@
                   </a:tcPr>
                 </a:tc>
               </a:tr>
-              <a:tr h="566928">
+              <a:tr h="457200">
                 <a:tc>
                   <a:txBody>
                     <a:bodyPr/>
@@ -15786,8 +15790,8 @@
         </p:nvSpPr>
         <p:spPr>
           <a:xfrm>
-            <a:off x="777240" y="5120640"/>
-            <a:ext cx="10634472" cy="1051560"/>
+            <a:off x="777240" y="4937760"/>
+            <a:ext cx="10634472" cy="1097280"/>
           </a:xfrm>
           <a:prstGeom prst="rect">
             <a:avLst/>
@@ -15832,8 +15836,8 @@
         </p:nvSpPr>
         <p:spPr>
           <a:xfrm>
-            <a:off x="1051560" y="5303520"/>
-            <a:ext cx="10058400" cy="822960"/>
+            <a:off x="1051560" y="5120640"/>
+            <a:ext cx="10058400" cy="868680"/>
           </a:xfrm>
           <a:prstGeom prst="rect">
             <a:avLst/>

</xml_diff>

<commit_message>
vault backup: 2026-08-09 22:06:21
</commit_message>
<xml_diff>
--- a/CdBd 문서 체계 진단 및 개편 제안.pptx
+++ b/CdBd 문서 체계 진단 및 개편 제안.pptx
@@ -13826,8 +13826,8 @@
         </p:nvSpPr>
         <p:spPr>
           <a:xfrm>
-            <a:off x="777240" y="5623560"/>
-            <a:ext cx="10634472" cy="731520"/>
+            <a:off x="777240" y="5504688"/>
+            <a:ext cx="10634472" cy="868680"/>
           </a:xfrm>
           <a:prstGeom prst="rect">
             <a:avLst/>
@@ -13872,8 +13872,8 @@
         </p:nvSpPr>
         <p:spPr>
           <a:xfrm>
-            <a:off x="1051560" y="5760720"/>
-            <a:ext cx="10058400" cy="548640"/>
+            <a:off x="1051560" y="5623560"/>
+            <a:ext cx="10058400" cy="685800"/>
           </a:xfrm>
           <a:prstGeom prst="rect">
             <a:avLst/>
@@ -13934,14 +13934,14 @@
                 <a:spcPct val="135000"/>
               </a:lnSpc>
               <a:spcBef>
-                <a:spcPts val="400"/>
-              </a:spcBef>
-              <a:spcAft>
-                <a:spcPts val="0"/>
-              </a:spcAft>
-            </a:pPr>
-            <a:r>
-              <a:rPr sz="1250" b="0">
+                <a:spcPts val="300"/>
+              </a:spcBef>
+              <a:spcAft>
+                <a:spcPts val="0"/>
+              </a:spcAft>
+            </a:pPr>
+            <a:r>
+              <a:rPr sz="1200" b="0">
                 <a:solidFill>
                   <a:srgbClr val="292929"/>
                 </a:solidFill>

</xml_diff>

<commit_message>
vault backup: 2026-08-09 22:07:30
</commit_message>
<xml_diff>
--- a/CdBd 문서 체계 진단 및 개편 제안.pptx
+++ b/CdBd 문서 체계 진단 및 개편 제안.pptx
@@ -14246,7 +14246,7 @@
                 <a:ea typeface="Pretendard"/>
                 <a:cs typeface="Pretendard"/>
               </a:rPr>
-              <a:t>새 저장소 1개를 만들고, 그 안의 내용을 5개 저장소 각각에 “_core” 폴더로 자동 연결합니다.</a:t>
+              <a:t>새 저장소를 2개 만듭니다 — 정본을 담는 cdbd-core(B안)와, 스킬을 나르는 cdbd-plugin(D안).</a:t>
             </a:r>
           </a:p>
         </p:txBody>
@@ -14259,8 +14259,8 @@
         </p:nvSpPr>
         <p:spPr>
           <a:xfrm>
-            <a:off x="3977639" y="2148840"/>
-            <a:ext cx="4233672" cy="1371600"/>
+            <a:off x="3977639" y="2084831"/>
+            <a:ext cx="4233672" cy="1207008"/>
           </a:xfrm>
           <a:prstGeom prst="rect">
             <a:avLst/>
@@ -14303,7 +14303,7 @@
         </p:nvSpPr>
         <p:spPr>
           <a:xfrm>
-            <a:off x="3977639" y="2286000"/>
+            <a:off x="3977639" y="2194560"/>
             <a:ext cx="4233672" cy="274320"/>
           </a:xfrm>
           <a:prstGeom prst="rect">
@@ -14329,7 +14329,7 @@
               </a:spcAft>
             </a:pPr>
             <a:r>
-              <a:rPr sz="1500" b="1">
+              <a:rPr sz="1400" b="1">
                 <a:solidFill>
                   <a:srgbClr val="3DF69B"/>
                 </a:solidFill>
@@ -14337,7 +14337,7 @@
                 <a:ea typeface="Pretendard"/>
                 <a:cs typeface="Pretendard"/>
               </a:rPr>
-              <a:t>cdbd-core   (신규 저장소)</a:t>
+              <a:t>B안  cdbd-core   (신규 저장소)</a:t>
             </a:r>
           </a:p>
         </p:txBody>
@@ -14350,8 +14350,8 @@
         </p:nvSpPr>
         <p:spPr>
           <a:xfrm>
-            <a:off x="3977639" y="2606040"/>
-            <a:ext cx="4233672" cy="822960"/>
+            <a:off x="3977639" y="2487168"/>
+            <a:ext cx="4233672" cy="731520"/>
           </a:xfrm>
           <a:prstGeom prst="rect">
             <a:avLst/>
@@ -14376,7 +14376,7 @@
               </a:spcAft>
             </a:pPr>
             <a:r>
-              <a:rPr sz="1200" b="0">
+              <a:rPr sz="1150" b="0">
                 <a:solidFill>
                   <a:srgbClr val="FFFFFF"/>
                 </a:solidFill>
@@ -14400,7 +14400,7 @@
               </a:spcAft>
             </a:pPr>
             <a:r>
-              <a:rPr sz="1200" b="0">
+              <a:rPr sz="1150" b="0">
                 <a:solidFill>
                   <a:srgbClr val="FFFFFF"/>
                 </a:solidFill>
@@ -14408,31 +14408,7 @@
                 <a:ea typeface="Pretendard"/>
                 <a:cs typeface="Pretendard"/>
               </a:rPr>
-              <a:t>공통 스킬 · 환경 셋업 스크립트</a:t>
-            </a:r>
-          </a:p>
-          <a:p>
-            <a:pPr algn="ctr">
-              <a:lnSpc>
-                <a:spcPct val="150000"/>
-              </a:lnSpc>
-              <a:spcBef>
-                <a:spcPts val="0"/>
-              </a:spcBef>
-              <a:spcAft>
-                <a:spcPts val="0"/>
-              </a:spcAft>
-            </a:pPr>
-            <a:r>
-              <a:rPr sz="1200" b="0">
-                <a:solidFill>
-                  <a:srgbClr val="FFFFFF"/>
-                </a:solidFill>
-                <a:latin typeface="Pretendard"/>
-                <a:ea typeface="Pretendard"/>
-                <a:cs typeface="Pretendard"/>
-              </a:rPr>
-              <a:t>자동 점검 스크립트</a:t>
+              <a:t>공통 자산 · 자동 점검 스크립트</a:t>
             </a:r>
           </a:p>
         </p:txBody>
@@ -14445,8 +14421,8 @@
         </p:nvSpPr>
         <p:spPr>
           <a:xfrm>
-            <a:off x="6062472" y="3520440"/>
-            <a:ext cx="41148" cy="384048"/>
+            <a:off x="6062472" y="3291840"/>
+            <a:ext cx="41148" cy="310896"/>
           </a:xfrm>
           <a:prstGeom prst="rect">
             <a:avLst/>
@@ -14489,8 +14465,8 @@
         </p:nvSpPr>
         <p:spPr>
           <a:xfrm>
-            <a:off x="6263640" y="3566160"/>
-            <a:ext cx="2743200" cy="256032"/>
+            <a:off x="6263640" y="3310128"/>
+            <a:ext cx="2926080" cy="237744"/>
           </a:xfrm>
           <a:prstGeom prst="rect">
             <a:avLst/>
@@ -14536,7 +14512,7 @@
         </p:nvSpPr>
         <p:spPr>
           <a:xfrm>
-            <a:off x="1481328" y="3899915"/>
+            <a:off x="1481328" y="3598164"/>
             <a:ext cx="9198864" cy="41148"/>
           </a:xfrm>
           <a:prstGeom prst="rect">
@@ -14580,8 +14556,8 @@
         </p:nvSpPr>
         <p:spPr>
           <a:xfrm>
-            <a:off x="1460754" y="3941063"/>
-            <a:ext cx="41148" cy="310896"/>
+            <a:off x="1460754" y="3639312"/>
+            <a:ext cx="41148" cy="274320"/>
           </a:xfrm>
           <a:prstGeom prst="rect">
             <a:avLst/>
@@ -14624,8 +14600,8 @@
         </p:nvSpPr>
         <p:spPr>
           <a:xfrm>
-            <a:off x="521208" y="4251960"/>
-            <a:ext cx="1920240" cy="1325880"/>
+            <a:off x="521208" y="3913632"/>
+            <a:ext cx="1920240" cy="1188720"/>
           </a:xfrm>
           <a:prstGeom prst="rect">
             <a:avLst/>
@@ -14670,7 +14646,7 @@
         </p:nvSpPr>
         <p:spPr>
           <a:xfrm>
-            <a:off x="521208" y="4370832"/>
+            <a:off x="521208" y="4023360"/>
             <a:ext cx="1920240" cy="457200"/>
           </a:xfrm>
           <a:prstGeom prst="rect">
@@ -14696,7 +14672,7 @@
               </a:spcAft>
             </a:pPr>
             <a:r>
-              <a:rPr sz="1150" b="1">
+              <a:rPr sz="1100" b="1">
                 <a:solidFill>
                   <a:srgbClr val="292929"/>
                 </a:solidFill>
@@ -14720,7 +14696,7 @@
               </a:spcAft>
             </a:pPr>
             <a:r>
-              <a:rPr sz="1150" b="1">
+              <a:rPr sz="1100" b="1">
                 <a:solidFill>
                   <a:srgbClr val="292929"/>
                 </a:solidFill>
@@ -14741,8 +14717,8 @@
         </p:nvSpPr>
         <p:spPr>
           <a:xfrm>
-            <a:off x="676656" y="4956048"/>
-            <a:ext cx="1609344" cy="292608"/>
+            <a:off x="676656" y="4553712"/>
+            <a:ext cx="1609344" cy="274320"/>
           </a:xfrm>
           <a:prstGeom prst="rect">
             <a:avLst/>
@@ -14785,8 +14761,8 @@
         </p:nvSpPr>
         <p:spPr>
           <a:xfrm>
-            <a:off x="676656" y="5020056"/>
-            <a:ext cx="1609344" cy="228600"/>
+            <a:off x="676656" y="4608576"/>
+            <a:ext cx="1609344" cy="219456"/>
           </a:xfrm>
           <a:prstGeom prst="rect">
             <a:avLst/>
@@ -14811,7 +14787,7 @@
               </a:spcAft>
             </a:pPr>
             <a:r>
-              <a:rPr sz="1150" b="1">
+              <a:rPr sz="1100" b="1">
                 <a:solidFill>
                   <a:srgbClr val="6C4CFF"/>
                 </a:solidFill>
@@ -14832,8 +14808,8 @@
         </p:nvSpPr>
         <p:spPr>
           <a:xfrm>
-            <a:off x="521208" y="5321808"/>
-            <a:ext cx="1920240" cy="228600"/>
+            <a:off x="521208" y="4864608"/>
+            <a:ext cx="1920240" cy="219456"/>
           </a:xfrm>
           <a:prstGeom prst="rect">
             <a:avLst/>
@@ -14858,7 +14834,7 @@
               </a:spcAft>
             </a:pPr>
             <a:r>
-              <a:rPr sz="1050" b="0">
+              <a:rPr sz="1000" b="0">
                 <a:solidFill>
                   <a:srgbClr val="6B6B6B"/>
                 </a:solidFill>
@@ -14879,8 +14855,8 @@
         </p:nvSpPr>
         <p:spPr>
           <a:xfrm>
-            <a:off x="3760470" y="3941063"/>
-            <a:ext cx="41148" cy="310896"/>
+            <a:off x="3760470" y="3639312"/>
+            <a:ext cx="41148" cy="274320"/>
           </a:xfrm>
           <a:prstGeom prst="rect">
             <a:avLst/>
@@ -14923,8 +14899,8 @@
         </p:nvSpPr>
         <p:spPr>
           <a:xfrm>
-            <a:off x="2820924" y="4251960"/>
-            <a:ext cx="1920240" cy="1325880"/>
+            <a:off x="2820924" y="3913632"/>
+            <a:ext cx="1920240" cy="1188720"/>
           </a:xfrm>
           <a:prstGeom prst="rect">
             <a:avLst/>
@@ -14969,7 +14945,7 @@
         </p:nvSpPr>
         <p:spPr>
           <a:xfrm>
-            <a:off x="2820924" y="4370832"/>
+            <a:off x="2820924" y="4023360"/>
             <a:ext cx="1920240" cy="457200"/>
           </a:xfrm>
           <a:prstGeom prst="rect">
@@ -14995,7 +14971,7 @@
               </a:spcAft>
             </a:pPr>
             <a:r>
-              <a:rPr sz="1150" b="1">
+              <a:rPr sz="1100" b="1">
                 <a:solidFill>
                   <a:srgbClr val="292929"/>
                 </a:solidFill>
@@ -15019,7 +14995,7 @@
               </a:spcAft>
             </a:pPr>
             <a:r>
-              <a:rPr sz="1150" b="1">
+              <a:rPr sz="1100" b="1">
                 <a:solidFill>
                   <a:srgbClr val="292929"/>
                 </a:solidFill>
@@ -15040,8 +15016,8 @@
         </p:nvSpPr>
         <p:spPr>
           <a:xfrm>
-            <a:off x="2976372" y="4956048"/>
-            <a:ext cx="1609344" cy="292608"/>
+            <a:off x="2976372" y="4553712"/>
+            <a:ext cx="1609344" cy="274320"/>
           </a:xfrm>
           <a:prstGeom prst="rect">
             <a:avLst/>
@@ -15084,8 +15060,8 @@
         </p:nvSpPr>
         <p:spPr>
           <a:xfrm>
-            <a:off x="2976372" y="5020056"/>
-            <a:ext cx="1609344" cy="228600"/>
+            <a:off x="2976372" y="4608576"/>
+            <a:ext cx="1609344" cy="219456"/>
           </a:xfrm>
           <a:prstGeom prst="rect">
             <a:avLst/>
@@ -15110,7 +15086,7 @@
               </a:spcAft>
             </a:pPr>
             <a:r>
-              <a:rPr sz="1150" b="1">
+              <a:rPr sz="1100" b="1">
                 <a:solidFill>
                   <a:srgbClr val="6C4CFF"/>
                 </a:solidFill>
@@ -15131,8 +15107,8 @@
         </p:nvSpPr>
         <p:spPr>
           <a:xfrm>
-            <a:off x="2820924" y="5321808"/>
-            <a:ext cx="1920240" cy="228600"/>
+            <a:off x="2820924" y="4864608"/>
+            <a:ext cx="1920240" cy="219456"/>
           </a:xfrm>
           <a:prstGeom prst="rect">
             <a:avLst/>
@@ -15157,7 +15133,7 @@
               </a:spcAft>
             </a:pPr>
             <a:r>
-              <a:rPr sz="1050" b="0">
+              <a:rPr sz="1000" b="0">
                 <a:solidFill>
                   <a:srgbClr val="6B6B6B"/>
                 </a:solidFill>
@@ -15178,8 +15154,8 @@
         </p:nvSpPr>
         <p:spPr>
           <a:xfrm>
-            <a:off x="6060186" y="3941063"/>
-            <a:ext cx="41148" cy="310896"/>
+            <a:off x="6060186" y="3639312"/>
+            <a:ext cx="41148" cy="274320"/>
           </a:xfrm>
           <a:prstGeom prst="rect">
             <a:avLst/>
@@ -15222,8 +15198,8 @@
         </p:nvSpPr>
         <p:spPr>
           <a:xfrm>
-            <a:off x="5120640" y="4251960"/>
-            <a:ext cx="1920240" cy="1325880"/>
+            <a:off x="5120640" y="3913632"/>
+            <a:ext cx="1920240" cy="1188720"/>
           </a:xfrm>
           <a:prstGeom prst="rect">
             <a:avLst/>
@@ -15268,7 +15244,7 @@
         </p:nvSpPr>
         <p:spPr>
           <a:xfrm>
-            <a:off x="5120640" y="4370832"/>
+            <a:off x="5120640" y="4023360"/>
             <a:ext cx="1920240" cy="457200"/>
           </a:xfrm>
           <a:prstGeom prst="rect">
@@ -15294,7 +15270,7 @@
               </a:spcAft>
             </a:pPr>
             <a:r>
-              <a:rPr sz="1150" b="1">
+              <a:rPr sz="1100" b="1">
                 <a:solidFill>
                   <a:srgbClr val="292929"/>
                 </a:solidFill>
@@ -15318,7 +15294,7 @@
               </a:spcAft>
             </a:pPr>
             <a:r>
-              <a:rPr sz="1150" b="1">
+              <a:rPr sz="1100" b="1">
                 <a:solidFill>
                   <a:srgbClr val="292929"/>
                 </a:solidFill>
@@ -15339,8 +15315,8 @@
         </p:nvSpPr>
         <p:spPr>
           <a:xfrm>
-            <a:off x="5276088" y="4956048"/>
-            <a:ext cx="1609344" cy="292608"/>
+            <a:off x="5276088" y="4553712"/>
+            <a:ext cx="1609344" cy="274320"/>
           </a:xfrm>
           <a:prstGeom prst="rect">
             <a:avLst/>
@@ -15383,8 +15359,8 @@
         </p:nvSpPr>
         <p:spPr>
           <a:xfrm>
-            <a:off x="5276088" y="5020056"/>
-            <a:ext cx="1609344" cy="228600"/>
+            <a:off x="5276088" y="4608576"/>
+            <a:ext cx="1609344" cy="219456"/>
           </a:xfrm>
           <a:prstGeom prst="rect">
             <a:avLst/>
@@ -15409,7 +15385,7 @@
               </a:spcAft>
             </a:pPr>
             <a:r>
-              <a:rPr sz="1150" b="1">
+              <a:rPr sz="1100" b="1">
                 <a:solidFill>
                   <a:srgbClr val="6C4CFF"/>
                 </a:solidFill>
@@ -15430,8 +15406,8 @@
         </p:nvSpPr>
         <p:spPr>
           <a:xfrm>
-            <a:off x="5120640" y="5321808"/>
-            <a:ext cx="1920240" cy="228600"/>
+            <a:off x="5120640" y="4864608"/>
+            <a:ext cx="1920240" cy="219456"/>
           </a:xfrm>
           <a:prstGeom prst="rect">
             <a:avLst/>
@@ -15456,7 +15432,7 @@
               </a:spcAft>
             </a:pPr>
             <a:r>
-              <a:rPr sz="1050" b="0">
+              <a:rPr sz="1000" b="0">
                 <a:solidFill>
                   <a:srgbClr val="6B6B6B"/>
                 </a:solidFill>
@@ -15477,8 +15453,8 @@
         </p:nvSpPr>
         <p:spPr>
           <a:xfrm>
-            <a:off x="8359901" y="3941063"/>
-            <a:ext cx="41148" cy="310896"/>
+            <a:off x="8359901" y="3639312"/>
+            <a:ext cx="41148" cy="274320"/>
           </a:xfrm>
           <a:prstGeom prst="rect">
             <a:avLst/>
@@ -15521,8 +15497,8 @@
         </p:nvSpPr>
         <p:spPr>
           <a:xfrm>
-            <a:off x="7420355" y="4251960"/>
-            <a:ext cx="1920240" cy="1325880"/>
+            <a:off x="7420355" y="3913632"/>
+            <a:ext cx="1920240" cy="1188720"/>
           </a:xfrm>
           <a:prstGeom prst="rect">
             <a:avLst/>
@@ -15567,7 +15543,7 @@
         </p:nvSpPr>
         <p:spPr>
           <a:xfrm>
-            <a:off x="7420355" y="4370832"/>
+            <a:off x="7420355" y="4023360"/>
             <a:ext cx="1920240" cy="457200"/>
           </a:xfrm>
           <a:prstGeom prst="rect">
@@ -15593,7 +15569,7 @@
               </a:spcAft>
             </a:pPr>
             <a:r>
-              <a:rPr sz="1150" b="1">
+              <a:rPr sz="1100" b="1">
                 <a:solidFill>
                   <a:srgbClr val="292929"/>
                 </a:solidFill>
@@ -15617,7 +15593,7 @@
               </a:spcAft>
             </a:pPr>
             <a:r>
-              <a:rPr sz="1150" b="1">
+              <a:rPr sz="1100" b="1">
                 <a:solidFill>
                   <a:srgbClr val="292929"/>
                 </a:solidFill>
@@ -15638,8 +15614,8 @@
         </p:nvSpPr>
         <p:spPr>
           <a:xfrm>
-            <a:off x="7575803" y="4956048"/>
-            <a:ext cx="1609344" cy="292608"/>
+            <a:off x="7575803" y="4553712"/>
+            <a:ext cx="1609344" cy="274320"/>
           </a:xfrm>
           <a:prstGeom prst="rect">
             <a:avLst/>
@@ -15682,8 +15658,8 @@
         </p:nvSpPr>
         <p:spPr>
           <a:xfrm>
-            <a:off x="7575803" y="5020056"/>
-            <a:ext cx="1609344" cy="228600"/>
+            <a:off x="7575803" y="4608576"/>
+            <a:ext cx="1609344" cy="219456"/>
           </a:xfrm>
           <a:prstGeom prst="rect">
             <a:avLst/>
@@ -15708,7 +15684,7 @@
               </a:spcAft>
             </a:pPr>
             <a:r>
-              <a:rPr sz="1150" b="1">
+              <a:rPr sz="1100" b="1">
                 <a:solidFill>
                   <a:srgbClr val="6C4CFF"/>
                 </a:solidFill>
@@ -15729,8 +15705,8 @@
         </p:nvSpPr>
         <p:spPr>
           <a:xfrm>
-            <a:off x="7420355" y="5321808"/>
-            <a:ext cx="1920240" cy="228600"/>
+            <a:off x="7420355" y="4864608"/>
+            <a:ext cx="1920240" cy="219456"/>
           </a:xfrm>
           <a:prstGeom prst="rect">
             <a:avLst/>
@@ -15755,7 +15731,7 @@
               </a:spcAft>
             </a:pPr>
             <a:r>
-              <a:rPr sz="1050" b="0">
+              <a:rPr sz="1000" b="0">
                 <a:solidFill>
                   <a:srgbClr val="6B6B6B"/>
                 </a:solidFill>
@@ -15776,8 +15752,8 @@
         </p:nvSpPr>
         <p:spPr>
           <a:xfrm>
-            <a:off x="10659617" y="3941063"/>
-            <a:ext cx="41148" cy="310896"/>
+            <a:off x="10659617" y="3639312"/>
+            <a:ext cx="41148" cy="274320"/>
           </a:xfrm>
           <a:prstGeom prst="rect">
             <a:avLst/>
@@ -15820,8 +15796,8 @@
         </p:nvSpPr>
         <p:spPr>
           <a:xfrm>
-            <a:off x="9720072" y="4251960"/>
-            <a:ext cx="1920240" cy="1325880"/>
+            <a:off x="9720072" y="3913632"/>
+            <a:ext cx="1920240" cy="1188720"/>
           </a:xfrm>
           <a:prstGeom prst="rect">
             <a:avLst/>
@@ -15866,7 +15842,7 @@
         </p:nvSpPr>
         <p:spPr>
           <a:xfrm>
-            <a:off x="9720072" y="4370832"/>
+            <a:off x="9720072" y="4023360"/>
             <a:ext cx="1920240" cy="457200"/>
           </a:xfrm>
           <a:prstGeom prst="rect">
@@ -15892,7 +15868,7 @@
               </a:spcAft>
             </a:pPr>
             <a:r>
-              <a:rPr sz="1150" b="1">
+              <a:rPr sz="1100" b="1">
                 <a:solidFill>
                   <a:srgbClr val="292929"/>
                 </a:solidFill>
@@ -15916,7 +15892,7 @@
               </a:spcAft>
             </a:pPr>
             <a:r>
-              <a:rPr sz="1150" b="1">
+              <a:rPr sz="1100" b="1">
                 <a:solidFill>
                   <a:srgbClr val="292929"/>
                 </a:solidFill>
@@ -15937,8 +15913,8 @@
         </p:nvSpPr>
         <p:spPr>
           <a:xfrm>
-            <a:off x="9875519" y="4956048"/>
-            <a:ext cx="1609344" cy="292608"/>
+            <a:off x="9875519" y="4553712"/>
+            <a:ext cx="1609344" cy="274320"/>
           </a:xfrm>
           <a:prstGeom prst="rect">
             <a:avLst/>
@@ -15981,8 +15957,8 @@
         </p:nvSpPr>
         <p:spPr>
           <a:xfrm>
-            <a:off x="9875519" y="5020056"/>
-            <a:ext cx="1609344" cy="228600"/>
+            <a:off x="9875519" y="4608576"/>
+            <a:ext cx="1609344" cy="219456"/>
           </a:xfrm>
           <a:prstGeom prst="rect">
             <a:avLst/>
@@ -16007,7 +15983,7 @@
               </a:spcAft>
             </a:pPr>
             <a:r>
-              <a:rPr sz="1150" b="1">
+              <a:rPr sz="1100" b="1">
                 <a:solidFill>
                   <a:srgbClr val="6C4CFF"/>
                 </a:solidFill>
@@ -16028,8 +16004,8 @@
         </p:nvSpPr>
         <p:spPr>
           <a:xfrm>
-            <a:off x="9720072" y="5321808"/>
-            <a:ext cx="1920240" cy="228600"/>
+            <a:off x="9720072" y="4864608"/>
+            <a:ext cx="1920240" cy="219456"/>
           </a:xfrm>
           <a:prstGeom prst="rect">
             <a:avLst/>
@@ -16054,7 +16030,7 @@
               </a:spcAft>
             </a:pPr>
             <a:r>
-              <a:rPr sz="1050" b="0">
+              <a:rPr sz="1000" b="0">
                 <a:solidFill>
                   <a:srgbClr val="6B6B6B"/>
                 </a:solidFill>
@@ -16075,17 +16051,19 @@
         </p:nvSpPr>
         <p:spPr>
           <a:xfrm>
-            <a:off x="777240" y="5806440"/>
-            <a:ext cx="10634472" cy="566928"/>
+            <a:off x="777240" y="5285232"/>
+            <a:ext cx="10634472" cy="658368"/>
           </a:xfrm>
           <a:prstGeom prst="rect">
             <a:avLst/>
           </a:prstGeom>
           <a:solidFill>
-            <a:srgbClr val="F2F0FF"/>
+            <a:srgbClr val="ECFAF2"/>
           </a:solidFill>
-          <a:ln>
-            <a:noFill/>
+          <a:ln w="19050">
+            <a:solidFill>
+              <a:srgbClr val="1C9E63"/>
+            </a:solidFill>
           </a:ln>
           <a:effectLst/>
         </p:spPr>
@@ -16119,8 +16097,8 @@
         </p:nvSpPr>
         <p:spPr>
           <a:xfrm>
-            <a:off x="1051560" y="5961888"/>
-            <a:ext cx="10241280" cy="274320"/>
+            <a:off x="1051560" y="5376672"/>
+            <a:ext cx="4572000" cy="256032"/>
           </a:xfrm>
           <a:prstGeom prst="rect">
             <a:avLst/>
@@ -16147,13 +16125,13 @@
             <a:r>
               <a:rPr sz="1300" b="1">
                 <a:solidFill>
-                  <a:srgbClr val="6C4CFF"/>
-                </a:solidFill>
-                <a:latin typeface="Pretendard"/>
-                <a:ea typeface="Pretendard"/>
-                <a:cs typeface="Pretendard"/>
-              </a:rPr>
-              <a:t>_core는 각 볼트 안에 실제 폴더로 들어갑니다. 그래서 옵시디언 위키링크도 되고 Claude도 읽습니다 — “볼트끼리 링크 불가” 제약을 우회합니다.</a:t>
+                  <a:srgbClr val="1C9E63"/>
+                </a:solidFill>
+                <a:latin typeface="Pretendard"/>
+                <a:ea typeface="Pretendard"/>
+                <a:cs typeface="Pretendard"/>
+              </a:rPr>
+              <a:t>D안  cdbd-plugin   (신규 저장소)</a:t>
             </a:r>
           </a:p>
         </p:txBody>
@@ -16166,8 +16144,8 @@
         </p:nvSpPr>
         <p:spPr>
           <a:xfrm>
-            <a:off x="777240" y="6455664"/>
-            <a:ext cx="9509760" cy="256032"/>
+            <a:off x="1051560" y="5614416"/>
+            <a:ext cx="10058400" cy="237744"/>
           </a:xfrm>
           <a:prstGeom prst="rect">
             <a:avLst/>
@@ -16192,6 +16170,100 @@
               </a:spcAft>
             </a:pPr>
             <a:r>
+              <a:rPr sz="1150" b="0">
+                <a:solidFill>
+                  <a:srgbClr val="292929"/>
+                </a:solidFill>
+                <a:latin typeface="Pretendard"/>
+                <a:ea typeface="Pretendard"/>
+                <a:cs typeface="Pretendard"/>
+              </a:rPr>
+              <a:t>스킬 · 에이전트 · Figma MCP 설정  →  팀원이 1회 설치하면 위 5개 저장소는 물론 허브·신규 저장소까지 어디서 켜도 자동 로드</a:t>
+            </a:r>
+          </a:p>
+        </p:txBody>
+      </p:sp>
+      <p:sp>
+        <p:nvSpPr>
+          <p:cNvPr id="45" name="TextBox 44"/>
+          <p:cNvSpPr txBox="1"/>
+          <p:nvPr/>
+        </p:nvSpPr>
+        <p:spPr>
+          <a:xfrm>
+            <a:off x="777240" y="6053328"/>
+            <a:ext cx="10607040" cy="274320"/>
+          </a:xfrm>
+          <a:prstGeom prst="rect">
+            <a:avLst/>
+          </a:prstGeom>
+          <a:noFill/>
+        </p:spPr>
+        <p:txBody>
+          <a:bodyPr wrap="square" lIns="0" rIns="0" tIns="0" bIns="0" anchor="t">
+            <a:spAutoFit/>
+          </a:bodyPr>
+          <a:lstStyle/>
+          <a:p>
+            <a:pPr algn="l">
+              <a:lnSpc>
+                <a:spcPct val="135000"/>
+              </a:lnSpc>
+              <a:spcBef>
+                <a:spcPts val="0"/>
+              </a:spcBef>
+              <a:spcAft>
+                <a:spcPts val="0"/>
+              </a:spcAft>
+            </a:pPr>
+            <a:r>
+              <a:rPr sz="1250" b="1">
+                <a:solidFill>
+                  <a:srgbClr val="6C4CFF"/>
+                </a:solidFill>
+                <a:latin typeface="Pretendard"/>
+                <a:ea typeface="Pretendard"/>
+                <a:cs typeface="Pretendard"/>
+              </a:rPr>
+              <a:t>_core는 볼트 안에 실제 폴더로 들어가 사람도 봅니다. 플러그인은 볼트 밖에서 스킬만 나릅니다 — 둘의 역할이 다릅니다.</a:t>
+            </a:r>
+          </a:p>
+        </p:txBody>
+      </p:sp>
+      <p:sp>
+        <p:nvSpPr>
+          <p:cNvPr id="46" name="TextBox 45"/>
+          <p:cNvSpPr txBox="1"/>
+          <p:nvPr/>
+        </p:nvSpPr>
+        <p:spPr>
+          <a:xfrm>
+            <a:off x="777240" y="6455664"/>
+            <a:ext cx="9509760" cy="256032"/>
+          </a:xfrm>
+          <a:prstGeom prst="rect">
+            <a:avLst/>
+          </a:prstGeom>
+          <a:noFill/>
+        </p:spPr>
+        <p:txBody>
+          <a:bodyPr wrap="square" lIns="0" rIns="0" tIns="0" bIns="0" anchor="t">
+            <a:spAutoFit/>
+          </a:bodyPr>
+          <a:lstStyle/>
+          <a:p>
+            <a:pPr algn="l">
+              <a:lnSpc>
+                <a:spcPct val="135000"/>
+              </a:lnSpc>
+              <a:spcBef>
+                <a:spcPts val="0"/>
+              </a:spcBef>
+              <a:spcAft>
+                <a:spcPts val="0"/>
+              </a:spcAft>
+            </a:pPr>
+            <a:r>
               <a:rPr sz="1000" b="0">
                 <a:solidFill>
                   <a:srgbClr val="9A9A9A"/>
@@ -16207,7 +16279,7 @@
       </p:sp>
       <p:sp>
         <p:nvSpPr>
-          <p:cNvPr id="45" name="TextBox 44"/>
+          <p:cNvPr id="47" name="TextBox 46"/>
           <p:cNvSpPr txBox="1"/>
           <p:nvPr/>
         </p:nvSpPr>
@@ -16851,7 +16923,7 @@
                 <a:ea typeface="Pretendard"/>
                 <a:cs typeface="Pretendard"/>
               </a:rPr>
-              <a:t>권장안 적용 후</a:t>
+              <a:t>추천안 적용 후</a:t>
             </a:r>
           </a:p>
         </p:txBody>

</xml_diff>

<commit_message>
vault backup: 2026-08-09 22:16:10
</commit_message>
<xml_diff>
--- a/CdBd 문서 체계 진단 및 개편 제안.pptx
+++ b/CdBd 문서 체계 진단 및 개편 제안.pptx
@@ -25,8 +25,6 @@
     <p:sldId id="273" r:id="rId24"/>
     <p:sldId id="274" r:id="rId25"/>
     <p:sldId id="275" r:id="rId26"/>
-    <p:sldId id="276" r:id="rId27"/>
-    <p:sldId id="277" r:id="rId28"/>
   </p:sldIdLst>
   <p:sldSz cx="12191695" cy="6858000" type="screen4x3"/>
   <p:notesSz cx="6858000" cy="9144000"/>
@@ -16333,2766 +16331,6 @@
 </file>
 
 <file path=ppt/slides/slide19.xml><?xml version="1.0" encoding="utf-8"?>
-<p:sld xmlns:a="http://schemas.openxmlformats.org/drawingml/2006/main" xmlns:p="http://schemas.openxmlformats.org/presentationml/2006/main" xmlns:r="http://schemas.openxmlformats.org/officeDocument/2006/relationships">
-  <p:cSld>
-    <p:spTree>
-      <p:nvGrpSpPr>
-        <p:cNvPr id="1" name=""/>
-        <p:cNvGrpSpPr/>
-        <p:nvPr/>
-      </p:nvGrpSpPr>
-      <p:grpSpPr/>
-      <p:sp>
-        <p:nvSpPr>
-          <p:cNvPr id="2" name="Rectangle 1"/>
-          <p:cNvSpPr/>
-          <p:nvPr/>
-        </p:nvSpPr>
-        <p:spPr>
-          <a:xfrm>
-            <a:off x="0" y="0"/>
-            <a:ext cx="12191695" cy="6858000"/>
-          </a:xfrm>
-          <a:prstGeom prst="rect">
-            <a:avLst/>
-          </a:prstGeom>
-          <a:solidFill>
-            <a:srgbClr val="FAFAFA"/>
-          </a:solidFill>
-          <a:ln>
-            <a:noFill/>
-          </a:ln>
-          <a:effectLst/>
-        </p:spPr>
-        <p:style>
-          <a:lnRef idx="1">
-            <a:schemeClr val="accent1"/>
-          </a:lnRef>
-          <a:fillRef idx="3">
-            <a:schemeClr val="accent1"/>
-          </a:fillRef>
-          <a:effectRef idx="2">
-            <a:schemeClr val="accent1"/>
-          </a:effectRef>
-          <a:fontRef idx="minor">
-            <a:schemeClr val="lt1"/>
-          </a:fontRef>
-        </p:style>
-        <p:txBody>
-          <a:bodyPr rtlCol="0" anchor="ctr" wrap="square"/>
-          <a:lstStyle/>
-          <a:p>
-            <a:pPr algn="ctr"/>
-          </a:p>
-        </p:txBody>
-      </p:sp>
-      <p:sp>
-        <p:nvSpPr>
-          <p:cNvPr id="3" name="TextBox 2"/>
-          <p:cNvSpPr txBox="1"/>
-          <p:nvPr/>
-        </p:nvSpPr>
-        <p:spPr>
-          <a:xfrm>
-            <a:off x="777240" y="548640"/>
-            <a:ext cx="10607040" cy="292608"/>
-          </a:xfrm>
-          <a:prstGeom prst="rect">
-            <a:avLst/>
-          </a:prstGeom>
-          <a:noFill/>
-        </p:spPr>
-        <p:txBody>
-          <a:bodyPr wrap="square" lIns="0" rIns="0" tIns="0" bIns="0" anchor="t">
-            <a:spAutoFit/>
-          </a:bodyPr>
-          <a:lstStyle/>
-          <a:p>
-            <a:pPr algn="l">
-              <a:lnSpc>
-                <a:spcPct val="135000"/>
-              </a:lnSpc>
-              <a:spcBef>
-                <a:spcPts val="0"/>
-              </a:spcBef>
-              <a:spcAft>
-                <a:spcPts val="0"/>
-              </a:spcAft>
-            </a:pPr>
-            <a:r>
-              <a:rPr sz="1300" b="1">
-                <a:solidFill>
-                  <a:srgbClr val="6C4CFF"/>
-                </a:solidFill>
-                <a:latin typeface="Pretendard"/>
-                <a:ea typeface="Pretendard"/>
-                <a:cs typeface="Pretendard"/>
-              </a:rPr>
-              <a:t>④ 해결 방안 · 적용 결과</a:t>
-            </a:r>
-          </a:p>
-        </p:txBody>
-      </p:sp>
-      <p:sp>
-        <p:nvSpPr>
-          <p:cNvPr id="4" name="TextBox 3"/>
-          <p:cNvSpPr txBox="1"/>
-          <p:nvPr/>
-        </p:nvSpPr>
-        <p:spPr>
-          <a:xfrm>
-            <a:off x="777240" y="914400"/>
-            <a:ext cx="10607040" cy="822960"/>
-          </a:xfrm>
-          <a:prstGeom prst="rect">
-            <a:avLst/>
-          </a:prstGeom>
-          <a:noFill/>
-        </p:spPr>
-        <p:txBody>
-          <a:bodyPr wrap="square" lIns="0" rIns="0" tIns="0" bIns="0" anchor="t">
-            <a:spAutoFit/>
-          </a:bodyPr>
-          <a:lstStyle/>
-          <a:p>
-            <a:pPr algn="l">
-              <a:lnSpc>
-                <a:spcPct val="120000"/>
-              </a:lnSpc>
-              <a:spcBef>
-                <a:spcPts val="0"/>
-              </a:spcBef>
-              <a:spcAft>
-                <a:spcPts val="0"/>
-              </a:spcAft>
-            </a:pPr>
-            <a:r>
-              <a:rPr sz="3300" b="1">
-                <a:solidFill>
-                  <a:srgbClr val="292929"/>
-                </a:solidFill>
-                <a:latin typeface="Pretendard"/>
-                <a:ea typeface="Pretendard"/>
-                <a:cs typeface="Pretendard"/>
-              </a:rPr>
-              <a:t>추천안을 적용하면 — ② 실제 폴더</a:t>
-            </a:r>
-          </a:p>
-        </p:txBody>
-      </p:sp>
-      <p:sp>
-        <p:nvSpPr>
-          <p:cNvPr id="5" name="TextBox 4"/>
-          <p:cNvSpPr txBox="1"/>
-          <p:nvPr/>
-        </p:nvSpPr>
-        <p:spPr>
-          <a:xfrm>
-            <a:off x="777240" y="1719072"/>
-            <a:ext cx="5120640" cy="274320"/>
-          </a:xfrm>
-          <a:prstGeom prst="rect">
-            <a:avLst/>
-          </a:prstGeom>
-          <a:noFill/>
-        </p:spPr>
-        <p:txBody>
-          <a:bodyPr wrap="square" lIns="0" rIns="0" tIns="0" bIns="0" anchor="t">
-            <a:spAutoFit/>
-          </a:bodyPr>
-          <a:lstStyle/>
-          <a:p>
-            <a:pPr algn="l">
-              <a:lnSpc>
-                <a:spcPct val="135000"/>
-              </a:lnSpc>
-              <a:spcBef>
-                <a:spcPts val="0"/>
-              </a:spcBef>
-              <a:spcAft>
-                <a:spcPts val="0"/>
-              </a:spcAft>
-            </a:pPr>
-            <a:r>
-              <a:rPr sz="1450" b="1">
-                <a:solidFill>
-                  <a:srgbClr val="E53A40"/>
-                </a:solidFill>
-                <a:latin typeface="Pretendard"/>
-                <a:ea typeface="Pretendard"/>
-                <a:cs typeface="Pretendard"/>
-              </a:rPr>
-              <a:t>지금 — cdbd-templates</a:t>
-            </a:r>
-          </a:p>
-        </p:txBody>
-      </p:sp>
-      <p:sp>
-        <p:nvSpPr>
-          <p:cNvPr id="6" name="Rectangle 5"/>
-          <p:cNvSpPr/>
-          <p:nvPr/>
-        </p:nvSpPr>
-        <p:spPr>
-          <a:xfrm>
-            <a:off x="777240" y="2084831"/>
-            <a:ext cx="5120640" cy="3063240"/>
-          </a:xfrm>
-          <a:prstGeom prst="rect">
-            <a:avLst/>
-          </a:prstGeom>
-          <a:solidFill>
-            <a:srgbClr val="2E2E32"/>
-          </a:solidFill>
-          <a:ln>
-            <a:noFill/>
-          </a:ln>
-          <a:effectLst/>
-        </p:spPr>
-        <p:style>
-          <a:lnRef idx="1">
-            <a:schemeClr val="accent1"/>
-          </a:lnRef>
-          <a:fillRef idx="3">
-            <a:schemeClr val="accent1"/>
-          </a:fillRef>
-          <a:effectRef idx="2">
-            <a:schemeClr val="accent1"/>
-          </a:effectRef>
-          <a:fontRef idx="minor">
-            <a:schemeClr val="lt1"/>
-          </a:fontRef>
-        </p:style>
-        <p:txBody>
-          <a:bodyPr rtlCol="0" anchor="ctr" wrap="square"/>
-          <a:lstStyle/>
-          <a:p>
-            <a:pPr algn="ctr"/>
-          </a:p>
-        </p:txBody>
-      </p:sp>
-      <p:sp>
-        <p:nvSpPr>
-          <p:cNvPr id="7" name="TextBox 6"/>
-          <p:cNvSpPr txBox="1"/>
-          <p:nvPr/>
-        </p:nvSpPr>
-        <p:spPr>
-          <a:xfrm>
-            <a:off x="987552" y="2240280"/>
-            <a:ext cx="4709160" cy="2743200"/>
-          </a:xfrm>
-          <a:prstGeom prst="rect">
-            <a:avLst/>
-          </a:prstGeom>
-          <a:noFill/>
-        </p:spPr>
-        <p:txBody>
-          <a:bodyPr wrap="square" lIns="0" rIns="0" tIns="0" bIns="0" anchor="t">
-            <a:spAutoFit/>
-          </a:bodyPr>
-          <a:lstStyle/>
-          <a:p>
-            <a:pPr algn="l">
-              <a:lnSpc>
-                <a:spcPct val="135000"/>
-              </a:lnSpc>
-              <a:spcBef>
-                <a:spcPts val="500"/>
-              </a:spcBef>
-              <a:spcAft>
-                <a:spcPts val="0"/>
-              </a:spcAft>
-            </a:pPr>
-            <a:r>
-              <a:rPr sz="1050" b="0">
-                <a:solidFill>
-                  <a:srgbClr val="FFFFFF"/>
-                </a:solidFill>
-                <a:latin typeface="SF Mono"/>
-                <a:ea typeface="SF Mono"/>
-                <a:cs typeface="SF Mono"/>
-              </a:rPr>
-              <a:t>cdbd-templates/</a:t>
-            </a:r>
-          </a:p>
-          <a:p>
-            <a:pPr>
-              <a:lnSpc>
-                <a:spcPct val="135000"/>
-              </a:lnSpc>
-              <a:spcBef>
-                <a:spcPts val="500"/>
-              </a:spcBef>
-              <a:spcAft>
-                <a:spcPts val="0"/>
-              </a:spcAft>
-            </a:pPr>
-            <a:r>
-              <a:rPr sz="1050" b="0">
-                <a:solidFill>
-                  <a:srgbClr val="F09E9E"/>
-                </a:solidFill>
-                <a:latin typeface="SF Mono"/>
-                <a:ea typeface="SF Mono"/>
-                <a:cs typeface="SF Mono"/>
-              </a:rPr>
-              <a:t>├─ CLAUDE.md          131 KB</a:t>
-            </a:r>
-          </a:p>
-          <a:p>
-            <a:pPr>
-              <a:lnSpc>
-                <a:spcPct val="135000"/>
-              </a:lnSpc>
-              <a:spcBef>
-                <a:spcPts val="500"/>
-              </a:spcBef>
-              <a:spcAft>
-                <a:spcPts val="0"/>
-              </a:spcAft>
-            </a:pPr>
-            <a:r>
-              <a:rPr sz="1050" b="0">
-                <a:solidFill>
-                  <a:srgbClr val="F09E9E"/>
-                </a:solidFill>
-                <a:latin typeface="SF Mono"/>
-                <a:ea typeface="SF Mono"/>
-                <a:cs typeface="SF Mono"/>
-              </a:rPr>
-              <a:t>├─ AGENTS.md          94 KB  (구버전)</a:t>
-            </a:r>
-          </a:p>
-          <a:p>
-            <a:pPr>
-              <a:lnSpc>
-                <a:spcPct val="135000"/>
-              </a:lnSpc>
-              <a:spcBef>
-                <a:spcPts val="500"/>
-              </a:spcBef>
-              <a:spcAft>
-                <a:spcPts val="0"/>
-              </a:spcAft>
-            </a:pPr>
-            <a:r>
-              <a:rPr sz="1050" b="0">
-                <a:solidFill>
-                  <a:srgbClr val="F09E9E"/>
-                </a:solidFill>
-                <a:latin typeface="SF Mono"/>
-                <a:ea typeface="SF Mono"/>
-                <a:cs typeface="SF Mono"/>
-              </a:rPr>
-              <a:t>├─ .agents/           (깨진 복사본)</a:t>
-            </a:r>
-          </a:p>
-          <a:p>
-            <a:pPr>
-              <a:lnSpc>
-                <a:spcPct val="135000"/>
-              </a:lnSpc>
-              <a:spcBef>
-                <a:spcPts val="500"/>
-              </a:spcBef>
-              <a:spcAft>
-                <a:spcPts val="0"/>
-              </a:spcAft>
-            </a:pPr>
-            <a:r>
-              <a:rPr sz="1050" b="0">
-                <a:solidFill>
-                  <a:srgbClr val="F09E9E"/>
-                </a:solidFill>
-                <a:latin typeface="SF Mono"/>
-                <a:ea typeface="SF Mono"/>
-                <a:cs typeface="SF Mono"/>
-              </a:rPr>
-              <a:t>├─ .codex/            (깨진 복사본)</a:t>
-            </a:r>
-          </a:p>
-          <a:p>
-            <a:pPr>
-              <a:lnSpc>
-                <a:spcPct val="135000"/>
-              </a:lnSpc>
-              <a:spcBef>
-                <a:spcPts val="500"/>
-              </a:spcBef>
-              <a:spcAft>
-                <a:spcPts val="0"/>
-              </a:spcAft>
-            </a:pPr>
-            <a:r>
-              <a:rPr sz="1050" b="0">
-                <a:solidFill>
-                  <a:srgbClr val="B0B0B0"/>
-                </a:solidFill>
-                <a:latin typeface="SF Mono"/>
-                <a:ea typeface="SF Mono"/>
-                <a:cs typeface="SF Mono"/>
-              </a:rPr>
-              <a:t>├─ .claude/skills/    스킬 5개</a:t>
-            </a:r>
-          </a:p>
-          <a:p>
-            <a:pPr>
-              <a:lnSpc>
-                <a:spcPct val="135000"/>
-              </a:lnSpc>
-              <a:spcBef>
-                <a:spcPts val="500"/>
-              </a:spcBef>
-              <a:spcAft>
-                <a:spcPts val="0"/>
-              </a:spcAft>
-            </a:pPr>
-            <a:r>
-              <a:rPr sz="1050" b="0">
-                <a:solidFill>
-                  <a:srgbClr val="FFFFFF"/>
-                </a:solidFill>
-                <a:latin typeface="SF Mono"/>
-                <a:ea typeface="SF Mono"/>
-                <a:cs typeface="SF Mono"/>
-              </a:rPr>
-              <a:t>└─ 1. 작업 가이드/</a:t>
-            </a:r>
-          </a:p>
-          <a:p>
-            <a:pPr>
-              <a:lnSpc>
-                <a:spcPct val="135000"/>
-              </a:lnSpc>
-              <a:spcBef>
-                <a:spcPts val="500"/>
-              </a:spcBef>
-              <a:spcAft>
-                <a:spcPts val="0"/>
-              </a:spcAft>
-            </a:pPr>
-            <a:r>
-              <a:rPr sz="1050" b="0">
-                <a:solidFill>
-                  <a:srgbClr val="F09E9E"/>
-                </a:solidFill>
-                <a:latin typeface="SF Mono"/>
-                <a:ea typeface="SF Mono"/>
-                <a:cs typeface="SF Mono"/>
-              </a:rPr>
-              <a:t>    ├─ 1-3. 색상 팔레트.md   ← 여기 복사본</a:t>
-            </a:r>
-          </a:p>
-          <a:p>
-            <a:pPr>
-              <a:lnSpc>
-                <a:spcPct val="135000"/>
-              </a:lnSpc>
-              <a:spcBef>
-                <a:spcPts val="500"/>
-              </a:spcBef>
-              <a:spcAft>
-                <a:spcPts val="0"/>
-              </a:spcAft>
-            </a:pPr>
-            <a:r>
-              <a:rPr sz="1050" b="0">
-                <a:solidFill>
-                  <a:srgbClr val="F09E9E"/>
-                </a:solidFill>
-                <a:latin typeface="SF Mono"/>
-                <a:ea typeface="SF Mono"/>
-                <a:cs typeface="SF Mono"/>
-              </a:rPr>
-              <a:t>    └─ 1-4. 폰트.md          ← 여기 복사본</a:t>
-            </a:r>
-          </a:p>
-        </p:txBody>
-      </p:sp>
-      <p:sp>
-        <p:nvSpPr>
-          <p:cNvPr id="8" name="TextBox 7"/>
-          <p:cNvSpPr txBox="1"/>
-          <p:nvPr/>
-        </p:nvSpPr>
-        <p:spPr>
-          <a:xfrm>
-            <a:off x="777240" y="5257800"/>
-            <a:ext cx="5120640" cy="548640"/>
-          </a:xfrm>
-          <a:prstGeom prst="rect">
-            <a:avLst/>
-          </a:prstGeom>
-          <a:noFill/>
-        </p:spPr>
-        <p:txBody>
-          <a:bodyPr wrap="square" lIns="0" rIns="0" tIns="0" bIns="0" anchor="t">
-            <a:spAutoFit/>
-          </a:bodyPr>
-          <a:lstStyle/>
-          <a:p>
-            <a:pPr algn="l">
-              <a:lnSpc>
-                <a:spcPct val="150000"/>
-              </a:lnSpc>
-              <a:spcBef>
-                <a:spcPts val="0"/>
-              </a:spcBef>
-              <a:spcAft>
-                <a:spcPts val="0"/>
-              </a:spcAft>
-            </a:pPr>
-            <a:r>
-              <a:rPr sz="1200" b="0">
-                <a:solidFill>
-                  <a:srgbClr val="E53A40"/>
-                </a:solidFill>
-                <a:latin typeface="Pretendard"/>
-                <a:ea typeface="Pretendard"/>
-                <a:cs typeface="Pretendard"/>
-              </a:rPr>
-              <a:t>· 규칙집 2권 + 깨진 복사본 2개</a:t>
-            </a:r>
-          </a:p>
-          <a:p>
-            <a:pPr>
-              <a:lnSpc>
-                <a:spcPct val="150000"/>
-              </a:lnSpc>
-              <a:spcBef>
-                <a:spcPts val="0"/>
-              </a:spcBef>
-              <a:spcAft>
-                <a:spcPts val="0"/>
-              </a:spcAft>
-            </a:pPr>
-            <a:r>
-              <a:rPr sz="1200" b="0">
-                <a:solidFill>
-                  <a:srgbClr val="E53A40"/>
-                </a:solidFill>
-                <a:latin typeface="Pretendard"/>
-                <a:ea typeface="Pretendard"/>
-                <a:cs typeface="Pretendard"/>
-              </a:rPr>
-              <a:t>· 팔레트·폰트를 다른 저장소가 각자 또 복사</a:t>
-            </a:r>
-          </a:p>
-        </p:txBody>
-      </p:sp>
-      <p:sp>
-        <p:nvSpPr>
-          <p:cNvPr id="9" name="TextBox 8"/>
-          <p:cNvSpPr txBox="1"/>
-          <p:nvPr/>
-        </p:nvSpPr>
-        <p:spPr>
-          <a:xfrm>
-            <a:off x="6263640" y="1719072"/>
-            <a:ext cx="5148072" cy="274320"/>
-          </a:xfrm>
-          <a:prstGeom prst="rect">
-            <a:avLst/>
-          </a:prstGeom>
-          <a:noFill/>
-        </p:spPr>
-        <p:txBody>
-          <a:bodyPr wrap="square" lIns="0" rIns="0" tIns="0" bIns="0" anchor="t">
-            <a:spAutoFit/>
-          </a:bodyPr>
-          <a:lstStyle/>
-          <a:p>
-            <a:pPr algn="l">
-              <a:lnSpc>
-                <a:spcPct val="135000"/>
-              </a:lnSpc>
-              <a:spcBef>
-                <a:spcPts val="0"/>
-              </a:spcBef>
-              <a:spcAft>
-                <a:spcPts val="0"/>
-              </a:spcAft>
-            </a:pPr>
-            <a:r>
-              <a:rPr sz="1450" b="1">
-                <a:solidFill>
-                  <a:srgbClr val="1C9E63"/>
-                </a:solidFill>
-                <a:latin typeface="Pretendard"/>
-                <a:ea typeface="Pretendard"/>
-                <a:cs typeface="Pretendard"/>
-              </a:rPr>
-              <a:t>추천안 적용 후</a:t>
-            </a:r>
-          </a:p>
-        </p:txBody>
-      </p:sp>
-      <p:sp>
-        <p:nvSpPr>
-          <p:cNvPr id="10" name="Rectangle 9"/>
-          <p:cNvSpPr/>
-          <p:nvPr/>
-        </p:nvSpPr>
-        <p:spPr>
-          <a:xfrm>
-            <a:off x="6263640" y="2084831"/>
-            <a:ext cx="5148072" cy="3063240"/>
-          </a:xfrm>
-          <a:prstGeom prst="rect">
-            <a:avLst/>
-          </a:prstGeom>
-          <a:solidFill>
-            <a:srgbClr val="2E2E32"/>
-          </a:solidFill>
-          <a:ln>
-            <a:noFill/>
-          </a:ln>
-          <a:effectLst/>
-        </p:spPr>
-        <p:style>
-          <a:lnRef idx="1">
-            <a:schemeClr val="accent1"/>
-          </a:lnRef>
-          <a:fillRef idx="3">
-            <a:schemeClr val="accent1"/>
-          </a:fillRef>
-          <a:effectRef idx="2">
-            <a:schemeClr val="accent1"/>
-          </a:effectRef>
-          <a:fontRef idx="minor">
-            <a:schemeClr val="lt1"/>
-          </a:fontRef>
-        </p:style>
-        <p:txBody>
-          <a:bodyPr rtlCol="0" anchor="ctr" wrap="square"/>
-          <a:lstStyle/>
-          <a:p>
-            <a:pPr algn="ctr"/>
-          </a:p>
-        </p:txBody>
-      </p:sp>
-      <p:sp>
-        <p:nvSpPr>
-          <p:cNvPr id="11" name="TextBox 10"/>
-          <p:cNvSpPr txBox="1"/>
-          <p:nvPr/>
-        </p:nvSpPr>
-        <p:spPr>
-          <a:xfrm>
-            <a:off x="6473952" y="2240280"/>
-            <a:ext cx="4736592" cy="2743200"/>
-          </a:xfrm>
-          <a:prstGeom prst="rect">
-            <a:avLst/>
-          </a:prstGeom>
-          <a:noFill/>
-        </p:spPr>
-        <p:txBody>
-          <a:bodyPr wrap="square" lIns="0" rIns="0" tIns="0" bIns="0" anchor="t">
-            <a:spAutoFit/>
-          </a:bodyPr>
-          <a:lstStyle/>
-          <a:p>
-            <a:pPr algn="l">
-              <a:lnSpc>
-                <a:spcPct val="135000"/>
-              </a:lnSpc>
-              <a:spcBef>
-                <a:spcPts val="500"/>
-              </a:spcBef>
-              <a:spcAft>
-                <a:spcPts val="0"/>
-              </a:spcAft>
-            </a:pPr>
-            <a:r>
-              <a:rPr sz="1050" b="0">
-                <a:solidFill>
-                  <a:srgbClr val="FFFFFF"/>
-                </a:solidFill>
-                <a:latin typeface="SF Mono"/>
-                <a:ea typeface="SF Mono"/>
-                <a:cs typeface="SF Mono"/>
-              </a:rPr>
-              <a:t>cdbd-templates/</a:t>
-            </a:r>
-          </a:p>
-          <a:p>
-            <a:pPr>
-              <a:lnSpc>
-                <a:spcPct val="135000"/>
-              </a:lnSpc>
-              <a:spcBef>
-                <a:spcPts val="500"/>
-              </a:spcBef>
-              <a:spcAft>
-                <a:spcPts val="0"/>
-              </a:spcAft>
-            </a:pPr>
-            <a:r>
-              <a:rPr sz="1050" b="0">
-                <a:solidFill>
-                  <a:srgbClr val="3DF69B"/>
-                </a:solidFill>
-                <a:latin typeface="SF Mono"/>
-                <a:ea typeface="SF Mono"/>
-                <a:cs typeface="SF Mono"/>
-              </a:rPr>
-              <a:t>├─ _core/             ← 공통 정본 (자동 연결)</a:t>
-            </a:r>
-          </a:p>
-          <a:p>
-            <a:pPr>
-              <a:lnSpc>
-                <a:spcPct val="135000"/>
-              </a:lnSpc>
-              <a:spcBef>
-                <a:spcPts val="500"/>
-              </a:spcBef>
-              <a:spcAft>
-                <a:spcPts val="0"/>
-              </a:spcAft>
-            </a:pPr>
-            <a:r>
-              <a:rPr sz="1050" b="0">
-                <a:solidFill>
-                  <a:srgbClr val="3DF69B"/>
-                </a:solidFill>
-                <a:latin typeface="SF Mono"/>
-                <a:ea typeface="SF Mono"/>
-                <a:cs typeface="SF Mono"/>
-              </a:rPr>
-              <a:t>│   ├─ 브랜드 토큰.md      #3DF69B 단 하나</a:t>
-            </a:r>
-          </a:p>
-          <a:p>
-            <a:pPr>
-              <a:lnSpc>
-                <a:spcPct val="135000"/>
-              </a:lnSpc>
-              <a:spcBef>
-                <a:spcPts val="500"/>
-              </a:spcBef>
-              <a:spcAft>
-                <a:spcPts val="0"/>
-              </a:spcAft>
-            </a:pPr>
-            <a:r>
-              <a:rPr sz="1050" b="0">
-                <a:solidFill>
-                  <a:srgbClr val="3DF69B"/>
-                </a:solidFill>
-                <a:latin typeface="SF Mono"/>
-                <a:ea typeface="SF Mono"/>
-                <a:cs typeface="SF Mono"/>
-              </a:rPr>
-              <a:t>│   ├─ 색상 팔레트.md      70색 원본</a:t>
-            </a:r>
-          </a:p>
-          <a:p>
-            <a:pPr>
-              <a:lnSpc>
-                <a:spcPct val="135000"/>
-              </a:lnSpc>
-              <a:spcBef>
-                <a:spcPts val="500"/>
-              </a:spcBef>
-              <a:spcAft>
-                <a:spcPts val="0"/>
-              </a:spcAft>
-            </a:pPr>
-            <a:r>
-              <a:rPr sz="1050" b="0">
-                <a:solidFill>
-                  <a:srgbClr val="3DF69B"/>
-                </a:solidFill>
-                <a:latin typeface="SF Mono"/>
-                <a:ea typeface="SF Mono"/>
-                <a:cs typeface="SF Mono"/>
-              </a:rPr>
-              <a:t>│   ├─ 폰트.md            44종 원본</a:t>
-            </a:r>
-          </a:p>
-          <a:p>
-            <a:pPr>
-              <a:lnSpc>
-                <a:spcPct val="135000"/>
-              </a:lnSpc>
-              <a:spcBef>
-                <a:spcPts val="500"/>
-              </a:spcBef>
-              <a:spcAft>
-                <a:spcPts val="0"/>
-              </a:spcAft>
-            </a:pPr>
-            <a:r>
-              <a:rPr sz="1050" b="0">
-                <a:solidFill>
-                  <a:srgbClr val="3DF69B"/>
-                </a:solidFill>
-                <a:latin typeface="SF Mono"/>
-                <a:ea typeface="SF Mono"/>
-                <a:cs typeface="SF Mono"/>
-              </a:rPr>
-              <a:t>│   ├─ 문서 작성 규칙.md</a:t>
-            </a:r>
-          </a:p>
-          <a:p>
-            <a:pPr>
-              <a:lnSpc>
-                <a:spcPct val="135000"/>
-              </a:lnSpc>
-              <a:spcBef>
-                <a:spcPts val="500"/>
-              </a:spcBef>
-              <a:spcAft>
-                <a:spcPts val="0"/>
-              </a:spcAft>
-            </a:pPr>
-            <a:r>
-              <a:rPr sz="1050" b="0">
-                <a:solidFill>
-                  <a:srgbClr val="3DF69B"/>
-                </a:solidFill>
-                <a:latin typeface="SF Mono"/>
-                <a:ea typeface="SF Mono"/>
-                <a:cs typeface="SF Mono"/>
-              </a:rPr>
-              <a:t>│   └─ setup.sh           환경 한 번에 설치</a:t>
-            </a:r>
-          </a:p>
-          <a:p>
-            <a:pPr>
-              <a:lnSpc>
-                <a:spcPct val="135000"/>
-              </a:lnSpc>
-              <a:spcBef>
-                <a:spcPts val="500"/>
-              </a:spcBef>
-              <a:spcAft>
-                <a:spcPts val="0"/>
-              </a:spcAft>
-            </a:pPr>
-            <a:r>
-              <a:rPr sz="1050" b="0">
-                <a:solidFill>
-                  <a:srgbClr val="FFFFFF"/>
-                </a:solidFill>
-                <a:latin typeface="SF Mono"/>
-                <a:ea typeface="SF Mono"/>
-                <a:cs typeface="SF Mono"/>
-              </a:rPr>
-              <a:t>├─ CLAUDE.md          150줄 (라우팅 표만)</a:t>
-            </a:r>
-          </a:p>
-          <a:p>
-            <a:pPr>
-              <a:lnSpc>
-                <a:spcPct val="135000"/>
-              </a:lnSpc>
-              <a:spcBef>
-                <a:spcPts val="500"/>
-              </a:spcBef>
-              <a:spcAft>
-                <a:spcPts val="0"/>
-              </a:spcAft>
-            </a:pPr>
-            <a:r>
-              <a:rPr sz="1050" b="0">
-                <a:solidFill>
-                  <a:srgbClr val="FFFFFF"/>
-                </a:solidFill>
-                <a:latin typeface="SF Mono"/>
-                <a:ea typeface="SF Mono"/>
-                <a:cs typeface="SF Mono"/>
-              </a:rPr>
-              <a:t>├─ .claude/skills/    스킬 17개 (전부 등록)</a:t>
-            </a:r>
-          </a:p>
-          <a:p>
-            <a:pPr>
-              <a:lnSpc>
-                <a:spcPct val="135000"/>
-              </a:lnSpc>
-              <a:spcBef>
-                <a:spcPts val="500"/>
-              </a:spcBef>
-              <a:spcAft>
-                <a:spcPts val="0"/>
-              </a:spcAft>
-            </a:pPr>
-            <a:r>
-              <a:rPr sz="1050" b="0">
-                <a:solidFill>
-                  <a:srgbClr val="FFFFFF"/>
-                </a:solidFill>
-                <a:latin typeface="SF Mono"/>
-                <a:ea typeface="SF Mono"/>
-                <a:cs typeface="SF Mono"/>
-              </a:rPr>
-              <a:t>└─ 1. 작업 가이드/     이 저장소 고유 문서만</a:t>
-            </a:r>
-          </a:p>
-        </p:txBody>
-      </p:sp>
-      <p:sp>
-        <p:nvSpPr>
-          <p:cNvPr id="12" name="TextBox 11"/>
-          <p:cNvSpPr txBox="1"/>
-          <p:nvPr/>
-        </p:nvSpPr>
-        <p:spPr>
-          <a:xfrm>
-            <a:off x="6263640" y="5257800"/>
-            <a:ext cx="5148072" cy="548640"/>
-          </a:xfrm>
-          <a:prstGeom prst="rect">
-            <a:avLst/>
-          </a:prstGeom>
-          <a:noFill/>
-        </p:spPr>
-        <p:txBody>
-          <a:bodyPr wrap="square" lIns="0" rIns="0" tIns="0" bIns="0" anchor="t">
-            <a:spAutoFit/>
-          </a:bodyPr>
-          <a:lstStyle/>
-          <a:p>
-            <a:pPr algn="l">
-              <a:lnSpc>
-                <a:spcPct val="150000"/>
-              </a:lnSpc>
-              <a:spcBef>
-                <a:spcPts val="0"/>
-              </a:spcBef>
-              <a:spcAft>
-                <a:spcPts val="0"/>
-              </a:spcAft>
-            </a:pPr>
-            <a:r>
-              <a:rPr sz="1200" b="0">
-                <a:solidFill>
-                  <a:srgbClr val="1C9E63"/>
-                </a:solidFill>
-                <a:latin typeface="Pretendard"/>
-                <a:ea typeface="Pretendard"/>
-                <a:cs typeface="Pretendard"/>
-              </a:rPr>
-              <a:t>· 규칙집 1권 · 복사본 0개</a:t>
-            </a:r>
-          </a:p>
-          <a:p>
-            <a:pPr>
-              <a:lnSpc>
-                <a:spcPct val="150000"/>
-              </a:lnSpc>
-              <a:spcBef>
-                <a:spcPts val="0"/>
-              </a:spcBef>
-              <a:spcAft>
-                <a:spcPts val="0"/>
-              </a:spcAft>
-            </a:pPr>
-            <a:r>
-              <a:rPr sz="1200" b="0">
-                <a:solidFill>
-                  <a:srgbClr val="1C9E63"/>
-                </a:solidFill>
-                <a:latin typeface="Pretendard"/>
-                <a:ea typeface="Pretendard"/>
-                <a:cs typeface="Pretendard"/>
-              </a:rPr>
-              <a:t>· 팔레트·폰트는 _core 하나만 봄</a:t>
-            </a:r>
-          </a:p>
-        </p:txBody>
-      </p:sp>
-      <p:sp>
-        <p:nvSpPr>
-          <p:cNvPr id="13" name="Rectangle 12"/>
-          <p:cNvSpPr/>
-          <p:nvPr/>
-        </p:nvSpPr>
-        <p:spPr>
-          <a:xfrm>
-            <a:off x="777240" y="5943600"/>
-            <a:ext cx="10634472" cy="457200"/>
-          </a:xfrm>
-          <a:prstGeom prst="rect">
-            <a:avLst/>
-          </a:prstGeom>
-          <a:solidFill>
-            <a:srgbClr val="292929"/>
-          </a:solidFill>
-          <a:ln>
-            <a:noFill/>
-          </a:ln>
-          <a:effectLst/>
-        </p:spPr>
-        <p:style>
-          <a:lnRef idx="1">
-            <a:schemeClr val="accent1"/>
-          </a:lnRef>
-          <a:fillRef idx="3">
-            <a:schemeClr val="accent1"/>
-          </a:fillRef>
-          <a:effectRef idx="2">
-            <a:schemeClr val="accent1"/>
-          </a:effectRef>
-          <a:fontRef idx="minor">
-            <a:schemeClr val="lt1"/>
-          </a:fontRef>
-        </p:style>
-        <p:txBody>
-          <a:bodyPr rtlCol="0" anchor="ctr" wrap="square"/>
-          <a:lstStyle/>
-          <a:p>
-            <a:pPr algn="ctr"/>
-          </a:p>
-        </p:txBody>
-      </p:sp>
-      <p:sp>
-        <p:nvSpPr>
-          <p:cNvPr id="14" name="TextBox 13"/>
-          <p:cNvSpPr txBox="1"/>
-          <p:nvPr/>
-        </p:nvSpPr>
-        <p:spPr>
-          <a:xfrm>
-            <a:off x="1051560" y="6053328"/>
-            <a:ext cx="10241280" cy="274320"/>
-          </a:xfrm>
-          <a:prstGeom prst="rect">
-            <a:avLst/>
-          </a:prstGeom>
-          <a:noFill/>
-        </p:spPr>
-        <p:txBody>
-          <a:bodyPr wrap="square" lIns="0" rIns="0" tIns="0" bIns="0" anchor="t">
-            <a:spAutoFit/>
-          </a:bodyPr>
-          <a:lstStyle/>
-          <a:p>
-            <a:pPr algn="l">
-              <a:lnSpc>
-                <a:spcPct val="135000"/>
-              </a:lnSpc>
-              <a:spcBef>
-                <a:spcPts val="0"/>
-              </a:spcBef>
-              <a:spcAft>
-                <a:spcPts val="0"/>
-              </a:spcAft>
-            </a:pPr>
-            <a:r>
-              <a:rPr sz="1300" b="1">
-                <a:solidFill>
-                  <a:srgbClr val="FFFFFF"/>
-                </a:solidFill>
-                <a:latin typeface="Pretendard"/>
-                <a:ea typeface="Pretendard"/>
-                <a:cs typeface="Pretendard"/>
-              </a:rPr>
-              <a:t>브랜드 색을 바꿔야 하면 _core의 파일 하나만 고칩니다. 5개 저장소에 동시에 반영됩니다.</a:t>
-            </a:r>
-          </a:p>
-        </p:txBody>
-      </p:sp>
-      <p:sp>
-        <p:nvSpPr>
-          <p:cNvPr id="15" name="TextBox 14"/>
-          <p:cNvSpPr txBox="1"/>
-          <p:nvPr/>
-        </p:nvSpPr>
-        <p:spPr>
-          <a:xfrm>
-            <a:off x="777240" y="6455664"/>
-            <a:ext cx="9509760" cy="256032"/>
-          </a:xfrm>
-          <a:prstGeom prst="rect">
-            <a:avLst/>
-          </a:prstGeom>
-          <a:noFill/>
-        </p:spPr>
-        <p:txBody>
-          <a:bodyPr wrap="square" lIns="0" rIns="0" tIns="0" bIns="0" anchor="t">
-            <a:spAutoFit/>
-          </a:bodyPr>
-          <a:lstStyle/>
-          <a:p>
-            <a:pPr algn="l">
-              <a:lnSpc>
-                <a:spcPct val="135000"/>
-              </a:lnSpc>
-              <a:spcBef>
-                <a:spcPts val="0"/>
-              </a:spcBef>
-              <a:spcAft>
-                <a:spcPts val="0"/>
-              </a:spcAft>
-            </a:pPr>
-            <a:r>
-              <a:rPr sz="1000" b="0">
-                <a:solidFill>
-                  <a:srgbClr val="9A9A9A"/>
-                </a:solidFill>
-                <a:latin typeface="Pretendard"/>
-                <a:ea typeface="Pretendard"/>
-                <a:cs typeface="Pretendard"/>
-              </a:rPr>
-              <a:t/>
-            </a:r>
-          </a:p>
-        </p:txBody>
-      </p:sp>
-      <p:sp>
-        <p:nvSpPr>
-          <p:cNvPr id="16" name="TextBox 15"/>
-          <p:cNvSpPr txBox="1"/>
-          <p:nvPr/>
-        </p:nvSpPr>
-        <p:spPr>
-          <a:xfrm>
-            <a:off x="10588752" y="6455664"/>
-            <a:ext cx="822960" cy="256032"/>
-          </a:xfrm>
-          <a:prstGeom prst="rect">
-            <a:avLst/>
-          </a:prstGeom>
-          <a:noFill/>
-        </p:spPr>
-        <p:txBody>
-          <a:bodyPr wrap="square" lIns="0" rIns="0" tIns="0" bIns="0" anchor="t">
-            <a:spAutoFit/>
-          </a:bodyPr>
-          <a:lstStyle/>
-          <a:p>
-            <a:pPr algn="r">
-              <a:lnSpc>
-                <a:spcPct val="135000"/>
-              </a:lnSpc>
-              <a:spcBef>
-                <a:spcPts val="0"/>
-              </a:spcBef>
-              <a:spcAft>
-                <a:spcPts val="0"/>
-              </a:spcAft>
-            </a:pPr>
-            <a:r>
-              <a:rPr sz="1000" b="0">
-                <a:solidFill>
-                  <a:srgbClr val="9A9A9A"/>
-                </a:solidFill>
-                <a:latin typeface="Pretendard"/>
-                <a:ea typeface="Pretendard"/>
-                <a:cs typeface="Pretendard"/>
-              </a:rPr>
-              <a:t>19</a:t>
-            </a:r>
-          </a:p>
-        </p:txBody>
-      </p:sp>
-    </p:spTree>
-  </p:cSld>
-  <p:clrMapOvr>
-    <a:masterClrMapping/>
-  </p:clrMapOvr>
-</p:sld>
-</file>
-
-<file path=ppt/slides/slide2.xml><?xml version="1.0" encoding="utf-8"?>
-<p:sld xmlns:a="http://schemas.openxmlformats.org/drawingml/2006/main" xmlns:p="http://schemas.openxmlformats.org/presentationml/2006/main" xmlns:r="http://schemas.openxmlformats.org/officeDocument/2006/relationships">
-  <p:cSld>
-    <p:spTree>
-      <p:nvGrpSpPr>
-        <p:cNvPr id="1" name=""/>
-        <p:cNvGrpSpPr/>
-        <p:nvPr/>
-      </p:nvGrpSpPr>
-      <p:grpSpPr/>
-      <p:sp>
-        <p:nvSpPr>
-          <p:cNvPr id="2" name="Rectangle 1"/>
-          <p:cNvSpPr/>
-          <p:nvPr/>
-        </p:nvSpPr>
-        <p:spPr>
-          <a:xfrm>
-            <a:off x="0" y="0"/>
-            <a:ext cx="12191695" cy="6858000"/>
-          </a:xfrm>
-          <a:prstGeom prst="rect">
-            <a:avLst/>
-          </a:prstGeom>
-          <a:solidFill>
-            <a:srgbClr val="FAFAFA"/>
-          </a:solidFill>
-          <a:ln>
-            <a:noFill/>
-          </a:ln>
-          <a:effectLst/>
-        </p:spPr>
-        <p:style>
-          <a:lnRef idx="1">
-            <a:schemeClr val="accent1"/>
-          </a:lnRef>
-          <a:fillRef idx="3">
-            <a:schemeClr val="accent1"/>
-          </a:fillRef>
-          <a:effectRef idx="2">
-            <a:schemeClr val="accent1"/>
-          </a:effectRef>
-          <a:fontRef idx="minor">
-            <a:schemeClr val="lt1"/>
-          </a:fontRef>
-        </p:style>
-        <p:txBody>
-          <a:bodyPr rtlCol="0" anchor="ctr" wrap="square"/>
-          <a:lstStyle/>
-          <a:p>
-            <a:pPr algn="ctr"/>
-          </a:p>
-        </p:txBody>
-      </p:sp>
-      <p:sp>
-        <p:nvSpPr>
-          <p:cNvPr id="3" name="TextBox 2"/>
-          <p:cNvSpPr txBox="1"/>
-          <p:nvPr/>
-        </p:nvSpPr>
-        <p:spPr>
-          <a:xfrm>
-            <a:off x="777240" y="548640"/>
-            <a:ext cx="10607040" cy="292608"/>
-          </a:xfrm>
-          <a:prstGeom prst="rect">
-            <a:avLst/>
-          </a:prstGeom>
-          <a:noFill/>
-        </p:spPr>
-        <p:txBody>
-          <a:bodyPr wrap="square" lIns="0" rIns="0" tIns="0" bIns="0" anchor="t">
-            <a:spAutoFit/>
-          </a:bodyPr>
-          <a:lstStyle/>
-          <a:p>
-            <a:pPr algn="l">
-              <a:lnSpc>
-                <a:spcPct val="135000"/>
-              </a:lnSpc>
-              <a:spcBef>
-                <a:spcPts val="0"/>
-              </a:spcBef>
-              <a:spcAft>
-                <a:spcPts val="0"/>
-              </a:spcAft>
-            </a:pPr>
-            <a:r>
-              <a:rPr sz="1300" b="1">
-                <a:solidFill>
-                  <a:srgbClr val="6C4CFF"/>
-                </a:solidFill>
-                <a:latin typeface="Pretendard"/>
-                <a:ea typeface="Pretendard"/>
-                <a:cs typeface="Pretendard"/>
-              </a:rPr>
-              <a:t>CONTENTS</a:t>
-            </a:r>
-          </a:p>
-        </p:txBody>
-      </p:sp>
-      <p:sp>
-        <p:nvSpPr>
-          <p:cNvPr id="4" name="TextBox 3"/>
-          <p:cNvSpPr txBox="1"/>
-          <p:nvPr/>
-        </p:nvSpPr>
-        <p:spPr>
-          <a:xfrm>
-            <a:off x="777240" y="914400"/>
-            <a:ext cx="10607040" cy="822960"/>
-          </a:xfrm>
-          <a:prstGeom prst="rect">
-            <a:avLst/>
-          </a:prstGeom>
-          <a:noFill/>
-        </p:spPr>
-        <p:txBody>
-          <a:bodyPr wrap="square" lIns="0" rIns="0" tIns="0" bIns="0" anchor="t">
-            <a:spAutoFit/>
-          </a:bodyPr>
-          <a:lstStyle/>
-          <a:p>
-            <a:pPr algn="l">
-              <a:lnSpc>
-                <a:spcPct val="120000"/>
-              </a:lnSpc>
-              <a:spcBef>
-                <a:spcPts val="0"/>
-              </a:spcBef>
-              <a:spcAft>
-                <a:spcPts val="0"/>
-              </a:spcAft>
-            </a:pPr>
-            <a:r>
-              <a:rPr sz="3300" b="1">
-                <a:solidFill>
-                  <a:srgbClr val="292929"/>
-                </a:solidFill>
-                <a:latin typeface="Pretendard"/>
-                <a:ea typeface="Pretendard"/>
-                <a:cs typeface="Pretendard"/>
-              </a:rPr>
-              <a:t>오늘 이야기 순서</a:t>
-            </a:r>
-          </a:p>
-        </p:txBody>
-      </p:sp>
-      <p:sp>
-        <p:nvSpPr>
-          <p:cNvPr id="5" name="Rectangle 4"/>
-          <p:cNvSpPr/>
-          <p:nvPr/>
-        </p:nvSpPr>
-        <p:spPr>
-          <a:xfrm>
-            <a:off x="777240" y="2103120"/>
-            <a:ext cx="10634472" cy="676656"/>
-          </a:xfrm>
-          <a:prstGeom prst="rect">
-            <a:avLst/>
-          </a:prstGeom>
-          <a:solidFill>
-            <a:srgbClr val="FFFFFF"/>
-          </a:solidFill>
-          <a:ln w="12700">
-            <a:solidFill>
-              <a:srgbClr val="E4E4E4"/>
-            </a:solidFill>
-          </a:ln>
-          <a:effectLst/>
-        </p:spPr>
-        <p:style>
-          <a:lnRef idx="1">
-            <a:schemeClr val="accent1"/>
-          </a:lnRef>
-          <a:fillRef idx="3">
-            <a:schemeClr val="accent1"/>
-          </a:fillRef>
-          <a:effectRef idx="2">
-            <a:schemeClr val="accent1"/>
-          </a:effectRef>
-          <a:fontRef idx="minor">
-            <a:schemeClr val="lt1"/>
-          </a:fontRef>
-        </p:style>
-        <p:txBody>
-          <a:bodyPr rtlCol="0" anchor="ctr" wrap="square"/>
-          <a:lstStyle/>
-          <a:p>
-            <a:pPr algn="ctr"/>
-          </a:p>
-        </p:txBody>
-      </p:sp>
-      <p:sp>
-        <p:nvSpPr>
-          <p:cNvPr id="6" name="Rectangle 5"/>
-          <p:cNvSpPr/>
-          <p:nvPr/>
-        </p:nvSpPr>
-        <p:spPr>
-          <a:xfrm>
-            <a:off x="777240" y="2103120"/>
-            <a:ext cx="82296" cy="676656"/>
-          </a:xfrm>
-          <a:prstGeom prst="rect">
-            <a:avLst/>
-          </a:prstGeom>
-          <a:solidFill>
-            <a:srgbClr val="6C4CFF"/>
-          </a:solidFill>
-          <a:ln>
-            <a:noFill/>
-          </a:ln>
-          <a:effectLst/>
-        </p:spPr>
-        <p:style>
-          <a:lnRef idx="1">
-            <a:schemeClr val="accent1"/>
-          </a:lnRef>
-          <a:fillRef idx="3">
-            <a:schemeClr val="accent1"/>
-          </a:fillRef>
-          <a:effectRef idx="2">
-            <a:schemeClr val="accent1"/>
-          </a:effectRef>
-          <a:fontRef idx="minor">
-            <a:schemeClr val="lt1"/>
-          </a:fontRef>
-        </p:style>
-        <p:txBody>
-          <a:bodyPr rtlCol="0" anchor="ctr" wrap="square"/>
-          <a:lstStyle/>
-          <a:p>
-            <a:pPr algn="ctr"/>
-          </a:p>
-        </p:txBody>
-      </p:sp>
-      <p:sp>
-        <p:nvSpPr>
-          <p:cNvPr id="7" name="TextBox 6"/>
-          <p:cNvSpPr txBox="1"/>
-          <p:nvPr/>
-        </p:nvSpPr>
-        <p:spPr>
-          <a:xfrm>
-            <a:off x="1143000" y="2286000"/>
-            <a:ext cx="731520" cy="320040"/>
-          </a:xfrm>
-          <a:prstGeom prst="rect">
-            <a:avLst/>
-          </a:prstGeom>
-          <a:noFill/>
-        </p:spPr>
-        <p:txBody>
-          <a:bodyPr wrap="square" lIns="0" rIns="0" tIns="0" bIns="0" anchor="t">
-            <a:spAutoFit/>
-          </a:bodyPr>
-          <a:lstStyle/>
-          <a:p>
-            <a:pPr algn="l">
-              <a:lnSpc>
-                <a:spcPct val="135000"/>
-              </a:lnSpc>
-              <a:spcBef>
-                <a:spcPts val="0"/>
-              </a:spcBef>
-              <a:spcAft>
-                <a:spcPts val="0"/>
-              </a:spcAft>
-            </a:pPr>
-            <a:r>
-              <a:rPr sz="1900" b="1">
-                <a:solidFill>
-                  <a:srgbClr val="6C4CFF"/>
-                </a:solidFill>
-                <a:latin typeface="Pretendard"/>
-                <a:ea typeface="Pretendard"/>
-                <a:cs typeface="Pretendard"/>
-              </a:rPr>
-              <a:t>01</a:t>
-            </a:r>
-          </a:p>
-        </p:txBody>
-      </p:sp>
-      <p:sp>
-        <p:nvSpPr>
-          <p:cNvPr id="8" name="TextBox 7"/>
-          <p:cNvSpPr txBox="1"/>
-          <p:nvPr/>
-        </p:nvSpPr>
-        <p:spPr>
-          <a:xfrm>
-            <a:off x="2057400" y="2221991"/>
-            <a:ext cx="2926080" cy="274320"/>
-          </a:xfrm>
-          <a:prstGeom prst="rect">
-            <a:avLst/>
-          </a:prstGeom>
-          <a:noFill/>
-        </p:spPr>
-        <p:txBody>
-          <a:bodyPr wrap="square" lIns="0" rIns="0" tIns="0" bIns="0" anchor="t">
-            <a:spAutoFit/>
-          </a:bodyPr>
-          <a:lstStyle/>
-          <a:p>
-            <a:pPr algn="l">
-              <a:lnSpc>
-                <a:spcPct val="135000"/>
-              </a:lnSpc>
-              <a:spcBef>
-                <a:spcPts val="0"/>
-              </a:spcBef>
-              <a:spcAft>
-                <a:spcPts val="0"/>
-              </a:spcAft>
-            </a:pPr>
-            <a:r>
-              <a:rPr sz="1650" b="1">
-                <a:solidFill>
-                  <a:srgbClr val="292929"/>
-                </a:solidFill>
-                <a:latin typeface="Pretendard"/>
-                <a:ea typeface="Pretendard"/>
-                <a:cs typeface="Pretendard"/>
-              </a:rPr>
-              <a:t>현황 파악</a:t>
-            </a:r>
-          </a:p>
-        </p:txBody>
-      </p:sp>
-      <p:sp>
-        <p:nvSpPr>
-          <p:cNvPr id="9" name="TextBox 8"/>
-          <p:cNvSpPr txBox="1"/>
-          <p:nvPr/>
-        </p:nvSpPr>
-        <p:spPr>
-          <a:xfrm>
-            <a:off x="2057400" y="2487168"/>
-            <a:ext cx="7589520" cy="256032"/>
-          </a:xfrm>
-          <a:prstGeom prst="rect">
-            <a:avLst/>
-          </a:prstGeom>
-          <a:noFill/>
-        </p:spPr>
-        <p:txBody>
-          <a:bodyPr wrap="square" lIns="0" rIns="0" tIns="0" bIns="0" anchor="t">
-            <a:spAutoFit/>
-          </a:bodyPr>
-          <a:lstStyle/>
-          <a:p>
-            <a:pPr algn="l">
-              <a:lnSpc>
-                <a:spcPct val="135000"/>
-              </a:lnSpc>
-              <a:spcBef>
-                <a:spcPts val="0"/>
-              </a:spcBef>
-              <a:spcAft>
-                <a:spcPts val="0"/>
-              </a:spcAft>
-            </a:pPr>
-            <a:r>
-              <a:rPr sz="1250" b="0">
-                <a:solidFill>
-                  <a:srgbClr val="6B6B6B"/>
-                </a:solidFill>
-                <a:latin typeface="Pretendard"/>
-                <a:ea typeface="Pretendard"/>
-                <a:cs typeface="Pretendard"/>
-              </a:rPr>
-              <a:t>우리 저장소가 몇 개이고 어떤 상태인지</a:t>
-            </a:r>
-          </a:p>
-        </p:txBody>
-      </p:sp>
-      <p:sp>
-        <p:nvSpPr>
-          <p:cNvPr id="10" name="TextBox 9"/>
-          <p:cNvSpPr txBox="1"/>
-          <p:nvPr/>
-        </p:nvSpPr>
-        <p:spPr>
-          <a:xfrm>
-            <a:off x="10058400" y="2322576"/>
-            <a:ext cx="1188720" cy="274320"/>
-          </a:xfrm>
-          <a:prstGeom prst="rect">
-            <a:avLst/>
-          </a:prstGeom>
-          <a:noFill/>
-        </p:spPr>
-        <p:txBody>
-          <a:bodyPr wrap="square" lIns="0" rIns="0" tIns="0" bIns="0" anchor="t">
-            <a:spAutoFit/>
-          </a:bodyPr>
-          <a:lstStyle/>
-          <a:p>
-            <a:pPr algn="r">
-              <a:lnSpc>
-                <a:spcPct val="135000"/>
-              </a:lnSpc>
-              <a:spcBef>
-                <a:spcPts val="0"/>
-              </a:spcBef>
-              <a:spcAft>
-                <a:spcPts val="0"/>
-              </a:spcAft>
-            </a:pPr>
-            <a:r>
-              <a:rPr sz="1200" b="0">
-                <a:solidFill>
-                  <a:srgbClr val="9A9A9A"/>
-                </a:solidFill>
-                <a:latin typeface="Pretendard"/>
-                <a:ea typeface="Pretendard"/>
-                <a:cs typeface="Pretendard"/>
-              </a:rPr>
-              <a:t>3 – 4</a:t>
-            </a:r>
-          </a:p>
-        </p:txBody>
-      </p:sp>
-      <p:sp>
-        <p:nvSpPr>
-          <p:cNvPr id="11" name="Rectangle 10"/>
-          <p:cNvSpPr/>
-          <p:nvPr/>
-        </p:nvSpPr>
-        <p:spPr>
-          <a:xfrm>
-            <a:off x="777240" y="2944368"/>
-            <a:ext cx="10634472" cy="676656"/>
-          </a:xfrm>
-          <a:prstGeom prst="rect">
-            <a:avLst/>
-          </a:prstGeom>
-          <a:solidFill>
-            <a:srgbClr val="FFFFFF"/>
-          </a:solidFill>
-          <a:ln w="12700">
-            <a:solidFill>
-              <a:srgbClr val="E4E4E4"/>
-            </a:solidFill>
-          </a:ln>
-          <a:effectLst/>
-        </p:spPr>
-        <p:style>
-          <a:lnRef idx="1">
-            <a:schemeClr val="accent1"/>
-          </a:lnRef>
-          <a:fillRef idx="3">
-            <a:schemeClr val="accent1"/>
-          </a:fillRef>
-          <a:effectRef idx="2">
-            <a:schemeClr val="accent1"/>
-          </a:effectRef>
-          <a:fontRef idx="minor">
-            <a:schemeClr val="lt1"/>
-          </a:fontRef>
-        </p:style>
-        <p:txBody>
-          <a:bodyPr rtlCol="0" anchor="ctr" wrap="square"/>
-          <a:lstStyle/>
-          <a:p>
-            <a:pPr algn="ctr"/>
-          </a:p>
-        </p:txBody>
-      </p:sp>
-      <p:sp>
-        <p:nvSpPr>
-          <p:cNvPr id="12" name="Rectangle 11"/>
-          <p:cNvSpPr/>
-          <p:nvPr/>
-        </p:nvSpPr>
-        <p:spPr>
-          <a:xfrm>
-            <a:off x="777240" y="2944368"/>
-            <a:ext cx="82296" cy="676656"/>
-          </a:xfrm>
-          <a:prstGeom prst="rect">
-            <a:avLst/>
-          </a:prstGeom>
-          <a:solidFill>
-            <a:srgbClr val="6C4CFF"/>
-          </a:solidFill>
-          <a:ln>
-            <a:noFill/>
-          </a:ln>
-          <a:effectLst/>
-        </p:spPr>
-        <p:style>
-          <a:lnRef idx="1">
-            <a:schemeClr val="accent1"/>
-          </a:lnRef>
-          <a:fillRef idx="3">
-            <a:schemeClr val="accent1"/>
-          </a:fillRef>
-          <a:effectRef idx="2">
-            <a:schemeClr val="accent1"/>
-          </a:effectRef>
-          <a:fontRef idx="minor">
-            <a:schemeClr val="lt1"/>
-          </a:fontRef>
-        </p:style>
-        <p:txBody>
-          <a:bodyPr rtlCol="0" anchor="ctr" wrap="square"/>
-          <a:lstStyle/>
-          <a:p>
-            <a:pPr algn="ctr"/>
-          </a:p>
-        </p:txBody>
-      </p:sp>
-      <p:sp>
-        <p:nvSpPr>
-          <p:cNvPr id="13" name="TextBox 12"/>
-          <p:cNvSpPr txBox="1"/>
-          <p:nvPr/>
-        </p:nvSpPr>
-        <p:spPr>
-          <a:xfrm>
-            <a:off x="1143000" y="3127248"/>
-            <a:ext cx="731520" cy="320040"/>
-          </a:xfrm>
-          <a:prstGeom prst="rect">
-            <a:avLst/>
-          </a:prstGeom>
-          <a:noFill/>
-        </p:spPr>
-        <p:txBody>
-          <a:bodyPr wrap="square" lIns="0" rIns="0" tIns="0" bIns="0" anchor="t">
-            <a:spAutoFit/>
-          </a:bodyPr>
-          <a:lstStyle/>
-          <a:p>
-            <a:pPr algn="l">
-              <a:lnSpc>
-                <a:spcPct val="135000"/>
-              </a:lnSpc>
-              <a:spcBef>
-                <a:spcPts val="0"/>
-              </a:spcBef>
-              <a:spcAft>
-                <a:spcPts val="0"/>
-              </a:spcAft>
-            </a:pPr>
-            <a:r>
-              <a:rPr sz="1900" b="1">
-                <a:solidFill>
-                  <a:srgbClr val="6C4CFF"/>
-                </a:solidFill>
-                <a:latin typeface="Pretendard"/>
-                <a:ea typeface="Pretendard"/>
-                <a:cs typeface="Pretendard"/>
-              </a:rPr>
-              <a:t>02</a:t>
-            </a:r>
-          </a:p>
-        </p:txBody>
-      </p:sp>
-      <p:sp>
-        <p:nvSpPr>
-          <p:cNvPr id="14" name="TextBox 13"/>
-          <p:cNvSpPr txBox="1"/>
-          <p:nvPr/>
-        </p:nvSpPr>
-        <p:spPr>
-          <a:xfrm>
-            <a:off x="2057400" y="3063239"/>
-            <a:ext cx="2926080" cy="274320"/>
-          </a:xfrm>
-          <a:prstGeom prst="rect">
-            <a:avLst/>
-          </a:prstGeom>
-          <a:noFill/>
-        </p:spPr>
-        <p:txBody>
-          <a:bodyPr wrap="square" lIns="0" rIns="0" tIns="0" bIns="0" anchor="t">
-            <a:spAutoFit/>
-          </a:bodyPr>
-          <a:lstStyle/>
-          <a:p>
-            <a:pPr algn="l">
-              <a:lnSpc>
-                <a:spcPct val="135000"/>
-              </a:lnSpc>
-              <a:spcBef>
-                <a:spcPts val="0"/>
-              </a:spcBef>
-              <a:spcAft>
-                <a:spcPts val="0"/>
-              </a:spcAft>
-            </a:pPr>
-            <a:r>
-              <a:rPr sz="1650" b="1">
-                <a:solidFill>
-                  <a:srgbClr val="292929"/>
-                </a:solidFill>
-                <a:latin typeface="Pretendard"/>
-                <a:ea typeface="Pretendard"/>
-                <a:cs typeface="Pretendard"/>
-              </a:rPr>
-              <a:t>진단</a:t>
-            </a:r>
-          </a:p>
-        </p:txBody>
-      </p:sp>
-      <p:sp>
-        <p:nvSpPr>
-          <p:cNvPr id="15" name="TextBox 14"/>
-          <p:cNvSpPr txBox="1"/>
-          <p:nvPr/>
-        </p:nvSpPr>
-        <p:spPr>
-          <a:xfrm>
-            <a:off x="2057400" y="3328415"/>
-            <a:ext cx="7589520" cy="256032"/>
-          </a:xfrm>
-          <a:prstGeom prst="rect">
-            <a:avLst/>
-          </a:prstGeom>
-          <a:noFill/>
-        </p:spPr>
-        <p:txBody>
-          <a:bodyPr wrap="square" lIns="0" rIns="0" tIns="0" bIns="0" anchor="t">
-            <a:spAutoFit/>
-          </a:bodyPr>
-          <a:lstStyle/>
-          <a:p>
-            <a:pPr algn="l">
-              <a:lnSpc>
-                <a:spcPct val="135000"/>
-              </a:lnSpc>
-              <a:spcBef>
-                <a:spcPts val="0"/>
-              </a:spcBef>
-              <a:spcAft>
-                <a:spcPts val="0"/>
-              </a:spcAft>
-            </a:pPr>
-            <a:r>
-              <a:rPr sz="1250" b="0">
-                <a:solidFill>
-                  <a:srgbClr val="6B6B6B"/>
-                </a:solidFill>
-                <a:latin typeface="Pretendard"/>
-                <a:ea typeface="Pretendard"/>
-                <a:cs typeface="Pretendard"/>
-              </a:rPr>
-              <a:t>기능 96개 중 Claude가 아는 건 7개 — 왜 그런지</a:t>
-            </a:r>
-          </a:p>
-        </p:txBody>
-      </p:sp>
-      <p:sp>
-        <p:nvSpPr>
-          <p:cNvPr id="16" name="TextBox 15"/>
-          <p:cNvSpPr txBox="1"/>
-          <p:nvPr/>
-        </p:nvSpPr>
-        <p:spPr>
-          <a:xfrm>
-            <a:off x="10058400" y="3163824"/>
-            <a:ext cx="1188720" cy="274320"/>
-          </a:xfrm>
-          <a:prstGeom prst="rect">
-            <a:avLst/>
-          </a:prstGeom>
-          <a:noFill/>
-        </p:spPr>
-        <p:txBody>
-          <a:bodyPr wrap="square" lIns="0" rIns="0" tIns="0" bIns="0" anchor="t">
-            <a:spAutoFit/>
-          </a:bodyPr>
-          <a:lstStyle/>
-          <a:p>
-            <a:pPr algn="r">
-              <a:lnSpc>
-                <a:spcPct val="135000"/>
-              </a:lnSpc>
-              <a:spcBef>
-                <a:spcPts val="0"/>
-              </a:spcBef>
-              <a:spcAft>
-                <a:spcPts val="0"/>
-              </a:spcAft>
-            </a:pPr>
-            <a:r>
-              <a:rPr sz="1200" b="0">
-                <a:solidFill>
-                  <a:srgbClr val="9A9A9A"/>
-                </a:solidFill>
-                <a:latin typeface="Pretendard"/>
-                <a:ea typeface="Pretendard"/>
-                <a:cs typeface="Pretendard"/>
-              </a:rPr>
-              <a:t>5 – 6</a:t>
-            </a:r>
-          </a:p>
-        </p:txBody>
-      </p:sp>
-      <p:sp>
-        <p:nvSpPr>
-          <p:cNvPr id="17" name="Rectangle 16"/>
-          <p:cNvSpPr/>
-          <p:nvPr/>
-        </p:nvSpPr>
-        <p:spPr>
-          <a:xfrm>
-            <a:off x="777240" y="3785615"/>
-            <a:ext cx="10634472" cy="676656"/>
-          </a:xfrm>
-          <a:prstGeom prst="rect">
-            <a:avLst/>
-          </a:prstGeom>
-          <a:solidFill>
-            <a:srgbClr val="FFFFFF"/>
-          </a:solidFill>
-          <a:ln w="12700">
-            <a:solidFill>
-              <a:srgbClr val="E4E4E4"/>
-            </a:solidFill>
-          </a:ln>
-          <a:effectLst/>
-        </p:spPr>
-        <p:style>
-          <a:lnRef idx="1">
-            <a:schemeClr val="accent1"/>
-          </a:lnRef>
-          <a:fillRef idx="3">
-            <a:schemeClr val="accent1"/>
-          </a:fillRef>
-          <a:effectRef idx="2">
-            <a:schemeClr val="accent1"/>
-          </a:effectRef>
-          <a:fontRef idx="minor">
-            <a:schemeClr val="lt1"/>
-          </a:fontRef>
-        </p:style>
-        <p:txBody>
-          <a:bodyPr rtlCol="0" anchor="ctr" wrap="square"/>
-          <a:lstStyle/>
-          <a:p>
-            <a:pPr algn="ctr"/>
-          </a:p>
-        </p:txBody>
-      </p:sp>
-      <p:sp>
-        <p:nvSpPr>
-          <p:cNvPr id="18" name="Rectangle 17"/>
-          <p:cNvSpPr/>
-          <p:nvPr/>
-        </p:nvSpPr>
-        <p:spPr>
-          <a:xfrm>
-            <a:off x="777240" y="3785615"/>
-            <a:ext cx="82296" cy="676656"/>
-          </a:xfrm>
-          <a:prstGeom prst="rect">
-            <a:avLst/>
-          </a:prstGeom>
-          <a:solidFill>
-            <a:srgbClr val="6C4CFF"/>
-          </a:solidFill>
-          <a:ln>
-            <a:noFill/>
-          </a:ln>
-          <a:effectLst/>
-        </p:spPr>
-        <p:style>
-          <a:lnRef idx="1">
-            <a:schemeClr val="accent1"/>
-          </a:lnRef>
-          <a:fillRef idx="3">
-            <a:schemeClr val="accent1"/>
-          </a:fillRef>
-          <a:effectRef idx="2">
-            <a:schemeClr val="accent1"/>
-          </a:effectRef>
-          <a:fontRef idx="minor">
-            <a:schemeClr val="lt1"/>
-          </a:fontRef>
-        </p:style>
-        <p:txBody>
-          <a:bodyPr rtlCol="0" anchor="ctr" wrap="square"/>
-          <a:lstStyle/>
-          <a:p>
-            <a:pPr algn="ctr"/>
-          </a:p>
-        </p:txBody>
-      </p:sp>
-      <p:sp>
-        <p:nvSpPr>
-          <p:cNvPr id="19" name="TextBox 18"/>
-          <p:cNvSpPr txBox="1"/>
-          <p:nvPr/>
-        </p:nvSpPr>
-        <p:spPr>
-          <a:xfrm>
-            <a:off x="1143000" y="3968496"/>
-            <a:ext cx="731520" cy="320040"/>
-          </a:xfrm>
-          <a:prstGeom prst="rect">
-            <a:avLst/>
-          </a:prstGeom>
-          <a:noFill/>
-        </p:spPr>
-        <p:txBody>
-          <a:bodyPr wrap="square" lIns="0" rIns="0" tIns="0" bIns="0" anchor="t">
-            <a:spAutoFit/>
-          </a:bodyPr>
-          <a:lstStyle/>
-          <a:p>
-            <a:pPr algn="l">
-              <a:lnSpc>
-                <a:spcPct val="135000"/>
-              </a:lnSpc>
-              <a:spcBef>
-                <a:spcPts val="0"/>
-              </a:spcBef>
-              <a:spcAft>
-                <a:spcPts val="0"/>
-              </a:spcAft>
-            </a:pPr>
-            <a:r>
-              <a:rPr sz="1900" b="1">
-                <a:solidFill>
-                  <a:srgbClr val="6C4CFF"/>
-                </a:solidFill>
-                <a:latin typeface="Pretendard"/>
-                <a:ea typeface="Pretendard"/>
-                <a:cs typeface="Pretendard"/>
-              </a:rPr>
-              <a:t>03</a:t>
-            </a:r>
-          </a:p>
-        </p:txBody>
-      </p:sp>
-      <p:sp>
-        <p:nvSpPr>
-          <p:cNvPr id="20" name="TextBox 19"/>
-          <p:cNvSpPr txBox="1"/>
-          <p:nvPr/>
-        </p:nvSpPr>
-        <p:spPr>
-          <a:xfrm>
-            <a:off x="2057400" y="3904487"/>
-            <a:ext cx="2926080" cy="274320"/>
-          </a:xfrm>
-          <a:prstGeom prst="rect">
-            <a:avLst/>
-          </a:prstGeom>
-          <a:noFill/>
-        </p:spPr>
-        <p:txBody>
-          <a:bodyPr wrap="square" lIns="0" rIns="0" tIns="0" bIns="0" anchor="t">
-            <a:spAutoFit/>
-          </a:bodyPr>
-          <a:lstStyle/>
-          <a:p>
-            <a:pPr algn="l">
-              <a:lnSpc>
-                <a:spcPct val="135000"/>
-              </a:lnSpc>
-              <a:spcBef>
-                <a:spcPts val="0"/>
-              </a:spcBef>
-              <a:spcAft>
-                <a:spcPts val="0"/>
-              </a:spcAft>
-            </a:pPr>
-            <a:r>
-              <a:rPr sz="1650" b="1">
-                <a:solidFill>
-                  <a:srgbClr val="292929"/>
-                </a:solidFill>
-                <a:latin typeface="Pretendard"/>
-                <a:ea typeface="Pretendard"/>
-                <a:cs typeface="Pretendard"/>
-              </a:rPr>
-              <a:t>근본 원인 5가지</a:t>
-            </a:r>
-          </a:p>
-        </p:txBody>
-      </p:sp>
-      <p:sp>
-        <p:nvSpPr>
-          <p:cNvPr id="21" name="TextBox 20"/>
-          <p:cNvSpPr txBox="1"/>
-          <p:nvPr/>
-        </p:nvSpPr>
-        <p:spPr>
-          <a:xfrm>
-            <a:off x="2057400" y="4169663"/>
-            <a:ext cx="7589520" cy="256032"/>
-          </a:xfrm>
-          <a:prstGeom prst="rect">
-            <a:avLst/>
-          </a:prstGeom>
-          <a:noFill/>
-        </p:spPr>
-        <p:txBody>
-          <a:bodyPr wrap="square" lIns="0" rIns="0" tIns="0" bIns="0" anchor="t">
-            <a:spAutoFit/>
-          </a:bodyPr>
-          <a:lstStyle/>
-          <a:p>
-            <a:pPr algn="l">
-              <a:lnSpc>
-                <a:spcPct val="135000"/>
-              </a:lnSpc>
-              <a:spcBef>
-                <a:spcPts val="0"/>
-              </a:spcBef>
-              <a:spcAft>
-                <a:spcPts val="0"/>
-              </a:spcAft>
-            </a:pPr>
-            <a:r>
-              <a:rPr sz="1250" b="0">
-                <a:solidFill>
-                  <a:srgbClr val="6B6B6B"/>
-                </a:solidFill>
-                <a:latin typeface="Pretendard"/>
-                <a:ea typeface="Pretendard"/>
-                <a:cs typeface="Pretendard"/>
-              </a:rPr>
-              <a:t>목표를 3가지 조건으로 나눠서 원인을 하나씩</a:t>
-            </a:r>
-          </a:p>
-        </p:txBody>
-      </p:sp>
-      <p:sp>
-        <p:nvSpPr>
-          <p:cNvPr id="22" name="TextBox 21"/>
-          <p:cNvSpPr txBox="1"/>
-          <p:nvPr/>
-        </p:nvSpPr>
-        <p:spPr>
-          <a:xfrm>
-            <a:off x="10058400" y="4005072"/>
-            <a:ext cx="1188720" cy="274320"/>
-          </a:xfrm>
-          <a:prstGeom prst="rect">
-            <a:avLst/>
-          </a:prstGeom>
-          <a:noFill/>
-        </p:spPr>
-        <p:txBody>
-          <a:bodyPr wrap="square" lIns="0" rIns="0" tIns="0" bIns="0" anchor="t">
-            <a:spAutoFit/>
-          </a:bodyPr>
-          <a:lstStyle/>
-          <a:p>
-            <a:pPr algn="r">
-              <a:lnSpc>
-                <a:spcPct val="135000"/>
-              </a:lnSpc>
-              <a:spcBef>
-                <a:spcPts val="0"/>
-              </a:spcBef>
-              <a:spcAft>
-                <a:spcPts val="0"/>
-              </a:spcAft>
-            </a:pPr>
-            <a:r>
-              <a:rPr sz="1200" b="0">
-                <a:solidFill>
-                  <a:srgbClr val="9A9A9A"/>
-                </a:solidFill>
-                <a:latin typeface="Pretendard"/>
-                <a:ea typeface="Pretendard"/>
-                <a:cs typeface="Pretendard"/>
-              </a:rPr>
-              <a:t>7 – 13</a:t>
-            </a:r>
-          </a:p>
-        </p:txBody>
-      </p:sp>
-      <p:sp>
-        <p:nvSpPr>
-          <p:cNvPr id="23" name="Rectangle 22"/>
-          <p:cNvSpPr/>
-          <p:nvPr/>
-        </p:nvSpPr>
-        <p:spPr>
-          <a:xfrm>
-            <a:off x="777240" y="4626864"/>
-            <a:ext cx="10634472" cy="676656"/>
-          </a:xfrm>
-          <a:prstGeom prst="rect">
-            <a:avLst/>
-          </a:prstGeom>
-          <a:solidFill>
-            <a:srgbClr val="FFFFFF"/>
-          </a:solidFill>
-          <a:ln w="12700">
-            <a:solidFill>
-              <a:srgbClr val="E4E4E4"/>
-            </a:solidFill>
-          </a:ln>
-          <a:effectLst/>
-        </p:spPr>
-        <p:style>
-          <a:lnRef idx="1">
-            <a:schemeClr val="accent1"/>
-          </a:lnRef>
-          <a:fillRef idx="3">
-            <a:schemeClr val="accent1"/>
-          </a:fillRef>
-          <a:effectRef idx="2">
-            <a:schemeClr val="accent1"/>
-          </a:effectRef>
-          <a:fontRef idx="minor">
-            <a:schemeClr val="lt1"/>
-          </a:fontRef>
-        </p:style>
-        <p:txBody>
-          <a:bodyPr rtlCol="0" anchor="ctr" wrap="square"/>
-          <a:lstStyle/>
-          <a:p>
-            <a:pPr algn="ctr"/>
-          </a:p>
-        </p:txBody>
-      </p:sp>
-      <p:sp>
-        <p:nvSpPr>
-          <p:cNvPr id="24" name="Rectangle 23"/>
-          <p:cNvSpPr/>
-          <p:nvPr/>
-        </p:nvSpPr>
-        <p:spPr>
-          <a:xfrm>
-            <a:off x="777240" y="4626864"/>
-            <a:ext cx="82296" cy="676656"/>
-          </a:xfrm>
-          <a:prstGeom prst="rect">
-            <a:avLst/>
-          </a:prstGeom>
-          <a:solidFill>
-            <a:srgbClr val="6C4CFF"/>
-          </a:solidFill>
-          <a:ln>
-            <a:noFill/>
-          </a:ln>
-          <a:effectLst/>
-        </p:spPr>
-        <p:style>
-          <a:lnRef idx="1">
-            <a:schemeClr val="accent1"/>
-          </a:lnRef>
-          <a:fillRef idx="3">
-            <a:schemeClr val="accent1"/>
-          </a:fillRef>
-          <a:effectRef idx="2">
-            <a:schemeClr val="accent1"/>
-          </a:effectRef>
-          <a:fontRef idx="minor">
-            <a:schemeClr val="lt1"/>
-          </a:fontRef>
-        </p:style>
-        <p:txBody>
-          <a:bodyPr rtlCol="0" anchor="ctr" wrap="square"/>
-          <a:lstStyle/>
-          <a:p>
-            <a:pPr algn="ctr"/>
-          </a:p>
-        </p:txBody>
-      </p:sp>
-      <p:sp>
-        <p:nvSpPr>
-          <p:cNvPr id="25" name="TextBox 24"/>
-          <p:cNvSpPr txBox="1"/>
-          <p:nvPr/>
-        </p:nvSpPr>
-        <p:spPr>
-          <a:xfrm>
-            <a:off x="1143000" y="4809744"/>
-            <a:ext cx="731520" cy="320040"/>
-          </a:xfrm>
-          <a:prstGeom prst="rect">
-            <a:avLst/>
-          </a:prstGeom>
-          <a:noFill/>
-        </p:spPr>
-        <p:txBody>
-          <a:bodyPr wrap="square" lIns="0" rIns="0" tIns="0" bIns="0" anchor="t">
-            <a:spAutoFit/>
-          </a:bodyPr>
-          <a:lstStyle/>
-          <a:p>
-            <a:pPr algn="l">
-              <a:lnSpc>
-                <a:spcPct val="135000"/>
-              </a:lnSpc>
-              <a:spcBef>
-                <a:spcPts val="0"/>
-              </a:spcBef>
-              <a:spcAft>
-                <a:spcPts val="0"/>
-              </a:spcAft>
-            </a:pPr>
-            <a:r>
-              <a:rPr sz="1900" b="1">
-                <a:solidFill>
-                  <a:srgbClr val="6C4CFF"/>
-                </a:solidFill>
-                <a:latin typeface="Pretendard"/>
-                <a:ea typeface="Pretendard"/>
-                <a:cs typeface="Pretendard"/>
-              </a:rPr>
-              <a:t>04</a:t>
-            </a:r>
-          </a:p>
-        </p:txBody>
-      </p:sp>
-      <p:sp>
-        <p:nvSpPr>
-          <p:cNvPr id="26" name="TextBox 25"/>
-          <p:cNvSpPr txBox="1"/>
-          <p:nvPr/>
-        </p:nvSpPr>
-        <p:spPr>
-          <a:xfrm>
-            <a:off x="2057400" y="4745736"/>
-            <a:ext cx="2926080" cy="274320"/>
-          </a:xfrm>
-          <a:prstGeom prst="rect">
-            <a:avLst/>
-          </a:prstGeom>
-          <a:noFill/>
-        </p:spPr>
-        <p:txBody>
-          <a:bodyPr wrap="square" lIns="0" rIns="0" tIns="0" bIns="0" anchor="t">
-            <a:spAutoFit/>
-          </a:bodyPr>
-          <a:lstStyle/>
-          <a:p>
-            <a:pPr algn="l">
-              <a:lnSpc>
-                <a:spcPct val="135000"/>
-              </a:lnSpc>
-              <a:spcBef>
-                <a:spcPts val="0"/>
-              </a:spcBef>
-              <a:spcAft>
-                <a:spcPts val="0"/>
-              </a:spcAft>
-            </a:pPr>
-            <a:r>
-              <a:rPr sz="1650" b="1">
-                <a:solidFill>
-                  <a:srgbClr val="292929"/>
-                </a:solidFill>
-                <a:latin typeface="Pretendard"/>
-                <a:ea typeface="Pretendard"/>
-                <a:cs typeface="Pretendard"/>
-              </a:rPr>
-              <a:t>해결 방안</a:t>
-            </a:r>
-          </a:p>
-        </p:txBody>
-      </p:sp>
-      <p:sp>
-        <p:nvSpPr>
-          <p:cNvPr id="27" name="TextBox 26"/>
-          <p:cNvSpPr txBox="1"/>
-          <p:nvPr/>
-        </p:nvSpPr>
-        <p:spPr>
-          <a:xfrm>
-            <a:off x="2057400" y="5010912"/>
-            <a:ext cx="7589520" cy="256032"/>
-          </a:xfrm>
-          <a:prstGeom prst="rect">
-            <a:avLst/>
-          </a:prstGeom>
-          <a:noFill/>
-        </p:spPr>
-        <p:txBody>
-          <a:bodyPr wrap="square" lIns="0" rIns="0" tIns="0" bIns="0" anchor="t">
-            <a:spAutoFit/>
-          </a:bodyPr>
-          <a:lstStyle/>
-          <a:p>
-            <a:pPr algn="l">
-              <a:lnSpc>
-                <a:spcPct val="135000"/>
-              </a:lnSpc>
-              <a:spcBef>
-                <a:spcPts val="0"/>
-              </a:spcBef>
-              <a:spcAft>
-                <a:spcPts val="0"/>
-              </a:spcAft>
-            </a:pPr>
-            <a:r>
-              <a:rPr sz="1250" b="0">
-                <a:solidFill>
-                  <a:srgbClr val="6B6B6B"/>
-                </a:solidFill>
-                <a:latin typeface="Pretendard"/>
-                <a:ea typeface="Pretendard"/>
-                <a:cs typeface="Pretendard"/>
-              </a:rPr>
-              <a:t>선택지 A~D · 추천안 · 적용하면 파일이 어떻게 바뀌나</a:t>
-            </a:r>
-          </a:p>
-        </p:txBody>
-      </p:sp>
-      <p:sp>
-        <p:nvSpPr>
-          <p:cNvPr id="28" name="TextBox 27"/>
-          <p:cNvSpPr txBox="1"/>
-          <p:nvPr/>
-        </p:nvSpPr>
-        <p:spPr>
-          <a:xfrm>
-            <a:off x="10058400" y="4846320"/>
-            <a:ext cx="1188720" cy="274320"/>
-          </a:xfrm>
-          <a:prstGeom prst="rect">
-            <a:avLst/>
-          </a:prstGeom>
-          <a:noFill/>
-        </p:spPr>
-        <p:txBody>
-          <a:bodyPr wrap="square" lIns="0" rIns="0" tIns="0" bIns="0" anchor="t">
-            <a:spAutoFit/>
-          </a:bodyPr>
-          <a:lstStyle/>
-          <a:p>
-            <a:pPr algn="r">
-              <a:lnSpc>
-                <a:spcPct val="135000"/>
-              </a:lnSpc>
-              <a:spcBef>
-                <a:spcPts val="0"/>
-              </a:spcBef>
-              <a:spcAft>
-                <a:spcPts val="0"/>
-              </a:spcAft>
-            </a:pPr>
-            <a:r>
-              <a:rPr sz="1200" b="0">
-                <a:solidFill>
-                  <a:srgbClr val="9A9A9A"/>
-                </a:solidFill>
-                <a:latin typeface="Pretendard"/>
-                <a:ea typeface="Pretendard"/>
-                <a:cs typeface="Pretendard"/>
-              </a:rPr>
-              <a:t>14 – 19</a:t>
-            </a:r>
-          </a:p>
-        </p:txBody>
-      </p:sp>
-      <p:sp>
-        <p:nvSpPr>
-          <p:cNvPr id="29" name="Rectangle 28"/>
-          <p:cNvSpPr/>
-          <p:nvPr/>
-        </p:nvSpPr>
-        <p:spPr>
-          <a:xfrm>
-            <a:off x="777240" y="5468112"/>
-            <a:ext cx="10634472" cy="676656"/>
-          </a:xfrm>
-          <a:prstGeom prst="rect">
-            <a:avLst/>
-          </a:prstGeom>
-          <a:solidFill>
-            <a:srgbClr val="FFFFFF"/>
-          </a:solidFill>
-          <a:ln w="12700">
-            <a:solidFill>
-              <a:srgbClr val="E4E4E4"/>
-            </a:solidFill>
-          </a:ln>
-          <a:effectLst/>
-        </p:spPr>
-        <p:style>
-          <a:lnRef idx="1">
-            <a:schemeClr val="accent1"/>
-          </a:lnRef>
-          <a:fillRef idx="3">
-            <a:schemeClr val="accent1"/>
-          </a:fillRef>
-          <a:effectRef idx="2">
-            <a:schemeClr val="accent1"/>
-          </a:effectRef>
-          <a:fontRef idx="minor">
-            <a:schemeClr val="lt1"/>
-          </a:fontRef>
-        </p:style>
-        <p:txBody>
-          <a:bodyPr rtlCol="0" anchor="ctr" wrap="square"/>
-          <a:lstStyle/>
-          <a:p>
-            <a:pPr algn="ctr"/>
-          </a:p>
-        </p:txBody>
-      </p:sp>
-      <p:sp>
-        <p:nvSpPr>
-          <p:cNvPr id="30" name="Rectangle 29"/>
-          <p:cNvSpPr/>
-          <p:nvPr/>
-        </p:nvSpPr>
-        <p:spPr>
-          <a:xfrm>
-            <a:off x="777240" y="5468112"/>
-            <a:ext cx="82296" cy="676656"/>
-          </a:xfrm>
-          <a:prstGeom prst="rect">
-            <a:avLst/>
-          </a:prstGeom>
-          <a:solidFill>
-            <a:srgbClr val="6C4CFF"/>
-          </a:solidFill>
-          <a:ln>
-            <a:noFill/>
-          </a:ln>
-          <a:effectLst/>
-        </p:spPr>
-        <p:style>
-          <a:lnRef idx="1">
-            <a:schemeClr val="accent1"/>
-          </a:lnRef>
-          <a:fillRef idx="3">
-            <a:schemeClr val="accent1"/>
-          </a:fillRef>
-          <a:effectRef idx="2">
-            <a:schemeClr val="accent1"/>
-          </a:effectRef>
-          <a:fontRef idx="minor">
-            <a:schemeClr val="lt1"/>
-          </a:fontRef>
-        </p:style>
-        <p:txBody>
-          <a:bodyPr rtlCol="0" anchor="ctr" wrap="square"/>
-          <a:lstStyle/>
-          <a:p>
-            <a:pPr algn="ctr"/>
-          </a:p>
-        </p:txBody>
-      </p:sp>
-      <p:sp>
-        <p:nvSpPr>
-          <p:cNvPr id="31" name="TextBox 30"/>
-          <p:cNvSpPr txBox="1"/>
-          <p:nvPr/>
-        </p:nvSpPr>
-        <p:spPr>
-          <a:xfrm>
-            <a:off x="1143000" y="5650992"/>
-            <a:ext cx="731520" cy="320040"/>
-          </a:xfrm>
-          <a:prstGeom prst="rect">
-            <a:avLst/>
-          </a:prstGeom>
-          <a:noFill/>
-        </p:spPr>
-        <p:txBody>
-          <a:bodyPr wrap="square" lIns="0" rIns="0" tIns="0" bIns="0" anchor="t">
-            <a:spAutoFit/>
-          </a:bodyPr>
-          <a:lstStyle/>
-          <a:p>
-            <a:pPr algn="l">
-              <a:lnSpc>
-                <a:spcPct val="135000"/>
-              </a:lnSpc>
-              <a:spcBef>
-                <a:spcPts val="0"/>
-              </a:spcBef>
-              <a:spcAft>
-                <a:spcPts val="0"/>
-              </a:spcAft>
-            </a:pPr>
-            <a:r>
-              <a:rPr sz="1900" b="1">
-                <a:solidFill>
-                  <a:srgbClr val="6C4CFF"/>
-                </a:solidFill>
-                <a:latin typeface="Pretendard"/>
-                <a:ea typeface="Pretendard"/>
-                <a:cs typeface="Pretendard"/>
-              </a:rPr>
-              <a:t>05</a:t>
-            </a:r>
-          </a:p>
-        </p:txBody>
-      </p:sp>
-      <p:sp>
-        <p:nvSpPr>
-          <p:cNvPr id="32" name="TextBox 31"/>
-          <p:cNvSpPr txBox="1"/>
-          <p:nvPr/>
-        </p:nvSpPr>
-        <p:spPr>
-          <a:xfrm>
-            <a:off x="2057400" y="5586984"/>
-            <a:ext cx="2926080" cy="274320"/>
-          </a:xfrm>
-          <a:prstGeom prst="rect">
-            <a:avLst/>
-          </a:prstGeom>
-          <a:noFill/>
-        </p:spPr>
-        <p:txBody>
-          <a:bodyPr wrap="square" lIns="0" rIns="0" tIns="0" bIns="0" anchor="t">
-            <a:spAutoFit/>
-          </a:bodyPr>
-          <a:lstStyle/>
-          <a:p>
-            <a:pPr algn="l">
-              <a:lnSpc>
-                <a:spcPct val="135000"/>
-              </a:lnSpc>
-              <a:spcBef>
-                <a:spcPts val="0"/>
-              </a:spcBef>
-              <a:spcAft>
-                <a:spcPts val="0"/>
-              </a:spcAft>
-            </a:pPr>
-            <a:r>
-              <a:rPr sz="1650" b="1">
-                <a:solidFill>
-                  <a:srgbClr val="292929"/>
-                </a:solidFill>
-                <a:latin typeface="Pretendard"/>
-                <a:ea typeface="Pretendard"/>
-                <a:cs typeface="Pretendard"/>
-              </a:rPr>
-              <a:t>비교 · 즉시 조치</a:t>
-            </a:r>
-          </a:p>
-        </p:txBody>
-      </p:sp>
-      <p:sp>
-        <p:nvSpPr>
-          <p:cNvPr id="33" name="TextBox 32"/>
-          <p:cNvSpPr txBox="1"/>
-          <p:nvPr/>
-        </p:nvSpPr>
-        <p:spPr>
-          <a:xfrm>
-            <a:off x="2057400" y="5852160"/>
-            <a:ext cx="7589520" cy="256032"/>
-          </a:xfrm>
-          <a:prstGeom prst="rect">
-            <a:avLst/>
-          </a:prstGeom>
-          <a:noFill/>
-        </p:spPr>
-        <p:txBody>
-          <a:bodyPr wrap="square" lIns="0" rIns="0" tIns="0" bIns="0" anchor="t">
-            <a:spAutoFit/>
-          </a:bodyPr>
-          <a:lstStyle/>
-          <a:p>
-            <a:pPr algn="l">
-              <a:lnSpc>
-                <a:spcPct val="135000"/>
-              </a:lnSpc>
-              <a:spcBef>
-                <a:spcPts val="0"/>
-              </a:spcBef>
-              <a:spcAft>
-                <a:spcPts val="0"/>
-              </a:spcAft>
-            </a:pPr>
-            <a:r>
-              <a:rPr sz="1250" b="0">
-                <a:solidFill>
-                  <a:srgbClr val="6B6B6B"/>
-                </a:solidFill>
-                <a:latin typeface="Pretendard"/>
-                <a:ea typeface="Pretendard"/>
-                <a:cs typeface="Pretendard"/>
-              </a:rPr>
-              <a:t>지금 vs 추천안, 어느 쪽이든 지금 해야 할 것</a:t>
-            </a:r>
-          </a:p>
-        </p:txBody>
-      </p:sp>
-      <p:sp>
-        <p:nvSpPr>
-          <p:cNvPr id="34" name="TextBox 33"/>
-          <p:cNvSpPr txBox="1"/>
-          <p:nvPr/>
-        </p:nvSpPr>
-        <p:spPr>
-          <a:xfrm>
-            <a:off x="10058400" y="5687568"/>
-            <a:ext cx="1188720" cy="274320"/>
-          </a:xfrm>
-          <a:prstGeom prst="rect">
-            <a:avLst/>
-          </a:prstGeom>
-          <a:noFill/>
-        </p:spPr>
-        <p:txBody>
-          <a:bodyPr wrap="square" lIns="0" rIns="0" tIns="0" bIns="0" anchor="t">
-            <a:spAutoFit/>
-          </a:bodyPr>
-          <a:lstStyle/>
-          <a:p>
-            <a:pPr algn="r">
-              <a:lnSpc>
-                <a:spcPct val="135000"/>
-              </a:lnSpc>
-              <a:spcBef>
-                <a:spcPts val="0"/>
-              </a:spcBef>
-              <a:spcAft>
-                <a:spcPts val="0"/>
-              </a:spcAft>
-            </a:pPr>
-            <a:r>
-              <a:rPr sz="1200" b="0">
-                <a:solidFill>
-                  <a:srgbClr val="9A9A9A"/>
-                </a:solidFill>
-                <a:latin typeface="Pretendard"/>
-                <a:ea typeface="Pretendard"/>
-                <a:cs typeface="Pretendard"/>
-              </a:rPr>
-              <a:t>20 – 22</a:t>
-            </a:r>
-          </a:p>
-        </p:txBody>
-      </p:sp>
-      <p:sp>
-        <p:nvSpPr>
-          <p:cNvPr id="35" name="TextBox 34"/>
-          <p:cNvSpPr txBox="1"/>
-          <p:nvPr/>
-        </p:nvSpPr>
-        <p:spPr>
-          <a:xfrm>
-            <a:off x="777240" y="6355080"/>
-            <a:ext cx="10607040" cy="274320"/>
-          </a:xfrm>
-          <a:prstGeom prst="rect">
-            <a:avLst/>
-          </a:prstGeom>
-          <a:noFill/>
-        </p:spPr>
-        <p:txBody>
-          <a:bodyPr wrap="square" lIns="0" rIns="0" tIns="0" bIns="0" anchor="t">
-            <a:spAutoFit/>
-          </a:bodyPr>
-          <a:lstStyle/>
-          <a:p>
-            <a:pPr algn="l">
-              <a:lnSpc>
-                <a:spcPct val="135000"/>
-              </a:lnSpc>
-              <a:spcBef>
-                <a:spcPts val="0"/>
-              </a:spcBef>
-              <a:spcAft>
-                <a:spcPts val="0"/>
-              </a:spcAft>
-            </a:pPr>
-            <a:r>
-              <a:rPr sz="1200" b="0">
-                <a:solidFill>
-                  <a:srgbClr val="6B6B6B"/>
-                </a:solidFill>
-                <a:latin typeface="Pretendard"/>
-                <a:ea typeface="Pretendard"/>
-                <a:cs typeface="Pretendard"/>
-              </a:rPr>
-              <a:t>총 22장 · 15~20분  ·  가장 중요한 장은 03번입니다. 원인을 알아야 어느 해결안이 맞는지 판단하실 수 있습니다.</a:t>
-            </a:r>
-          </a:p>
-        </p:txBody>
-      </p:sp>
-    </p:spTree>
-  </p:cSld>
-  <p:clrMapOvr>
-    <a:masterClrMapping/>
-  </p:clrMapOvr>
-</p:sld>
-</file>
-
-<file path=ppt/slides/slide20.xml><?xml version="1.0" encoding="utf-8"?>
 <p:sld xmlns:a="http://schemas.openxmlformats.org/drawingml/2006/main" xmlns:p="http://schemas.openxmlformats.org/presentationml/2006/main" xmlns:r="http://schemas.openxmlformats.org/officeDocument/2006/relationships">
   <p:cSld>
     <p:spTree>
@@ -20772,7 +18010,7 @@
                 <a:ea typeface="Pretendard"/>
                 <a:cs typeface="Pretendard"/>
               </a:rPr>
-              <a:t>20</a:t>
+              <a:t>19</a:t>
             </a:r>
           </a:p>
         </p:txBody>
@@ -20785,7 +18023,7 @@
 </p:sld>
 </file>
 
-<file path=ppt/slides/slide21.xml><?xml version="1.0" encoding="utf-8"?>
+<file path=ppt/slides/slide2.xml><?xml version="1.0" encoding="utf-8"?>
 <p:sld xmlns:a="http://schemas.openxmlformats.org/drawingml/2006/main" xmlns:p="http://schemas.openxmlformats.org/presentationml/2006/main" xmlns:r="http://schemas.openxmlformats.org/officeDocument/2006/relationships">
   <p:cSld>
     <p:spTree>
@@ -20881,7 +18119,7 @@
                 <a:ea typeface="Pretendard"/>
                 <a:cs typeface="Pretendard"/>
               </a:rPr>
-              <a:t>⑤ 즉시 조치</a:t>
+              <a:t>CONTENTS</a:t>
             </a:r>
           </a:p>
         </p:txBody>
@@ -20928,7 +18166,1600 @@
                 <a:ea typeface="Pretendard"/>
                 <a:cs typeface="Pretendard"/>
               </a:rPr>
-              <a:t>어느 방식을 택하든, 지금 고쳐야 할 8가지</a:t>
+              <a:t>오늘 이야기 순서</a:t>
+            </a:r>
+          </a:p>
+        </p:txBody>
+      </p:sp>
+      <p:sp>
+        <p:nvSpPr>
+          <p:cNvPr id="5" name="Rectangle 4"/>
+          <p:cNvSpPr/>
+          <p:nvPr/>
+        </p:nvSpPr>
+        <p:spPr>
+          <a:xfrm>
+            <a:off x="777240" y="2103120"/>
+            <a:ext cx="10634472" cy="676656"/>
+          </a:xfrm>
+          <a:prstGeom prst="rect">
+            <a:avLst/>
+          </a:prstGeom>
+          <a:solidFill>
+            <a:srgbClr val="FFFFFF"/>
+          </a:solidFill>
+          <a:ln w="12700">
+            <a:solidFill>
+              <a:srgbClr val="E4E4E4"/>
+            </a:solidFill>
+          </a:ln>
+          <a:effectLst/>
+        </p:spPr>
+        <p:style>
+          <a:lnRef idx="1">
+            <a:schemeClr val="accent1"/>
+          </a:lnRef>
+          <a:fillRef idx="3">
+            <a:schemeClr val="accent1"/>
+          </a:fillRef>
+          <a:effectRef idx="2">
+            <a:schemeClr val="accent1"/>
+          </a:effectRef>
+          <a:fontRef idx="minor">
+            <a:schemeClr val="lt1"/>
+          </a:fontRef>
+        </p:style>
+        <p:txBody>
+          <a:bodyPr rtlCol="0" anchor="ctr" wrap="square"/>
+          <a:lstStyle/>
+          <a:p>
+            <a:pPr algn="ctr"/>
+          </a:p>
+        </p:txBody>
+      </p:sp>
+      <p:sp>
+        <p:nvSpPr>
+          <p:cNvPr id="6" name="Rectangle 5"/>
+          <p:cNvSpPr/>
+          <p:nvPr/>
+        </p:nvSpPr>
+        <p:spPr>
+          <a:xfrm>
+            <a:off x="777240" y="2103120"/>
+            <a:ext cx="82296" cy="676656"/>
+          </a:xfrm>
+          <a:prstGeom prst="rect">
+            <a:avLst/>
+          </a:prstGeom>
+          <a:solidFill>
+            <a:srgbClr val="6C4CFF"/>
+          </a:solidFill>
+          <a:ln>
+            <a:noFill/>
+          </a:ln>
+          <a:effectLst/>
+        </p:spPr>
+        <p:style>
+          <a:lnRef idx="1">
+            <a:schemeClr val="accent1"/>
+          </a:lnRef>
+          <a:fillRef idx="3">
+            <a:schemeClr val="accent1"/>
+          </a:fillRef>
+          <a:effectRef idx="2">
+            <a:schemeClr val="accent1"/>
+          </a:effectRef>
+          <a:fontRef idx="minor">
+            <a:schemeClr val="lt1"/>
+          </a:fontRef>
+        </p:style>
+        <p:txBody>
+          <a:bodyPr rtlCol="0" anchor="ctr" wrap="square"/>
+          <a:lstStyle/>
+          <a:p>
+            <a:pPr algn="ctr"/>
+          </a:p>
+        </p:txBody>
+      </p:sp>
+      <p:sp>
+        <p:nvSpPr>
+          <p:cNvPr id="7" name="TextBox 6"/>
+          <p:cNvSpPr txBox="1"/>
+          <p:nvPr/>
+        </p:nvSpPr>
+        <p:spPr>
+          <a:xfrm>
+            <a:off x="1143000" y="2286000"/>
+            <a:ext cx="731520" cy="320040"/>
+          </a:xfrm>
+          <a:prstGeom prst="rect">
+            <a:avLst/>
+          </a:prstGeom>
+          <a:noFill/>
+        </p:spPr>
+        <p:txBody>
+          <a:bodyPr wrap="square" lIns="0" rIns="0" tIns="0" bIns="0" anchor="t">
+            <a:spAutoFit/>
+          </a:bodyPr>
+          <a:lstStyle/>
+          <a:p>
+            <a:pPr algn="l">
+              <a:lnSpc>
+                <a:spcPct val="135000"/>
+              </a:lnSpc>
+              <a:spcBef>
+                <a:spcPts val="0"/>
+              </a:spcBef>
+              <a:spcAft>
+                <a:spcPts val="0"/>
+              </a:spcAft>
+            </a:pPr>
+            <a:r>
+              <a:rPr sz="1900" b="1">
+                <a:solidFill>
+                  <a:srgbClr val="6C4CFF"/>
+                </a:solidFill>
+                <a:latin typeface="Pretendard"/>
+                <a:ea typeface="Pretendard"/>
+                <a:cs typeface="Pretendard"/>
+              </a:rPr>
+              <a:t>01</a:t>
+            </a:r>
+          </a:p>
+        </p:txBody>
+      </p:sp>
+      <p:sp>
+        <p:nvSpPr>
+          <p:cNvPr id="8" name="TextBox 7"/>
+          <p:cNvSpPr txBox="1"/>
+          <p:nvPr/>
+        </p:nvSpPr>
+        <p:spPr>
+          <a:xfrm>
+            <a:off x="2057400" y="2221991"/>
+            <a:ext cx="2926080" cy="274320"/>
+          </a:xfrm>
+          <a:prstGeom prst="rect">
+            <a:avLst/>
+          </a:prstGeom>
+          <a:noFill/>
+        </p:spPr>
+        <p:txBody>
+          <a:bodyPr wrap="square" lIns="0" rIns="0" tIns="0" bIns="0" anchor="t">
+            <a:spAutoFit/>
+          </a:bodyPr>
+          <a:lstStyle/>
+          <a:p>
+            <a:pPr algn="l">
+              <a:lnSpc>
+                <a:spcPct val="135000"/>
+              </a:lnSpc>
+              <a:spcBef>
+                <a:spcPts val="0"/>
+              </a:spcBef>
+              <a:spcAft>
+                <a:spcPts val="0"/>
+              </a:spcAft>
+            </a:pPr>
+            <a:r>
+              <a:rPr sz="1650" b="1">
+                <a:solidFill>
+                  <a:srgbClr val="292929"/>
+                </a:solidFill>
+                <a:latin typeface="Pretendard"/>
+                <a:ea typeface="Pretendard"/>
+                <a:cs typeface="Pretendard"/>
+              </a:rPr>
+              <a:t>현황 파악</a:t>
+            </a:r>
+          </a:p>
+        </p:txBody>
+      </p:sp>
+      <p:sp>
+        <p:nvSpPr>
+          <p:cNvPr id="9" name="TextBox 8"/>
+          <p:cNvSpPr txBox="1"/>
+          <p:nvPr/>
+        </p:nvSpPr>
+        <p:spPr>
+          <a:xfrm>
+            <a:off x="2057400" y="2487168"/>
+            <a:ext cx="7589520" cy="256032"/>
+          </a:xfrm>
+          <a:prstGeom prst="rect">
+            <a:avLst/>
+          </a:prstGeom>
+          <a:noFill/>
+        </p:spPr>
+        <p:txBody>
+          <a:bodyPr wrap="square" lIns="0" rIns="0" tIns="0" bIns="0" anchor="t">
+            <a:spAutoFit/>
+          </a:bodyPr>
+          <a:lstStyle/>
+          <a:p>
+            <a:pPr algn="l">
+              <a:lnSpc>
+                <a:spcPct val="135000"/>
+              </a:lnSpc>
+              <a:spcBef>
+                <a:spcPts val="0"/>
+              </a:spcBef>
+              <a:spcAft>
+                <a:spcPts val="0"/>
+              </a:spcAft>
+            </a:pPr>
+            <a:r>
+              <a:rPr sz="1250" b="0">
+                <a:solidFill>
+                  <a:srgbClr val="6B6B6B"/>
+                </a:solidFill>
+                <a:latin typeface="Pretendard"/>
+                <a:ea typeface="Pretendard"/>
+                <a:cs typeface="Pretendard"/>
+              </a:rPr>
+              <a:t>우리 저장소가 몇 개이고 어떤 상태인지</a:t>
+            </a:r>
+          </a:p>
+        </p:txBody>
+      </p:sp>
+      <p:sp>
+        <p:nvSpPr>
+          <p:cNvPr id="10" name="TextBox 9"/>
+          <p:cNvSpPr txBox="1"/>
+          <p:nvPr/>
+        </p:nvSpPr>
+        <p:spPr>
+          <a:xfrm>
+            <a:off x="10058400" y="2322576"/>
+            <a:ext cx="1188720" cy="274320"/>
+          </a:xfrm>
+          <a:prstGeom prst="rect">
+            <a:avLst/>
+          </a:prstGeom>
+          <a:noFill/>
+        </p:spPr>
+        <p:txBody>
+          <a:bodyPr wrap="square" lIns="0" rIns="0" tIns="0" bIns="0" anchor="t">
+            <a:spAutoFit/>
+          </a:bodyPr>
+          <a:lstStyle/>
+          <a:p>
+            <a:pPr algn="r">
+              <a:lnSpc>
+                <a:spcPct val="135000"/>
+              </a:lnSpc>
+              <a:spcBef>
+                <a:spcPts val="0"/>
+              </a:spcBef>
+              <a:spcAft>
+                <a:spcPts val="0"/>
+              </a:spcAft>
+            </a:pPr>
+            <a:r>
+              <a:rPr sz="1200" b="0">
+                <a:solidFill>
+                  <a:srgbClr val="9A9A9A"/>
+                </a:solidFill>
+                <a:latin typeface="Pretendard"/>
+                <a:ea typeface="Pretendard"/>
+                <a:cs typeface="Pretendard"/>
+              </a:rPr>
+              <a:t>3 – 4</a:t>
+            </a:r>
+          </a:p>
+        </p:txBody>
+      </p:sp>
+      <p:sp>
+        <p:nvSpPr>
+          <p:cNvPr id="11" name="Rectangle 10"/>
+          <p:cNvSpPr/>
+          <p:nvPr/>
+        </p:nvSpPr>
+        <p:spPr>
+          <a:xfrm>
+            <a:off x="777240" y="2944368"/>
+            <a:ext cx="10634472" cy="676656"/>
+          </a:xfrm>
+          <a:prstGeom prst="rect">
+            <a:avLst/>
+          </a:prstGeom>
+          <a:solidFill>
+            <a:srgbClr val="FFFFFF"/>
+          </a:solidFill>
+          <a:ln w="12700">
+            <a:solidFill>
+              <a:srgbClr val="E4E4E4"/>
+            </a:solidFill>
+          </a:ln>
+          <a:effectLst/>
+        </p:spPr>
+        <p:style>
+          <a:lnRef idx="1">
+            <a:schemeClr val="accent1"/>
+          </a:lnRef>
+          <a:fillRef idx="3">
+            <a:schemeClr val="accent1"/>
+          </a:fillRef>
+          <a:effectRef idx="2">
+            <a:schemeClr val="accent1"/>
+          </a:effectRef>
+          <a:fontRef idx="minor">
+            <a:schemeClr val="lt1"/>
+          </a:fontRef>
+        </p:style>
+        <p:txBody>
+          <a:bodyPr rtlCol="0" anchor="ctr" wrap="square"/>
+          <a:lstStyle/>
+          <a:p>
+            <a:pPr algn="ctr"/>
+          </a:p>
+        </p:txBody>
+      </p:sp>
+      <p:sp>
+        <p:nvSpPr>
+          <p:cNvPr id="12" name="Rectangle 11"/>
+          <p:cNvSpPr/>
+          <p:nvPr/>
+        </p:nvSpPr>
+        <p:spPr>
+          <a:xfrm>
+            <a:off x="777240" y="2944368"/>
+            <a:ext cx="82296" cy="676656"/>
+          </a:xfrm>
+          <a:prstGeom prst="rect">
+            <a:avLst/>
+          </a:prstGeom>
+          <a:solidFill>
+            <a:srgbClr val="6C4CFF"/>
+          </a:solidFill>
+          <a:ln>
+            <a:noFill/>
+          </a:ln>
+          <a:effectLst/>
+        </p:spPr>
+        <p:style>
+          <a:lnRef idx="1">
+            <a:schemeClr val="accent1"/>
+          </a:lnRef>
+          <a:fillRef idx="3">
+            <a:schemeClr val="accent1"/>
+          </a:fillRef>
+          <a:effectRef idx="2">
+            <a:schemeClr val="accent1"/>
+          </a:effectRef>
+          <a:fontRef idx="minor">
+            <a:schemeClr val="lt1"/>
+          </a:fontRef>
+        </p:style>
+        <p:txBody>
+          <a:bodyPr rtlCol="0" anchor="ctr" wrap="square"/>
+          <a:lstStyle/>
+          <a:p>
+            <a:pPr algn="ctr"/>
+          </a:p>
+        </p:txBody>
+      </p:sp>
+      <p:sp>
+        <p:nvSpPr>
+          <p:cNvPr id="13" name="TextBox 12"/>
+          <p:cNvSpPr txBox="1"/>
+          <p:nvPr/>
+        </p:nvSpPr>
+        <p:spPr>
+          <a:xfrm>
+            <a:off x="1143000" y="3127248"/>
+            <a:ext cx="731520" cy="320040"/>
+          </a:xfrm>
+          <a:prstGeom prst="rect">
+            <a:avLst/>
+          </a:prstGeom>
+          <a:noFill/>
+        </p:spPr>
+        <p:txBody>
+          <a:bodyPr wrap="square" lIns="0" rIns="0" tIns="0" bIns="0" anchor="t">
+            <a:spAutoFit/>
+          </a:bodyPr>
+          <a:lstStyle/>
+          <a:p>
+            <a:pPr algn="l">
+              <a:lnSpc>
+                <a:spcPct val="135000"/>
+              </a:lnSpc>
+              <a:spcBef>
+                <a:spcPts val="0"/>
+              </a:spcBef>
+              <a:spcAft>
+                <a:spcPts val="0"/>
+              </a:spcAft>
+            </a:pPr>
+            <a:r>
+              <a:rPr sz="1900" b="1">
+                <a:solidFill>
+                  <a:srgbClr val="6C4CFF"/>
+                </a:solidFill>
+                <a:latin typeface="Pretendard"/>
+                <a:ea typeface="Pretendard"/>
+                <a:cs typeface="Pretendard"/>
+              </a:rPr>
+              <a:t>02</a:t>
+            </a:r>
+          </a:p>
+        </p:txBody>
+      </p:sp>
+      <p:sp>
+        <p:nvSpPr>
+          <p:cNvPr id="14" name="TextBox 13"/>
+          <p:cNvSpPr txBox="1"/>
+          <p:nvPr/>
+        </p:nvSpPr>
+        <p:spPr>
+          <a:xfrm>
+            <a:off x="2057400" y="3063239"/>
+            <a:ext cx="2926080" cy="274320"/>
+          </a:xfrm>
+          <a:prstGeom prst="rect">
+            <a:avLst/>
+          </a:prstGeom>
+          <a:noFill/>
+        </p:spPr>
+        <p:txBody>
+          <a:bodyPr wrap="square" lIns="0" rIns="0" tIns="0" bIns="0" anchor="t">
+            <a:spAutoFit/>
+          </a:bodyPr>
+          <a:lstStyle/>
+          <a:p>
+            <a:pPr algn="l">
+              <a:lnSpc>
+                <a:spcPct val="135000"/>
+              </a:lnSpc>
+              <a:spcBef>
+                <a:spcPts val="0"/>
+              </a:spcBef>
+              <a:spcAft>
+                <a:spcPts val="0"/>
+              </a:spcAft>
+            </a:pPr>
+            <a:r>
+              <a:rPr sz="1650" b="1">
+                <a:solidFill>
+                  <a:srgbClr val="292929"/>
+                </a:solidFill>
+                <a:latin typeface="Pretendard"/>
+                <a:ea typeface="Pretendard"/>
+                <a:cs typeface="Pretendard"/>
+              </a:rPr>
+              <a:t>진단</a:t>
+            </a:r>
+          </a:p>
+        </p:txBody>
+      </p:sp>
+      <p:sp>
+        <p:nvSpPr>
+          <p:cNvPr id="15" name="TextBox 14"/>
+          <p:cNvSpPr txBox="1"/>
+          <p:nvPr/>
+        </p:nvSpPr>
+        <p:spPr>
+          <a:xfrm>
+            <a:off x="2057400" y="3328415"/>
+            <a:ext cx="7589520" cy="256032"/>
+          </a:xfrm>
+          <a:prstGeom prst="rect">
+            <a:avLst/>
+          </a:prstGeom>
+          <a:noFill/>
+        </p:spPr>
+        <p:txBody>
+          <a:bodyPr wrap="square" lIns="0" rIns="0" tIns="0" bIns="0" anchor="t">
+            <a:spAutoFit/>
+          </a:bodyPr>
+          <a:lstStyle/>
+          <a:p>
+            <a:pPr algn="l">
+              <a:lnSpc>
+                <a:spcPct val="135000"/>
+              </a:lnSpc>
+              <a:spcBef>
+                <a:spcPts val="0"/>
+              </a:spcBef>
+              <a:spcAft>
+                <a:spcPts val="0"/>
+              </a:spcAft>
+            </a:pPr>
+            <a:r>
+              <a:rPr sz="1250" b="0">
+                <a:solidFill>
+                  <a:srgbClr val="6B6B6B"/>
+                </a:solidFill>
+                <a:latin typeface="Pretendard"/>
+                <a:ea typeface="Pretendard"/>
+                <a:cs typeface="Pretendard"/>
+              </a:rPr>
+              <a:t>기능 96개 중 Claude가 아는 건 7개 — 왜 그런지</a:t>
+            </a:r>
+          </a:p>
+        </p:txBody>
+      </p:sp>
+      <p:sp>
+        <p:nvSpPr>
+          <p:cNvPr id="16" name="TextBox 15"/>
+          <p:cNvSpPr txBox="1"/>
+          <p:nvPr/>
+        </p:nvSpPr>
+        <p:spPr>
+          <a:xfrm>
+            <a:off x="10058400" y="3163824"/>
+            <a:ext cx="1188720" cy="274320"/>
+          </a:xfrm>
+          <a:prstGeom prst="rect">
+            <a:avLst/>
+          </a:prstGeom>
+          <a:noFill/>
+        </p:spPr>
+        <p:txBody>
+          <a:bodyPr wrap="square" lIns="0" rIns="0" tIns="0" bIns="0" anchor="t">
+            <a:spAutoFit/>
+          </a:bodyPr>
+          <a:lstStyle/>
+          <a:p>
+            <a:pPr algn="r">
+              <a:lnSpc>
+                <a:spcPct val="135000"/>
+              </a:lnSpc>
+              <a:spcBef>
+                <a:spcPts val="0"/>
+              </a:spcBef>
+              <a:spcAft>
+                <a:spcPts val="0"/>
+              </a:spcAft>
+            </a:pPr>
+            <a:r>
+              <a:rPr sz="1200" b="0">
+                <a:solidFill>
+                  <a:srgbClr val="9A9A9A"/>
+                </a:solidFill>
+                <a:latin typeface="Pretendard"/>
+                <a:ea typeface="Pretendard"/>
+                <a:cs typeface="Pretendard"/>
+              </a:rPr>
+              <a:t>5 – 6</a:t>
+            </a:r>
+          </a:p>
+        </p:txBody>
+      </p:sp>
+      <p:sp>
+        <p:nvSpPr>
+          <p:cNvPr id="17" name="Rectangle 16"/>
+          <p:cNvSpPr/>
+          <p:nvPr/>
+        </p:nvSpPr>
+        <p:spPr>
+          <a:xfrm>
+            <a:off x="777240" y="3785615"/>
+            <a:ext cx="10634472" cy="676656"/>
+          </a:xfrm>
+          <a:prstGeom prst="rect">
+            <a:avLst/>
+          </a:prstGeom>
+          <a:solidFill>
+            <a:srgbClr val="FFFFFF"/>
+          </a:solidFill>
+          <a:ln w="12700">
+            <a:solidFill>
+              <a:srgbClr val="E4E4E4"/>
+            </a:solidFill>
+          </a:ln>
+          <a:effectLst/>
+        </p:spPr>
+        <p:style>
+          <a:lnRef idx="1">
+            <a:schemeClr val="accent1"/>
+          </a:lnRef>
+          <a:fillRef idx="3">
+            <a:schemeClr val="accent1"/>
+          </a:fillRef>
+          <a:effectRef idx="2">
+            <a:schemeClr val="accent1"/>
+          </a:effectRef>
+          <a:fontRef idx="minor">
+            <a:schemeClr val="lt1"/>
+          </a:fontRef>
+        </p:style>
+        <p:txBody>
+          <a:bodyPr rtlCol="0" anchor="ctr" wrap="square"/>
+          <a:lstStyle/>
+          <a:p>
+            <a:pPr algn="ctr"/>
+          </a:p>
+        </p:txBody>
+      </p:sp>
+      <p:sp>
+        <p:nvSpPr>
+          <p:cNvPr id="18" name="Rectangle 17"/>
+          <p:cNvSpPr/>
+          <p:nvPr/>
+        </p:nvSpPr>
+        <p:spPr>
+          <a:xfrm>
+            <a:off x="777240" y="3785615"/>
+            <a:ext cx="82296" cy="676656"/>
+          </a:xfrm>
+          <a:prstGeom prst="rect">
+            <a:avLst/>
+          </a:prstGeom>
+          <a:solidFill>
+            <a:srgbClr val="6C4CFF"/>
+          </a:solidFill>
+          <a:ln>
+            <a:noFill/>
+          </a:ln>
+          <a:effectLst/>
+        </p:spPr>
+        <p:style>
+          <a:lnRef idx="1">
+            <a:schemeClr val="accent1"/>
+          </a:lnRef>
+          <a:fillRef idx="3">
+            <a:schemeClr val="accent1"/>
+          </a:fillRef>
+          <a:effectRef idx="2">
+            <a:schemeClr val="accent1"/>
+          </a:effectRef>
+          <a:fontRef idx="minor">
+            <a:schemeClr val="lt1"/>
+          </a:fontRef>
+        </p:style>
+        <p:txBody>
+          <a:bodyPr rtlCol="0" anchor="ctr" wrap="square"/>
+          <a:lstStyle/>
+          <a:p>
+            <a:pPr algn="ctr"/>
+          </a:p>
+        </p:txBody>
+      </p:sp>
+      <p:sp>
+        <p:nvSpPr>
+          <p:cNvPr id="19" name="TextBox 18"/>
+          <p:cNvSpPr txBox="1"/>
+          <p:nvPr/>
+        </p:nvSpPr>
+        <p:spPr>
+          <a:xfrm>
+            <a:off x="1143000" y="3968496"/>
+            <a:ext cx="731520" cy="320040"/>
+          </a:xfrm>
+          <a:prstGeom prst="rect">
+            <a:avLst/>
+          </a:prstGeom>
+          <a:noFill/>
+        </p:spPr>
+        <p:txBody>
+          <a:bodyPr wrap="square" lIns="0" rIns="0" tIns="0" bIns="0" anchor="t">
+            <a:spAutoFit/>
+          </a:bodyPr>
+          <a:lstStyle/>
+          <a:p>
+            <a:pPr algn="l">
+              <a:lnSpc>
+                <a:spcPct val="135000"/>
+              </a:lnSpc>
+              <a:spcBef>
+                <a:spcPts val="0"/>
+              </a:spcBef>
+              <a:spcAft>
+                <a:spcPts val="0"/>
+              </a:spcAft>
+            </a:pPr>
+            <a:r>
+              <a:rPr sz="1900" b="1">
+                <a:solidFill>
+                  <a:srgbClr val="6C4CFF"/>
+                </a:solidFill>
+                <a:latin typeface="Pretendard"/>
+                <a:ea typeface="Pretendard"/>
+                <a:cs typeface="Pretendard"/>
+              </a:rPr>
+              <a:t>03</a:t>
+            </a:r>
+          </a:p>
+        </p:txBody>
+      </p:sp>
+      <p:sp>
+        <p:nvSpPr>
+          <p:cNvPr id="20" name="TextBox 19"/>
+          <p:cNvSpPr txBox="1"/>
+          <p:nvPr/>
+        </p:nvSpPr>
+        <p:spPr>
+          <a:xfrm>
+            <a:off x="2057400" y="3904487"/>
+            <a:ext cx="2926080" cy="274320"/>
+          </a:xfrm>
+          <a:prstGeom prst="rect">
+            <a:avLst/>
+          </a:prstGeom>
+          <a:noFill/>
+        </p:spPr>
+        <p:txBody>
+          <a:bodyPr wrap="square" lIns="0" rIns="0" tIns="0" bIns="0" anchor="t">
+            <a:spAutoFit/>
+          </a:bodyPr>
+          <a:lstStyle/>
+          <a:p>
+            <a:pPr algn="l">
+              <a:lnSpc>
+                <a:spcPct val="135000"/>
+              </a:lnSpc>
+              <a:spcBef>
+                <a:spcPts val="0"/>
+              </a:spcBef>
+              <a:spcAft>
+                <a:spcPts val="0"/>
+              </a:spcAft>
+            </a:pPr>
+            <a:r>
+              <a:rPr sz="1650" b="1">
+                <a:solidFill>
+                  <a:srgbClr val="292929"/>
+                </a:solidFill>
+                <a:latin typeface="Pretendard"/>
+                <a:ea typeface="Pretendard"/>
+                <a:cs typeface="Pretendard"/>
+              </a:rPr>
+              <a:t>근본 원인 5가지</a:t>
+            </a:r>
+          </a:p>
+        </p:txBody>
+      </p:sp>
+      <p:sp>
+        <p:nvSpPr>
+          <p:cNvPr id="21" name="TextBox 20"/>
+          <p:cNvSpPr txBox="1"/>
+          <p:nvPr/>
+        </p:nvSpPr>
+        <p:spPr>
+          <a:xfrm>
+            <a:off x="2057400" y="4169663"/>
+            <a:ext cx="7589520" cy="256032"/>
+          </a:xfrm>
+          <a:prstGeom prst="rect">
+            <a:avLst/>
+          </a:prstGeom>
+          <a:noFill/>
+        </p:spPr>
+        <p:txBody>
+          <a:bodyPr wrap="square" lIns="0" rIns="0" tIns="0" bIns="0" anchor="t">
+            <a:spAutoFit/>
+          </a:bodyPr>
+          <a:lstStyle/>
+          <a:p>
+            <a:pPr algn="l">
+              <a:lnSpc>
+                <a:spcPct val="135000"/>
+              </a:lnSpc>
+              <a:spcBef>
+                <a:spcPts val="0"/>
+              </a:spcBef>
+              <a:spcAft>
+                <a:spcPts val="0"/>
+              </a:spcAft>
+            </a:pPr>
+            <a:r>
+              <a:rPr sz="1250" b="0">
+                <a:solidFill>
+                  <a:srgbClr val="6B6B6B"/>
+                </a:solidFill>
+                <a:latin typeface="Pretendard"/>
+                <a:ea typeface="Pretendard"/>
+                <a:cs typeface="Pretendard"/>
+              </a:rPr>
+              <a:t>목표를 3가지 조건으로 나눠서 원인을 하나씩</a:t>
+            </a:r>
+          </a:p>
+        </p:txBody>
+      </p:sp>
+      <p:sp>
+        <p:nvSpPr>
+          <p:cNvPr id="22" name="TextBox 21"/>
+          <p:cNvSpPr txBox="1"/>
+          <p:nvPr/>
+        </p:nvSpPr>
+        <p:spPr>
+          <a:xfrm>
+            <a:off x="10058400" y="4005072"/>
+            <a:ext cx="1188720" cy="274320"/>
+          </a:xfrm>
+          <a:prstGeom prst="rect">
+            <a:avLst/>
+          </a:prstGeom>
+          <a:noFill/>
+        </p:spPr>
+        <p:txBody>
+          <a:bodyPr wrap="square" lIns="0" rIns="0" tIns="0" bIns="0" anchor="t">
+            <a:spAutoFit/>
+          </a:bodyPr>
+          <a:lstStyle/>
+          <a:p>
+            <a:pPr algn="r">
+              <a:lnSpc>
+                <a:spcPct val="135000"/>
+              </a:lnSpc>
+              <a:spcBef>
+                <a:spcPts val="0"/>
+              </a:spcBef>
+              <a:spcAft>
+                <a:spcPts val="0"/>
+              </a:spcAft>
+            </a:pPr>
+            <a:r>
+              <a:rPr sz="1200" b="0">
+                <a:solidFill>
+                  <a:srgbClr val="9A9A9A"/>
+                </a:solidFill>
+                <a:latin typeface="Pretendard"/>
+                <a:ea typeface="Pretendard"/>
+                <a:cs typeface="Pretendard"/>
+              </a:rPr>
+              <a:t>7 – 13</a:t>
+            </a:r>
+          </a:p>
+        </p:txBody>
+      </p:sp>
+      <p:sp>
+        <p:nvSpPr>
+          <p:cNvPr id="23" name="Rectangle 22"/>
+          <p:cNvSpPr/>
+          <p:nvPr/>
+        </p:nvSpPr>
+        <p:spPr>
+          <a:xfrm>
+            <a:off x="777240" y="4626864"/>
+            <a:ext cx="10634472" cy="676656"/>
+          </a:xfrm>
+          <a:prstGeom prst="rect">
+            <a:avLst/>
+          </a:prstGeom>
+          <a:solidFill>
+            <a:srgbClr val="FFFFFF"/>
+          </a:solidFill>
+          <a:ln w="12700">
+            <a:solidFill>
+              <a:srgbClr val="E4E4E4"/>
+            </a:solidFill>
+          </a:ln>
+          <a:effectLst/>
+        </p:spPr>
+        <p:style>
+          <a:lnRef idx="1">
+            <a:schemeClr val="accent1"/>
+          </a:lnRef>
+          <a:fillRef idx="3">
+            <a:schemeClr val="accent1"/>
+          </a:fillRef>
+          <a:effectRef idx="2">
+            <a:schemeClr val="accent1"/>
+          </a:effectRef>
+          <a:fontRef idx="minor">
+            <a:schemeClr val="lt1"/>
+          </a:fontRef>
+        </p:style>
+        <p:txBody>
+          <a:bodyPr rtlCol="0" anchor="ctr" wrap="square"/>
+          <a:lstStyle/>
+          <a:p>
+            <a:pPr algn="ctr"/>
+          </a:p>
+        </p:txBody>
+      </p:sp>
+      <p:sp>
+        <p:nvSpPr>
+          <p:cNvPr id="24" name="Rectangle 23"/>
+          <p:cNvSpPr/>
+          <p:nvPr/>
+        </p:nvSpPr>
+        <p:spPr>
+          <a:xfrm>
+            <a:off x="777240" y="4626864"/>
+            <a:ext cx="82296" cy="676656"/>
+          </a:xfrm>
+          <a:prstGeom prst="rect">
+            <a:avLst/>
+          </a:prstGeom>
+          <a:solidFill>
+            <a:srgbClr val="6C4CFF"/>
+          </a:solidFill>
+          <a:ln>
+            <a:noFill/>
+          </a:ln>
+          <a:effectLst/>
+        </p:spPr>
+        <p:style>
+          <a:lnRef idx="1">
+            <a:schemeClr val="accent1"/>
+          </a:lnRef>
+          <a:fillRef idx="3">
+            <a:schemeClr val="accent1"/>
+          </a:fillRef>
+          <a:effectRef idx="2">
+            <a:schemeClr val="accent1"/>
+          </a:effectRef>
+          <a:fontRef idx="minor">
+            <a:schemeClr val="lt1"/>
+          </a:fontRef>
+        </p:style>
+        <p:txBody>
+          <a:bodyPr rtlCol="0" anchor="ctr" wrap="square"/>
+          <a:lstStyle/>
+          <a:p>
+            <a:pPr algn="ctr"/>
+          </a:p>
+        </p:txBody>
+      </p:sp>
+      <p:sp>
+        <p:nvSpPr>
+          <p:cNvPr id="25" name="TextBox 24"/>
+          <p:cNvSpPr txBox="1"/>
+          <p:nvPr/>
+        </p:nvSpPr>
+        <p:spPr>
+          <a:xfrm>
+            <a:off x="1143000" y="4809744"/>
+            <a:ext cx="731520" cy="320040"/>
+          </a:xfrm>
+          <a:prstGeom prst="rect">
+            <a:avLst/>
+          </a:prstGeom>
+          <a:noFill/>
+        </p:spPr>
+        <p:txBody>
+          <a:bodyPr wrap="square" lIns="0" rIns="0" tIns="0" bIns="0" anchor="t">
+            <a:spAutoFit/>
+          </a:bodyPr>
+          <a:lstStyle/>
+          <a:p>
+            <a:pPr algn="l">
+              <a:lnSpc>
+                <a:spcPct val="135000"/>
+              </a:lnSpc>
+              <a:spcBef>
+                <a:spcPts val="0"/>
+              </a:spcBef>
+              <a:spcAft>
+                <a:spcPts val="0"/>
+              </a:spcAft>
+            </a:pPr>
+            <a:r>
+              <a:rPr sz="1900" b="1">
+                <a:solidFill>
+                  <a:srgbClr val="6C4CFF"/>
+                </a:solidFill>
+                <a:latin typeface="Pretendard"/>
+                <a:ea typeface="Pretendard"/>
+                <a:cs typeface="Pretendard"/>
+              </a:rPr>
+              <a:t>04</a:t>
+            </a:r>
+          </a:p>
+        </p:txBody>
+      </p:sp>
+      <p:sp>
+        <p:nvSpPr>
+          <p:cNvPr id="26" name="TextBox 25"/>
+          <p:cNvSpPr txBox="1"/>
+          <p:nvPr/>
+        </p:nvSpPr>
+        <p:spPr>
+          <a:xfrm>
+            <a:off x="2057400" y="4745736"/>
+            <a:ext cx="2926080" cy="274320"/>
+          </a:xfrm>
+          <a:prstGeom prst="rect">
+            <a:avLst/>
+          </a:prstGeom>
+          <a:noFill/>
+        </p:spPr>
+        <p:txBody>
+          <a:bodyPr wrap="square" lIns="0" rIns="0" tIns="0" bIns="0" anchor="t">
+            <a:spAutoFit/>
+          </a:bodyPr>
+          <a:lstStyle/>
+          <a:p>
+            <a:pPr algn="l">
+              <a:lnSpc>
+                <a:spcPct val="135000"/>
+              </a:lnSpc>
+              <a:spcBef>
+                <a:spcPts val="0"/>
+              </a:spcBef>
+              <a:spcAft>
+                <a:spcPts val="0"/>
+              </a:spcAft>
+            </a:pPr>
+            <a:r>
+              <a:rPr sz="1650" b="1">
+                <a:solidFill>
+                  <a:srgbClr val="292929"/>
+                </a:solidFill>
+                <a:latin typeface="Pretendard"/>
+                <a:ea typeface="Pretendard"/>
+                <a:cs typeface="Pretendard"/>
+              </a:rPr>
+              <a:t>해결 방안</a:t>
+            </a:r>
+          </a:p>
+        </p:txBody>
+      </p:sp>
+      <p:sp>
+        <p:nvSpPr>
+          <p:cNvPr id="27" name="TextBox 26"/>
+          <p:cNvSpPr txBox="1"/>
+          <p:nvPr/>
+        </p:nvSpPr>
+        <p:spPr>
+          <a:xfrm>
+            <a:off x="2057400" y="5010912"/>
+            <a:ext cx="7589520" cy="256032"/>
+          </a:xfrm>
+          <a:prstGeom prst="rect">
+            <a:avLst/>
+          </a:prstGeom>
+          <a:noFill/>
+        </p:spPr>
+        <p:txBody>
+          <a:bodyPr wrap="square" lIns="0" rIns="0" tIns="0" bIns="0" anchor="t">
+            <a:spAutoFit/>
+          </a:bodyPr>
+          <a:lstStyle/>
+          <a:p>
+            <a:pPr algn="l">
+              <a:lnSpc>
+                <a:spcPct val="135000"/>
+              </a:lnSpc>
+              <a:spcBef>
+                <a:spcPts val="0"/>
+              </a:spcBef>
+              <a:spcAft>
+                <a:spcPts val="0"/>
+              </a:spcAft>
+            </a:pPr>
+            <a:r>
+              <a:rPr sz="1250" b="0">
+                <a:solidFill>
+                  <a:srgbClr val="6B6B6B"/>
+                </a:solidFill>
+                <a:latin typeface="Pretendard"/>
+                <a:ea typeface="Pretendard"/>
+                <a:cs typeface="Pretendard"/>
+              </a:rPr>
+              <a:t>선택지 A~D · 추천안 · 적용하면 구조가 어떻게 바뀌나</a:t>
+            </a:r>
+          </a:p>
+        </p:txBody>
+      </p:sp>
+      <p:sp>
+        <p:nvSpPr>
+          <p:cNvPr id="28" name="TextBox 27"/>
+          <p:cNvSpPr txBox="1"/>
+          <p:nvPr/>
+        </p:nvSpPr>
+        <p:spPr>
+          <a:xfrm>
+            <a:off x="10058400" y="4846320"/>
+            <a:ext cx="1188720" cy="274320"/>
+          </a:xfrm>
+          <a:prstGeom prst="rect">
+            <a:avLst/>
+          </a:prstGeom>
+          <a:noFill/>
+        </p:spPr>
+        <p:txBody>
+          <a:bodyPr wrap="square" lIns="0" rIns="0" tIns="0" bIns="0" anchor="t">
+            <a:spAutoFit/>
+          </a:bodyPr>
+          <a:lstStyle/>
+          <a:p>
+            <a:pPr algn="r">
+              <a:lnSpc>
+                <a:spcPct val="135000"/>
+              </a:lnSpc>
+              <a:spcBef>
+                <a:spcPts val="0"/>
+              </a:spcBef>
+              <a:spcAft>
+                <a:spcPts val="0"/>
+              </a:spcAft>
+            </a:pPr>
+            <a:r>
+              <a:rPr sz="1200" b="0">
+                <a:solidFill>
+                  <a:srgbClr val="9A9A9A"/>
+                </a:solidFill>
+                <a:latin typeface="Pretendard"/>
+                <a:ea typeface="Pretendard"/>
+                <a:cs typeface="Pretendard"/>
+              </a:rPr>
+              <a:t>14 – 18</a:t>
+            </a:r>
+          </a:p>
+        </p:txBody>
+      </p:sp>
+      <p:sp>
+        <p:nvSpPr>
+          <p:cNvPr id="29" name="Rectangle 28"/>
+          <p:cNvSpPr/>
+          <p:nvPr/>
+        </p:nvSpPr>
+        <p:spPr>
+          <a:xfrm>
+            <a:off x="777240" y="5468112"/>
+            <a:ext cx="10634472" cy="676656"/>
+          </a:xfrm>
+          <a:prstGeom prst="rect">
+            <a:avLst/>
+          </a:prstGeom>
+          <a:solidFill>
+            <a:srgbClr val="FFFFFF"/>
+          </a:solidFill>
+          <a:ln w="12700">
+            <a:solidFill>
+              <a:srgbClr val="E4E4E4"/>
+            </a:solidFill>
+          </a:ln>
+          <a:effectLst/>
+        </p:spPr>
+        <p:style>
+          <a:lnRef idx="1">
+            <a:schemeClr val="accent1"/>
+          </a:lnRef>
+          <a:fillRef idx="3">
+            <a:schemeClr val="accent1"/>
+          </a:fillRef>
+          <a:effectRef idx="2">
+            <a:schemeClr val="accent1"/>
+          </a:effectRef>
+          <a:fontRef idx="minor">
+            <a:schemeClr val="lt1"/>
+          </a:fontRef>
+        </p:style>
+        <p:txBody>
+          <a:bodyPr rtlCol="0" anchor="ctr" wrap="square"/>
+          <a:lstStyle/>
+          <a:p>
+            <a:pPr algn="ctr"/>
+          </a:p>
+        </p:txBody>
+      </p:sp>
+      <p:sp>
+        <p:nvSpPr>
+          <p:cNvPr id="30" name="Rectangle 29"/>
+          <p:cNvSpPr/>
+          <p:nvPr/>
+        </p:nvSpPr>
+        <p:spPr>
+          <a:xfrm>
+            <a:off x="777240" y="5468112"/>
+            <a:ext cx="82296" cy="676656"/>
+          </a:xfrm>
+          <a:prstGeom prst="rect">
+            <a:avLst/>
+          </a:prstGeom>
+          <a:solidFill>
+            <a:srgbClr val="6C4CFF"/>
+          </a:solidFill>
+          <a:ln>
+            <a:noFill/>
+          </a:ln>
+          <a:effectLst/>
+        </p:spPr>
+        <p:style>
+          <a:lnRef idx="1">
+            <a:schemeClr val="accent1"/>
+          </a:lnRef>
+          <a:fillRef idx="3">
+            <a:schemeClr val="accent1"/>
+          </a:fillRef>
+          <a:effectRef idx="2">
+            <a:schemeClr val="accent1"/>
+          </a:effectRef>
+          <a:fontRef idx="minor">
+            <a:schemeClr val="lt1"/>
+          </a:fontRef>
+        </p:style>
+        <p:txBody>
+          <a:bodyPr rtlCol="0" anchor="ctr" wrap="square"/>
+          <a:lstStyle/>
+          <a:p>
+            <a:pPr algn="ctr"/>
+          </a:p>
+        </p:txBody>
+      </p:sp>
+      <p:sp>
+        <p:nvSpPr>
+          <p:cNvPr id="31" name="TextBox 30"/>
+          <p:cNvSpPr txBox="1"/>
+          <p:nvPr/>
+        </p:nvSpPr>
+        <p:spPr>
+          <a:xfrm>
+            <a:off x="1143000" y="5650992"/>
+            <a:ext cx="731520" cy="320040"/>
+          </a:xfrm>
+          <a:prstGeom prst="rect">
+            <a:avLst/>
+          </a:prstGeom>
+          <a:noFill/>
+        </p:spPr>
+        <p:txBody>
+          <a:bodyPr wrap="square" lIns="0" rIns="0" tIns="0" bIns="0" anchor="t">
+            <a:spAutoFit/>
+          </a:bodyPr>
+          <a:lstStyle/>
+          <a:p>
+            <a:pPr algn="l">
+              <a:lnSpc>
+                <a:spcPct val="135000"/>
+              </a:lnSpc>
+              <a:spcBef>
+                <a:spcPts val="0"/>
+              </a:spcBef>
+              <a:spcAft>
+                <a:spcPts val="0"/>
+              </a:spcAft>
+            </a:pPr>
+            <a:r>
+              <a:rPr sz="1900" b="1">
+                <a:solidFill>
+                  <a:srgbClr val="6C4CFF"/>
+                </a:solidFill>
+                <a:latin typeface="Pretendard"/>
+                <a:ea typeface="Pretendard"/>
+                <a:cs typeface="Pretendard"/>
+              </a:rPr>
+              <a:t>05</a:t>
+            </a:r>
+          </a:p>
+        </p:txBody>
+      </p:sp>
+      <p:sp>
+        <p:nvSpPr>
+          <p:cNvPr id="32" name="TextBox 31"/>
+          <p:cNvSpPr txBox="1"/>
+          <p:nvPr/>
+        </p:nvSpPr>
+        <p:spPr>
+          <a:xfrm>
+            <a:off x="2057400" y="5586984"/>
+            <a:ext cx="2926080" cy="274320"/>
+          </a:xfrm>
+          <a:prstGeom prst="rect">
+            <a:avLst/>
+          </a:prstGeom>
+          <a:noFill/>
+        </p:spPr>
+        <p:txBody>
+          <a:bodyPr wrap="square" lIns="0" rIns="0" tIns="0" bIns="0" anchor="t">
+            <a:spAutoFit/>
+          </a:bodyPr>
+          <a:lstStyle/>
+          <a:p>
+            <a:pPr algn="l">
+              <a:lnSpc>
+                <a:spcPct val="135000"/>
+              </a:lnSpc>
+              <a:spcBef>
+                <a:spcPts val="0"/>
+              </a:spcBef>
+              <a:spcAft>
+                <a:spcPts val="0"/>
+              </a:spcAft>
+            </a:pPr>
+            <a:r>
+              <a:rPr sz="1650" b="1">
+                <a:solidFill>
+                  <a:srgbClr val="292929"/>
+                </a:solidFill>
+                <a:latin typeface="Pretendard"/>
+                <a:ea typeface="Pretendard"/>
+                <a:cs typeface="Pretendard"/>
+              </a:rPr>
+              <a:t>비교 · 즉시 조치</a:t>
+            </a:r>
+          </a:p>
+        </p:txBody>
+      </p:sp>
+      <p:sp>
+        <p:nvSpPr>
+          <p:cNvPr id="33" name="TextBox 32"/>
+          <p:cNvSpPr txBox="1"/>
+          <p:nvPr/>
+        </p:nvSpPr>
+        <p:spPr>
+          <a:xfrm>
+            <a:off x="2057400" y="5852160"/>
+            <a:ext cx="7589520" cy="256032"/>
+          </a:xfrm>
+          <a:prstGeom prst="rect">
+            <a:avLst/>
+          </a:prstGeom>
+          <a:noFill/>
+        </p:spPr>
+        <p:txBody>
+          <a:bodyPr wrap="square" lIns="0" rIns="0" tIns="0" bIns="0" anchor="t">
+            <a:spAutoFit/>
+          </a:bodyPr>
+          <a:lstStyle/>
+          <a:p>
+            <a:pPr algn="l">
+              <a:lnSpc>
+                <a:spcPct val="135000"/>
+              </a:lnSpc>
+              <a:spcBef>
+                <a:spcPts val="0"/>
+              </a:spcBef>
+              <a:spcAft>
+                <a:spcPts val="0"/>
+              </a:spcAft>
+            </a:pPr>
+            <a:r>
+              <a:rPr sz="1250" b="0">
+                <a:solidFill>
+                  <a:srgbClr val="6B6B6B"/>
+                </a:solidFill>
+                <a:latin typeface="Pretendard"/>
+                <a:ea typeface="Pretendard"/>
+                <a:cs typeface="Pretendard"/>
+              </a:rPr>
+              <a:t>지금 vs 추천안, 어느 쪽이든 지금 해야 할 것</a:t>
+            </a:r>
+          </a:p>
+        </p:txBody>
+      </p:sp>
+      <p:sp>
+        <p:nvSpPr>
+          <p:cNvPr id="34" name="TextBox 33"/>
+          <p:cNvSpPr txBox="1"/>
+          <p:nvPr/>
+        </p:nvSpPr>
+        <p:spPr>
+          <a:xfrm>
+            <a:off x="10058400" y="5687568"/>
+            <a:ext cx="1188720" cy="274320"/>
+          </a:xfrm>
+          <a:prstGeom prst="rect">
+            <a:avLst/>
+          </a:prstGeom>
+          <a:noFill/>
+        </p:spPr>
+        <p:txBody>
+          <a:bodyPr wrap="square" lIns="0" rIns="0" tIns="0" bIns="0" anchor="t">
+            <a:spAutoFit/>
+          </a:bodyPr>
+          <a:lstStyle/>
+          <a:p>
+            <a:pPr algn="r">
+              <a:lnSpc>
+                <a:spcPct val="135000"/>
+              </a:lnSpc>
+              <a:spcBef>
+                <a:spcPts val="0"/>
+              </a:spcBef>
+              <a:spcAft>
+                <a:spcPts val="0"/>
+              </a:spcAft>
+            </a:pPr>
+            <a:r>
+              <a:rPr sz="1200" b="0">
+                <a:solidFill>
+                  <a:srgbClr val="9A9A9A"/>
+                </a:solidFill>
+                <a:latin typeface="Pretendard"/>
+                <a:ea typeface="Pretendard"/>
+                <a:cs typeface="Pretendard"/>
+              </a:rPr>
+              <a:t>19 – 20</a:t>
+            </a:r>
+          </a:p>
+        </p:txBody>
+      </p:sp>
+      <p:sp>
+        <p:nvSpPr>
+          <p:cNvPr id="35" name="TextBox 34"/>
+          <p:cNvSpPr txBox="1"/>
+          <p:nvPr/>
+        </p:nvSpPr>
+        <p:spPr>
+          <a:xfrm>
+            <a:off x="777240" y="6355080"/>
+            <a:ext cx="10607040" cy="274320"/>
+          </a:xfrm>
+          <a:prstGeom prst="rect">
+            <a:avLst/>
+          </a:prstGeom>
+          <a:noFill/>
+        </p:spPr>
+        <p:txBody>
+          <a:bodyPr wrap="square" lIns="0" rIns="0" tIns="0" bIns="0" anchor="t">
+            <a:spAutoFit/>
+          </a:bodyPr>
+          <a:lstStyle/>
+          <a:p>
+            <a:pPr algn="l">
+              <a:lnSpc>
+                <a:spcPct val="135000"/>
+              </a:lnSpc>
+              <a:spcBef>
+                <a:spcPts val="0"/>
+              </a:spcBef>
+              <a:spcAft>
+                <a:spcPts val="0"/>
+              </a:spcAft>
+            </a:pPr>
+            <a:r>
+              <a:rPr sz="1200" b="0">
+                <a:solidFill>
+                  <a:srgbClr val="6B6B6B"/>
+                </a:solidFill>
+                <a:latin typeface="Pretendard"/>
+                <a:ea typeface="Pretendard"/>
+                <a:cs typeface="Pretendard"/>
+              </a:rPr>
+              <a:t>총 20장 · 15분  ·  가장 중요한 장은 03번입니다. 원인을 알아야 어느 해결안이 맞는지 판단하실 수 있습니다.</a:t>
+            </a:r>
+          </a:p>
+        </p:txBody>
+      </p:sp>
+    </p:spTree>
+  </p:cSld>
+  <p:clrMapOvr>
+    <a:masterClrMapping/>
+  </p:clrMapOvr>
+</p:sld>
+</file>
+
+<file path=ppt/slides/slide20.xml><?xml version="1.0" encoding="utf-8"?>
+<p:sld xmlns:a="http://schemas.openxmlformats.org/drawingml/2006/main" xmlns:p="http://schemas.openxmlformats.org/presentationml/2006/main" xmlns:r="http://schemas.openxmlformats.org/officeDocument/2006/relationships">
+  <p:cSld>
+    <p:spTree>
+      <p:nvGrpSpPr>
+        <p:cNvPr id="1" name=""/>
+        <p:cNvGrpSpPr/>
+        <p:nvPr/>
+      </p:nvGrpSpPr>
+      <p:grpSpPr/>
+      <p:sp>
+        <p:nvSpPr>
+          <p:cNvPr id="2" name="Rectangle 1"/>
+          <p:cNvSpPr/>
+          <p:nvPr/>
+        </p:nvSpPr>
+        <p:spPr>
+          <a:xfrm>
+            <a:off x="0" y="0"/>
+            <a:ext cx="12191695" cy="6858000"/>
+          </a:xfrm>
+          <a:prstGeom prst="rect">
+            <a:avLst/>
+          </a:prstGeom>
+          <a:solidFill>
+            <a:srgbClr val="FAFAFA"/>
+          </a:solidFill>
+          <a:ln>
+            <a:noFill/>
+          </a:ln>
+          <a:effectLst/>
+        </p:spPr>
+        <p:style>
+          <a:lnRef idx="1">
+            <a:schemeClr val="accent1"/>
+          </a:lnRef>
+          <a:fillRef idx="3">
+            <a:schemeClr val="accent1"/>
+          </a:fillRef>
+          <a:effectRef idx="2">
+            <a:schemeClr val="accent1"/>
+          </a:effectRef>
+          <a:fontRef idx="minor">
+            <a:schemeClr val="lt1"/>
+          </a:fontRef>
+        </p:style>
+        <p:txBody>
+          <a:bodyPr rtlCol="0" anchor="ctr" wrap="square"/>
+          <a:lstStyle/>
+          <a:p>
+            <a:pPr algn="ctr"/>
+          </a:p>
+        </p:txBody>
+      </p:sp>
+      <p:sp>
+        <p:nvSpPr>
+          <p:cNvPr id="3" name="TextBox 2"/>
+          <p:cNvSpPr txBox="1"/>
+          <p:nvPr/>
+        </p:nvSpPr>
+        <p:spPr>
+          <a:xfrm>
+            <a:off x="777240" y="548640"/>
+            <a:ext cx="10607040" cy="292608"/>
+          </a:xfrm>
+          <a:prstGeom prst="rect">
+            <a:avLst/>
+          </a:prstGeom>
+          <a:noFill/>
+        </p:spPr>
+        <p:txBody>
+          <a:bodyPr wrap="square" lIns="0" rIns="0" tIns="0" bIns="0" anchor="t">
+            <a:spAutoFit/>
+          </a:bodyPr>
+          <a:lstStyle/>
+          <a:p>
+            <a:pPr algn="l">
+              <a:lnSpc>
+                <a:spcPct val="135000"/>
+              </a:lnSpc>
+              <a:spcBef>
+                <a:spcPts val="0"/>
+              </a:spcBef>
+              <a:spcAft>
+                <a:spcPts val="0"/>
+              </a:spcAft>
+            </a:pPr>
+            <a:r>
+              <a:rPr sz="1300" b="1">
+                <a:solidFill>
+                  <a:srgbClr val="6C4CFF"/>
+                </a:solidFill>
+                <a:latin typeface="Pretendard"/>
+                <a:ea typeface="Pretendard"/>
+                <a:cs typeface="Pretendard"/>
+              </a:rPr>
+              <a:t>⑤ 즉시 조치</a:t>
+            </a:r>
+          </a:p>
+        </p:txBody>
+      </p:sp>
+      <p:sp>
+        <p:nvSpPr>
+          <p:cNvPr id="4" name="TextBox 3"/>
+          <p:cNvSpPr txBox="1"/>
+          <p:nvPr/>
+        </p:nvSpPr>
+        <p:spPr>
+          <a:xfrm>
+            <a:off x="777240" y="914400"/>
+            <a:ext cx="10607040" cy="822960"/>
+          </a:xfrm>
+          <a:prstGeom prst="rect">
+            <a:avLst/>
+          </a:prstGeom>
+          <a:noFill/>
+        </p:spPr>
+        <p:txBody>
+          <a:bodyPr wrap="square" lIns="0" rIns="0" tIns="0" bIns="0" anchor="t">
+            <a:spAutoFit/>
+          </a:bodyPr>
+          <a:lstStyle/>
+          <a:p>
+            <a:pPr algn="l">
+              <a:lnSpc>
+                <a:spcPct val="120000"/>
+              </a:lnSpc>
+              <a:spcBef>
+                <a:spcPts val="0"/>
+              </a:spcBef>
+              <a:spcAft>
+                <a:spcPts val="0"/>
+              </a:spcAft>
+            </a:pPr>
+            <a:r>
+              <a:rPr sz="3300" b="1">
+                <a:solidFill>
+                  <a:srgbClr val="292929"/>
+                </a:solidFill>
+                <a:latin typeface="Pretendard"/>
+                <a:ea typeface="Pretendard"/>
+                <a:cs typeface="Pretendard"/>
+              </a:rPr>
+              <a:t>어느 안을 택하든, 지금 고쳐야 할 8가지</a:t>
             </a:r>
           </a:p>
         </p:txBody>
@@ -22112,514 +20943,7 @@
                 <a:ea typeface="Pretendard"/>
                 <a:cs typeface="Pretendard"/>
               </a:rPr>
-              <a:t>21</a:t>
-            </a:r>
-          </a:p>
-        </p:txBody>
-      </p:sp>
-    </p:spTree>
-  </p:cSld>
-  <p:clrMapOvr>
-    <a:masterClrMapping/>
-  </p:clrMapOvr>
-</p:sld>
-</file>
-
-<file path=ppt/slides/slide22.xml><?xml version="1.0" encoding="utf-8"?>
-<p:sld xmlns:a="http://schemas.openxmlformats.org/drawingml/2006/main" xmlns:p="http://schemas.openxmlformats.org/presentationml/2006/main" xmlns:r="http://schemas.openxmlformats.org/officeDocument/2006/relationships">
-  <p:cSld>
-    <p:spTree>
-      <p:nvGrpSpPr>
-        <p:cNvPr id="1" name=""/>
-        <p:cNvGrpSpPr/>
-        <p:nvPr/>
-      </p:nvGrpSpPr>
-      <p:grpSpPr/>
-      <p:sp>
-        <p:nvSpPr>
-          <p:cNvPr id="2" name="Rectangle 1"/>
-          <p:cNvSpPr/>
-          <p:nvPr/>
-        </p:nvSpPr>
-        <p:spPr>
-          <a:xfrm>
-            <a:off x="0" y="0"/>
-            <a:ext cx="12191695" cy="6858000"/>
-          </a:xfrm>
-          <a:prstGeom prst="rect">
-            <a:avLst/>
-          </a:prstGeom>
-          <a:solidFill>
-            <a:srgbClr val="FAFAFA"/>
-          </a:solidFill>
-          <a:ln>
-            <a:noFill/>
-          </a:ln>
-          <a:effectLst/>
-        </p:spPr>
-        <p:style>
-          <a:lnRef idx="1">
-            <a:schemeClr val="accent1"/>
-          </a:lnRef>
-          <a:fillRef idx="3">
-            <a:schemeClr val="accent1"/>
-          </a:fillRef>
-          <a:effectRef idx="2">
-            <a:schemeClr val="accent1"/>
-          </a:effectRef>
-          <a:fontRef idx="minor">
-            <a:schemeClr val="lt1"/>
-          </a:fontRef>
-        </p:style>
-        <p:txBody>
-          <a:bodyPr rtlCol="0" anchor="ctr" wrap="square"/>
-          <a:lstStyle/>
-          <a:p>
-            <a:pPr algn="ctr"/>
-          </a:p>
-        </p:txBody>
-      </p:sp>
-      <p:sp>
-        <p:nvSpPr>
-          <p:cNvPr id="3" name="Rectangle 2"/>
-          <p:cNvSpPr/>
-          <p:nvPr/>
-        </p:nvSpPr>
-        <p:spPr>
-          <a:xfrm>
-            <a:off x="777240" y="1371600"/>
-            <a:ext cx="10634472" cy="54864"/>
-          </a:xfrm>
-          <a:prstGeom prst="rect">
-            <a:avLst/>
-          </a:prstGeom>
-          <a:solidFill>
-            <a:srgbClr val="6C4CFF"/>
-          </a:solidFill>
-          <a:ln>
-            <a:noFill/>
-          </a:ln>
-          <a:effectLst/>
-        </p:spPr>
-        <p:style>
-          <a:lnRef idx="1">
-            <a:schemeClr val="accent1"/>
-          </a:lnRef>
-          <a:fillRef idx="3">
-            <a:schemeClr val="accent1"/>
-          </a:fillRef>
-          <a:effectRef idx="2">
-            <a:schemeClr val="accent1"/>
-          </a:effectRef>
-          <a:fontRef idx="minor">
-            <a:schemeClr val="lt1"/>
-          </a:fontRef>
-        </p:style>
-        <p:txBody>
-          <a:bodyPr rtlCol="0" anchor="ctr" wrap="square"/>
-          <a:lstStyle/>
-          <a:p>
-            <a:pPr algn="ctr"/>
-          </a:p>
-        </p:txBody>
-      </p:sp>
-      <p:sp>
-        <p:nvSpPr>
-          <p:cNvPr id="4" name="TextBox 3"/>
-          <p:cNvSpPr txBox="1"/>
-          <p:nvPr/>
-        </p:nvSpPr>
-        <p:spPr>
-          <a:xfrm>
-            <a:off x="777240" y="1783080"/>
-            <a:ext cx="10607040" cy="457200"/>
-          </a:xfrm>
-          <a:prstGeom prst="rect">
-            <a:avLst/>
-          </a:prstGeom>
-          <a:noFill/>
-        </p:spPr>
-        <p:txBody>
-          <a:bodyPr wrap="square" lIns="0" rIns="0" tIns="0" bIns="0" anchor="t">
-            <a:spAutoFit/>
-          </a:bodyPr>
-          <a:lstStyle/>
-          <a:p>
-            <a:pPr algn="l">
-              <a:lnSpc>
-                <a:spcPct val="135000"/>
-              </a:lnSpc>
-              <a:spcBef>
-                <a:spcPts val="0"/>
-              </a:spcBef>
-              <a:spcAft>
-                <a:spcPts val="0"/>
-              </a:spcAft>
-            </a:pPr>
-            <a:r>
-              <a:rPr sz="3000" b="1">
-                <a:solidFill>
-                  <a:srgbClr val="292929"/>
-                </a:solidFill>
-                <a:latin typeface="Pretendard"/>
-                <a:ea typeface="Pretendard"/>
-                <a:cs typeface="Pretendard"/>
-              </a:rPr>
-              <a:t>마지막으로 — 우리는 이미 한 번 진단했습니다</a:t>
-            </a:r>
-          </a:p>
-        </p:txBody>
-      </p:sp>
-      <p:sp>
-        <p:nvSpPr>
-          <p:cNvPr id="5" name="Rectangle 4"/>
-          <p:cNvSpPr/>
-          <p:nvPr/>
-        </p:nvSpPr>
-        <p:spPr>
-          <a:xfrm>
-            <a:off x="777240" y="2606040"/>
-            <a:ext cx="10634472" cy="1691640"/>
-          </a:xfrm>
-          <a:prstGeom prst="rect">
-            <a:avLst/>
-          </a:prstGeom>
-          <a:solidFill>
-            <a:srgbClr val="FFFFFF"/>
-          </a:solidFill>
-          <a:ln w="12700">
-            <a:solidFill>
-              <a:srgbClr val="E4E4E4"/>
-            </a:solidFill>
-          </a:ln>
-          <a:effectLst/>
-        </p:spPr>
-        <p:style>
-          <a:lnRef idx="1">
-            <a:schemeClr val="accent1"/>
-          </a:lnRef>
-          <a:fillRef idx="3">
-            <a:schemeClr val="accent1"/>
-          </a:fillRef>
-          <a:effectRef idx="2">
-            <a:schemeClr val="accent1"/>
-          </a:effectRef>
-          <a:fontRef idx="minor">
-            <a:schemeClr val="lt1"/>
-          </a:fontRef>
-        </p:style>
-        <p:txBody>
-          <a:bodyPr rtlCol="0" anchor="ctr" wrap="square"/>
-          <a:lstStyle/>
-          <a:p>
-            <a:pPr algn="ctr"/>
-          </a:p>
-        </p:txBody>
-      </p:sp>
-      <p:sp>
-        <p:nvSpPr>
-          <p:cNvPr id="6" name="TextBox 5"/>
-          <p:cNvSpPr txBox="1"/>
-          <p:nvPr/>
-        </p:nvSpPr>
-        <p:spPr>
-          <a:xfrm>
-            <a:off x="1143000" y="2880360"/>
-            <a:ext cx="9966960" cy="1280160"/>
-          </a:xfrm>
-          <a:prstGeom prst="rect">
-            <a:avLst/>
-          </a:prstGeom>
-          <a:noFill/>
-        </p:spPr>
-        <p:txBody>
-          <a:bodyPr wrap="square" lIns="0" rIns="0" tIns="0" bIns="0" anchor="t">
-            <a:spAutoFit/>
-          </a:bodyPr>
-          <a:lstStyle/>
-          <a:p>
-            <a:pPr algn="l">
-              <a:lnSpc>
-                <a:spcPct val="135000"/>
-              </a:lnSpc>
-              <a:spcBef>
-                <a:spcPts val="0"/>
-              </a:spcBef>
-              <a:spcAft>
-                <a:spcPts val="0"/>
-              </a:spcAft>
-            </a:pPr>
-            <a:r>
-              <a:rPr sz="1200" b="0">
-                <a:solidFill>
-                  <a:srgbClr val="6B6B6B"/>
-                </a:solidFill>
-                <a:latin typeface="Pretendard"/>
-                <a:ea typeface="Pretendard"/>
-                <a:cs typeface="Pretendard"/>
-              </a:rPr>
-              <a:t>cdbd-design-system/docs/CdBd 에디터 문서 구축 계획.html</a:t>
-            </a:r>
-          </a:p>
-          <a:p>
-            <a:pPr>
-              <a:lnSpc>
-                <a:spcPct val="135000"/>
-              </a:lnSpc>
-              <a:spcBef>
-                <a:spcPts val="1000"/>
-              </a:spcBef>
-              <a:spcAft>
-                <a:spcPts val="0"/>
-              </a:spcAft>
-            </a:pPr>
-            <a:r>
-              <a:rPr sz="1700" b="1">
-                <a:solidFill>
-                  <a:srgbClr val="292929"/>
-                </a:solidFill>
-                <a:latin typeface="Pretendard"/>
-                <a:ea typeface="Pretendard"/>
-                <a:cs typeface="Pretendard"/>
-              </a:rPr>
-              <a:t>“팀원 A·B·C가 각자의 Claude에게 똑같이 부탁했을 때 같은 결과가 나오게”</a:t>
-            </a:r>
-          </a:p>
-          <a:p>
-            <a:pPr>
-              <a:lnSpc>
-                <a:spcPct val="135000"/>
-              </a:lnSpc>
-              <a:spcBef>
-                <a:spcPts val="600"/>
-              </a:spcBef>
-              <a:spcAft>
-                <a:spcPts val="0"/>
-              </a:spcAft>
-            </a:pPr>
-            <a:r>
-              <a:rPr sz="1700" b="1">
-                <a:solidFill>
-                  <a:srgbClr val="292929"/>
-                </a:solidFill>
-                <a:latin typeface="Pretendard"/>
-                <a:ea typeface="Pretendard"/>
-                <a:cs typeface="Pretendard"/>
-              </a:rPr>
-              <a:t>“위키링크는 Claude에게 클릭이 아닙니다”</a:t>
-            </a:r>
-          </a:p>
-          <a:p>
-            <a:pPr>
-              <a:lnSpc>
-                <a:spcPct val="135000"/>
-              </a:lnSpc>
-              <a:spcBef>
-                <a:spcPts val="600"/>
-              </a:spcBef>
-              <a:spcAft>
-                <a:spcPts val="0"/>
-              </a:spcAft>
-            </a:pPr>
-            <a:r>
-              <a:rPr sz="1700" b="1">
-                <a:solidFill>
-                  <a:srgbClr val="292929"/>
-                </a:solidFill>
-                <a:latin typeface="Pretendard"/>
-                <a:ea typeface="Pretendard"/>
-                <a:cs typeface="Pretendard"/>
-              </a:rPr>
-              <a:t>“CLAUDE.md 679바이트, 카드 문서 49개 언급 0줄”</a:t>
-            </a:r>
-          </a:p>
-        </p:txBody>
-      </p:sp>
-      <p:sp>
-        <p:nvSpPr>
-          <p:cNvPr id="7" name="TextBox 6"/>
-          <p:cNvSpPr txBox="1"/>
-          <p:nvPr/>
-        </p:nvSpPr>
-        <p:spPr>
-          <a:xfrm>
-            <a:off x="777240" y="4617720"/>
-            <a:ext cx="10607040" cy="1280160"/>
-          </a:xfrm>
-          <a:prstGeom prst="rect">
-            <a:avLst/>
-          </a:prstGeom>
-          <a:noFill/>
-        </p:spPr>
-        <p:txBody>
-          <a:bodyPr wrap="square" lIns="0" rIns="0" tIns="0" bIns="0" anchor="t">
-            <a:spAutoFit/>
-          </a:bodyPr>
-          <a:lstStyle/>
-          <a:p>
-            <a:pPr algn="l">
-              <a:lnSpc>
-                <a:spcPct val="135000"/>
-              </a:lnSpc>
-              <a:spcBef>
-                <a:spcPts val="0"/>
-              </a:spcBef>
-              <a:spcAft>
-                <a:spcPts val="0"/>
-              </a:spcAft>
-            </a:pPr>
-            <a:r>
-              <a:rPr sz="1600" b="0">
-                <a:solidFill>
-                  <a:srgbClr val="292929"/>
-                </a:solidFill>
-                <a:latin typeface="Pretendard"/>
-                <a:ea typeface="Pretendard"/>
-                <a:cs typeface="Pretendard"/>
-              </a:rPr>
-              <a:t>진단도 처방도 이미 정확하게 나와 있었습니다. 그런데 채택률은 0%였습니다.</a:t>
-            </a:r>
-          </a:p>
-          <a:p>
-            <a:pPr>
-              <a:lnSpc>
-                <a:spcPct val="135000"/>
-              </a:lnSpc>
-              <a:spcBef>
-                <a:spcPts val="800"/>
-              </a:spcBef>
-              <a:spcAft>
-                <a:spcPts val="0"/>
-              </a:spcAft>
-            </a:pPr>
-            <a:r>
-              <a:rPr sz="1600" b="0">
-                <a:solidFill>
-                  <a:srgbClr val="292929"/>
-                </a:solidFill>
-                <a:latin typeface="Pretendard"/>
-                <a:ea typeface="Pretendard"/>
-                <a:cs typeface="Pretendard"/>
-              </a:rPr>
-              <a:t>이유는 그 계획서 자체가 HTML 파일 한 장이라 볼트 검색에서 빠져, 아무도 — Claude조차 — 읽지 못했기 때문입니다.</a:t>
-            </a:r>
-          </a:p>
-          <a:p>
-            <a:pPr>
-              <a:lnSpc>
-                <a:spcPct val="135000"/>
-              </a:lnSpc>
-              <a:spcBef>
-                <a:spcPts val="1200"/>
-              </a:spcBef>
-              <a:spcAft>
-                <a:spcPts val="0"/>
-              </a:spcAft>
-            </a:pPr>
-            <a:r>
-              <a:rPr sz="1700" b="1">
-                <a:solidFill>
-                  <a:srgbClr val="6C4CFF"/>
-                </a:solidFill>
-                <a:latin typeface="Pretendard"/>
-                <a:ea typeface="Pretendard"/>
-                <a:cs typeface="Pretendard"/>
-              </a:rPr>
-              <a:t>그래서 이번 제안에는 “자동 점검”이 반드시 포함되어야 합니다.</a:t>
-            </a:r>
-          </a:p>
-        </p:txBody>
-      </p:sp>
-      <p:sp>
-        <p:nvSpPr>
-          <p:cNvPr id="8" name="TextBox 7"/>
-          <p:cNvSpPr txBox="1"/>
-          <p:nvPr/>
-        </p:nvSpPr>
-        <p:spPr>
-          <a:xfrm>
-            <a:off x="777240" y="6455664"/>
-            <a:ext cx="9509760" cy="256032"/>
-          </a:xfrm>
-          <a:prstGeom prst="rect">
-            <a:avLst/>
-          </a:prstGeom>
-          <a:noFill/>
-        </p:spPr>
-        <p:txBody>
-          <a:bodyPr wrap="square" lIns="0" rIns="0" tIns="0" bIns="0" anchor="t">
-            <a:spAutoFit/>
-          </a:bodyPr>
-          <a:lstStyle/>
-          <a:p>
-            <a:pPr algn="l">
-              <a:lnSpc>
-                <a:spcPct val="135000"/>
-              </a:lnSpc>
-              <a:spcBef>
-                <a:spcPts val="0"/>
-              </a:spcBef>
-              <a:spcAft>
-                <a:spcPts val="0"/>
-              </a:spcAft>
-            </a:pPr>
-            <a:r>
-              <a:rPr sz="1000" b="0">
-                <a:solidFill>
-                  <a:srgbClr val="9A9A9A"/>
-                </a:solidFill>
-                <a:latin typeface="Pretendard"/>
-                <a:ea typeface="Pretendard"/>
-                <a:cs typeface="Pretendard"/>
-              </a:rPr>
-              <a:t/>
-            </a:r>
-          </a:p>
-        </p:txBody>
-      </p:sp>
-      <p:sp>
-        <p:nvSpPr>
-          <p:cNvPr id="9" name="TextBox 8"/>
-          <p:cNvSpPr txBox="1"/>
-          <p:nvPr/>
-        </p:nvSpPr>
-        <p:spPr>
-          <a:xfrm>
-            <a:off x="10588752" y="6455664"/>
-            <a:ext cx="822960" cy="256032"/>
-          </a:xfrm>
-          <a:prstGeom prst="rect">
-            <a:avLst/>
-          </a:prstGeom>
-          <a:noFill/>
-        </p:spPr>
-        <p:txBody>
-          <a:bodyPr wrap="square" lIns="0" rIns="0" tIns="0" bIns="0" anchor="t">
-            <a:spAutoFit/>
-          </a:bodyPr>
-          <a:lstStyle/>
-          <a:p>
-            <a:pPr algn="r">
-              <a:lnSpc>
-                <a:spcPct val="135000"/>
-              </a:lnSpc>
-              <a:spcBef>
-                <a:spcPts val="0"/>
-              </a:spcBef>
-              <a:spcAft>
-                <a:spcPts val="0"/>
-              </a:spcAft>
-            </a:pPr>
-            <a:r>
-              <a:rPr sz="1000" b="0">
-                <a:solidFill>
-                  <a:srgbClr val="9A9A9A"/>
-                </a:solidFill>
-                <a:latin typeface="Pretendard"/>
-                <a:ea typeface="Pretendard"/>
-                <a:cs typeface="Pretendard"/>
-              </a:rPr>
-              <a:t>22</a:t>
+              <a:t>20</a:t>
             </a:r>
           </a:p>
         </p:txBody>

</xml_diff>

<commit_message>
vault backup: 2026-08-09 22:17:17
</commit_message>
<xml_diff>
--- a/CdBd 문서 체계 진단 및 개편 제안.pptx
+++ b/CdBd 문서 체계 진단 및 개편 제안.pptx
@@ -19773,8 +19773,8 @@
           <p:nvPr/>
         </p:nvGraphicFramePr>
         <p:xfrm>
-          <a:off x="777240" y="1965960"/>
-          <a:ext cx="10634472" cy="3867912"/>
+          <a:off x="777240" y="1938528"/>
+          <a:ext cx="10634472" cy="3291840"/>
         </p:xfrm>
         <a:graphic>
           <a:graphicData uri="http://schemas.openxmlformats.org/drawingml/2006/table">
@@ -19788,7 +19788,7 @@
                 <a:gridCol w="3657600"/>
                 <a:gridCol w="1673352"/>
               </a:tblGrid>
-              <a:tr h="429768">
+              <a:tr h="365760">
                 <a:tc>
                   <a:txBody>
                     <a:bodyPr/>
@@ -19800,7 +19800,7 @@
                         </a:lnSpc>
                       </a:pPr>
                       <a:r>
-                        <a:rPr sz="1250" b="1">
+                        <a:rPr sz="1200" b="1">
                           <a:solidFill>
                             <a:srgbClr val="FFFFFF"/>
                           </a:solidFill>
@@ -19829,7 +19829,7 @@
                         </a:lnSpc>
                       </a:pPr>
                       <a:r>
-                        <a:rPr sz="1250" b="1">
+                        <a:rPr sz="1200" b="1">
                           <a:solidFill>
                             <a:srgbClr val="FFFFFF"/>
                           </a:solidFill>
@@ -19858,7 +19858,7 @@
                         </a:lnSpc>
                       </a:pPr>
                       <a:r>
-                        <a:rPr sz="1250" b="1">
+                        <a:rPr sz="1200" b="1">
                           <a:solidFill>
                             <a:srgbClr val="FFFFFF"/>
                           </a:solidFill>
@@ -19887,7 +19887,7 @@
                         </a:lnSpc>
                       </a:pPr>
                       <a:r>
-                        <a:rPr sz="1250" b="1">
+                        <a:rPr sz="1200" b="1">
                           <a:solidFill>
                             <a:srgbClr val="FFFFFF"/>
                           </a:solidFill>
@@ -19906,7 +19906,7 @@
                   </a:tcPr>
                 </a:tc>
               </a:tr>
-              <a:tr h="429768">
+              <a:tr h="365760">
                 <a:tc>
                   <a:txBody>
                     <a:bodyPr/>
@@ -19918,7 +19918,7 @@
                         </a:lnSpc>
                       </a:pPr>
                       <a:r>
-                        <a:rPr sz="1250" b="0">
+                        <a:rPr sz="1200" b="0">
                           <a:solidFill>
                             <a:srgbClr val="292929"/>
                           </a:solidFill>
@@ -19947,7 +19947,7 @@
                         </a:lnSpc>
                       </a:pPr>
                       <a:r>
-                        <a:rPr sz="1250" b="0">
+                        <a:rPr sz="1200" b="0">
                           <a:solidFill>
                             <a:srgbClr val="292929"/>
                           </a:solidFill>
@@ -19976,7 +19976,7 @@
                         </a:lnSpc>
                       </a:pPr>
                       <a:r>
-                        <a:rPr sz="1250" b="0">
+                        <a:rPr sz="1200" b="0">
                           <a:solidFill>
                             <a:srgbClr val="292929"/>
                           </a:solidFill>
@@ -20005,7 +20005,7 @@
                         </a:lnSpc>
                       </a:pPr>
                       <a:r>
-                        <a:rPr sz="1250" b="0">
+                        <a:rPr sz="1200" b="0">
                           <a:solidFill>
                             <a:srgbClr val="292929"/>
                           </a:solidFill>
@@ -20024,7 +20024,7 @@
                   </a:tcPr>
                 </a:tc>
               </a:tr>
-              <a:tr h="429768">
+              <a:tr h="365760">
                 <a:tc>
                   <a:txBody>
                     <a:bodyPr/>
@@ -20036,7 +20036,7 @@
                         </a:lnSpc>
                       </a:pPr>
                       <a:r>
-                        <a:rPr sz="1250" b="0">
+                        <a:rPr sz="1200" b="0">
                           <a:solidFill>
                             <a:srgbClr val="292929"/>
                           </a:solidFill>
@@ -20065,7 +20065,7 @@
                         </a:lnSpc>
                       </a:pPr>
                       <a:r>
-                        <a:rPr sz="1250" b="0">
+                        <a:rPr sz="1200" b="0">
                           <a:solidFill>
                             <a:srgbClr val="292929"/>
                           </a:solidFill>
@@ -20094,7 +20094,7 @@
                         </a:lnSpc>
                       </a:pPr>
                       <a:r>
-                        <a:rPr sz="1250" b="0">
+                        <a:rPr sz="1200" b="0">
                           <a:solidFill>
                             <a:srgbClr val="292929"/>
                           </a:solidFill>
@@ -20123,7 +20123,7 @@
                         </a:lnSpc>
                       </a:pPr>
                       <a:r>
-                        <a:rPr sz="1250" b="0">
+                        <a:rPr sz="1200" b="0">
                           <a:solidFill>
                             <a:srgbClr val="292929"/>
                           </a:solidFill>
@@ -20142,7 +20142,7 @@
                   </a:tcPr>
                 </a:tc>
               </a:tr>
-              <a:tr h="429768">
+              <a:tr h="365760">
                 <a:tc>
                   <a:txBody>
                     <a:bodyPr/>
@@ -20154,7 +20154,7 @@
                         </a:lnSpc>
                       </a:pPr>
                       <a:r>
-                        <a:rPr sz="1250" b="0">
+                        <a:rPr sz="1200" b="0">
                           <a:solidFill>
                             <a:srgbClr val="292929"/>
                           </a:solidFill>
@@ -20183,7 +20183,7 @@
                         </a:lnSpc>
                       </a:pPr>
                       <a:r>
-                        <a:rPr sz="1250" b="0">
+                        <a:rPr sz="1200" b="0">
                           <a:solidFill>
                             <a:srgbClr val="292929"/>
                           </a:solidFill>
@@ -20212,7 +20212,7 @@
                         </a:lnSpc>
                       </a:pPr>
                       <a:r>
-                        <a:rPr sz="1250" b="0">
+                        <a:rPr sz="1200" b="0">
                           <a:solidFill>
                             <a:srgbClr val="292929"/>
                           </a:solidFill>
@@ -20241,7 +20241,7 @@
                         </a:lnSpc>
                       </a:pPr>
                       <a:r>
-                        <a:rPr sz="1250" b="0">
+                        <a:rPr sz="1200" b="0">
                           <a:solidFill>
                             <a:srgbClr val="292929"/>
                           </a:solidFill>
@@ -20260,7 +20260,7 @@
                   </a:tcPr>
                 </a:tc>
               </a:tr>
-              <a:tr h="429768">
+              <a:tr h="365760">
                 <a:tc>
                   <a:txBody>
                     <a:bodyPr/>
@@ -20272,7 +20272,7 @@
                         </a:lnSpc>
                       </a:pPr>
                       <a:r>
-                        <a:rPr sz="1250" b="0">
+                        <a:rPr sz="1200" b="0">
                           <a:solidFill>
                             <a:srgbClr val="292929"/>
                           </a:solidFill>
@@ -20301,7 +20301,7 @@
                         </a:lnSpc>
                       </a:pPr>
                       <a:r>
-                        <a:rPr sz="1250" b="0">
+                        <a:rPr sz="1200" b="0">
                           <a:solidFill>
                             <a:srgbClr val="292929"/>
                           </a:solidFill>
@@ -20330,7 +20330,7 @@
                         </a:lnSpc>
                       </a:pPr>
                       <a:r>
-                        <a:rPr sz="1250" b="0">
+                        <a:rPr sz="1200" b="0">
                           <a:solidFill>
                             <a:srgbClr val="292929"/>
                           </a:solidFill>
@@ -20359,7 +20359,7 @@
                         </a:lnSpc>
                       </a:pPr>
                       <a:r>
-                        <a:rPr sz="1250" b="0">
+                        <a:rPr sz="1200" b="0">
                           <a:solidFill>
                             <a:srgbClr val="292929"/>
                           </a:solidFill>
@@ -20378,7 +20378,7 @@
                   </a:tcPr>
                 </a:tc>
               </a:tr>
-              <a:tr h="429768">
+              <a:tr h="365760">
                 <a:tc>
                   <a:txBody>
                     <a:bodyPr/>
@@ -20390,7 +20390,7 @@
                         </a:lnSpc>
                       </a:pPr>
                       <a:r>
-                        <a:rPr sz="1250" b="0">
+                        <a:rPr sz="1200" b="0">
                           <a:solidFill>
                             <a:srgbClr val="292929"/>
                           </a:solidFill>
@@ -20419,7 +20419,7 @@
                         </a:lnSpc>
                       </a:pPr>
                       <a:r>
-                        <a:rPr sz="1250" b="0">
+                        <a:rPr sz="1200" b="0">
                           <a:solidFill>
                             <a:srgbClr val="292929"/>
                           </a:solidFill>
@@ -20448,7 +20448,7 @@
                         </a:lnSpc>
                       </a:pPr>
                       <a:r>
-                        <a:rPr sz="1250" b="0">
+                        <a:rPr sz="1200" b="0">
                           <a:solidFill>
                             <a:srgbClr val="292929"/>
                           </a:solidFill>
@@ -20477,7 +20477,7 @@
                         </a:lnSpc>
                       </a:pPr>
                       <a:r>
-                        <a:rPr sz="1250" b="0">
+                        <a:rPr sz="1200" b="0">
                           <a:solidFill>
                             <a:srgbClr val="292929"/>
                           </a:solidFill>
@@ -20496,7 +20496,7 @@
                   </a:tcPr>
                 </a:tc>
               </a:tr>
-              <a:tr h="429768">
+              <a:tr h="365760">
                 <a:tc>
                   <a:txBody>
                     <a:bodyPr/>
@@ -20508,7 +20508,7 @@
                         </a:lnSpc>
                       </a:pPr>
                       <a:r>
-                        <a:rPr sz="1250" b="0">
+                        <a:rPr sz="1200" b="0">
                           <a:solidFill>
                             <a:srgbClr val="292929"/>
                           </a:solidFill>
@@ -20537,7 +20537,7 @@
                         </a:lnSpc>
                       </a:pPr>
                       <a:r>
-                        <a:rPr sz="1250" b="0">
+                        <a:rPr sz="1200" b="0">
                           <a:solidFill>
                             <a:srgbClr val="292929"/>
                           </a:solidFill>
@@ -20566,7 +20566,7 @@
                         </a:lnSpc>
                       </a:pPr>
                       <a:r>
-                        <a:rPr sz="1250" b="0">
+                        <a:rPr sz="1200" b="0">
                           <a:solidFill>
                             <a:srgbClr val="292929"/>
                           </a:solidFill>
@@ -20595,7 +20595,7 @@
                         </a:lnSpc>
                       </a:pPr>
                       <a:r>
-                        <a:rPr sz="1250" b="0">
+                        <a:rPr sz="1200" b="0">
                           <a:solidFill>
                             <a:srgbClr val="292929"/>
                           </a:solidFill>
@@ -20614,7 +20614,7 @@
                   </a:tcPr>
                 </a:tc>
               </a:tr>
-              <a:tr h="429768">
+              <a:tr h="365760">
                 <a:tc>
                   <a:txBody>
                     <a:bodyPr/>
@@ -20626,7 +20626,7 @@
                         </a:lnSpc>
                       </a:pPr>
                       <a:r>
-                        <a:rPr sz="1250" b="0">
+                        <a:rPr sz="1200" b="0">
                           <a:solidFill>
                             <a:srgbClr val="292929"/>
                           </a:solidFill>
@@ -20655,7 +20655,7 @@
                         </a:lnSpc>
                       </a:pPr>
                       <a:r>
-                        <a:rPr sz="1250" b="0">
+                        <a:rPr sz="1200" b="0">
                           <a:solidFill>
                             <a:srgbClr val="292929"/>
                           </a:solidFill>
@@ -20684,7 +20684,7 @@
                         </a:lnSpc>
                       </a:pPr>
                       <a:r>
-                        <a:rPr sz="1250" b="0">
+                        <a:rPr sz="1200" b="0">
                           <a:solidFill>
                             <a:srgbClr val="292929"/>
                           </a:solidFill>
@@ -20713,7 +20713,7 @@
                         </a:lnSpc>
                       </a:pPr>
                       <a:r>
-                        <a:rPr sz="1250" b="0">
+                        <a:rPr sz="1200" b="0">
                           <a:solidFill>
                             <a:srgbClr val="292929"/>
                           </a:solidFill>
@@ -20732,7 +20732,7 @@
                   </a:tcPr>
                 </a:tc>
               </a:tr>
-              <a:tr h="429768">
+              <a:tr h="365760">
                 <a:tc>
                   <a:txBody>
                     <a:bodyPr/>
@@ -20744,7 +20744,7 @@
                         </a:lnSpc>
                       </a:pPr>
                       <a:r>
-                        <a:rPr sz="1250" b="0">
+                        <a:rPr sz="1200" b="0">
                           <a:solidFill>
                             <a:srgbClr val="292929"/>
                           </a:solidFill>
@@ -20773,7 +20773,7 @@
                         </a:lnSpc>
                       </a:pPr>
                       <a:r>
-                        <a:rPr sz="1250" b="0">
+                        <a:rPr sz="1200" b="0">
                           <a:solidFill>
                             <a:srgbClr val="292929"/>
                           </a:solidFill>
@@ -20802,7 +20802,7 @@
                         </a:lnSpc>
                       </a:pPr>
                       <a:r>
-                        <a:rPr sz="1250" b="0">
+                        <a:rPr sz="1200" b="0">
                           <a:solidFill>
                             <a:srgbClr val="292929"/>
                           </a:solidFill>
@@ -20831,7 +20831,7 @@
                         </a:lnSpc>
                       </a:pPr>
                       <a:r>
-                        <a:rPr sz="1250" b="0">
+                        <a:rPr sz="1200" b="0">
                           <a:solidFill>
                             <a:srgbClr val="292929"/>
                           </a:solidFill>
@@ -20856,14 +20856,58 @@
       </p:graphicFrame>
       <p:sp>
         <p:nvSpPr>
-          <p:cNvPr id="6" name="TextBox 5"/>
+          <p:cNvPr id="6" name="Rectangle 5"/>
+          <p:cNvSpPr/>
+          <p:nvPr/>
+        </p:nvSpPr>
+        <p:spPr>
+          <a:xfrm>
+            <a:off x="777240" y="5349240"/>
+            <a:ext cx="10634472" cy="685800"/>
+          </a:xfrm>
+          <a:prstGeom prst="rect">
+            <a:avLst/>
+          </a:prstGeom>
+          <a:solidFill>
+            <a:srgbClr val="F2F0FF"/>
+          </a:solidFill>
+          <a:ln>
+            <a:noFill/>
+          </a:ln>
+          <a:effectLst/>
+        </p:spPr>
+        <p:style>
+          <a:lnRef idx="1">
+            <a:schemeClr val="accent1"/>
+          </a:lnRef>
+          <a:fillRef idx="3">
+            <a:schemeClr val="accent1"/>
+          </a:fillRef>
+          <a:effectRef idx="2">
+            <a:schemeClr val="accent1"/>
+          </a:effectRef>
+          <a:fontRef idx="minor">
+            <a:schemeClr val="lt1"/>
+          </a:fontRef>
+        </p:style>
+        <p:txBody>
+          <a:bodyPr rtlCol="0" anchor="ctr" wrap="square"/>
+          <a:lstStyle/>
+          <a:p>
+            <a:pPr algn="ctr"/>
+          </a:p>
+        </p:txBody>
+      </p:sp>
+      <p:sp>
+        <p:nvSpPr>
+          <p:cNvPr id="7" name="TextBox 6"/>
           <p:cNvSpPr txBox="1"/>
           <p:nvPr/>
         </p:nvSpPr>
         <p:spPr>
           <a:xfrm>
-            <a:off x="777240" y="6455664"/>
-            <a:ext cx="9509760" cy="256032"/>
+            <a:off x="1051560" y="5477256"/>
+            <a:ext cx="10241280" cy="502920"/>
           </a:xfrm>
           <a:prstGeom prst="rect">
             <a:avLst/>
@@ -20888,6 +20932,77 @@
               </a:spcAft>
             </a:pPr>
             <a:r>
+              <a:rPr sz="1400" b="1">
+                <a:solidFill>
+                  <a:srgbClr val="6C4CFF"/>
+                </a:solidFill>
+                <a:latin typeface="Pretendard"/>
+                <a:ea typeface="Pretendard"/>
+                <a:cs typeface="Pretendard"/>
+              </a:rPr>
+              <a:t>1·2번은 오늘, 3~5번은 이번 주, 6~8번은 이번 달 안에 처리하면 됩니다.</a:t>
+            </a:r>
+          </a:p>
+          <a:p>
+            <a:pPr>
+              <a:lnSpc>
+                <a:spcPct val="135000"/>
+              </a:lnSpc>
+              <a:spcBef>
+                <a:spcPts val="400"/>
+              </a:spcBef>
+              <a:spcAft>
+                <a:spcPts val="0"/>
+              </a:spcAft>
+            </a:pPr>
+            <a:r>
+              <a:rPr sz="1250" b="0">
+                <a:solidFill>
+                  <a:srgbClr val="292929"/>
+                </a:solidFill>
+                <a:latin typeface="Pretendard"/>
+                <a:ea typeface="Pretendard"/>
+                <a:cs typeface="Pretendard"/>
+              </a:rPr>
+              <a:t>그 뒤에 A안을 저장소 1개에 시범 적용해보고, 효과가 확인되면 B(_core)와 D(플러그인)로 확장합니다.</a:t>
+            </a:r>
+          </a:p>
+        </p:txBody>
+      </p:sp>
+      <p:sp>
+        <p:nvSpPr>
+          <p:cNvPr id="8" name="TextBox 7"/>
+          <p:cNvSpPr txBox="1"/>
+          <p:nvPr/>
+        </p:nvSpPr>
+        <p:spPr>
+          <a:xfrm>
+            <a:off x="777240" y="6455664"/>
+            <a:ext cx="9509760" cy="256032"/>
+          </a:xfrm>
+          <a:prstGeom prst="rect">
+            <a:avLst/>
+          </a:prstGeom>
+          <a:noFill/>
+        </p:spPr>
+        <p:txBody>
+          <a:bodyPr wrap="square" lIns="0" rIns="0" tIns="0" bIns="0" anchor="t">
+            <a:spAutoFit/>
+          </a:bodyPr>
+          <a:lstStyle/>
+          <a:p>
+            <a:pPr algn="l">
+              <a:lnSpc>
+                <a:spcPct val="135000"/>
+              </a:lnSpc>
+              <a:spcBef>
+                <a:spcPts val="0"/>
+              </a:spcBef>
+              <a:spcAft>
+                <a:spcPts val="0"/>
+              </a:spcAft>
+            </a:pPr>
+            <a:r>
               <a:rPr sz="1000" b="0">
                 <a:solidFill>
                   <a:srgbClr val="9A9A9A"/>
@@ -20903,7 +21018,7 @@
       </p:sp>
       <p:sp>
         <p:nvSpPr>
-          <p:cNvPr id="7" name="TextBox 6"/>
+          <p:cNvPr id="9" name="TextBox 8"/>
           <p:cNvSpPr txBox="1"/>
           <p:nvPr/>
         </p:nvSpPr>

</xml_diff>

<commit_message>
vault backup: 2026-08-09 22:39:50
</commit_message>
<xml_diff>
--- a/CdBd 문서 체계 진단 및 개편 제안.pptx
+++ b/CdBd 문서 체계 진단 및 개편 제안.pptx
@@ -6424,7 +6424,7 @@
         </p:nvSpPr>
         <p:spPr>
           <a:xfrm>
-            <a:off x="777240" y="4681728"/>
+            <a:off x="777240" y="4590288"/>
             <a:ext cx="10607040" cy="274320"/>
           </a:xfrm>
           <a:prstGeom prst="rect">
@@ -6471,8 +6471,8 @@
         </p:nvSpPr>
         <p:spPr>
           <a:xfrm>
-            <a:off x="777240" y="5047488"/>
-            <a:ext cx="10634472" cy="960120"/>
+            <a:off x="777240" y="4937760"/>
+            <a:ext cx="10634472" cy="1024128"/>
           </a:xfrm>
           <a:prstGeom prst="rect">
             <a:avLst/>
@@ -6515,8 +6515,8 @@
         </p:nvSpPr>
         <p:spPr>
           <a:xfrm>
-            <a:off x="1051560" y="5193792"/>
-            <a:ext cx="10058400" cy="731520"/>
+            <a:off x="1051560" y="5074920"/>
+            <a:ext cx="10058400" cy="822960"/>
           </a:xfrm>
           <a:prstGeom prst="rect">
             <a:avLst/>
@@ -6610,7 +6610,7 @@
         </p:nvSpPr>
         <p:spPr>
           <a:xfrm>
-            <a:off x="777240" y="6108192"/>
+            <a:off x="777240" y="6053328"/>
             <a:ext cx="10607040" cy="274320"/>
           </a:xfrm>
           <a:prstGeom prst="rect">

</xml_diff>

<commit_message>
vault backup: 2026-08-09 22:54:52
</commit_message>
<xml_diff>
--- a/CdBd 문서 체계 진단 및 개편 제안.pptx
+++ b/CdBd 문서 체계 진단 및 개편 제안.pptx
@@ -12480,7 +12480,7 @@
                 <a:ea typeface="Pretendard"/>
                 <a:cs typeface="Pretendard"/>
               </a:rPr>
-              <a:t>저는 A + B + D 를 추천합니다</a:t>
+              <a:t>저는 A + D 를 추천합니다</a:t>
             </a:r>
           </a:p>
         </p:txBody>
@@ -12527,7 +12527,7 @@
                 <a:ea typeface="Pretendard"/>
                 <a:cs typeface="Pretendard"/>
               </a:rPr>
-              <a:t>기본 정리(A) 위에, 정본은 _core로 묶고(B), 전달은 플러그인으로(D). C는 보류합니다.</a:t>
+              <a:t>기본 정리(A) 위에, 전달은 플러그인으로(D). B와 C는 지금은 보류합니다.</a:t>
             </a:r>
           </a:p>
         </p:txBody>
@@ -12540,8 +12540,8 @@
         </p:nvSpPr>
         <p:spPr>
           <a:xfrm>
-            <a:off x="777240" y="2148840"/>
-            <a:ext cx="2743200" cy="1143000"/>
+            <a:off x="777240" y="2121408"/>
+            <a:ext cx="3611880" cy="1188720"/>
           </a:xfrm>
           <a:prstGeom prst="rect">
             <a:avLst/>
@@ -12586,8 +12586,8 @@
         </p:nvSpPr>
         <p:spPr>
           <a:xfrm>
-            <a:off x="777240" y="2304288"/>
-            <a:ext cx="2743200" cy="228600"/>
+            <a:off x="777240" y="2249424"/>
+            <a:ext cx="3611880" cy="228600"/>
           </a:xfrm>
           <a:prstGeom prst="rect">
             <a:avLst/>
@@ -12633,8 +12633,8 @@
         </p:nvSpPr>
         <p:spPr>
           <a:xfrm>
-            <a:off x="777240" y="2542032"/>
-            <a:ext cx="2743200" cy="274320"/>
+            <a:off x="777240" y="2468880"/>
+            <a:ext cx="3611880" cy="274320"/>
           </a:xfrm>
           <a:prstGeom prst="rect">
             <a:avLst/>
@@ -12659,7 +12659,7 @@
               </a:spcAft>
             </a:pPr>
             <a:r>
-              <a:rPr sz="1700" b="1">
+              <a:rPr sz="1800" b="1">
                 <a:solidFill>
                   <a:srgbClr val="292929"/>
                 </a:solidFill>
@@ -12680,8 +12680,8 @@
         </p:nvSpPr>
         <p:spPr>
           <a:xfrm>
-            <a:off x="777240" y="2880360"/>
-            <a:ext cx="2743200" cy="228600"/>
+            <a:off x="777240" y="2798064"/>
+            <a:ext cx="3611880" cy="457200"/>
           </a:xfrm>
           <a:prstGeom prst="rect">
             <a:avLst/>
@@ -12696,7 +12696,7 @@
           <a:p>
             <a:pPr algn="ctr">
               <a:lnSpc>
-                <a:spcPct val="135000"/>
+                <a:spcPct val="140000"/>
               </a:lnSpc>
               <a:spcBef>
                 <a:spcPts val="0"/>
@@ -12714,7 +12714,31 @@
                 <a:ea typeface="Pretendard"/>
                 <a:cs typeface="Pretendard"/>
               </a:rPr>
-              <a:t>안내판·스킬·링크</a:t>
+              <a:t>안내판 · 스킬 · 링크</a:t>
+            </a:r>
+          </a:p>
+          <a:p>
+            <a:pPr algn="ctr">
+              <a:lnSpc>
+                <a:spcPct val="140000"/>
+              </a:lnSpc>
+              <a:spcBef>
+                <a:spcPts val="0"/>
+              </a:spcBef>
+              <a:spcAft>
+                <a:spcPts val="0"/>
+              </a:spcAft>
+            </a:pPr>
+            <a:r>
+              <a:rPr sz="1150" b="0">
+                <a:solidFill>
+                  <a:srgbClr val="6B6B6B"/>
+                </a:solidFill>
+                <a:latin typeface="Pretendard"/>
+                <a:ea typeface="Pretendard"/>
+                <a:cs typeface="Pretendard"/>
+              </a:rPr>
+              <a:t>＋ 브랜드 값 1회 통일</a:t>
             </a:r>
           </a:p>
         </p:txBody>
@@ -12727,8 +12751,8 @@
         </p:nvSpPr>
         <p:spPr>
           <a:xfrm>
-            <a:off x="3520440" y="2578608"/>
-            <a:ext cx="320040" cy="274320"/>
+            <a:off x="4389120" y="2578608"/>
+            <a:ext cx="365760" cy="274320"/>
           </a:xfrm>
           <a:prstGeom prst="rect">
             <a:avLst/>
@@ -12774,8 +12798,8 @@
         </p:nvSpPr>
         <p:spPr>
           <a:xfrm>
-            <a:off x="3840480" y="2148840"/>
-            <a:ext cx="2743200" cy="1143000"/>
+            <a:off x="4754879" y="2121408"/>
+            <a:ext cx="3611880" cy="1188720"/>
           </a:xfrm>
           <a:prstGeom prst="rect">
             <a:avLst/>
@@ -12820,8 +12844,8 @@
         </p:nvSpPr>
         <p:spPr>
           <a:xfrm>
-            <a:off x="3840480" y="2304288"/>
-            <a:ext cx="2743200" cy="228600"/>
+            <a:off x="4754879" y="2249424"/>
+            <a:ext cx="3611880" cy="228600"/>
           </a:xfrm>
           <a:prstGeom prst="rect">
             <a:avLst/>
@@ -12854,7 +12878,7 @@
                 <a:ea typeface="Pretendard"/>
                 <a:cs typeface="Pretendard"/>
               </a:rPr>
-              <a:t>B안</a:t>
+              <a:t>D안</a:t>
             </a:r>
           </a:p>
         </p:txBody>
@@ -12867,8 +12891,8 @@
         </p:nvSpPr>
         <p:spPr>
           <a:xfrm>
-            <a:off x="3840480" y="2542032"/>
-            <a:ext cx="2743200" cy="274320"/>
+            <a:off x="4754879" y="2468880"/>
+            <a:ext cx="3611880" cy="274320"/>
           </a:xfrm>
           <a:prstGeom prst="rect">
             <a:avLst/>
@@ -12893,7 +12917,7 @@
               </a:spcAft>
             </a:pPr>
             <a:r>
-              <a:rPr sz="1700" b="1">
+              <a:rPr sz="1800" b="1">
                 <a:solidFill>
                   <a:srgbClr val="292929"/>
                 </a:solidFill>
@@ -12901,7 +12925,7 @@
                 <a:ea typeface="Pretendard"/>
                 <a:cs typeface="Pretendard"/>
               </a:rPr>
-              <a:t>정본 단일화</a:t>
+              <a:t>볼트 밖 배포</a:t>
             </a:r>
           </a:p>
         </p:txBody>
@@ -12914,8 +12938,8 @@
         </p:nvSpPr>
         <p:spPr>
           <a:xfrm>
-            <a:off x="3840480" y="2880360"/>
-            <a:ext cx="2743200" cy="228600"/>
+            <a:off x="4754879" y="2798064"/>
+            <a:ext cx="3611880" cy="457200"/>
           </a:xfrm>
           <a:prstGeom prst="rect">
             <a:avLst/>
@@ -12930,7 +12954,7 @@
           <a:p>
             <a:pPr algn="ctr">
               <a:lnSpc>
-                <a:spcPct val="135000"/>
+                <a:spcPct val="140000"/>
               </a:lnSpc>
               <a:spcBef>
                 <a:spcPts val="0"/>
@@ -12948,255 +12972,45 @@
                 <a:ea typeface="Pretendard"/>
                 <a:cs typeface="Pretendard"/>
               </a:rPr>
-              <a:t>cdbd-core + _core/</a:t>
-            </a:r>
-          </a:p>
-        </p:txBody>
-      </p:sp>
-      <p:sp>
-        <p:nvSpPr>
-          <p:cNvPr id="15" name="TextBox 14"/>
-          <p:cNvSpPr txBox="1"/>
-          <p:nvPr/>
-        </p:nvSpPr>
-        <p:spPr>
-          <a:xfrm>
-            <a:off x="6583680" y="2578608"/>
-            <a:ext cx="320040" cy="274320"/>
-          </a:xfrm>
-          <a:prstGeom prst="rect">
-            <a:avLst/>
-          </a:prstGeom>
-          <a:noFill/>
-        </p:spPr>
-        <p:txBody>
-          <a:bodyPr wrap="square" lIns="0" rIns="0" tIns="0" bIns="0" anchor="t">
-            <a:spAutoFit/>
-          </a:bodyPr>
-          <a:lstStyle/>
+              <a:t>cdbd-plugin</a:t>
+            </a:r>
+          </a:p>
           <a:p>
             <a:pPr algn="ctr">
               <a:lnSpc>
-                <a:spcPct val="135000"/>
-              </a:lnSpc>
-              <a:spcBef>
-                <a:spcPts val="0"/>
-              </a:spcBef>
-              <a:spcAft>
-                <a:spcPts val="0"/>
-              </a:spcAft>
-            </a:pPr>
-            <a:r>
-              <a:rPr sz="1800" b="1">
-                <a:solidFill>
-                  <a:srgbClr val="9A9A9A"/>
-                </a:solidFill>
-                <a:latin typeface="Pretendard"/>
-                <a:ea typeface="Pretendard"/>
-                <a:cs typeface="Pretendard"/>
-              </a:rPr>
-              <a:t>＋</a:t>
-            </a:r>
-          </a:p>
-        </p:txBody>
-      </p:sp>
-      <p:sp>
-        <p:nvSpPr>
-          <p:cNvPr id="16" name="Rectangle 15"/>
+                <a:spcPct val="140000"/>
+              </a:lnSpc>
+              <a:spcBef>
+                <a:spcPts val="0"/>
+              </a:spcBef>
+              <a:spcAft>
+                <a:spcPts val="0"/>
+              </a:spcAft>
+            </a:pPr>
+            <a:r>
+              <a:rPr sz="1150" b="0">
+                <a:solidFill>
+                  <a:srgbClr val="6B6B6B"/>
+                </a:solidFill>
+                <a:latin typeface="Pretendard"/>
+                <a:ea typeface="Pretendard"/>
+                <a:cs typeface="Pretendard"/>
+              </a:rPr>
+              <a:t>＋ 값 어긋남 자동 점검</a:t>
+            </a:r>
+          </a:p>
+        </p:txBody>
+      </p:sp>
+      <p:sp>
+        <p:nvSpPr>
+          <p:cNvPr id="15" name="Rectangle 14"/>
           <p:cNvSpPr/>
           <p:nvPr/>
         </p:nvSpPr>
         <p:spPr>
           <a:xfrm>
-            <a:off x="6903720" y="2148840"/>
-            <a:ext cx="2743200" cy="1143000"/>
-          </a:xfrm>
-          <a:prstGeom prst="rect">
-            <a:avLst/>
-          </a:prstGeom>
-          <a:solidFill>
-            <a:srgbClr val="F2F0FF"/>
-          </a:solidFill>
-          <a:ln w="19050">
-            <a:solidFill>
-              <a:srgbClr val="6C4CFF"/>
-            </a:solidFill>
-          </a:ln>
-          <a:effectLst/>
-        </p:spPr>
-        <p:style>
-          <a:lnRef idx="1">
-            <a:schemeClr val="accent1"/>
-          </a:lnRef>
-          <a:fillRef idx="3">
-            <a:schemeClr val="accent1"/>
-          </a:fillRef>
-          <a:effectRef idx="2">
-            <a:schemeClr val="accent1"/>
-          </a:effectRef>
-          <a:fontRef idx="minor">
-            <a:schemeClr val="lt1"/>
-          </a:fontRef>
-        </p:style>
-        <p:txBody>
-          <a:bodyPr rtlCol="0" anchor="ctr" wrap="square"/>
-          <a:lstStyle/>
-          <a:p>
-            <a:pPr algn="ctr"/>
-          </a:p>
-        </p:txBody>
-      </p:sp>
-      <p:sp>
-        <p:nvSpPr>
-          <p:cNvPr id="17" name="TextBox 16"/>
-          <p:cNvSpPr txBox="1"/>
-          <p:nvPr/>
-        </p:nvSpPr>
-        <p:spPr>
-          <a:xfrm>
-            <a:off x="6903720" y="2304288"/>
-            <a:ext cx="2743200" cy="228600"/>
-          </a:xfrm>
-          <a:prstGeom prst="rect">
-            <a:avLst/>
-          </a:prstGeom>
-          <a:noFill/>
-        </p:spPr>
-        <p:txBody>
-          <a:bodyPr wrap="square" lIns="0" rIns="0" tIns="0" bIns="0" anchor="t">
-            <a:spAutoFit/>
-          </a:bodyPr>
-          <a:lstStyle/>
-          <a:p>
-            <a:pPr algn="ctr">
-              <a:lnSpc>
-                <a:spcPct val="135000"/>
-              </a:lnSpc>
-              <a:spcBef>
-                <a:spcPts val="0"/>
-              </a:spcBef>
-              <a:spcAft>
-                <a:spcPts val="0"/>
-              </a:spcAft>
-            </a:pPr>
-            <a:r>
-              <a:rPr sz="1200" b="1">
-                <a:solidFill>
-                  <a:srgbClr val="6C4CFF"/>
-                </a:solidFill>
-                <a:latin typeface="Pretendard"/>
-                <a:ea typeface="Pretendard"/>
-                <a:cs typeface="Pretendard"/>
-              </a:rPr>
-              <a:t>D안</a:t>
-            </a:r>
-          </a:p>
-        </p:txBody>
-      </p:sp>
-      <p:sp>
-        <p:nvSpPr>
-          <p:cNvPr id="18" name="TextBox 17"/>
-          <p:cNvSpPr txBox="1"/>
-          <p:nvPr/>
-        </p:nvSpPr>
-        <p:spPr>
-          <a:xfrm>
-            <a:off x="6903720" y="2542032"/>
-            <a:ext cx="2743200" cy="274320"/>
-          </a:xfrm>
-          <a:prstGeom prst="rect">
-            <a:avLst/>
-          </a:prstGeom>
-          <a:noFill/>
-        </p:spPr>
-        <p:txBody>
-          <a:bodyPr wrap="square" lIns="0" rIns="0" tIns="0" bIns="0" anchor="t">
-            <a:spAutoFit/>
-          </a:bodyPr>
-          <a:lstStyle/>
-          <a:p>
-            <a:pPr algn="ctr">
-              <a:lnSpc>
-                <a:spcPct val="135000"/>
-              </a:lnSpc>
-              <a:spcBef>
-                <a:spcPts val="0"/>
-              </a:spcBef>
-              <a:spcAft>
-                <a:spcPts val="0"/>
-              </a:spcAft>
-            </a:pPr>
-            <a:r>
-              <a:rPr sz="1700" b="1">
-                <a:solidFill>
-                  <a:srgbClr val="292929"/>
-                </a:solidFill>
-                <a:latin typeface="Pretendard"/>
-                <a:ea typeface="Pretendard"/>
-                <a:cs typeface="Pretendard"/>
-              </a:rPr>
-              <a:t>볼트 밖 배포</a:t>
-            </a:r>
-          </a:p>
-        </p:txBody>
-      </p:sp>
-      <p:sp>
-        <p:nvSpPr>
-          <p:cNvPr id="19" name="TextBox 18"/>
-          <p:cNvSpPr txBox="1"/>
-          <p:nvPr/>
-        </p:nvSpPr>
-        <p:spPr>
-          <a:xfrm>
-            <a:off x="6903720" y="2880360"/>
-            <a:ext cx="2743200" cy="228600"/>
-          </a:xfrm>
-          <a:prstGeom prst="rect">
-            <a:avLst/>
-          </a:prstGeom>
-          <a:noFill/>
-        </p:spPr>
-        <p:txBody>
-          <a:bodyPr wrap="square" lIns="0" rIns="0" tIns="0" bIns="0" anchor="t">
-            <a:spAutoFit/>
-          </a:bodyPr>
-          <a:lstStyle/>
-          <a:p>
-            <a:pPr algn="ctr">
-              <a:lnSpc>
-                <a:spcPct val="135000"/>
-              </a:lnSpc>
-              <a:spcBef>
-                <a:spcPts val="0"/>
-              </a:spcBef>
-              <a:spcAft>
-                <a:spcPts val="0"/>
-              </a:spcAft>
-            </a:pPr>
-            <a:r>
-              <a:rPr sz="1150" b="0">
-                <a:solidFill>
-                  <a:srgbClr val="6B6B6B"/>
-                </a:solidFill>
-                <a:latin typeface="Pretendard"/>
-                <a:ea typeface="Pretendard"/>
-                <a:cs typeface="Pretendard"/>
-              </a:rPr>
-              <a:t>cdbd-plugin</a:t>
-            </a:r>
-          </a:p>
-        </p:txBody>
-      </p:sp>
-      <p:sp>
-        <p:nvSpPr>
-          <p:cNvPr id="20" name="Rectangle 19"/>
-          <p:cNvSpPr/>
-          <p:nvPr/>
-        </p:nvSpPr>
-        <p:spPr>
-          <a:xfrm>
-            <a:off x="9966960" y="2148840"/>
-            <a:ext cx="1444752" cy="1143000"/>
+            <a:off x="8732520" y="2121408"/>
+            <a:ext cx="2679192" cy="1188720"/>
           </a:xfrm>
           <a:prstGeom prst="rect">
             <a:avLst/>
@@ -13233,14 +13047,14 @@
       </p:sp>
       <p:sp>
         <p:nvSpPr>
-          <p:cNvPr id="21" name="TextBox 20"/>
+          <p:cNvPr id="16" name="TextBox 15"/>
           <p:cNvSpPr txBox="1"/>
           <p:nvPr/>
         </p:nvSpPr>
         <p:spPr>
           <a:xfrm>
-            <a:off x="9966960" y="2395728"/>
-            <a:ext cx="1444752" cy="274320"/>
+            <a:off x="8732520" y="2286000"/>
+            <a:ext cx="2679192" cy="228600"/>
           </a:xfrm>
           <a:prstGeom prst="rect">
             <a:avLst/>
@@ -13280,14 +13094,14 @@
       </p:sp>
       <p:sp>
         <p:nvSpPr>
-          <p:cNvPr id="22" name="TextBox 21"/>
+          <p:cNvPr id="17" name="TextBox 16"/>
           <p:cNvSpPr txBox="1"/>
           <p:nvPr/>
         </p:nvSpPr>
         <p:spPr>
           <a:xfrm>
-            <a:off x="9966960" y="2633472"/>
-            <a:ext cx="1444752" cy="320040"/>
+            <a:off x="8732520" y="2505456"/>
+            <a:ext cx="2679192" cy="320040"/>
           </a:xfrm>
           <a:prstGeom prst="rect">
             <a:avLst/>
@@ -13312,7 +13126,7 @@
               </a:spcAft>
             </a:pPr>
             <a:r>
-              <a:rPr sz="1500" b="1">
+              <a:rPr sz="1700" b="1">
                 <a:solidFill>
                   <a:srgbClr val="3DF69B"/>
                 </a:solidFill>
@@ -13327,14 +13141,14 @@
       </p:sp>
       <p:sp>
         <p:nvSpPr>
-          <p:cNvPr id="23" name="TextBox 22"/>
+          <p:cNvPr id="18" name="TextBox 17"/>
           <p:cNvSpPr txBox="1"/>
           <p:nvPr/>
         </p:nvSpPr>
         <p:spPr>
           <a:xfrm>
-            <a:off x="9966960" y="2944368"/>
-            <a:ext cx="1444752" cy="228600"/>
+            <a:off x="8732520" y="2862072"/>
+            <a:ext cx="2679192" cy="365760"/>
           </a:xfrm>
           <a:prstGeom prst="rect">
             <a:avLst/>
@@ -13359,7 +13173,7 @@
               </a:spcAft>
             </a:pPr>
             <a:r>
-              <a:rPr sz="1100" b="0">
+              <a:rPr sz="1000" b="0">
                 <a:solidFill>
                   <a:srgbClr val="FFFFFF"/>
                 </a:solidFill>
@@ -13370,17 +13184,41 @@
               <a:t>전부 해결</a:t>
             </a:r>
           </a:p>
-        </p:txBody>
-      </p:sp>
-      <p:sp>
-        <p:nvSpPr>
-          <p:cNvPr id="24" name="TextBox 23"/>
+          <a:p>
+            <a:pPr algn="ctr">
+              <a:lnSpc>
+                <a:spcPct val="135000"/>
+              </a:lnSpc>
+              <a:spcBef>
+                <a:spcPts val="0"/>
+              </a:spcBef>
+              <a:spcAft>
+                <a:spcPts val="0"/>
+              </a:spcAft>
+            </a:pPr>
+            <a:r>
+              <a:rPr sz="1000" b="0">
+                <a:solidFill>
+                  <a:srgbClr val="FFFFFF"/>
+                </a:solidFill>
+                <a:latin typeface="Pretendard"/>
+                <a:ea typeface="Pretendard"/>
+                <a:cs typeface="Pretendard"/>
+              </a:rPr>
+              <a:t>(③은 자동 점검으로 관리)</a:t>
+            </a:r>
+          </a:p>
+        </p:txBody>
+      </p:sp>
+      <p:sp>
+        <p:nvSpPr>
+          <p:cNvPr id="19" name="TextBox 18"/>
           <p:cNvSpPr txBox="1"/>
           <p:nvPr/>
         </p:nvSpPr>
         <p:spPr>
           <a:xfrm>
-            <a:off x="777240" y="3474720"/>
+            <a:off x="777240" y="3493008"/>
             <a:ext cx="10607040" cy="274320"/>
           </a:xfrm>
           <a:prstGeom prst="rect">
@@ -13421,7 +13259,7 @@
       </p:sp>
       <p:graphicFrame>
         <p:nvGraphicFramePr>
-          <p:cNvPr id="25" name="Table 24"/>
+          <p:cNvPr id="20" name="Table 19"/>
           <p:cNvGraphicFramePr>
             <a:graphicFrameLocks noGrp="1"/>
           </p:cNvGraphicFramePr>
@@ -13429,7 +13267,7 @@
         </p:nvGraphicFramePr>
         <p:xfrm>
           <a:off x="777240" y="3840480"/>
-          <a:ext cx="10634472" cy="1682496"/>
+          <a:ext cx="10634472" cy="1371600"/>
         </p:xfrm>
         <a:graphic>
           <a:graphicData uri="http://schemas.openxmlformats.org/drawingml/2006/table">
@@ -13442,7 +13280,7 @@
                 <a:gridCol w="6949440"/>
                 <a:gridCol w="2587752"/>
               </a:tblGrid>
-              <a:tr h="420624">
+              <a:tr h="457200">
                 <a:tc>
                   <a:txBody>
                     <a:bodyPr/>
@@ -13531,7 +13369,7 @@
                   </a:tcPr>
                 </a:tc>
               </a:tr>
-              <a:tr h="420624">
+              <a:tr h="457200">
                 <a:tc>
                   <a:txBody>
                     <a:bodyPr/>
@@ -13580,96 +13418,7 @@
                           <a:ea typeface="Pretendard"/>
                           <a:cs typeface="Pretendard"/>
                         </a:rPr>
-                        <a:t>원인 ③(정보 갈라짐)이 그대로 → 6개월 뒤 또 갈라짐</a:t>
-                      </a:r>
-                    </a:p>
-                  </a:txBody>
-                  <a:tcPr marL="128016" marR="91440" marT="36576" marB="36576" anchor="ctr">
-                    <a:solidFill>
-                      <a:srgbClr val="FFF6E6"/>
-                    </a:solidFill>
-                  </a:tcPr>
-                </a:tc>
-                <a:tc>
-                  <a:txBody>
-                    <a:bodyPr/>
-                    <a:lstStyle/>
-                    <a:p>
-                      <a:pPr algn="ctr">
-                        <a:lnSpc>
-                          <a:spcPct val="115000"/>
-                        </a:lnSpc>
-                      </a:pPr>
-                      <a:r>
-                        <a:rPr sz="1250" b="0">
-                          <a:solidFill>
-                            <a:srgbClr val="292929"/>
-                          </a:solidFill>
-                          <a:latin typeface="Pretendard"/>
-                          <a:ea typeface="Pretendard"/>
-                          <a:cs typeface="Pretendard"/>
-                        </a:rPr>
-                        <a:t>B가 필요</a:t>
-                      </a:r>
-                    </a:p>
-                  </a:txBody>
-                  <a:tcPr marL="128016" marR="91440" marT="36576" marB="36576" anchor="ctr">
-                    <a:solidFill>
-                      <a:srgbClr val="FFF6E6"/>
-                    </a:solidFill>
-                  </a:tcPr>
-                </a:tc>
-              </a:tr>
-              <a:tr h="420624">
-                <a:tc>
-                  <a:txBody>
-                    <a:bodyPr/>
-                    <a:lstStyle/>
-                    <a:p>
-                      <a:pPr algn="ctr">
-                        <a:lnSpc>
-                          <a:spcPct val="115000"/>
-                        </a:lnSpc>
-                      </a:pPr>
-                      <a:r>
-                        <a:rPr sz="1250" b="0">
-                          <a:solidFill>
-                            <a:srgbClr val="292929"/>
-                          </a:solidFill>
-                          <a:latin typeface="Pretendard"/>
-                          <a:ea typeface="Pretendard"/>
-                          <a:cs typeface="Pretendard"/>
-                        </a:rPr>
-                        <a:t>B만</a:t>
-                      </a:r>
-                    </a:p>
-                  </a:txBody>
-                  <a:tcPr marL="128016" marR="91440" marT="36576" marB="36576" anchor="ctr">
-                    <a:solidFill>
-                      <a:srgbClr val="FFF6E6"/>
-                    </a:solidFill>
-                  </a:tcPr>
-                </a:tc>
-                <a:tc>
-                  <a:txBody>
-                    <a:bodyPr/>
-                    <a:lstStyle/>
-                    <a:p>
-                      <a:pPr algn="l">
-                        <a:lnSpc>
-                          <a:spcPct val="115000"/>
-                        </a:lnSpc>
-                      </a:pPr>
-                      <a:r>
-                        <a:rPr sz="1250" b="0">
-                          <a:solidFill>
-                            <a:srgbClr val="292929"/>
-                          </a:solidFill>
-                          <a:latin typeface="Pretendard"/>
-                          <a:ea typeface="Pretendard"/>
-                          <a:cs typeface="Pretendard"/>
-                        </a:rPr>
-                        <a:t>맨 바깥에서 켜면 여전히 0개 · 3대에 수동 설치</a:t>
+                        <a:t>맨 바깥에서 켜면 여전히 0개 · 3대에 수동 설치 · 새 저장소마다 반복</a:t>
                       </a:r>
                     </a:p>
                   </a:txBody>
@@ -13709,7 +13458,7 @@
                   </a:tcPr>
                 </a:tc>
               </a:tr>
-              <a:tr h="420624">
+              <a:tr h="457200">
                 <a:tc>
                   <a:txBody>
                     <a:bodyPr/>
@@ -13758,7 +13507,7 @@
                           <a:ea typeface="Pretendard"/>
                           <a:cs typeface="Pretendard"/>
                         </a:rPr>
-                        <a:t>원인 ③④ 미해결 · 스킬이 볼트 밖이라 또 갈라질 위험</a:t>
+                        <a:t>안내문·깨진 주소가 그대로 · 스킬이 가리킬 정본 문서가 정리 안 됨</a:t>
                       </a:r>
                     </a:p>
                   </a:txBody>
@@ -13787,7 +13536,7 @@
                           <a:ea typeface="Pretendard"/>
                           <a:cs typeface="Pretendard"/>
                         </a:rPr>
-                        <a:t>A·B가 필요</a:t>
+                        <a:t>A가 필요</a:t>
                       </a:r>
                     </a:p>
                   </a:txBody>
@@ -13804,14 +13553,61 @@
       </p:graphicFrame>
       <p:sp>
         <p:nvSpPr>
-          <p:cNvPr id="26" name="Rectangle 25"/>
+          <p:cNvPr id="21" name="TextBox 20"/>
+          <p:cNvSpPr txBox="1"/>
+          <p:nvPr/>
+        </p:nvSpPr>
+        <p:spPr>
+          <a:xfrm>
+            <a:off x="777240" y="5349240"/>
+            <a:ext cx="10607040" cy="274320"/>
+          </a:xfrm>
+          <a:prstGeom prst="rect">
+            <a:avLst/>
+          </a:prstGeom>
+          <a:noFill/>
+        </p:spPr>
+        <p:txBody>
+          <a:bodyPr wrap="square" lIns="0" rIns="0" tIns="0" bIns="0" anchor="t">
+            <a:spAutoFit/>
+          </a:bodyPr>
+          <a:lstStyle/>
+          <a:p>
+            <a:pPr algn="l">
+              <a:lnSpc>
+                <a:spcPct val="135000"/>
+              </a:lnSpc>
+              <a:spcBef>
+                <a:spcPts val="0"/>
+              </a:spcBef>
+              <a:spcAft>
+                <a:spcPts val="0"/>
+              </a:spcAft>
+            </a:pPr>
+            <a:r>
+              <a:rPr sz="1500" b="1">
+                <a:solidFill>
+                  <a:srgbClr val="E53A40"/>
+                </a:solidFill>
+                <a:latin typeface="Pretendard"/>
+                <a:ea typeface="Pretendard"/>
+                <a:cs typeface="Pretendard"/>
+              </a:rPr>
+              <a:t>B와 C를 지금 하지 않는 이유</a:t>
+            </a:r>
+          </a:p>
+        </p:txBody>
+      </p:sp>
+      <p:sp>
+        <p:nvSpPr>
+          <p:cNvPr id="22" name="Rectangle 21"/>
           <p:cNvSpPr/>
           <p:nvPr/>
         </p:nvSpPr>
         <p:spPr>
           <a:xfrm>
-            <a:off x="777240" y="5504688"/>
-            <a:ext cx="10634472" cy="868680"/>
+            <a:off x="777240" y="5687568"/>
+            <a:ext cx="2377440" cy="384048"/>
           </a:xfrm>
           <a:prstGeom prst="rect">
             <a:avLst/>
@@ -13819,10 +13615,8 @@
           <a:solidFill>
             <a:srgbClr val="FDEEEE"/>
           </a:solidFill>
-          <a:ln w="15240">
-            <a:solidFill>
-              <a:srgbClr val="E53A40"/>
-            </a:solidFill>
+          <a:ln>
+            <a:noFill/>
           </a:ln>
           <a:effectLst/>
         </p:spPr>
@@ -13850,14 +13644,14 @@
       </p:sp>
       <p:sp>
         <p:nvSpPr>
-          <p:cNvPr id="27" name="TextBox 26"/>
+          <p:cNvPr id="23" name="TextBox 22"/>
           <p:cNvSpPr txBox="1"/>
           <p:nvPr/>
         </p:nvSpPr>
         <p:spPr>
           <a:xfrm>
-            <a:off x="1051560" y="5623560"/>
-            <a:ext cx="10058400" cy="685800"/>
+            <a:off x="932688" y="5769864"/>
+            <a:ext cx="2194560" cy="228600"/>
           </a:xfrm>
           <a:prstGeom prst="rect">
             <a:avLst/>
@@ -13872,14 +13666,17 @@
           <a:p>
             <a:pPr algn="l">
               <a:lnSpc>
-                <a:spcPct val="140000"/>
-              </a:lnSpc>
-              <a:spcBef>
-                <a:spcPts val="0"/>
-              </a:spcBef>
-            </a:pPr>
-            <a:r>
-              <a:rPr sz="1350" b="1">
+                <a:spcPct val="135000"/>
+              </a:lnSpc>
+              <a:spcBef>
+                <a:spcPts val="0"/>
+              </a:spcBef>
+              <a:spcAft>
+                <a:spcPts val="0"/>
+              </a:spcAft>
+            </a:pPr>
+            <a:r>
+              <a:rPr sz="1150" b="1">
                 <a:solidFill>
                   <a:srgbClr val="E53A40"/>
                 </a:solidFill>
@@ -13887,67 +13684,21 @@
                 <a:ea typeface="Pretendard"/>
                 <a:cs typeface="Pretendard"/>
               </a:rPr>
-              <a:t>C안(저장소 합치기)을 보류한 이유 — </a:t>
-            </a:r>
-            <a:r>
-              <a:rPr sz="1300" b="0">
-                <a:solidFill>
-                  <a:srgbClr val="292929"/>
-                </a:solidFill>
-                <a:latin typeface="Pretendard"/>
-                <a:ea typeface="Pretendard"/>
-                <a:cs typeface="Pretendard"/>
-              </a:rPr>
-              <a:t>볼트 730MB+ · 고객 자료 권한 분리 약화 · </a:t>
-            </a:r>
-            <a:r>
-              <a:rPr sz="1300" b="1">
-                <a:solidFill>
-                  <a:srgbClr val="292929"/>
-                </a:solidFill>
-                <a:latin typeface="Pretendard"/>
-                <a:ea typeface="Pretendard"/>
-                <a:cs typeface="Pretendard"/>
-              </a:rPr>
-              <a:t>그리고 2026-05에 정확히 반대로 결정한 사안인데 “왜 나눴는지”가 기록에 없습니다.</a:t>
-            </a:r>
-          </a:p>
-          <a:p>
-            <a:pPr>
-              <a:lnSpc>
-                <a:spcPct val="135000"/>
-              </a:lnSpc>
-              <a:spcBef>
-                <a:spcPts val="300"/>
-              </a:spcBef>
-              <a:spcAft>
-                <a:spcPts val="0"/>
-              </a:spcAft>
-            </a:pPr>
-            <a:r>
-              <a:rPr sz="1200" b="0">
-                <a:solidFill>
-                  <a:srgbClr val="292929"/>
-                </a:solidFill>
-                <a:latin typeface="Pretendard"/>
-                <a:ea typeface="Pretendard"/>
-                <a:cs typeface="Pretendard"/>
-              </a:rPr>
-              <a:t>이유를 모른 채 되돌리면 그때 문제가 재발할 수 있어, 근거가 확인되기 전까지는 B로 갑니다.</a:t>
-            </a:r>
-          </a:p>
-        </p:txBody>
-      </p:sp>
-      <p:sp>
-        <p:nvSpPr>
-          <p:cNvPr id="28" name="TextBox 27"/>
+              <a:t>B  공통 정본 만들기</a:t>
+            </a:r>
+          </a:p>
+        </p:txBody>
+      </p:sp>
+      <p:sp>
+        <p:nvSpPr>
+          <p:cNvPr id="24" name="TextBox 23"/>
           <p:cNvSpPr txBox="1"/>
           <p:nvPr/>
         </p:nvSpPr>
         <p:spPr>
           <a:xfrm>
-            <a:off x="777240" y="6455664"/>
-            <a:ext cx="9509760" cy="256032"/>
+            <a:off x="3337560" y="5669280"/>
+            <a:ext cx="8074152" cy="457200"/>
           </a:xfrm>
           <a:prstGeom prst="rect">
             <a:avLst/>
@@ -13972,6 +13723,215 @@
               </a:spcAft>
             </a:pPr>
             <a:r>
+              <a:rPr sz="1050" b="0">
+                <a:solidFill>
+                  <a:srgbClr val="292929"/>
+                </a:solidFill>
+                <a:latin typeface="Pretendard"/>
+                <a:ea typeface="Pretendard"/>
+                <a:cs typeface="Pretendard"/>
+              </a:rPr>
+              <a:t>submodule은 obsidian-git 기본값이 꺼져 있어(updateSubmodules: false) 팀원이 직접 명령을 쳐야 합니다.</a:t>
+            </a:r>
+          </a:p>
+          <a:p>
+            <a:pPr>
+              <a:lnSpc>
+                <a:spcPct val="135000"/>
+              </a:lnSpc>
+              <a:spcBef>
+                <a:spcPts val="0"/>
+              </a:spcBef>
+              <a:spcAft>
+                <a:spcPts val="0"/>
+              </a:spcAft>
+            </a:pPr>
+            <a:r>
+              <a:rPr sz="1050" b="0">
+                <a:solidFill>
+                  <a:srgbClr val="292929"/>
+                </a:solidFill>
+                <a:latin typeface="Pretendard"/>
+                <a:ea typeface="Pretendard"/>
+                <a:cs typeface="Pretendard"/>
+              </a:rPr>
+              <a:t>“잊으면 낡는” 함정을 하나 더 만드는 셈입니다. 게다가 실제 공유 대상은 팔레트·폰트 2~3개뿐이고, 정본 값은 D가 실어 나를 수 있습니다.</a:t>
+            </a:r>
+          </a:p>
+        </p:txBody>
+      </p:sp>
+      <p:sp>
+        <p:nvSpPr>
+          <p:cNvPr id="25" name="Rectangle 24"/>
+          <p:cNvSpPr/>
+          <p:nvPr/>
+        </p:nvSpPr>
+        <p:spPr>
+          <a:xfrm>
+            <a:off x="777240" y="6144768"/>
+            <a:ext cx="2377440" cy="384048"/>
+          </a:xfrm>
+          <a:prstGeom prst="rect">
+            <a:avLst/>
+          </a:prstGeom>
+          <a:solidFill>
+            <a:srgbClr val="FDEEEE"/>
+          </a:solidFill>
+          <a:ln>
+            <a:noFill/>
+          </a:ln>
+          <a:effectLst/>
+        </p:spPr>
+        <p:style>
+          <a:lnRef idx="1">
+            <a:schemeClr val="accent1"/>
+          </a:lnRef>
+          <a:fillRef idx="3">
+            <a:schemeClr val="accent1"/>
+          </a:fillRef>
+          <a:effectRef idx="2">
+            <a:schemeClr val="accent1"/>
+          </a:effectRef>
+          <a:fontRef idx="minor">
+            <a:schemeClr val="lt1"/>
+          </a:fontRef>
+        </p:style>
+        <p:txBody>
+          <a:bodyPr rtlCol="0" anchor="ctr" wrap="square"/>
+          <a:lstStyle/>
+          <a:p>
+            <a:pPr algn="ctr"/>
+          </a:p>
+        </p:txBody>
+      </p:sp>
+      <p:sp>
+        <p:nvSpPr>
+          <p:cNvPr id="26" name="TextBox 25"/>
+          <p:cNvSpPr txBox="1"/>
+          <p:nvPr/>
+        </p:nvSpPr>
+        <p:spPr>
+          <a:xfrm>
+            <a:off x="932688" y="6227064"/>
+            <a:ext cx="2194560" cy="228600"/>
+          </a:xfrm>
+          <a:prstGeom prst="rect">
+            <a:avLst/>
+          </a:prstGeom>
+          <a:noFill/>
+        </p:spPr>
+        <p:txBody>
+          <a:bodyPr wrap="square" lIns="0" rIns="0" tIns="0" bIns="0" anchor="t">
+            <a:spAutoFit/>
+          </a:bodyPr>
+          <a:lstStyle/>
+          <a:p>
+            <a:pPr algn="l">
+              <a:lnSpc>
+                <a:spcPct val="135000"/>
+              </a:lnSpc>
+              <a:spcBef>
+                <a:spcPts val="0"/>
+              </a:spcBef>
+              <a:spcAft>
+                <a:spcPts val="0"/>
+              </a:spcAft>
+            </a:pPr>
+            <a:r>
+              <a:rPr sz="1150" b="1">
+                <a:solidFill>
+                  <a:srgbClr val="E53A40"/>
+                </a:solidFill>
+                <a:latin typeface="Pretendard"/>
+                <a:ea typeface="Pretendard"/>
+                <a:cs typeface="Pretendard"/>
+              </a:rPr>
+              <a:t>C  저장소 합치기</a:t>
+            </a:r>
+          </a:p>
+        </p:txBody>
+      </p:sp>
+      <p:sp>
+        <p:nvSpPr>
+          <p:cNvPr id="27" name="TextBox 26"/>
+          <p:cNvSpPr txBox="1"/>
+          <p:nvPr/>
+        </p:nvSpPr>
+        <p:spPr>
+          <a:xfrm>
+            <a:off x="3337560" y="6126480"/>
+            <a:ext cx="8074152" cy="457200"/>
+          </a:xfrm>
+          <a:prstGeom prst="rect">
+            <a:avLst/>
+          </a:prstGeom>
+          <a:noFill/>
+        </p:spPr>
+        <p:txBody>
+          <a:bodyPr wrap="square" lIns="0" rIns="0" tIns="0" bIns="0" anchor="t">
+            <a:spAutoFit/>
+          </a:bodyPr>
+          <a:lstStyle/>
+          <a:p>
+            <a:pPr algn="l">
+              <a:lnSpc>
+                <a:spcPct val="135000"/>
+              </a:lnSpc>
+              <a:spcBef>
+                <a:spcPts val="0"/>
+              </a:spcBef>
+              <a:spcAft>
+                <a:spcPts val="0"/>
+              </a:spcAft>
+            </a:pPr>
+            <a:r>
+              <a:rPr sz="1050" b="0">
+                <a:solidFill>
+                  <a:srgbClr val="292929"/>
+                </a:solidFill>
+                <a:latin typeface="Pretendard"/>
+                <a:ea typeface="Pretendard"/>
+                <a:cs typeface="Pretendard"/>
+              </a:rPr>
+              <a:t>볼트 730MB+ · 고객 자료 권한 분리 약화 · 2026-05에 정확히 반대로 결정한 사안인데 “왜 나눴는지”가 기록에 없습니다.</a:t>
+            </a:r>
+          </a:p>
+        </p:txBody>
+      </p:sp>
+      <p:sp>
+        <p:nvSpPr>
+          <p:cNvPr id="28" name="TextBox 27"/>
+          <p:cNvSpPr txBox="1"/>
+          <p:nvPr/>
+        </p:nvSpPr>
+        <p:spPr>
+          <a:xfrm>
+            <a:off x="777240" y="6455664"/>
+            <a:ext cx="9509760" cy="256032"/>
+          </a:xfrm>
+          <a:prstGeom prst="rect">
+            <a:avLst/>
+          </a:prstGeom>
+          <a:noFill/>
+        </p:spPr>
+        <p:txBody>
+          <a:bodyPr wrap="square" lIns="0" rIns="0" tIns="0" bIns="0" anchor="t">
+            <a:spAutoFit/>
+          </a:bodyPr>
+          <a:lstStyle/>
+          <a:p>
+            <a:pPr algn="l">
+              <a:lnSpc>
+                <a:spcPct val="135000"/>
+              </a:lnSpc>
+              <a:spcBef>
+                <a:spcPts val="0"/>
+              </a:spcBef>
+              <a:spcAft>
+                <a:spcPts val="0"/>
+              </a:spcAft>
+            </a:pPr>
+            <a:r>
               <a:rPr sz="1000" b="0">
                 <a:solidFill>
                   <a:srgbClr val="9A9A9A"/>
@@ -13980,7 +13940,7 @@
                 <a:ea typeface="Pretendard"/>
                 <a:cs typeface="Pretendard"/>
               </a:rPr>
-              <a:t/>
+              <a:t>B가 정말 필요해지면 submodule 말고 git subtree를 쓰면 됩니다 — 팀원은 아무 명령도 칠 필요가 없습니다</a:t>
             </a:r>
           </a:p>
         </p:txBody>
@@ -14230,7 +14190,7 @@
                 <a:ea typeface="Pretendard"/>
                 <a:cs typeface="Pretendard"/>
               </a:rPr>
-              <a:t>A·B로 저장소를 아무리 잘 정리해도, 저장소 안에 넣는 방식만으로는 남는 문제가 셋 있습니다.</a:t>
+              <a:t>A안으로 저장소를 아무리 잘 정리해도, 저장소 안에 넣는 방식만으로는 남는 문제가 셋 있습니다.</a:t>
             </a:r>
           </a:p>
         </p:txBody>
@@ -15535,7 +15495,7 @@
                 <a:ea typeface="Pretendard"/>
                 <a:cs typeface="Pretendard"/>
               </a:rPr>
-              <a:t>추천안을 적용하면 — ① 전체 구조</a:t>
+              <a:t>추천안을 적용하면 이렇게 됩니다</a:t>
             </a:r>
           </a:p>
         </p:txBody>
@@ -15548,8 +15508,8 @@
         </p:nvSpPr>
         <p:spPr>
           <a:xfrm>
-            <a:off x="777240" y="1737360"/>
-            <a:ext cx="10607040" cy="274320"/>
+            <a:off x="777240" y="1755648"/>
+            <a:ext cx="10607040" cy="365760"/>
           </a:xfrm>
           <a:prstGeom prst="rect">
             <a:avLst/>
@@ -15574,7 +15534,7 @@
               </a:spcAft>
             </a:pPr>
             <a:r>
-              <a:rPr sz="1400" b="0">
+              <a:rPr sz="1450" b="0">
                 <a:solidFill>
                   <a:srgbClr val="6B6B6B"/>
                 </a:solidFill>
@@ -15582,7 +15542,7 @@
                 <a:ea typeface="Pretendard"/>
                 <a:cs typeface="Pretendard"/>
               </a:rPr>
-              <a:t>새 저장소를 2개 만듭니다 — 정본을 담는 cdbd-core(B안)와, 스킬을 나르는 cdbd-plugin(D안).</a:t>
+              <a:t>새로 만드는 저장소는 cdbd-plugin 하나뿐입니다. 기존 6개 저장소의 구조는 바뀌지 않습니다.</a:t>
             </a:r>
           </a:p>
         </p:txBody>
@@ -15595,8 +15555,8 @@
         </p:nvSpPr>
         <p:spPr>
           <a:xfrm>
-            <a:off x="3977639" y="2084831"/>
-            <a:ext cx="4233672" cy="1207008"/>
+            <a:off x="3566160" y="2121408"/>
+            <a:ext cx="5056632" cy="1417320"/>
           </a:xfrm>
           <a:prstGeom prst="rect">
             <a:avLst/>
@@ -15639,8 +15599,8 @@
         </p:nvSpPr>
         <p:spPr>
           <a:xfrm>
-            <a:off x="3977639" y="2194560"/>
-            <a:ext cx="4233672" cy="274320"/>
+            <a:off x="3566160" y="2249424"/>
+            <a:ext cx="5056632" cy="274320"/>
           </a:xfrm>
           <a:prstGeom prst="rect">
             <a:avLst/>
@@ -15665,7 +15625,7 @@
               </a:spcAft>
             </a:pPr>
             <a:r>
-              <a:rPr sz="1400" b="1">
+              <a:rPr sz="1450" b="1">
                 <a:solidFill>
                   <a:srgbClr val="3DF69B"/>
                 </a:solidFill>
@@ -15673,7 +15633,7 @@
                 <a:ea typeface="Pretendard"/>
                 <a:cs typeface="Pretendard"/>
               </a:rPr>
-              <a:t>B안  cdbd-core   (신규 저장소)</a:t>
+              <a:t>cdbd-plugin   (신규 저장소 1개)</a:t>
             </a:r>
           </a:p>
         </p:txBody>
@@ -15686,8 +15646,8 @@
         </p:nvSpPr>
         <p:spPr>
           <a:xfrm>
-            <a:off x="3977639" y="2487168"/>
-            <a:ext cx="4233672" cy="731520"/>
+            <a:off x="3566160" y="2560320"/>
+            <a:ext cx="5056632" cy="914400"/>
           </a:xfrm>
           <a:prstGeom prst="rect">
             <a:avLst/>
@@ -15702,7 +15662,7 @@
           <a:p>
             <a:pPr algn="ctr">
               <a:lnSpc>
-                <a:spcPct val="150000"/>
+                <a:spcPct val="155000"/>
               </a:lnSpc>
               <a:spcBef>
                 <a:spcPts val="0"/>
@@ -15720,13 +15680,13 @@
                 <a:ea typeface="Pretendard"/>
                 <a:cs typeface="Pretendard"/>
               </a:rPr>
-              <a:t>브랜드 토큰 · 문서 작성 규칙</a:t>
+              <a:t>스킬 · 에이전트 · commands</a:t>
             </a:r>
           </a:p>
           <a:p>
             <a:pPr algn="ctr">
               <a:lnSpc>
-                <a:spcPct val="150000"/>
+                <a:spcPct val="155000"/>
               </a:lnSpc>
               <a:spcBef>
                 <a:spcPts val="0"/>
@@ -15744,7 +15704,31 @@
                 <a:ea typeface="Pretendard"/>
                 <a:cs typeface="Pretendard"/>
               </a:rPr>
-              <a:t>공통 자산 · 자동 점검 스크립트</a:t>
+              <a:t>.mcp.json (Figma 연결)</a:t>
+            </a:r>
+          </a:p>
+          <a:p>
+            <a:pPr algn="ctr">
+              <a:lnSpc>
+                <a:spcPct val="155000"/>
+              </a:lnSpc>
+              <a:spcBef>
+                <a:spcPts val="0"/>
+              </a:spcBef>
+              <a:spcAft>
+                <a:spcPts val="0"/>
+              </a:spcAft>
+            </a:pPr>
+            <a:r>
+              <a:rPr sz="1150" b="0">
+                <a:solidFill>
+                  <a:srgbClr val="FFFFFF"/>
+                </a:solidFill>
+                <a:latin typeface="Pretendard"/>
+                <a:ea typeface="Pretendard"/>
+                <a:cs typeface="Pretendard"/>
+              </a:rPr>
+              <a:t>브랜드 토큰 정본 · 자동 점검 스크립트</a:t>
             </a:r>
           </a:p>
         </p:txBody>
@@ -15757,14 +15741,14 @@
         </p:nvSpPr>
         <p:spPr>
           <a:xfrm>
-            <a:off x="6062472" y="3291840"/>
-            <a:ext cx="41148" cy="310896"/>
+            <a:off x="6076188" y="3538728"/>
+            <a:ext cx="41148" cy="347472"/>
           </a:xfrm>
           <a:prstGeom prst="rect">
             <a:avLst/>
           </a:prstGeom>
           <a:solidFill>
-            <a:srgbClr val="6C4CFF"/>
+            <a:srgbClr val="1C9E63"/>
           </a:solidFill>
           <a:ln>
             <a:noFill/>
@@ -15801,8 +15785,8 @@
         </p:nvSpPr>
         <p:spPr>
           <a:xfrm>
-            <a:off x="6263640" y="3310128"/>
-            <a:ext cx="2926080" cy="237744"/>
+            <a:off x="6309360" y="3566160"/>
+            <a:ext cx="3291840" cy="237744"/>
           </a:xfrm>
           <a:prstGeom prst="rect">
             <a:avLst/>
@@ -15829,13 +15813,13 @@
             <a:r>
               <a:rPr sz="1050" b="1">
                 <a:solidFill>
-                  <a:srgbClr val="6C4CFF"/>
-                </a:solidFill>
-                <a:latin typeface="Pretendard"/>
-                <a:ea typeface="Pretendard"/>
-                <a:cs typeface="Pretendard"/>
-              </a:rPr>
-              <a:t>자동 연결 (git submodule)</a:t>
+                  <a:srgbClr val="1C9E63"/>
+                </a:solidFill>
+                <a:latin typeface="Pretendard"/>
+                <a:ea typeface="Pretendard"/>
+                <a:cs typeface="Pretendard"/>
+              </a:rPr>
+              <a:t>팀원이 1회 설치  →  이후 자동 동기화</a:t>
             </a:r>
           </a:p>
         </p:txBody>
@@ -15848,14 +15832,14 @@
         </p:nvSpPr>
         <p:spPr>
           <a:xfrm>
-            <a:off x="1481328" y="3598164"/>
+            <a:off x="1481328" y="3886200"/>
             <a:ext cx="9198864" cy="41148"/>
           </a:xfrm>
           <a:prstGeom prst="rect">
             <a:avLst/>
           </a:prstGeom>
           <a:solidFill>
-            <a:srgbClr val="6C4CFF"/>
+            <a:srgbClr val="1C9E63"/>
           </a:solidFill>
           <a:ln>
             <a:noFill/>
@@ -15892,14 +15876,14 @@
         </p:nvSpPr>
         <p:spPr>
           <a:xfrm>
-            <a:off x="1460754" y="3639312"/>
+            <a:off x="1460754" y="3927348"/>
             <a:ext cx="41148" cy="274320"/>
           </a:xfrm>
           <a:prstGeom prst="rect">
             <a:avLst/>
           </a:prstGeom>
           <a:solidFill>
-            <a:srgbClr val="6C4CFF"/>
+            <a:srgbClr val="1C9E63"/>
           </a:solidFill>
           <a:ln>
             <a:noFill/>
@@ -15936,8 +15920,8 @@
         </p:nvSpPr>
         <p:spPr>
           <a:xfrm>
-            <a:off x="521208" y="3913632"/>
-            <a:ext cx="1920240" cy="1188720"/>
+            <a:off x="521208" y="4206240"/>
+            <a:ext cx="1920240" cy="1097280"/>
           </a:xfrm>
           <a:prstGeom prst="rect">
             <a:avLst/>
@@ -15982,7 +15966,7 @@
         </p:nvSpPr>
         <p:spPr>
           <a:xfrm>
-            <a:off x="521208" y="4023360"/>
+            <a:off x="521208" y="4343400"/>
             <a:ext cx="1920240" cy="457200"/>
           </a:xfrm>
           <a:prstGeom prst="rect">
@@ -16047,20 +16031,67 @@
       </p:sp>
       <p:sp>
         <p:nvSpPr>
-          <p:cNvPr id="15" name="Rectangle 14"/>
+          <p:cNvPr id="15" name="TextBox 14"/>
+          <p:cNvSpPr txBox="1"/>
+          <p:nvPr/>
+        </p:nvSpPr>
+        <p:spPr>
+          <a:xfrm>
+            <a:off x="521208" y="4892040"/>
+            <a:ext cx="1920240" cy="219456"/>
+          </a:xfrm>
+          <a:prstGeom prst="rect">
+            <a:avLst/>
+          </a:prstGeom>
+          <a:noFill/>
+        </p:spPr>
+        <p:txBody>
+          <a:bodyPr wrap="square" lIns="0" rIns="0" tIns="0" bIns="0" anchor="t">
+            <a:spAutoFit/>
+          </a:bodyPr>
+          <a:lstStyle/>
+          <a:p>
+            <a:pPr algn="ctr">
+              <a:lnSpc>
+                <a:spcPct val="135000"/>
+              </a:lnSpc>
+              <a:spcBef>
+                <a:spcPts val="0"/>
+              </a:spcBef>
+              <a:spcAft>
+                <a:spcPts val="0"/>
+              </a:spcAft>
+            </a:pPr>
+            <a:r>
+              <a:rPr sz="1050" b="0">
+                <a:solidFill>
+                  <a:srgbClr val="6B6B6B"/>
+                </a:solidFill>
+                <a:latin typeface="Pretendard"/>
+                <a:ea typeface="Pretendard"/>
+                <a:cs typeface="Pretendard"/>
+              </a:rPr>
+              <a:t>구조 그대로</a:t>
+            </a:r>
+          </a:p>
+        </p:txBody>
+      </p:sp>
+      <p:sp>
+        <p:nvSpPr>
+          <p:cNvPr id="16" name="Rectangle 15"/>
           <p:cNvSpPr/>
           <p:nvPr/>
         </p:nvSpPr>
         <p:spPr>
           <a:xfrm>
-            <a:off x="676656" y="4553712"/>
-            <a:ext cx="1609344" cy="274320"/>
+            <a:off x="3760470" y="3927348"/>
+            <a:ext cx="41148" cy="274320"/>
           </a:xfrm>
           <a:prstGeom prst="rect">
             <a:avLst/>
           </a:prstGeom>
           <a:solidFill>
-            <a:srgbClr val="F2F0FF"/>
+            <a:srgbClr val="1C9E63"/>
           </a:solidFill>
           <a:ln>
             <a:noFill/>
@@ -16091,152 +16122,14 @@
       </p:sp>
       <p:sp>
         <p:nvSpPr>
-          <p:cNvPr id="16" name="TextBox 15"/>
-          <p:cNvSpPr txBox="1"/>
-          <p:nvPr/>
-        </p:nvSpPr>
-        <p:spPr>
-          <a:xfrm>
-            <a:off x="676656" y="4608576"/>
-            <a:ext cx="1609344" cy="219456"/>
-          </a:xfrm>
-          <a:prstGeom prst="rect">
-            <a:avLst/>
-          </a:prstGeom>
-          <a:noFill/>
-        </p:spPr>
-        <p:txBody>
-          <a:bodyPr wrap="square" lIns="0" rIns="0" tIns="0" bIns="0" anchor="t">
-            <a:spAutoFit/>
-          </a:bodyPr>
-          <a:lstStyle/>
-          <a:p>
-            <a:pPr algn="ctr">
-              <a:lnSpc>
-                <a:spcPct val="135000"/>
-              </a:lnSpc>
-              <a:spcBef>
-                <a:spcPts val="0"/>
-              </a:spcBef>
-              <a:spcAft>
-                <a:spcPts val="0"/>
-              </a:spcAft>
-            </a:pPr>
-            <a:r>
-              <a:rPr sz="1100" b="1">
-                <a:solidFill>
-                  <a:srgbClr val="6C4CFF"/>
-                </a:solidFill>
-                <a:latin typeface="Pretendard"/>
-                <a:ea typeface="Pretendard"/>
-                <a:cs typeface="Pretendard"/>
-              </a:rPr>
-              <a:t>_core/</a:t>
-            </a:r>
-          </a:p>
-        </p:txBody>
-      </p:sp>
-      <p:sp>
-        <p:nvSpPr>
-          <p:cNvPr id="17" name="TextBox 16"/>
-          <p:cNvSpPr txBox="1"/>
-          <p:nvPr/>
-        </p:nvSpPr>
-        <p:spPr>
-          <a:xfrm>
-            <a:off x="521208" y="4864608"/>
-            <a:ext cx="1920240" cy="219456"/>
-          </a:xfrm>
-          <a:prstGeom prst="rect">
-            <a:avLst/>
-          </a:prstGeom>
-          <a:noFill/>
-        </p:spPr>
-        <p:txBody>
-          <a:bodyPr wrap="square" lIns="0" rIns="0" tIns="0" bIns="0" anchor="t">
-            <a:spAutoFit/>
-          </a:bodyPr>
-          <a:lstStyle/>
-          <a:p>
-            <a:pPr algn="ctr">
-              <a:lnSpc>
-                <a:spcPct val="135000"/>
-              </a:lnSpc>
-              <a:spcBef>
-                <a:spcPts val="0"/>
-              </a:spcBef>
-              <a:spcAft>
-                <a:spcPts val="0"/>
-              </a:spcAft>
-            </a:pPr>
-            <a:r>
-              <a:rPr sz="1000" b="0">
-                <a:solidFill>
-                  <a:srgbClr val="6B6B6B"/>
-                </a:solidFill>
-                <a:latin typeface="Pretendard"/>
-                <a:ea typeface="Pretendard"/>
-                <a:cs typeface="Pretendard"/>
-              </a:rPr>
-              <a:t>＋ 자기 문서</a:t>
-            </a:r>
-          </a:p>
-        </p:txBody>
-      </p:sp>
-      <p:sp>
-        <p:nvSpPr>
-          <p:cNvPr id="18" name="Rectangle 17"/>
+          <p:cNvPr id="17" name="Rectangle 16"/>
           <p:cNvSpPr/>
           <p:nvPr/>
         </p:nvSpPr>
         <p:spPr>
           <a:xfrm>
-            <a:off x="3760470" y="3639312"/>
-            <a:ext cx="41148" cy="274320"/>
-          </a:xfrm>
-          <a:prstGeom prst="rect">
-            <a:avLst/>
-          </a:prstGeom>
-          <a:solidFill>
-            <a:srgbClr val="6C4CFF"/>
-          </a:solidFill>
-          <a:ln>
-            <a:noFill/>
-          </a:ln>
-          <a:effectLst/>
-        </p:spPr>
-        <p:style>
-          <a:lnRef idx="1">
-            <a:schemeClr val="accent1"/>
-          </a:lnRef>
-          <a:fillRef idx="3">
-            <a:schemeClr val="accent1"/>
-          </a:fillRef>
-          <a:effectRef idx="2">
-            <a:schemeClr val="accent1"/>
-          </a:effectRef>
-          <a:fontRef idx="minor">
-            <a:schemeClr val="lt1"/>
-          </a:fontRef>
-        </p:style>
-        <p:txBody>
-          <a:bodyPr rtlCol="0" anchor="ctr" wrap="square"/>
-          <a:lstStyle/>
-          <a:p>
-            <a:pPr algn="ctr"/>
-          </a:p>
-        </p:txBody>
-      </p:sp>
-      <p:sp>
-        <p:nvSpPr>
-          <p:cNvPr id="19" name="Rectangle 18"/>
-          <p:cNvSpPr/>
-          <p:nvPr/>
-        </p:nvSpPr>
-        <p:spPr>
-          <a:xfrm>
-            <a:off x="2820924" y="3913632"/>
-            <a:ext cx="1920240" cy="1188720"/>
+            <a:off x="2820924" y="4206240"/>
+            <a:ext cx="1920240" cy="1097280"/>
           </a:xfrm>
           <a:prstGeom prst="rect">
             <a:avLst/>
@@ -16275,13 +16168,13 @@
       </p:sp>
       <p:sp>
         <p:nvSpPr>
-          <p:cNvPr id="20" name="TextBox 19"/>
+          <p:cNvPr id="18" name="TextBox 17"/>
           <p:cNvSpPr txBox="1"/>
           <p:nvPr/>
         </p:nvSpPr>
         <p:spPr>
           <a:xfrm>
-            <a:off x="2820924" y="4023360"/>
+            <a:off x="2820924" y="4343400"/>
             <a:ext cx="1920240" cy="457200"/>
           </a:xfrm>
           <a:prstGeom prst="rect">
@@ -16346,20 +16239,67 @@
       </p:sp>
       <p:sp>
         <p:nvSpPr>
-          <p:cNvPr id="21" name="Rectangle 20"/>
+          <p:cNvPr id="19" name="TextBox 18"/>
+          <p:cNvSpPr txBox="1"/>
+          <p:nvPr/>
+        </p:nvSpPr>
+        <p:spPr>
+          <a:xfrm>
+            <a:off x="2820924" y="4892040"/>
+            <a:ext cx="1920240" cy="219456"/>
+          </a:xfrm>
+          <a:prstGeom prst="rect">
+            <a:avLst/>
+          </a:prstGeom>
+          <a:noFill/>
+        </p:spPr>
+        <p:txBody>
+          <a:bodyPr wrap="square" lIns="0" rIns="0" tIns="0" bIns="0" anchor="t">
+            <a:spAutoFit/>
+          </a:bodyPr>
+          <a:lstStyle/>
+          <a:p>
+            <a:pPr algn="ctr">
+              <a:lnSpc>
+                <a:spcPct val="135000"/>
+              </a:lnSpc>
+              <a:spcBef>
+                <a:spcPts val="0"/>
+              </a:spcBef>
+              <a:spcAft>
+                <a:spcPts val="0"/>
+              </a:spcAft>
+            </a:pPr>
+            <a:r>
+              <a:rPr sz="1050" b="0">
+                <a:solidFill>
+                  <a:srgbClr val="6B6B6B"/>
+                </a:solidFill>
+                <a:latin typeface="Pretendard"/>
+                <a:ea typeface="Pretendard"/>
+                <a:cs typeface="Pretendard"/>
+              </a:rPr>
+              <a:t>구조 그대로</a:t>
+            </a:r>
+          </a:p>
+        </p:txBody>
+      </p:sp>
+      <p:sp>
+        <p:nvSpPr>
+          <p:cNvPr id="20" name="Rectangle 19"/>
           <p:cNvSpPr/>
           <p:nvPr/>
         </p:nvSpPr>
         <p:spPr>
           <a:xfrm>
-            <a:off x="2976372" y="4553712"/>
-            <a:ext cx="1609344" cy="274320"/>
+            <a:off x="6060186" y="3927348"/>
+            <a:ext cx="41148" cy="274320"/>
           </a:xfrm>
           <a:prstGeom prst="rect">
             <a:avLst/>
           </a:prstGeom>
           <a:solidFill>
-            <a:srgbClr val="F2F0FF"/>
+            <a:srgbClr val="1C9E63"/>
           </a:solidFill>
           <a:ln>
             <a:noFill/>
@@ -16390,152 +16330,14 @@
       </p:sp>
       <p:sp>
         <p:nvSpPr>
-          <p:cNvPr id="22" name="TextBox 21"/>
-          <p:cNvSpPr txBox="1"/>
-          <p:nvPr/>
-        </p:nvSpPr>
-        <p:spPr>
-          <a:xfrm>
-            <a:off x="2976372" y="4608576"/>
-            <a:ext cx="1609344" cy="219456"/>
-          </a:xfrm>
-          <a:prstGeom prst="rect">
-            <a:avLst/>
-          </a:prstGeom>
-          <a:noFill/>
-        </p:spPr>
-        <p:txBody>
-          <a:bodyPr wrap="square" lIns="0" rIns="0" tIns="0" bIns="0" anchor="t">
-            <a:spAutoFit/>
-          </a:bodyPr>
-          <a:lstStyle/>
-          <a:p>
-            <a:pPr algn="ctr">
-              <a:lnSpc>
-                <a:spcPct val="135000"/>
-              </a:lnSpc>
-              <a:spcBef>
-                <a:spcPts val="0"/>
-              </a:spcBef>
-              <a:spcAft>
-                <a:spcPts val="0"/>
-              </a:spcAft>
-            </a:pPr>
-            <a:r>
-              <a:rPr sz="1100" b="1">
-                <a:solidFill>
-                  <a:srgbClr val="6C4CFF"/>
-                </a:solidFill>
-                <a:latin typeface="Pretendard"/>
-                <a:ea typeface="Pretendard"/>
-                <a:cs typeface="Pretendard"/>
-              </a:rPr>
-              <a:t>_core/</a:t>
-            </a:r>
-          </a:p>
-        </p:txBody>
-      </p:sp>
-      <p:sp>
-        <p:nvSpPr>
-          <p:cNvPr id="23" name="TextBox 22"/>
-          <p:cNvSpPr txBox="1"/>
-          <p:nvPr/>
-        </p:nvSpPr>
-        <p:spPr>
-          <a:xfrm>
-            <a:off x="2820924" y="4864608"/>
-            <a:ext cx="1920240" cy="219456"/>
-          </a:xfrm>
-          <a:prstGeom prst="rect">
-            <a:avLst/>
-          </a:prstGeom>
-          <a:noFill/>
-        </p:spPr>
-        <p:txBody>
-          <a:bodyPr wrap="square" lIns="0" rIns="0" tIns="0" bIns="0" anchor="t">
-            <a:spAutoFit/>
-          </a:bodyPr>
-          <a:lstStyle/>
-          <a:p>
-            <a:pPr algn="ctr">
-              <a:lnSpc>
-                <a:spcPct val="135000"/>
-              </a:lnSpc>
-              <a:spcBef>
-                <a:spcPts val="0"/>
-              </a:spcBef>
-              <a:spcAft>
-                <a:spcPts val="0"/>
-              </a:spcAft>
-            </a:pPr>
-            <a:r>
-              <a:rPr sz="1000" b="0">
-                <a:solidFill>
-                  <a:srgbClr val="6B6B6B"/>
-                </a:solidFill>
-                <a:latin typeface="Pretendard"/>
-                <a:ea typeface="Pretendard"/>
-                <a:cs typeface="Pretendard"/>
-              </a:rPr>
-              <a:t>＋ 자기 문서</a:t>
-            </a:r>
-          </a:p>
-        </p:txBody>
-      </p:sp>
-      <p:sp>
-        <p:nvSpPr>
-          <p:cNvPr id="24" name="Rectangle 23"/>
+          <p:cNvPr id="21" name="Rectangle 20"/>
           <p:cNvSpPr/>
           <p:nvPr/>
         </p:nvSpPr>
         <p:spPr>
           <a:xfrm>
-            <a:off x="6060186" y="3639312"/>
-            <a:ext cx="41148" cy="274320"/>
-          </a:xfrm>
-          <a:prstGeom prst="rect">
-            <a:avLst/>
-          </a:prstGeom>
-          <a:solidFill>
-            <a:srgbClr val="6C4CFF"/>
-          </a:solidFill>
-          <a:ln>
-            <a:noFill/>
-          </a:ln>
-          <a:effectLst/>
-        </p:spPr>
-        <p:style>
-          <a:lnRef idx="1">
-            <a:schemeClr val="accent1"/>
-          </a:lnRef>
-          <a:fillRef idx="3">
-            <a:schemeClr val="accent1"/>
-          </a:fillRef>
-          <a:effectRef idx="2">
-            <a:schemeClr val="accent1"/>
-          </a:effectRef>
-          <a:fontRef idx="minor">
-            <a:schemeClr val="lt1"/>
-          </a:fontRef>
-        </p:style>
-        <p:txBody>
-          <a:bodyPr rtlCol="0" anchor="ctr" wrap="square"/>
-          <a:lstStyle/>
-          <a:p>
-            <a:pPr algn="ctr"/>
-          </a:p>
-        </p:txBody>
-      </p:sp>
-      <p:sp>
-        <p:nvSpPr>
-          <p:cNvPr id="25" name="Rectangle 24"/>
-          <p:cNvSpPr/>
-          <p:nvPr/>
-        </p:nvSpPr>
-        <p:spPr>
-          <a:xfrm>
-            <a:off x="5120640" y="3913632"/>
-            <a:ext cx="1920240" cy="1188720"/>
+            <a:off x="5120640" y="4206240"/>
+            <a:ext cx="1920240" cy="1097280"/>
           </a:xfrm>
           <a:prstGeom prst="rect">
             <a:avLst/>
@@ -16574,13 +16376,13 @@
       </p:sp>
       <p:sp>
         <p:nvSpPr>
-          <p:cNvPr id="26" name="TextBox 25"/>
+          <p:cNvPr id="22" name="TextBox 21"/>
           <p:cNvSpPr txBox="1"/>
           <p:nvPr/>
         </p:nvSpPr>
         <p:spPr>
           <a:xfrm>
-            <a:off x="5120640" y="4023360"/>
+            <a:off x="5120640" y="4343400"/>
             <a:ext cx="1920240" cy="457200"/>
           </a:xfrm>
           <a:prstGeom prst="rect">
@@ -16645,20 +16447,67 @@
       </p:sp>
       <p:sp>
         <p:nvSpPr>
-          <p:cNvPr id="27" name="Rectangle 26"/>
+          <p:cNvPr id="23" name="TextBox 22"/>
+          <p:cNvSpPr txBox="1"/>
+          <p:nvPr/>
+        </p:nvSpPr>
+        <p:spPr>
+          <a:xfrm>
+            <a:off x="5120640" y="4892040"/>
+            <a:ext cx="1920240" cy="219456"/>
+          </a:xfrm>
+          <a:prstGeom prst="rect">
+            <a:avLst/>
+          </a:prstGeom>
+          <a:noFill/>
+        </p:spPr>
+        <p:txBody>
+          <a:bodyPr wrap="square" lIns="0" rIns="0" tIns="0" bIns="0" anchor="t">
+            <a:spAutoFit/>
+          </a:bodyPr>
+          <a:lstStyle/>
+          <a:p>
+            <a:pPr algn="ctr">
+              <a:lnSpc>
+                <a:spcPct val="135000"/>
+              </a:lnSpc>
+              <a:spcBef>
+                <a:spcPts val="0"/>
+              </a:spcBef>
+              <a:spcAft>
+                <a:spcPts val="0"/>
+              </a:spcAft>
+            </a:pPr>
+            <a:r>
+              <a:rPr sz="1050" b="0">
+                <a:solidFill>
+                  <a:srgbClr val="6B6B6B"/>
+                </a:solidFill>
+                <a:latin typeface="Pretendard"/>
+                <a:ea typeface="Pretendard"/>
+                <a:cs typeface="Pretendard"/>
+              </a:rPr>
+              <a:t>구조 그대로</a:t>
+            </a:r>
+          </a:p>
+        </p:txBody>
+      </p:sp>
+      <p:sp>
+        <p:nvSpPr>
+          <p:cNvPr id="24" name="Rectangle 23"/>
           <p:cNvSpPr/>
           <p:nvPr/>
         </p:nvSpPr>
         <p:spPr>
           <a:xfrm>
-            <a:off x="5276088" y="4553712"/>
-            <a:ext cx="1609344" cy="274320"/>
+            <a:off x="8359901" y="3927348"/>
+            <a:ext cx="41148" cy="274320"/>
           </a:xfrm>
           <a:prstGeom prst="rect">
             <a:avLst/>
           </a:prstGeom>
           <a:solidFill>
-            <a:srgbClr val="F2F0FF"/>
+            <a:srgbClr val="1C9E63"/>
           </a:solidFill>
           <a:ln>
             <a:noFill/>
@@ -16689,152 +16538,14 @@
       </p:sp>
       <p:sp>
         <p:nvSpPr>
-          <p:cNvPr id="28" name="TextBox 27"/>
-          <p:cNvSpPr txBox="1"/>
-          <p:nvPr/>
-        </p:nvSpPr>
-        <p:spPr>
-          <a:xfrm>
-            <a:off x="5276088" y="4608576"/>
-            <a:ext cx="1609344" cy="219456"/>
-          </a:xfrm>
-          <a:prstGeom prst="rect">
-            <a:avLst/>
-          </a:prstGeom>
-          <a:noFill/>
-        </p:spPr>
-        <p:txBody>
-          <a:bodyPr wrap="square" lIns="0" rIns="0" tIns="0" bIns="0" anchor="t">
-            <a:spAutoFit/>
-          </a:bodyPr>
-          <a:lstStyle/>
-          <a:p>
-            <a:pPr algn="ctr">
-              <a:lnSpc>
-                <a:spcPct val="135000"/>
-              </a:lnSpc>
-              <a:spcBef>
-                <a:spcPts val="0"/>
-              </a:spcBef>
-              <a:spcAft>
-                <a:spcPts val="0"/>
-              </a:spcAft>
-            </a:pPr>
-            <a:r>
-              <a:rPr sz="1100" b="1">
-                <a:solidFill>
-                  <a:srgbClr val="6C4CFF"/>
-                </a:solidFill>
-                <a:latin typeface="Pretendard"/>
-                <a:ea typeface="Pretendard"/>
-                <a:cs typeface="Pretendard"/>
-              </a:rPr>
-              <a:t>_core/</a:t>
-            </a:r>
-          </a:p>
-        </p:txBody>
-      </p:sp>
-      <p:sp>
-        <p:nvSpPr>
-          <p:cNvPr id="29" name="TextBox 28"/>
-          <p:cNvSpPr txBox="1"/>
-          <p:nvPr/>
-        </p:nvSpPr>
-        <p:spPr>
-          <a:xfrm>
-            <a:off x="5120640" y="4864608"/>
-            <a:ext cx="1920240" cy="219456"/>
-          </a:xfrm>
-          <a:prstGeom prst="rect">
-            <a:avLst/>
-          </a:prstGeom>
-          <a:noFill/>
-        </p:spPr>
-        <p:txBody>
-          <a:bodyPr wrap="square" lIns="0" rIns="0" tIns="0" bIns="0" anchor="t">
-            <a:spAutoFit/>
-          </a:bodyPr>
-          <a:lstStyle/>
-          <a:p>
-            <a:pPr algn="ctr">
-              <a:lnSpc>
-                <a:spcPct val="135000"/>
-              </a:lnSpc>
-              <a:spcBef>
-                <a:spcPts val="0"/>
-              </a:spcBef>
-              <a:spcAft>
-                <a:spcPts val="0"/>
-              </a:spcAft>
-            </a:pPr>
-            <a:r>
-              <a:rPr sz="1000" b="0">
-                <a:solidFill>
-                  <a:srgbClr val="6B6B6B"/>
-                </a:solidFill>
-                <a:latin typeface="Pretendard"/>
-                <a:ea typeface="Pretendard"/>
-                <a:cs typeface="Pretendard"/>
-              </a:rPr>
-              <a:t>＋ 자기 문서</a:t>
-            </a:r>
-          </a:p>
-        </p:txBody>
-      </p:sp>
-      <p:sp>
-        <p:nvSpPr>
-          <p:cNvPr id="30" name="Rectangle 29"/>
+          <p:cNvPr id="25" name="Rectangle 24"/>
           <p:cNvSpPr/>
           <p:nvPr/>
         </p:nvSpPr>
         <p:spPr>
           <a:xfrm>
-            <a:off x="8359901" y="3639312"/>
-            <a:ext cx="41148" cy="274320"/>
-          </a:xfrm>
-          <a:prstGeom prst="rect">
-            <a:avLst/>
-          </a:prstGeom>
-          <a:solidFill>
-            <a:srgbClr val="6C4CFF"/>
-          </a:solidFill>
-          <a:ln>
-            <a:noFill/>
-          </a:ln>
-          <a:effectLst/>
-        </p:spPr>
-        <p:style>
-          <a:lnRef idx="1">
-            <a:schemeClr val="accent1"/>
-          </a:lnRef>
-          <a:fillRef idx="3">
-            <a:schemeClr val="accent1"/>
-          </a:fillRef>
-          <a:effectRef idx="2">
-            <a:schemeClr val="accent1"/>
-          </a:effectRef>
-          <a:fontRef idx="minor">
-            <a:schemeClr val="lt1"/>
-          </a:fontRef>
-        </p:style>
-        <p:txBody>
-          <a:bodyPr rtlCol="0" anchor="ctr" wrap="square"/>
-          <a:lstStyle/>
-          <a:p>
-            <a:pPr algn="ctr"/>
-          </a:p>
-        </p:txBody>
-      </p:sp>
-      <p:sp>
-        <p:nvSpPr>
-          <p:cNvPr id="31" name="Rectangle 30"/>
-          <p:cNvSpPr/>
-          <p:nvPr/>
-        </p:nvSpPr>
-        <p:spPr>
-          <a:xfrm>
-            <a:off x="7420355" y="3913632"/>
-            <a:ext cx="1920240" cy="1188720"/>
+            <a:off x="7420355" y="4206240"/>
+            <a:ext cx="1920240" cy="1097280"/>
           </a:xfrm>
           <a:prstGeom prst="rect">
             <a:avLst/>
@@ -16873,13 +16584,13 @@
       </p:sp>
       <p:sp>
         <p:nvSpPr>
-          <p:cNvPr id="32" name="TextBox 31"/>
+          <p:cNvPr id="26" name="TextBox 25"/>
           <p:cNvSpPr txBox="1"/>
           <p:nvPr/>
         </p:nvSpPr>
         <p:spPr>
           <a:xfrm>
-            <a:off x="7420355" y="4023360"/>
+            <a:off x="7420355" y="4343400"/>
             <a:ext cx="1920240" cy="457200"/>
           </a:xfrm>
           <a:prstGeom prst="rect">
@@ -16944,20 +16655,67 @@
       </p:sp>
       <p:sp>
         <p:nvSpPr>
-          <p:cNvPr id="33" name="Rectangle 32"/>
+          <p:cNvPr id="27" name="TextBox 26"/>
+          <p:cNvSpPr txBox="1"/>
+          <p:nvPr/>
+        </p:nvSpPr>
+        <p:spPr>
+          <a:xfrm>
+            <a:off x="7420355" y="4892040"/>
+            <a:ext cx="1920240" cy="219456"/>
+          </a:xfrm>
+          <a:prstGeom prst="rect">
+            <a:avLst/>
+          </a:prstGeom>
+          <a:noFill/>
+        </p:spPr>
+        <p:txBody>
+          <a:bodyPr wrap="square" lIns="0" rIns="0" tIns="0" bIns="0" anchor="t">
+            <a:spAutoFit/>
+          </a:bodyPr>
+          <a:lstStyle/>
+          <a:p>
+            <a:pPr algn="ctr">
+              <a:lnSpc>
+                <a:spcPct val="135000"/>
+              </a:lnSpc>
+              <a:spcBef>
+                <a:spcPts val="0"/>
+              </a:spcBef>
+              <a:spcAft>
+                <a:spcPts val="0"/>
+              </a:spcAft>
+            </a:pPr>
+            <a:r>
+              <a:rPr sz="1050" b="0">
+                <a:solidFill>
+                  <a:srgbClr val="6B6B6B"/>
+                </a:solidFill>
+                <a:latin typeface="Pretendard"/>
+                <a:ea typeface="Pretendard"/>
+                <a:cs typeface="Pretendard"/>
+              </a:rPr>
+              <a:t>구조 그대로</a:t>
+            </a:r>
+          </a:p>
+        </p:txBody>
+      </p:sp>
+      <p:sp>
+        <p:nvSpPr>
+          <p:cNvPr id="28" name="Rectangle 27"/>
           <p:cNvSpPr/>
           <p:nvPr/>
         </p:nvSpPr>
         <p:spPr>
           <a:xfrm>
-            <a:off x="7575803" y="4553712"/>
-            <a:ext cx="1609344" cy="274320"/>
+            <a:off x="10659617" y="3927348"/>
+            <a:ext cx="41148" cy="274320"/>
           </a:xfrm>
           <a:prstGeom prst="rect">
             <a:avLst/>
           </a:prstGeom>
           <a:solidFill>
-            <a:srgbClr val="F2F0FF"/>
+            <a:srgbClr val="1C9E63"/>
           </a:solidFill>
           <a:ln>
             <a:noFill/>
@@ -16988,152 +16746,14 @@
       </p:sp>
       <p:sp>
         <p:nvSpPr>
-          <p:cNvPr id="34" name="TextBox 33"/>
-          <p:cNvSpPr txBox="1"/>
-          <p:nvPr/>
-        </p:nvSpPr>
-        <p:spPr>
-          <a:xfrm>
-            <a:off x="7575803" y="4608576"/>
-            <a:ext cx="1609344" cy="219456"/>
-          </a:xfrm>
-          <a:prstGeom prst="rect">
-            <a:avLst/>
-          </a:prstGeom>
-          <a:noFill/>
-        </p:spPr>
-        <p:txBody>
-          <a:bodyPr wrap="square" lIns="0" rIns="0" tIns="0" bIns="0" anchor="t">
-            <a:spAutoFit/>
-          </a:bodyPr>
-          <a:lstStyle/>
-          <a:p>
-            <a:pPr algn="ctr">
-              <a:lnSpc>
-                <a:spcPct val="135000"/>
-              </a:lnSpc>
-              <a:spcBef>
-                <a:spcPts val="0"/>
-              </a:spcBef>
-              <a:spcAft>
-                <a:spcPts val="0"/>
-              </a:spcAft>
-            </a:pPr>
-            <a:r>
-              <a:rPr sz="1100" b="1">
-                <a:solidFill>
-                  <a:srgbClr val="6C4CFF"/>
-                </a:solidFill>
-                <a:latin typeface="Pretendard"/>
-                <a:ea typeface="Pretendard"/>
-                <a:cs typeface="Pretendard"/>
-              </a:rPr>
-              <a:t>_core/</a:t>
-            </a:r>
-          </a:p>
-        </p:txBody>
-      </p:sp>
-      <p:sp>
-        <p:nvSpPr>
-          <p:cNvPr id="35" name="TextBox 34"/>
-          <p:cNvSpPr txBox="1"/>
-          <p:nvPr/>
-        </p:nvSpPr>
-        <p:spPr>
-          <a:xfrm>
-            <a:off x="7420355" y="4864608"/>
-            <a:ext cx="1920240" cy="219456"/>
-          </a:xfrm>
-          <a:prstGeom prst="rect">
-            <a:avLst/>
-          </a:prstGeom>
-          <a:noFill/>
-        </p:spPr>
-        <p:txBody>
-          <a:bodyPr wrap="square" lIns="0" rIns="0" tIns="0" bIns="0" anchor="t">
-            <a:spAutoFit/>
-          </a:bodyPr>
-          <a:lstStyle/>
-          <a:p>
-            <a:pPr algn="ctr">
-              <a:lnSpc>
-                <a:spcPct val="135000"/>
-              </a:lnSpc>
-              <a:spcBef>
-                <a:spcPts val="0"/>
-              </a:spcBef>
-              <a:spcAft>
-                <a:spcPts val="0"/>
-              </a:spcAft>
-            </a:pPr>
-            <a:r>
-              <a:rPr sz="1000" b="0">
-                <a:solidFill>
-                  <a:srgbClr val="6B6B6B"/>
-                </a:solidFill>
-                <a:latin typeface="Pretendard"/>
-                <a:ea typeface="Pretendard"/>
-                <a:cs typeface="Pretendard"/>
-              </a:rPr>
-              <a:t>＋ 자기 문서</a:t>
-            </a:r>
-          </a:p>
-        </p:txBody>
-      </p:sp>
-      <p:sp>
-        <p:nvSpPr>
-          <p:cNvPr id="36" name="Rectangle 35"/>
+          <p:cNvPr id="29" name="Rectangle 28"/>
           <p:cNvSpPr/>
           <p:nvPr/>
         </p:nvSpPr>
         <p:spPr>
           <a:xfrm>
-            <a:off x="10659617" y="3639312"/>
-            <a:ext cx="41148" cy="274320"/>
-          </a:xfrm>
-          <a:prstGeom prst="rect">
-            <a:avLst/>
-          </a:prstGeom>
-          <a:solidFill>
-            <a:srgbClr val="6C4CFF"/>
-          </a:solidFill>
-          <a:ln>
-            <a:noFill/>
-          </a:ln>
-          <a:effectLst/>
-        </p:spPr>
-        <p:style>
-          <a:lnRef idx="1">
-            <a:schemeClr val="accent1"/>
-          </a:lnRef>
-          <a:fillRef idx="3">
-            <a:schemeClr val="accent1"/>
-          </a:fillRef>
-          <a:effectRef idx="2">
-            <a:schemeClr val="accent1"/>
-          </a:effectRef>
-          <a:fontRef idx="minor">
-            <a:schemeClr val="lt1"/>
-          </a:fontRef>
-        </p:style>
-        <p:txBody>
-          <a:bodyPr rtlCol="0" anchor="ctr" wrap="square"/>
-          <a:lstStyle/>
-          <a:p>
-            <a:pPr algn="ctr"/>
-          </a:p>
-        </p:txBody>
-      </p:sp>
-      <p:sp>
-        <p:nvSpPr>
-          <p:cNvPr id="37" name="Rectangle 36"/>
-          <p:cNvSpPr/>
-          <p:nvPr/>
-        </p:nvSpPr>
-        <p:spPr>
-          <a:xfrm>
-            <a:off x="9720072" y="3913632"/>
-            <a:ext cx="1920240" cy="1188720"/>
+            <a:off x="9720072" y="4206240"/>
+            <a:ext cx="1920240" cy="1097280"/>
           </a:xfrm>
           <a:prstGeom prst="rect">
             <a:avLst/>
@@ -17172,13 +16792,13 @@
       </p:sp>
       <p:sp>
         <p:nvSpPr>
-          <p:cNvPr id="38" name="TextBox 37"/>
+          <p:cNvPr id="30" name="TextBox 29"/>
           <p:cNvSpPr txBox="1"/>
           <p:nvPr/>
         </p:nvSpPr>
         <p:spPr>
           <a:xfrm>
-            <a:off x="9720072" y="4023360"/>
+            <a:off x="9720072" y="4343400"/>
             <a:ext cx="1920240" cy="457200"/>
           </a:xfrm>
           <a:prstGeom prst="rect">
@@ -17243,23 +16863,119 @@
       </p:sp>
       <p:sp>
         <p:nvSpPr>
-          <p:cNvPr id="39" name="Rectangle 38"/>
+          <p:cNvPr id="31" name="TextBox 30"/>
+          <p:cNvSpPr txBox="1"/>
+          <p:nvPr/>
+        </p:nvSpPr>
+        <p:spPr>
+          <a:xfrm>
+            <a:off x="9720072" y="4892040"/>
+            <a:ext cx="1920240" cy="219456"/>
+          </a:xfrm>
+          <a:prstGeom prst="rect">
+            <a:avLst/>
+          </a:prstGeom>
+          <a:noFill/>
+        </p:spPr>
+        <p:txBody>
+          <a:bodyPr wrap="square" lIns="0" rIns="0" tIns="0" bIns="0" anchor="t">
+            <a:spAutoFit/>
+          </a:bodyPr>
+          <a:lstStyle/>
+          <a:p>
+            <a:pPr algn="ctr">
+              <a:lnSpc>
+                <a:spcPct val="135000"/>
+              </a:lnSpc>
+              <a:spcBef>
+                <a:spcPts val="0"/>
+              </a:spcBef>
+              <a:spcAft>
+                <a:spcPts val="0"/>
+              </a:spcAft>
+            </a:pPr>
+            <a:r>
+              <a:rPr sz="1050" b="0">
+                <a:solidFill>
+                  <a:srgbClr val="6B6B6B"/>
+                </a:solidFill>
+                <a:latin typeface="Pretendard"/>
+                <a:ea typeface="Pretendard"/>
+                <a:cs typeface="Pretendard"/>
+              </a:rPr>
+              <a:t>구조 그대로</a:t>
+            </a:r>
+          </a:p>
+        </p:txBody>
+      </p:sp>
+      <p:sp>
+        <p:nvSpPr>
+          <p:cNvPr id="32" name="TextBox 31"/>
+          <p:cNvSpPr txBox="1"/>
+          <p:nvPr/>
+        </p:nvSpPr>
+        <p:spPr>
+          <a:xfrm>
+            <a:off x="777240" y="5394960"/>
+            <a:ext cx="10607040" cy="274320"/>
+          </a:xfrm>
+          <a:prstGeom prst="rect">
+            <a:avLst/>
+          </a:prstGeom>
+          <a:noFill/>
+        </p:spPr>
+        <p:txBody>
+          <a:bodyPr wrap="square" lIns="0" rIns="0" tIns="0" bIns="0" anchor="t">
+            <a:spAutoFit/>
+          </a:bodyPr>
+          <a:lstStyle/>
+          <a:p>
+            <a:pPr algn="l">
+              <a:lnSpc>
+                <a:spcPct val="135000"/>
+              </a:lnSpc>
+              <a:spcBef>
+                <a:spcPts val="0"/>
+              </a:spcBef>
+              <a:spcAft>
+                <a:spcPts val="0"/>
+              </a:spcAft>
+            </a:pPr>
+            <a:r>
+              <a:rPr sz="1250" b="1">
+                <a:solidFill>
+                  <a:srgbClr val="1C9E63"/>
+                </a:solidFill>
+                <a:latin typeface="Pretendard"/>
+                <a:ea typeface="Pretendard"/>
+                <a:cs typeface="Pretendard"/>
+              </a:rPr>
+              <a:t>＋  맨 바깥 design(허브) · 앞으로 만들 새 저장소에서도 똑같이 로드됩니다</a:t>
+            </a:r>
+          </a:p>
+        </p:txBody>
+      </p:sp>
+      <p:sp>
+        <p:nvSpPr>
+          <p:cNvPr id="33" name="Rectangle 32"/>
           <p:cNvSpPr/>
           <p:nvPr/>
         </p:nvSpPr>
         <p:spPr>
           <a:xfrm>
-            <a:off x="9875519" y="4553712"/>
-            <a:ext cx="1609344" cy="274320"/>
+            <a:off x="777240" y="5779008"/>
+            <a:ext cx="5120640" cy="566928"/>
           </a:xfrm>
           <a:prstGeom prst="rect">
             <a:avLst/>
           </a:prstGeom>
           <a:solidFill>
-            <a:srgbClr val="F2F0FF"/>
+            <a:srgbClr val="ECFAF2"/>
           </a:solidFill>
-          <a:ln>
-            <a:noFill/>
+          <a:ln w="12700">
+            <a:solidFill>
+              <a:srgbClr val="E4E4E4"/>
+            </a:solidFill>
           </a:ln>
           <a:effectLst/>
         </p:spPr>
@@ -17287,14 +17003,14 @@
       </p:sp>
       <p:sp>
         <p:nvSpPr>
-          <p:cNvPr id="40" name="TextBox 39"/>
+          <p:cNvPr id="34" name="TextBox 33"/>
           <p:cNvSpPr txBox="1"/>
           <p:nvPr/>
         </p:nvSpPr>
         <p:spPr>
           <a:xfrm>
-            <a:off x="9875519" y="4608576"/>
-            <a:ext cx="1609344" cy="219456"/>
+            <a:off x="987552" y="5870448"/>
+            <a:ext cx="4709160" cy="411480"/>
           </a:xfrm>
           <a:prstGeom prst="rect">
             <a:avLst/>
@@ -17307,98 +17023,75 @@
           </a:bodyPr>
           <a:lstStyle/>
           <a:p>
-            <a:pPr algn="ctr">
-              <a:lnSpc>
-                <a:spcPct val="135000"/>
-              </a:lnSpc>
-              <a:spcBef>
-                <a:spcPts val="0"/>
-              </a:spcBef>
-              <a:spcAft>
-                <a:spcPts val="0"/>
-              </a:spcAft>
-            </a:pPr>
-            <a:r>
-              <a:rPr sz="1100" b="1">
-                <a:solidFill>
-                  <a:srgbClr val="6C4CFF"/>
-                </a:solidFill>
-                <a:latin typeface="Pretendard"/>
-                <a:ea typeface="Pretendard"/>
-                <a:cs typeface="Pretendard"/>
-              </a:rPr>
-              <a:t>_core/</a:t>
-            </a:r>
-          </a:p>
-        </p:txBody>
-      </p:sp>
-      <p:sp>
-        <p:nvSpPr>
-          <p:cNvPr id="41" name="TextBox 40"/>
-          <p:cNvSpPr txBox="1"/>
-          <p:nvPr/>
-        </p:nvSpPr>
-        <p:spPr>
-          <a:xfrm>
-            <a:off x="9720072" y="4864608"/>
-            <a:ext cx="1920240" cy="219456"/>
-          </a:xfrm>
-          <a:prstGeom prst="rect">
-            <a:avLst/>
-          </a:prstGeom>
-          <a:noFill/>
-        </p:spPr>
-        <p:txBody>
-          <a:bodyPr wrap="square" lIns="0" rIns="0" tIns="0" bIns="0" anchor="t">
-            <a:spAutoFit/>
-          </a:bodyPr>
-          <a:lstStyle/>
-          <a:p>
-            <a:pPr algn="ctr">
-              <a:lnSpc>
-                <a:spcPct val="135000"/>
-              </a:lnSpc>
-              <a:spcBef>
-                <a:spcPts val="0"/>
-              </a:spcBef>
-              <a:spcAft>
-                <a:spcPts val="0"/>
-              </a:spcAft>
-            </a:pPr>
-            <a:r>
-              <a:rPr sz="1000" b="0">
-                <a:solidFill>
-                  <a:srgbClr val="6B6B6B"/>
-                </a:solidFill>
-                <a:latin typeface="Pretendard"/>
-                <a:ea typeface="Pretendard"/>
-                <a:cs typeface="Pretendard"/>
-              </a:rPr>
-              <a:t>＋ 자기 문서</a:t>
-            </a:r>
-          </a:p>
-        </p:txBody>
-      </p:sp>
-      <p:sp>
-        <p:nvSpPr>
-          <p:cNvPr id="42" name="Rectangle 41"/>
+            <a:pPr algn="l">
+              <a:lnSpc>
+                <a:spcPct val="140000"/>
+              </a:lnSpc>
+              <a:spcBef>
+                <a:spcPts val="0"/>
+              </a:spcBef>
+              <a:spcAft>
+                <a:spcPts val="0"/>
+              </a:spcAft>
+            </a:pPr>
+            <a:r>
+              <a:rPr sz="1150" b="0">
+                <a:solidFill>
+                  <a:srgbClr val="292929"/>
+                </a:solidFill>
+                <a:latin typeface="Pretendard"/>
+                <a:ea typeface="Pretendard"/>
+                <a:cs typeface="Pretendard"/>
+              </a:rPr>
+              <a:t>A안이 하는 일</a:t>
+            </a:r>
+          </a:p>
+          <a:p>
+            <a:pPr>
+              <a:lnSpc>
+                <a:spcPct val="140000"/>
+              </a:lnSpc>
+              <a:spcBef>
+                <a:spcPts val="0"/>
+              </a:spcBef>
+              <a:spcAft>
+                <a:spcPts val="0"/>
+              </a:spcAft>
+            </a:pPr>
+            <a:r>
+              <a:rPr sz="1150" b="0">
+                <a:solidFill>
+                  <a:srgbClr val="292929"/>
+                </a:solidFill>
+                <a:latin typeface="Pretendard"/>
+                <a:ea typeface="Pretendard"/>
+                <a:cs typeface="Pretendard"/>
+              </a:rPr>
+              <a:t>각 저장소의 안내문·깨진 주소 정리 + 브랜드 값 1회 통일</a:t>
+            </a:r>
+          </a:p>
+        </p:txBody>
+      </p:sp>
+      <p:sp>
+        <p:nvSpPr>
+          <p:cNvPr id="35" name="Rectangle 34"/>
           <p:cNvSpPr/>
           <p:nvPr/>
         </p:nvSpPr>
         <p:spPr>
           <a:xfrm>
-            <a:off x="777240" y="5285232"/>
-            <a:ext cx="10634472" cy="658368"/>
+            <a:off x="6263640" y="5779008"/>
+            <a:ext cx="5148072" cy="566928"/>
           </a:xfrm>
           <a:prstGeom prst="rect">
             <a:avLst/>
           </a:prstGeom>
           <a:solidFill>
-            <a:srgbClr val="ECFAF2"/>
+            <a:srgbClr val="F2F0FF"/>
           </a:solidFill>
-          <a:ln w="19050">
+          <a:ln w="12700">
             <a:solidFill>
-              <a:srgbClr val="1C9E63"/>
+              <a:srgbClr val="E4E4E4"/>
             </a:solidFill>
           </a:ln>
           <a:effectLst/>
@@ -17427,14 +17120,14 @@
       </p:sp>
       <p:sp>
         <p:nvSpPr>
-          <p:cNvPr id="43" name="TextBox 42"/>
+          <p:cNvPr id="36" name="TextBox 35"/>
           <p:cNvSpPr txBox="1"/>
           <p:nvPr/>
         </p:nvSpPr>
         <p:spPr>
           <a:xfrm>
-            <a:off x="1051560" y="5376672"/>
-            <a:ext cx="4572000" cy="256032"/>
+            <a:off x="6473952" y="5870448"/>
+            <a:ext cx="4709160" cy="411480"/>
           </a:xfrm>
           <a:prstGeom prst="rect">
             <a:avLst/>
@@ -17449,39 +17142,63 @@
           <a:p>
             <a:pPr algn="l">
               <a:lnSpc>
-                <a:spcPct val="135000"/>
-              </a:lnSpc>
-              <a:spcBef>
-                <a:spcPts val="0"/>
-              </a:spcBef>
-              <a:spcAft>
-                <a:spcPts val="0"/>
-              </a:spcAft>
-            </a:pPr>
-            <a:r>
-              <a:rPr sz="1300" b="1">
-                <a:solidFill>
-                  <a:srgbClr val="1C9E63"/>
-                </a:solidFill>
-                <a:latin typeface="Pretendard"/>
-                <a:ea typeface="Pretendard"/>
-                <a:cs typeface="Pretendard"/>
-              </a:rPr>
-              <a:t>D안  cdbd-plugin   (신규 저장소)</a:t>
-            </a:r>
-          </a:p>
-        </p:txBody>
-      </p:sp>
-      <p:sp>
-        <p:nvSpPr>
-          <p:cNvPr id="44" name="TextBox 43"/>
+                <a:spcPct val="140000"/>
+              </a:lnSpc>
+              <a:spcBef>
+                <a:spcPts val="0"/>
+              </a:spcBef>
+              <a:spcAft>
+                <a:spcPts val="0"/>
+              </a:spcAft>
+            </a:pPr>
+            <a:r>
+              <a:rPr sz="1150" b="0">
+                <a:solidFill>
+                  <a:srgbClr val="292929"/>
+                </a:solidFill>
+                <a:latin typeface="Pretendard"/>
+                <a:ea typeface="Pretendard"/>
+                <a:cs typeface="Pretendard"/>
+              </a:rPr>
+              <a:t>자동 점검이 하는 일</a:t>
+            </a:r>
+          </a:p>
+          <a:p>
+            <a:pPr>
+              <a:lnSpc>
+                <a:spcPct val="140000"/>
+              </a:lnSpc>
+              <a:spcBef>
+                <a:spcPts val="0"/>
+              </a:spcBef>
+              <a:spcAft>
+                <a:spcPts val="0"/>
+              </a:spcAft>
+            </a:pPr>
+            <a:r>
+              <a:rPr sz="1150" b="0">
+                <a:solidFill>
+                  <a:srgbClr val="292929"/>
+                </a:solidFill>
+                <a:latin typeface="Pretendard"/>
+                <a:ea typeface="Pretendard"/>
+                <a:cs typeface="Pretendard"/>
+              </a:rPr>
+              <a:t>저장소 문서 값이 정본과 어긋나면 바로 잡아냄</a:t>
+            </a:r>
+          </a:p>
+        </p:txBody>
+      </p:sp>
+      <p:sp>
+        <p:nvSpPr>
+          <p:cNvPr id="37" name="TextBox 36"/>
           <p:cNvSpPr txBox="1"/>
           <p:nvPr/>
         </p:nvSpPr>
         <p:spPr>
           <a:xfrm>
-            <a:off x="1051560" y="5614416"/>
-            <a:ext cx="10058400" cy="237744"/>
+            <a:off x="777240" y="6455664"/>
+            <a:ext cx="9509760" cy="256032"/>
           </a:xfrm>
           <a:prstGeom prst="rect">
             <a:avLst/>
@@ -17506,100 +17223,6 @@
               </a:spcAft>
             </a:pPr>
             <a:r>
-              <a:rPr sz="1150" b="0">
-                <a:solidFill>
-                  <a:srgbClr val="292929"/>
-                </a:solidFill>
-                <a:latin typeface="Pretendard"/>
-                <a:ea typeface="Pretendard"/>
-                <a:cs typeface="Pretendard"/>
-              </a:rPr>
-              <a:t>스킬 · 에이전트 · Figma MCP 설정  →  팀원이 1회 설치하면 위 5개 저장소는 물론 허브·신규 저장소까지 어디서 켜도 자동 로드</a:t>
-            </a:r>
-          </a:p>
-        </p:txBody>
-      </p:sp>
-      <p:sp>
-        <p:nvSpPr>
-          <p:cNvPr id="45" name="TextBox 44"/>
-          <p:cNvSpPr txBox="1"/>
-          <p:nvPr/>
-        </p:nvSpPr>
-        <p:spPr>
-          <a:xfrm>
-            <a:off x="777240" y="6053328"/>
-            <a:ext cx="10607040" cy="274320"/>
-          </a:xfrm>
-          <a:prstGeom prst="rect">
-            <a:avLst/>
-          </a:prstGeom>
-          <a:noFill/>
-        </p:spPr>
-        <p:txBody>
-          <a:bodyPr wrap="square" lIns="0" rIns="0" tIns="0" bIns="0" anchor="t">
-            <a:spAutoFit/>
-          </a:bodyPr>
-          <a:lstStyle/>
-          <a:p>
-            <a:pPr algn="l">
-              <a:lnSpc>
-                <a:spcPct val="135000"/>
-              </a:lnSpc>
-              <a:spcBef>
-                <a:spcPts val="0"/>
-              </a:spcBef>
-              <a:spcAft>
-                <a:spcPts val="0"/>
-              </a:spcAft>
-            </a:pPr>
-            <a:r>
-              <a:rPr sz="1250" b="1">
-                <a:solidFill>
-                  <a:srgbClr val="6C4CFF"/>
-                </a:solidFill>
-                <a:latin typeface="Pretendard"/>
-                <a:ea typeface="Pretendard"/>
-                <a:cs typeface="Pretendard"/>
-              </a:rPr>
-              <a:t>_core는 볼트 안에 실제 폴더로 들어가 사람도 봅니다. 플러그인은 볼트 밖에서 스킬만 나릅니다 — 둘의 역할이 다릅니다.</a:t>
-            </a:r>
-          </a:p>
-        </p:txBody>
-      </p:sp>
-      <p:sp>
-        <p:nvSpPr>
-          <p:cNvPr id="46" name="TextBox 45"/>
-          <p:cNvSpPr txBox="1"/>
-          <p:nvPr/>
-        </p:nvSpPr>
-        <p:spPr>
-          <a:xfrm>
-            <a:off x="777240" y="6455664"/>
-            <a:ext cx="9509760" cy="256032"/>
-          </a:xfrm>
-          <a:prstGeom prst="rect">
-            <a:avLst/>
-          </a:prstGeom>
-          <a:noFill/>
-        </p:spPr>
-        <p:txBody>
-          <a:bodyPr wrap="square" lIns="0" rIns="0" tIns="0" bIns="0" anchor="t">
-            <a:spAutoFit/>
-          </a:bodyPr>
-          <a:lstStyle/>
-          <a:p>
-            <a:pPr algn="l">
-              <a:lnSpc>
-                <a:spcPct val="135000"/>
-              </a:lnSpc>
-              <a:spcBef>
-                <a:spcPts val="0"/>
-              </a:spcBef>
-              <a:spcAft>
-                <a:spcPts val="0"/>
-              </a:spcAft>
-            </a:pPr>
-            <a:r>
               <a:rPr sz="1000" b="0">
                 <a:solidFill>
                   <a:srgbClr val="9A9A9A"/>
@@ -17615,7 +17238,7 @@
       </p:sp>
       <p:sp>
         <p:nvSpPr>
-          <p:cNvPr id="47" name="TextBox 46"/>
+          <p:cNvPr id="38" name="TextBox 37"/>
           <p:cNvSpPr txBox="1"/>
           <p:nvPr/>
         </p:nvSpPr>
@@ -18876,7 +18499,7 @@
                 <a:ea typeface="Pretendard"/>
                 <a:cs typeface="Pretendard"/>
               </a:rPr>
-              <a:t>선택지 A~D · 추천안 · D안이 필요한 이유 · 적용 결과</a:t>
+              <a:t>선택지 A~D · 추천(A+D) · D안이 필요한 이유 · 적용 결과</a:t>
             </a:r>
           </a:p>
         </p:txBody>
@@ -19570,7 +19193,7 @@
                           <a:ea typeface="Pretendard"/>
                           <a:cs typeface="Pretendard"/>
                         </a:rPr>
-                        <a:t>추천안 A+B+D</a:t>
+                        <a:t>추천안 A+D</a:t>
                       </a:r>
                     </a:p>
                   </a:txBody>
@@ -20100,7 +19723,7 @@
                           <a:ea typeface="Pretendard"/>
                           <a:cs typeface="Pretendard"/>
                         </a:rPr>
-                        <a:t>갈라짐</a:t>
+                        <a:t>2개월간 몰랐음</a:t>
                       </a:r>
                     </a:p>
                   </a:txBody>
@@ -20158,7 +19781,7 @@
                           <a:ea typeface="Pretendard"/>
                           <a:cs typeface="Pretendard"/>
                         </a:rPr>
-                        <a:t>구조적으로 불가</a:t>
+                        <a:t>자동 점검이 하루 만에 잡음</a:t>
                       </a:r>
                     </a:p>
                   </a:txBody>
@@ -20746,7 +20369,7 @@
                           <a:ea typeface="Pretendard"/>
                           <a:cs typeface="Pretendard"/>
                         </a:rPr>
-                        <a:t>큼 · 필요</a:t>
+                        <a:t>중간 · 신규 저장소 1개</a:t>
                       </a:r>
                     </a:p>
                   </a:txBody>
@@ -20847,7 +20470,7 @@
                 <a:ea typeface="Pretendard"/>
                 <a:cs typeface="Pretendard"/>
               </a:rPr>
-              <a:t>권장 순서: A를 저장소 1개에 먼저 적용해 효과를 확인한 뒤, B(_core)와 D(플러그인)로 확장합니다.</a:t>
+              <a:t>권장 순서: A를 저장소 1개에 먼저 적용해 효과를 확인한 뒤, D(플러그인)로 확장합니다. B는 공유 문서가 늘면 그때 재검토합니다.</a:t>
             </a:r>
           </a:p>
         </p:txBody>
@@ -22302,7 +21925,7 @@
                 <a:ea typeface="Pretendard"/>
                 <a:cs typeface="Pretendard"/>
               </a:rPr>
-              <a:t>그 뒤에 A안을 저장소 1개에 시범 적용해보고, 효과가 확인되면 B(_core)와 D(플러그인)로 확장합니다.</a:t>
+              <a:t>그 뒤에 A안을 저장소 1개에 시범 적용해보고, 효과가 확인되면 D(플러그인)로 확장합니다.</a:t>
             </a:r>
           </a:p>
         </p:txBody>

</xml_diff>

<commit_message>
vault backup: 2026-08-09 22:56:01
</commit_message>
<xml_diff>
--- a/CdBd 문서 체계 진단 및 개편 제안.pptx
+++ b/CdBd 문서 체계 진단 및 개편 제안.pptx
@@ -13559,7 +13559,7 @@
         </p:nvSpPr>
         <p:spPr>
           <a:xfrm>
-            <a:off x="777240" y="5349240"/>
+            <a:off x="777240" y="5285232"/>
             <a:ext cx="10607040" cy="274320"/>
           </a:xfrm>
           <a:prstGeom prst="rect">
@@ -13585,7 +13585,7 @@
               </a:spcAft>
             </a:pPr>
             <a:r>
-              <a:rPr sz="1500" b="1">
+              <a:rPr sz="1450" b="1">
                 <a:solidFill>
                   <a:srgbClr val="E53A40"/>
                 </a:solidFill>
@@ -13606,8 +13606,8 @@
         </p:nvSpPr>
         <p:spPr>
           <a:xfrm>
-            <a:off x="777240" y="5687568"/>
-            <a:ext cx="2377440" cy="384048"/>
+            <a:off x="777240" y="5596128"/>
+            <a:ext cx="2377440" cy="365760"/>
           </a:xfrm>
           <a:prstGeom prst="rect">
             <a:avLst/>
@@ -13650,7 +13650,7 @@
         </p:nvSpPr>
         <p:spPr>
           <a:xfrm>
-            <a:off x="932688" y="5769864"/>
+            <a:off x="932688" y="5669280"/>
             <a:ext cx="2194560" cy="228600"/>
           </a:xfrm>
           <a:prstGeom prst="rect">
@@ -13676,7 +13676,7 @@
               </a:spcAft>
             </a:pPr>
             <a:r>
-              <a:rPr sz="1150" b="1">
+              <a:rPr sz="1100" b="1">
                 <a:solidFill>
                   <a:srgbClr val="E53A40"/>
                 </a:solidFill>
@@ -13697,8 +13697,8 @@
         </p:nvSpPr>
         <p:spPr>
           <a:xfrm>
-            <a:off x="3337560" y="5669280"/>
-            <a:ext cx="8074152" cy="457200"/>
+            <a:off x="3337560" y="5568696"/>
+            <a:ext cx="8074152" cy="438912"/>
           </a:xfrm>
           <a:prstGeom prst="rect">
             <a:avLst/>
@@ -13713,17 +13713,17 @@
           <a:p>
             <a:pPr algn="l">
               <a:lnSpc>
-                <a:spcPct val="135000"/>
-              </a:lnSpc>
-              <a:spcBef>
-                <a:spcPts val="0"/>
-              </a:spcBef>
-              <a:spcAft>
-                <a:spcPts val="0"/>
-              </a:spcAft>
-            </a:pPr>
-            <a:r>
-              <a:rPr sz="1050" b="0">
+                <a:spcPct val="132000"/>
+              </a:lnSpc>
+              <a:spcBef>
+                <a:spcPts val="0"/>
+              </a:spcBef>
+              <a:spcAft>
+                <a:spcPts val="0"/>
+              </a:spcAft>
+            </a:pPr>
+            <a:r>
+              <a:rPr sz="1000" b="0">
                 <a:solidFill>
                   <a:srgbClr val="292929"/>
                 </a:solidFill>
@@ -13737,17 +13737,17 @@
           <a:p>
             <a:pPr>
               <a:lnSpc>
-                <a:spcPct val="135000"/>
-              </a:lnSpc>
-              <a:spcBef>
-                <a:spcPts val="0"/>
-              </a:spcBef>
-              <a:spcAft>
-                <a:spcPts val="0"/>
-              </a:spcAft>
-            </a:pPr>
-            <a:r>
-              <a:rPr sz="1050" b="0">
+                <a:spcPct val="132000"/>
+              </a:lnSpc>
+              <a:spcBef>
+                <a:spcPts val="0"/>
+              </a:spcBef>
+              <a:spcAft>
+                <a:spcPts val="0"/>
+              </a:spcAft>
+            </a:pPr>
+            <a:r>
+              <a:rPr sz="1000" b="0">
                 <a:solidFill>
                   <a:srgbClr val="292929"/>
                 </a:solidFill>
@@ -13768,8 +13768,8 @@
         </p:nvSpPr>
         <p:spPr>
           <a:xfrm>
-            <a:off x="777240" y="6144768"/>
-            <a:ext cx="2377440" cy="384048"/>
+            <a:off x="777240" y="6007608"/>
+            <a:ext cx="2377440" cy="365760"/>
           </a:xfrm>
           <a:prstGeom prst="rect">
             <a:avLst/>
@@ -13812,7 +13812,7 @@
         </p:nvSpPr>
         <p:spPr>
           <a:xfrm>
-            <a:off x="932688" y="6227064"/>
+            <a:off x="932688" y="6080760"/>
             <a:ext cx="2194560" cy="228600"/>
           </a:xfrm>
           <a:prstGeom prst="rect">
@@ -13838,7 +13838,7 @@
               </a:spcAft>
             </a:pPr>
             <a:r>
-              <a:rPr sz="1150" b="1">
+              <a:rPr sz="1100" b="1">
                 <a:solidFill>
                   <a:srgbClr val="E53A40"/>
                 </a:solidFill>
@@ -13859,8 +13859,8 @@
         </p:nvSpPr>
         <p:spPr>
           <a:xfrm>
-            <a:off x="3337560" y="6126480"/>
-            <a:ext cx="8074152" cy="457200"/>
+            <a:off x="3337560" y="5980176"/>
+            <a:ext cx="8074152" cy="438912"/>
           </a:xfrm>
           <a:prstGeom prst="rect">
             <a:avLst/>
@@ -13875,17 +13875,17 @@
           <a:p>
             <a:pPr algn="l">
               <a:lnSpc>
-                <a:spcPct val="135000"/>
-              </a:lnSpc>
-              <a:spcBef>
-                <a:spcPts val="0"/>
-              </a:spcBef>
-              <a:spcAft>
-                <a:spcPts val="0"/>
-              </a:spcAft>
-            </a:pPr>
-            <a:r>
-              <a:rPr sz="1050" b="0">
+                <a:spcPct val="132000"/>
+              </a:lnSpc>
+              <a:spcBef>
+                <a:spcPts val="0"/>
+              </a:spcBef>
+              <a:spcAft>
+                <a:spcPts val="0"/>
+              </a:spcAft>
+            </a:pPr>
+            <a:r>
+              <a:rPr sz="1000" b="0">
                 <a:solidFill>
                   <a:srgbClr val="292929"/>
                 </a:solidFill>

</xml_diff>